<commit_message>
Deck: structural-only framing; slide 4 = one opening -> research question
Per feedback:
- Slide 4 "The opening they left": replaced the 4-row Sandhu-vs-this-work table
  with a single opening (their undirected correlation graph cannot see direction)
  that lands directly on the research question via a highlighted call-out box.
- Removed the dedicated predictive-IC results slide; this is a structural-only
  talk. Folded a single honest line ("we make no predictive claim") into the
  implications slide.
- Pipeline slide stage 6 reworded from the exploratory-IC step to "select & report
  the structurally isolated pairs."
Deck is now 16 slides, fully structural.

Co-Authored-By: Claude Opus 4.8 (1M context) <noreply@anthropic.com>
</commit_message>
<xml_diff>
--- a/slides/Ricci_Curvature_LeadLag.pptx
+++ b/slides/Ricci_Curvature_LeadLag.pptx
@@ -21,7 +21,6 @@
     <p:sldId id="269" r:id="rId20"/>
     <p:sldId id="270" r:id="rId21"/>
     <p:sldId id="271" r:id="rId22"/>
-    <p:sldId id="272" r:id="rId23"/>
   </p:sldIdLst>
   <p:sldSz cx="12191695" cy="6858000" type="screen4x3"/>
   <p:notesSz cx="6858000" cy="9144000"/>
@@ -4913,7 +4912,7 @@
                 </a:solidFill>
                 <a:latin typeface="Calibri"/>
               </a:rPr>
-              <a:t>The predictive question — an honest null</a:t>
+              <a:t>What it means</a:t>
             </a:r>
           </a:p>
         </p:txBody>
@@ -4971,7 +4970,7 @@
         <p:spPr>
           <a:xfrm>
             <a:off x="777240" y="1783080"/>
-            <a:ext cx="10607040" cy="640080"/>
+            <a:ext cx="10607040" cy="3657600"/>
           </a:xfrm>
           <a:prstGeom prst="rect">
             <a:avLst/>
@@ -4984,410 +4983,81 @@
           </a:bodyPr>
           <a:lstStyle/>
           <a:p>
-            <a:r>
-              <a:rPr sz="1800" b="0" i="1">
-                <a:solidFill>
-                  <a:srgbClr val="2563EB"/>
-                </a:solidFill>
-                <a:latin typeface="Calibri"/>
-              </a:rPr>
-              <a:t>Out-of-sample directional IC (full-year 2019, within-day horizon).</a:t>
-            </a:r>
-          </a:p>
-        </p:txBody>
-      </p:sp>
-      <p:graphicFrame>
-        <p:nvGraphicFramePr>
-          <p:cNvPr id="5" name="Table 4"/>
-          <p:cNvGraphicFramePr>
-            <a:graphicFrameLocks noGrp="1"/>
-          </p:cNvGraphicFramePr>
-          <p:nvPr/>
-        </p:nvGraphicFramePr>
-        <p:xfrm>
-          <a:off x="777240" y="2377440"/>
-          <a:ext cx="10607040" cy="2286000"/>
-        </p:xfrm>
-        <a:graphic>
-          <a:graphicData uri="http://schemas.openxmlformats.org/drawingml/2006/table">
-            <a:tbl>
-              <a:tblPr firstRow="1" bandRow="1">
-                <a:tableStyleId>{5C22544A-7EE6-4342-B048-85BDC9FD1C3A}</a:tableStyleId>
-              </a:tblPr>
-              <a:tblGrid>
-                <a:gridCol w="4572000"/>
-                <a:gridCol w="2377440"/>
-                <a:gridCol w="3657600"/>
-              </a:tblGrid>
-              <a:tr h="457200">
-                <a:tc>
-                  <a:txBody>
-                    <a:bodyPr/>
-                    <a:lstStyle/>
-                    <a:p>
-                      <a:pPr algn="l"/>
-                      <a:r>
-                        <a:rPr sz="1500" b="1" i="0">
-                          <a:solidFill>
-                            <a:srgbClr val="FFFFFF"/>
-                          </a:solidFill>
-                          <a:latin typeface="Calibri"/>
-                        </a:rPr>
-                        <a:t>Method</a:t>
-                      </a:r>
-                    </a:p>
-                  </a:txBody>
-                  <a:tcPr anchor="ctr">
-                    <a:solidFill>
-                      <a:srgbClr val="2563EB"/>
-                    </a:solidFill>
-                  </a:tcPr>
-                </a:tc>
-                <a:tc>
-                  <a:txBody>
-                    <a:bodyPr/>
-                    <a:lstStyle/>
-                    <a:p>
-                      <a:pPr algn="ctr"/>
-                      <a:r>
-                        <a:rPr sz="1500" b="1" i="0">
-                          <a:solidFill>
-                            <a:srgbClr val="FFFFFF"/>
-                          </a:solidFill>
-                          <a:latin typeface="Calibri"/>
-                        </a:rPr>
-                        <a:t>Mean IC</a:t>
-                      </a:r>
-                    </a:p>
-                  </a:txBody>
-                  <a:tcPr anchor="ctr">
-                    <a:solidFill>
-                      <a:srgbClr val="2563EB"/>
-                    </a:solidFill>
-                  </a:tcPr>
-                </a:tc>
-                <a:tc>
-                  <a:txBody>
-                    <a:bodyPr/>
-                    <a:lstStyle/>
-                    <a:p>
-                      <a:pPr algn="ctr"/>
-                      <a:r>
-                        <a:rPr sz="1500" b="1" i="0">
-                          <a:solidFill>
-                            <a:srgbClr val="FFFFFF"/>
-                          </a:solidFill>
-                          <a:latin typeface="Calibri"/>
-                        </a:rPr>
-                        <a:t>95% CI</a:t>
-                      </a:r>
-                    </a:p>
-                  </a:txBody>
-                  <a:tcPr anchor="ctr">
-                    <a:solidFill>
-                      <a:srgbClr val="2563EB"/>
-                    </a:solidFill>
-                  </a:tcPr>
-                </a:tc>
-              </a:tr>
-              <a:tr h="457200">
-                <a:tc>
-                  <a:txBody>
-                    <a:bodyPr/>
-                    <a:lstStyle/>
-                    <a:p>
-                      <a:pPr algn="l"/>
-                      <a:r>
-                        <a:rPr sz="1400" b="1" i="0">
-                          <a:solidFill>
-                            <a:srgbClr val="1F2937"/>
-                          </a:solidFill>
-                          <a:latin typeface="Calibri"/>
-                        </a:rPr>
-                        <a:t>Undirected Forman</a:t>
-                      </a:r>
-                    </a:p>
-                  </a:txBody>
-                  <a:tcPr anchor="ctr">
-                    <a:solidFill>
-                      <a:srgbClr val="EFF2FB"/>
-                    </a:solidFill>
-                  </a:tcPr>
-                </a:tc>
-                <a:tc>
-                  <a:txBody>
-                    <a:bodyPr/>
-                    <a:lstStyle/>
-                    <a:p>
-                      <a:pPr algn="ctr"/>
-                      <a:r>
-                        <a:rPr sz="1400" b="1" i="0">
-                          <a:solidFill>
-                            <a:srgbClr val="1F2937"/>
-                          </a:solidFill>
-                          <a:latin typeface="Calibri"/>
-                        </a:rPr>
-                        <a:t>+0.013</a:t>
-                      </a:r>
-                    </a:p>
-                  </a:txBody>
-                  <a:tcPr anchor="ctr">
-                    <a:solidFill>
-                      <a:srgbClr val="EFF2FB"/>
-                    </a:solidFill>
-                  </a:tcPr>
-                </a:tc>
-                <a:tc>
-                  <a:txBody>
-                    <a:bodyPr/>
-                    <a:lstStyle/>
-                    <a:p>
-                      <a:pPr algn="ctr"/>
-                      <a:r>
-                        <a:rPr sz="1400" b="1" i="0">
-                          <a:solidFill>
-                            <a:srgbClr val="1F2937"/>
-                          </a:solidFill>
-                          <a:latin typeface="Calibri"/>
-                        </a:rPr>
-                        <a:t>[−0.016, +0.040]</a:t>
-                      </a:r>
-                    </a:p>
-                  </a:txBody>
-                  <a:tcPr anchor="ctr">
-                    <a:solidFill>
-                      <a:srgbClr val="EFF2FB"/>
-                    </a:solidFill>
-                  </a:tcPr>
-                </a:tc>
-              </a:tr>
-              <a:tr h="457200">
-                <a:tc>
-                  <a:txBody>
-                    <a:bodyPr/>
-                    <a:lstStyle/>
-                    <a:p>
-                      <a:pPr algn="l"/>
-                      <a:r>
-                        <a:rPr sz="1400" b="1" i="0">
-                          <a:solidFill>
-                            <a:srgbClr val="1F2937"/>
-                          </a:solidFill>
-                          <a:latin typeface="Calibri"/>
-                        </a:rPr>
-                        <a:t>Curvature (aug, directed)</a:t>
-                      </a:r>
-                    </a:p>
-                  </a:txBody>
-                  <a:tcPr anchor="ctr">
-                    <a:solidFill>
-                      <a:srgbClr val="EFF2FB"/>
-                    </a:solidFill>
-                  </a:tcPr>
-                </a:tc>
-                <a:tc>
-                  <a:txBody>
-                    <a:bodyPr/>
-                    <a:lstStyle/>
-                    <a:p>
-                      <a:pPr algn="ctr"/>
-                      <a:r>
-                        <a:rPr sz="1400" b="1" i="0">
-                          <a:solidFill>
-                            <a:srgbClr val="1F2937"/>
-                          </a:solidFill>
-                          <a:latin typeface="Calibri"/>
-                        </a:rPr>
-                        <a:t>+0.005</a:t>
-                      </a:r>
-                    </a:p>
-                  </a:txBody>
-                  <a:tcPr anchor="ctr">
-                    <a:solidFill>
-                      <a:srgbClr val="EFF2FB"/>
-                    </a:solidFill>
-                  </a:tcPr>
-                </a:tc>
-                <a:tc>
-                  <a:txBody>
-                    <a:bodyPr/>
-                    <a:lstStyle/>
-                    <a:p>
-                      <a:pPr algn="ctr"/>
-                      <a:r>
-                        <a:rPr sz="1400" b="1" i="0">
-                          <a:solidFill>
-                            <a:srgbClr val="1F2937"/>
-                          </a:solidFill>
-                          <a:latin typeface="Calibri"/>
-                        </a:rPr>
-                        <a:t>[−0.016, +0.026]</a:t>
-                      </a:r>
-                    </a:p>
-                  </a:txBody>
-                  <a:tcPr anchor="ctr">
-                    <a:solidFill>
-                      <a:srgbClr val="EFF2FB"/>
-                    </a:solidFill>
-                  </a:tcPr>
-                </a:tc>
-              </a:tr>
-              <a:tr h="457200">
-                <a:tc>
-                  <a:txBody>
-                    <a:bodyPr/>
-                    <a:lstStyle/>
-                    <a:p>
-                      <a:pPr algn="l"/>
-                      <a:r>
-                        <a:rPr sz="1400" b="0" i="0">
-                          <a:solidFill>
-                            <a:srgbClr val="374151"/>
-                          </a:solidFill>
-                          <a:latin typeface="Calibri"/>
-                        </a:rPr>
-                        <a:t>Correlation</a:t>
-                      </a:r>
-                    </a:p>
-                  </a:txBody>
-                  <a:tcPr anchor="ctr">
-                    <a:solidFill>
-                      <a:srgbClr val="FFFFFF"/>
-                    </a:solidFill>
-                  </a:tcPr>
-                </a:tc>
-                <a:tc>
-                  <a:txBody>
-                    <a:bodyPr/>
-                    <a:lstStyle/>
-                    <a:p>
-                      <a:pPr algn="ctr"/>
-                      <a:r>
-                        <a:rPr sz="1400" b="0" i="0">
-                          <a:solidFill>
-                            <a:srgbClr val="374151"/>
-                          </a:solidFill>
-                          <a:latin typeface="Calibri"/>
-                        </a:rPr>
-                        <a:t>−0.003</a:t>
-                      </a:r>
-                    </a:p>
-                  </a:txBody>
-                  <a:tcPr anchor="ctr">
-                    <a:solidFill>
-                      <a:srgbClr val="FFFFFF"/>
-                    </a:solidFill>
-                  </a:tcPr>
-                </a:tc>
-                <a:tc>
-                  <a:txBody>
-                    <a:bodyPr/>
-                    <a:lstStyle/>
-                    <a:p>
-                      <a:pPr algn="ctr"/>
-                      <a:r>
-                        <a:rPr sz="1400" b="0" i="0">
-                          <a:solidFill>
-                            <a:srgbClr val="374151"/>
-                          </a:solidFill>
-                          <a:latin typeface="Calibri"/>
-                        </a:rPr>
-                        <a:t>[−0.027, +0.024]</a:t>
-                      </a:r>
-                    </a:p>
-                  </a:txBody>
-                  <a:tcPr anchor="ctr">
-                    <a:solidFill>
-                      <a:srgbClr val="FFFFFF"/>
-                    </a:solidFill>
-                  </a:tcPr>
-                </a:tc>
-              </a:tr>
-              <a:tr h="457200">
-                <a:tc>
-                  <a:txBody>
-                    <a:bodyPr/>
-                    <a:lstStyle/>
-                    <a:p>
-                      <a:pPr algn="l"/>
-                      <a:r>
-                        <a:rPr sz="1400" b="0" i="0">
-                          <a:solidFill>
-                            <a:srgbClr val="374151"/>
-                          </a:solidFill>
-                          <a:latin typeface="Calibri"/>
-                        </a:rPr>
-                        <a:t>Random</a:t>
-                      </a:r>
-                    </a:p>
-                  </a:txBody>
-                  <a:tcPr anchor="ctr">
-                    <a:solidFill>
-                      <a:srgbClr val="EFF2FB"/>
-                    </a:solidFill>
-                  </a:tcPr>
-                </a:tc>
-                <a:tc>
-                  <a:txBody>
-                    <a:bodyPr/>
-                    <a:lstStyle/>
-                    <a:p>
-                      <a:pPr algn="ctr"/>
-                      <a:r>
-                        <a:rPr sz="1400" b="0" i="0">
-                          <a:solidFill>
-                            <a:srgbClr val="374151"/>
-                          </a:solidFill>
-                          <a:latin typeface="Calibri"/>
-                        </a:rPr>
-                        <a:t>−0.015</a:t>
-                      </a:r>
-                    </a:p>
-                  </a:txBody>
-                  <a:tcPr anchor="ctr">
-                    <a:solidFill>
-                      <a:srgbClr val="EFF2FB"/>
-                    </a:solidFill>
-                  </a:tcPr>
-                </a:tc>
-                <a:tc>
-                  <a:txBody>
-                    <a:bodyPr/>
-                    <a:lstStyle/>
-                    <a:p>
-                      <a:pPr algn="ctr"/>
-                      <a:r>
-                        <a:rPr sz="1400" b="0" i="0">
-                          <a:solidFill>
-                            <a:srgbClr val="374151"/>
-                          </a:solidFill>
-                          <a:latin typeface="Calibri"/>
-                        </a:rPr>
-                        <a:t>[−0.031, +0.006]</a:t>
-                      </a:r>
-                    </a:p>
-                  </a:txBody>
-                  <a:tcPr anchor="ctr">
-                    <a:solidFill>
-                      <a:srgbClr val="EFF2FB"/>
-                    </a:solidFill>
-                  </a:tcPr>
-                </a:tc>
-              </a:tr>
-            </a:tbl>
-          </a:graphicData>
-        </a:graphic>
-      </p:graphicFrame>
-      <p:sp>
-        <p:nvSpPr>
-          <p:cNvPr id="6" name="TextBox 5"/>
+            <a:pPr>
+              <a:spcAft>
+                <a:spcPts val="1200"/>
+              </a:spcAft>
+            </a:pPr>
+            <a:r>
+              <a:rPr sz="2100" b="0" i="0">
+                <a:solidFill>
+                  <a:srgbClr val="374151"/>
+                </a:solidFill>
+                <a:latin typeface="Calibri"/>
+              </a:rPr>
+              <a:t>•  A new structural lens: directed, residualized curvature surfaces pair structure correlation / degree / undirected methods miss.</a:t>
+            </a:r>
+          </a:p>
+          <a:p>
+            <a:pPr>
+              <a:spcAft>
+                <a:spcPts val="1200"/>
+              </a:spcAft>
+            </a:pPr>
+            <a:r>
+              <a:rPr sz="2100" b="0" i="0">
+                <a:solidFill>
+                  <a:srgbClr val="374151"/>
+                </a:solidFill>
+                <a:latin typeface="Calibri"/>
+              </a:rPr>
+              <a:t>•  Directedness changes the geometry — the directed graph is provably distinct from its symmetrized version.</a:t>
+            </a:r>
+          </a:p>
+          <a:p>
+            <a:pPr>
+              <a:spcAft>
+                <a:spcPts val="1200"/>
+              </a:spcAft>
+            </a:pPr>
+            <a:r>
+              <a:rPr sz="2100" b="0" i="0">
+                <a:solidFill>
+                  <a:srgbClr val="374151"/>
+                </a:solidFill>
+                <a:latin typeface="Calibri"/>
+              </a:rPr>
+              <a:t>•  Triangle sparsity is a first-class constraint for curvature methods in finance.</a:t>
+            </a:r>
+          </a:p>
+          <a:p>
+            <a:pPr>
+              <a:spcAft>
+                <a:spcPts val="1200"/>
+              </a:spcAft>
+            </a:pPr>
+            <a:r>
+              <a:rPr sz="2100" b="0" i="0">
+                <a:solidFill>
+                  <a:srgbClr val="374151"/>
+                </a:solidFill>
+                <a:latin typeface="Calibri"/>
+              </a:rPr>
+              <a:t>•  This is a structural study — we make no predictive claim (Sandhu's precedent: structural-only is publishable).</a:t>
+            </a:r>
+          </a:p>
+        </p:txBody>
+      </p:sp>
+      <p:sp>
+        <p:nvSpPr>
+          <p:cNvPr id="5" name="TextBox 4"/>
           <p:cNvSpPr txBox="1"/>
           <p:nvPr/>
         </p:nvSpPr>
         <p:spPr>
           <a:xfrm>
-            <a:off x="777240" y="5715000"/>
-            <a:ext cx="10607040" cy="640080"/>
+            <a:off x="777240" y="6355080"/>
+            <a:ext cx="10607040" cy="365760"/>
           </a:xfrm>
           <a:prstGeom prst="rect">
             <a:avLst/>
@@ -5401,54 +5071,20 @@
           <a:lstStyle/>
           <a:p>
             <a:r>
-              <a:rPr sz="1400" b="0" i="1">
+              <a:rPr sz="1100" b="0" i="0">
                 <a:solidFill>
                   <a:srgbClr val="9CA3AF"/>
                 </a:solidFill>
                 <a:latin typeface="Calibri"/>
               </a:rPr>
-              <a:t>Forman leads — but every CI spans zero, ranking flips across samples, and undirected ties directed. No significant predictive edge.</a:t>
-            </a:r>
-          </a:p>
-        </p:txBody>
-      </p:sp>
-      <p:sp>
-        <p:nvSpPr>
-          <p:cNvPr id="7" name="TextBox 6"/>
-          <p:cNvSpPr txBox="1"/>
-          <p:nvPr/>
-        </p:nvSpPr>
-        <p:spPr>
-          <a:xfrm>
-            <a:off x="777240" y="6355080"/>
-            <a:ext cx="10607040" cy="365760"/>
-          </a:xfrm>
-          <a:prstGeom prst="rect">
-            <a:avLst/>
-          </a:prstGeom>
-          <a:noFill/>
-        </p:spPr>
-        <p:txBody>
-          <a:bodyPr wrap="square">
-            <a:spAutoFit/>
-          </a:bodyPr>
-          <a:lstStyle/>
-          <a:p>
-            <a:r>
-              <a:rPr sz="1100" b="0" i="0">
-                <a:solidFill>
-                  <a:srgbClr val="9CA3AF"/>
-                </a:solidFill>
-                <a:latin typeface="Calibri"/>
-              </a:rPr>
-              <a:t>Results</a:t>
-            </a:r>
-          </a:p>
-        </p:txBody>
-      </p:sp>
-      <p:sp>
-        <p:nvSpPr>
-          <p:cNvPr id="8" name="TextBox 7"/>
+              <a:t>Implications</a:t>
+            </a:r>
+          </a:p>
+        </p:txBody>
+      </p:sp>
+      <p:sp>
+        <p:nvSpPr>
+          <p:cNvPr id="6" name="TextBox 5"/>
           <p:cNvSpPr txBox="1"/>
           <p:nvPr/>
         </p:nvSpPr>
@@ -5528,7 +5164,7 @@
                 </a:solidFill>
                 <a:latin typeface="Calibri"/>
               </a:rPr>
-              <a:t>What it means</a:t>
+              <a:t>Next steps &amp; thanks</a:t>
             </a:r>
           </a:p>
         </p:txBody>
@@ -5586,6 +5222,40 @@
         <p:spPr>
           <a:xfrm>
             <a:off x="777240" y="1783080"/>
+            <a:ext cx="10607040" cy="731520"/>
+          </a:xfrm>
+          <a:prstGeom prst="rect">
+            <a:avLst/>
+          </a:prstGeom>
+          <a:noFill/>
+        </p:spPr>
+        <p:txBody>
+          <a:bodyPr wrap="square">
+            <a:spAutoFit/>
+          </a:bodyPr>
+          <a:lstStyle/>
+          <a:p>
+            <a:r>
+              <a:rPr sz="1900" b="0" i="1">
+                <a:solidFill>
+                  <a:srgbClr val="2563EB"/>
+                </a:solidFill>
+                <a:latin typeface="Calibri"/>
+              </a:rPr>
+              <a:t>The paper stands on the structural result.</a:t>
+            </a:r>
+          </a:p>
+        </p:txBody>
+      </p:sp>
+      <p:sp>
+        <p:nvSpPr>
+          <p:cNvPr id="5" name="TextBox 4"/>
+          <p:cNvSpPr txBox="1"/>
+          <p:nvPr/>
+        </p:nvSpPr>
+        <p:spPr>
+          <a:xfrm>
+            <a:off x="777240" y="2514600"/>
             <a:ext cx="10607040" cy="3657600"/>
           </a:xfrm>
           <a:prstGeom prst="rect">
@@ -5611,7 +5281,7 @@
                 </a:solidFill>
                 <a:latin typeface="Calibri"/>
               </a:rPr>
-              <a:t>•  A new structural lens: directed residualized curvature surfaces pair structure correlation / degree / undirected methods miss.</a:t>
+              <a:t>•  Directed line-graph &amp; directed AFRC-gap theory (possible Weber collaboration).</a:t>
             </a:r>
           </a:p>
           <a:p>
@@ -5627,7 +5297,7 @@
                 </a:solidFill>
                 <a:latin typeface="Calibri"/>
               </a:rPr>
-              <a:t>•  Directedness is structurally informative even where it is not predictive.</a:t>
+              <a:t>•  Multi-frequency replication and curvature dynamics through 2020 stress.</a:t>
             </a:r>
           </a:p>
           <a:p>
@@ -5643,7 +5313,7 @@
                 </a:solidFill>
                 <a:latin typeface="Calibri"/>
               </a:rPr>
-              <a:t>•  Triangle sparsity is a first-class constraint for curvature methods in finance.</a:t>
+              <a:t>•  Write-up → 8-page ACM sigconf for ICAIF 2026.</a:t>
             </a:r>
           </a:p>
           <a:p>
@@ -5659,14 +5329,14 @@
                 </a:solidFill>
                 <a:latin typeface="Calibri"/>
               </a:rPr>
-              <a:t>•  An honest predictive null is a result — Sandhu's precedent: structural-only is publishable.</a:t>
-            </a:r>
-          </a:p>
-        </p:txBody>
-      </p:sp>
-      <p:sp>
-        <p:nvSpPr>
-          <p:cNvPr id="5" name="TextBox 4"/>
+              <a:t>•  Thanks to Prof. Mihai Cucuringu and the 285J group.</a:t>
+            </a:r>
+          </a:p>
+        </p:txBody>
+      </p:sp>
+      <p:sp>
+        <p:nvSpPr>
+          <p:cNvPr id="6" name="TextBox 5"/>
           <p:cNvSpPr txBox="1"/>
           <p:nvPr/>
         </p:nvSpPr>
@@ -5693,14 +5363,14 @@
                 </a:solidFill>
                 <a:latin typeface="Calibri"/>
               </a:rPr>
-              <a:t>Implications</a:t>
-            </a:r>
-          </a:p>
-        </p:txBody>
-      </p:sp>
-      <p:sp>
-        <p:nvSpPr>
-          <p:cNvPr id="6" name="TextBox 5"/>
+              <a:t>Close</a:t>
+            </a:r>
+          </a:p>
+        </p:txBody>
+      </p:sp>
+      <p:sp>
+        <p:nvSpPr>
+          <p:cNvPr id="7" name="TextBox 6"/>
           <p:cNvSpPr txBox="1"/>
           <p:nvPr/>
         </p:nvSpPr>
@@ -5729,292 +5399,6 @@
                 <a:latin typeface="Calibri"/>
               </a:rPr>
               <a:t>15</a:t>
-            </a:r>
-          </a:p>
-        </p:txBody>
-      </p:sp>
-    </p:spTree>
-  </p:cSld>
-  <p:clrMapOvr>
-    <a:masterClrMapping/>
-  </p:clrMapOvr>
-</p:sld>
-</file>
-
-<file path=ppt/slides/slide17.xml><?xml version="1.0" encoding="utf-8"?>
-<p:sld xmlns:a="http://schemas.openxmlformats.org/drawingml/2006/main" xmlns:p="http://schemas.openxmlformats.org/presentationml/2006/main" xmlns:r="http://schemas.openxmlformats.org/officeDocument/2006/relationships">
-  <p:cSld>
-    <p:spTree>
-      <p:nvGrpSpPr>
-        <p:cNvPr id="1" name=""/>
-        <p:cNvGrpSpPr/>
-        <p:nvPr/>
-      </p:nvGrpSpPr>
-      <p:grpSpPr/>
-      <p:sp>
-        <p:nvSpPr>
-          <p:cNvPr id="2" name="TextBox 1"/>
-          <p:cNvSpPr txBox="1"/>
-          <p:nvPr/>
-        </p:nvSpPr>
-        <p:spPr>
-          <a:xfrm>
-            <a:off x="777240" y="640080"/>
-            <a:ext cx="10607040" cy="822960"/>
-          </a:xfrm>
-          <a:prstGeom prst="rect">
-            <a:avLst/>
-          </a:prstGeom>
-          <a:noFill/>
-        </p:spPr>
-        <p:txBody>
-          <a:bodyPr wrap="square">
-            <a:spAutoFit/>
-          </a:bodyPr>
-          <a:lstStyle/>
-          <a:p>
-            <a:r>
-              <a:rPr sz="3000" b="1" i="0">
-                <a:solidFill>
-                  <a:srgbClr val="1F2937"/>
-                </a:solidFill>
-                <a:latin typeface="Calibri"/>
-              </a:rPr>
-              <a:t>Next steps &amp; thanks</a:t>
-            </a:r>
-          </a:p>
-        </p:txBody>
-      </p:sp>
-      <p:sp>
-        <p:nvSpPr>
-          <p:cNvPr id="3" name="Rectangle 2"/>
-          <p:cNvSpPr/>
-          <p:nvPr/>
-        </p:nvSpPr>
-        <p:spPr>
-          <a:xfrm>
-            <a:off x="777240" y="1417320"/>
-            <a:ext cx="1828800" cy="38100"/>
-          </a:xfrm>
-          <a:prstGeom prst="rect">
-            <a:avLst/>
-          </a:prstGeom>
-          <a:solidFill>
-            <a:srgbClr val="2563EB"/>
-          </a:solidFill>
-          <a:ln>
-            <a:noFill/>
-          </a:ln>
-          <a:effectLst/>
-        </p:spPr>
-        <p:style>
-          <a:lnRef idx="1">
-            <a:schemeClr val="accent1"/>
-          </a:lnRef>
-          <a:fillRef idx="3">
-            <a:schemeClr val="accent1"/>
-          </a:fillRef>
-          <a:effectRef idx="2">
-            <a:schemeClr val="accent1"/>
-          </a:effectRef>
-          <a:fontRef idx="minor">
-            <a:schemeClr val="lt1"/>
-          </a:fontRef>
-        </p:style>
-        <p:txBody>
-          <a:bodyPr rtlCol="0" anchor="ctr"/>
-          <a:lstStyle/>
-          <a:p>
-            <a:pPr algn="ctr"/>
-          </a:p>
-        </p:txBody>
-      </p:sp>
-      <p:sp>
-        <p:nvSpPr>
-          <p:cNvPr id="4" name="TextBox 3"/>
-          <p:cNvSpPr txBox="1"/>
-          <p:nvPr/>
-        </p:nvSpPr>
-        <p:spPr>
-          <a:xfrm>
-            <a:off x="777240" y="1783080"/>
-            <a:ext cx="10607040" cy="731520"/>
-          </a:xfrm>
-          <a:prstGeom prst="rect">
-            <a:avLst/>
-          </a:prstGeom>
-          <a:noFill/>
-        </p:spPr>
-        <p:txBody>
-          <a:bodyPr wrap="square">
-            <a:spAutoFit/>
-          </a:bodyPr>
-          <a:lstStyle/>
-          <a:p>
-            <a:r>
-              <a:rPr sz="1900" b="0" i="1">
-                <a:solidFill>
-                  <a:srgbClr val="2563EB"/>
-                </a:solidFill>
-                <a:latin typeface="Calibri"/>
-              </a:rPr>
-              <a:t>The paper stands on the structural result.</a:t>
-            </a:r>
-          </a:p>
-        </p:txBody>
-      </p:sp>
-      <p:sp>
-        <p:nvSpPr>
-          <p:cNvPr id="5" name="TextBox 4"/>
-          <p:cNvSpPr txBox="1"/>
-          <p:nvPr/>
-        </p:nvSpPr>
-        <p:spPr>
-          <a:xfrm>
-            <a:off x="777240" y="2514600"/>
-            <a:ext cx="10607040" cy="3657600"/>
-          </a:xfrm>
-          <a:prstGeom prst="rect">
-            <a:avLst/>
-          </a:prstGeom>
-          <a:noFill/>
-        </p:spPr>
-        <p:txBody>
-          <a:bodyPr wrap="square">
-            <a:spAutoFit/>
-          </a:bodyPr>
-          <a:lstStyle/>
-          <a:p>
-            <a:pPr>
-              <a:spcAft>
-                <a:spcPts val="1200"/>
-              </a:spcAft>
-            </a:pPr>
-            <a:r>
-              <a:rPr sz="2100" b="0" i="0">
-                <a:solidFill>
-                  <a:srgbClr val="374151"/>
-                </a:solidFill>
-                <a:latin typeface="Calibri"/>
-              </a:rPr>
-              <a:t>•  Directed line-graph &amp; directed AFRC-gap theory (possible Weber collaboration).</a:t>
-            </a:r>
-          </a:p>
-          <a:p>
-            <a:pPr>
-              <a:spcAft>
-                <a:spcPts val="1200"/>
-              </a:spcAft>
-            </a:pPr>
-            <a:r>
-              <a:rPr sz="2100" b="0" i="0">
-                <a:solidFill>
-                  <a:srgbClr val="374151"/>
-                </a:solidFill>
-                <a:latin typeface="Calibri"/>
-              </a:rPr>
-              <a:t>•  Multi-frequency replication and curvature dynamics through 2020 stress.</a:t>
-            </a:r>
-          </a:p>
-          <a:p>
-            <a:pPr>
-              <a:spcAft>
-                <a:spcPts val="1200"/>
-              </a:spcAft>
-            </a:pPr>
-            <a:r>
-              <a:rPr sz="2100" b="0" i="0">
-                <a:solidFill>
-                  <a:srgbClr val="374151"/>
-                </a:solidFill>
-                <a:latin typeface="Calibri"/>
-              </a:rPr>
-              <a:t>•  Write-up → 8-page ACM sigconf for ICAIF 2026.</a:t>
-            </a:r>
-          </a:p>
-          <a:p>
-            <a:pPr>
-              <a:spcAft>
-                <a:spcPts val="1200"/>
-              </a:spcAft>
-            </a:pPr>
-            <a:r>
-              <a:rPr sz="2100" b="0" i="0">
-                <a:solidFill>
-                  <a:srgbClr val="374151"/>
-                </a:solidFill>
-                <a:latin typeface="Calibri"/>
-              </a:rPr>
-              <a:t>•  Thanks to Prof. Mihai Cucuringu and the 285J group.</a:t>
-            </a:r>
-          </a:p>
-        </p:txBody>
-      </p:sp>
-      <p:sp>
-        <p:nvSpPr>
-          <p:cNvPr id="6" name="TextBox 5"/>
-          <p:cNvSpPr txBox="1"/>
-          <p:nvPr/>
-        </p:nvSpPr>
-        <p:spPr>
-          <a:xfrm>
-            <a:off x="777240" y="6355080"/>
-            <a:ext cx="10607040" cy="365760"/>
-          </a:xfrm>
-          <a:prstGeom prst="rect">
-            <a:avLst/>
-          </a:prstGeom>
-          <a:noFill/>
-        </p:spPr>
-        <p:txBody>
-          <a:bodyPr wrap="square">
-            <a:spAutoFit/>
-          </a:bodyPr>
-          <a:lstStyle/>
-          <a:p>
-            <a:r>
-              <a:rPr sz="1100" b="0" i="0">
-                <a:solidFill>
-                  <a:srgbClr val="9CA3AF"/>
-                </a:solidFill>
-                <a:latin typeface="Calibri"/>
-              </a:rPr>
-              <a:t>Close</a:t>
-            </a:r>
-          </a:p>
-        </p:txBody>
-      </p:sp>
-      <p:sp>
-        <p:nvSpPr>
-          <p:cNvPr id="7" name="TextBox 6"/>
-          <p:cNvSpPr txBox="1"/>
-          <p:nvPr/>
-        </p:nvSpPr>
-        <p:spPr>
-          <a:xfrm>
-            <a:off x="10789920" y="6355080"/>
-            <a:ext cx="1280160" cy="365760"/>
-          </a:xfrm>
-          <a:prstGeom prst="rect">
-            <a:avLst/>
-          </a:prstGeom>
-          <a:noFill/>
-        </p:spPr>
-        <p:txBody>
-          <a:bodyPr wrap="square">
-            <a:spAutoFit/>
-          </a:bodyPr>
-          <a:lstStyle/>
-          <a:p>
-            <a:pPr algn="r"/>
-            <a:r>
-              <a:rPr sz="1100" b="0" i="0">
-                <a:solidFill>
-                  <a:srgbClr val="9CA3AF"/>
-                </a:solidFill>
-                <a:latin typeface="Calibri"/>
-              </a:rPr>
-              <a:t>16</a:t>
             </a:r>
           </a:p>
         </p:txBody>
@@ -6685,282 +6069,16 @@
           </a:p>
         </p:txBody>
       </p:sp>
-      <p:graphicFrame>
-        <p:nvGraphicFramePr>
-          <p:cNvPr id="4" name="Table 3"/>
-          <p:cNvGraphicFramePr>
-            <a:graphicFrameLocks noGrp="1"/>
-          </p:cNvGraphicFramePr>
-          <p:nvPr/>
-        </p:nvGraphicFramePr>
-        <p:xfrm>
-          <a:off x="777240" y="1783080"/>
-          <a:ext cx="10607040" cy="2286000"/>
-        </p:xfrm>
-        <a:graphic>
-          <a:graphicData uri="http://schemas.openxmlformats.org/drawingml/2006/table">
-            <a:tbl>
-              <a:tblPr firstRow="1" bandRow="1">
-                <a:tableStyleId>{5C22544A-7EE6-4342-B048-85BDC9FD1C3A}</a:tableStyleId>
-              </a:tblPr>
-              <a:tblGrid>
-                <a:gridCol w="5303520"/>
-                <a:gridCol w="5303520"/>
-              </a:tblGrid>
-              <a:tr h="457200">
-                <a:tc>
-                  <a:txBody>
-                    <a:bodyPr/>
-                    <a:lstStyle/>
-                    <a:p>
-                      <a:pPr algn="l"/>
-                      <a:r>
-                        <a:rPr sz="1500" b="1" i="0">
-                          <a:solidFill>
-                            <a:srgbClr val="FFFFFF"/>
-                          </a:solidFill>
-                          <a:latin typeface="Calibri"/>
-                        </a:rPr>
-                        <a:t>Sandhu et al. (2016)</a:t>
-                      </a:r>
-                    </a:p>
-                  </a:txBody>
-                  <a:tcPr anchor="ctr">
-                    <a:solidFill>
-                      <a:srgbClr val="2563EB"/>
-                    </a:solidFill>
-                  </a:tcPr>
-                </a:tc>
-                <a:tc>
-                  <a:txBody>
-                    <a:bodyPr/>
-                    <a:lstStyle/>
-                    <a:p>
-                      <a:pPr algn="ctr"/>
-                      <a:r>
-                        <a:rPr sz="1500" b="1" i="0">
-                          <a:solidFill>
-                            <a:srgbClr val="FFFFFF"/>
-                          </a:solidFill>
-                          <a:latin typeface="Calibri"/>
-                        </a:rPr>
-                        <a:t>This work</a:t>
-                      </a:r>
-                    </a:p>
-                  </a:txBody>
-                  <a:tcPr anchor="ctr">
-                    <a:solidFill>
-                      <a:srgbClr val="2563EB"/>
-                    </a:solidFill>
-                  </a:tcPr>
-                </a:tc>
-              </a:tr>
-              <a:tr h="457200">
-                <a:tc>
-                  <a:txBody>
-                    <a:bodyPr/>
-                    <a:lstStyle/>
-                    <a:p>
-                      <a:pPr algn="l"/>
-                      <a:r>
-                        <a:rPr sz="1400" b="0" i="0">
-                          <a:solidFill>
-                            <a:srgbClr val="374151"/>
-                          </a:solidFill>
-                          <a:latin typeface="Calibri"/>
-                        </a:rPr>
-                        <a:t>Undirected correlation graph</a:t>
-                      </a:r>
-                    </a:p>
-                  </a:txBody>
-                  <a:tcPr anchor="ctr">
-                    <a:solidFill>
-                      <a:srgbClr val="FFFFFF"/>
-                    </a:solidFill>
-                  </a:tcPr>
-                </a:tc>
-                <a:tc>
-                  <a:txBody>
-                    <a:bodyPr/>
-                    <a:lstStyle/>
-                    <a:p>
-                      <a:pPr algn="ctr"/>
-                      <a:r>
-                        <a:rPr sz="1400" b="0" i="0">
-                          <a:solidFill>
-                            <a:srgbClr val="374151"/>
-                          </a:solidFill>
-                          <a:latin typeface="Calibri"/>
-                        </a:rPr>
-                        <a:t>Directed lead-lag graph</a:t>
-                      </a:r>
-                    </a:p>
-                  </a:txBody>
-                  <a:tcPr anchor="ctr">
-                    <a:solidFill>
-                      <a:srgbClr val="FFFFFF"/>
-                    </a:solidFill>
-                  </a:tcPr>
-                </a:tc>
-              </a:tr>
-              <a:tr h="457200">
-                <a:tc>
-                  <a:txBody>
-                    <a:bodyPr/>
-                    <a:lstStyle/>
-                    <a:p>
-                      <a:pPr algn="l"/>
-                      <a:r>
-                        <a:rPr sz="1400" b="0" i="0">
-                          <a:solidFill>
-                            <a:srgbClr val="374151"/>
-                          </a:solidFill>
-                          <a:latin typeface="Calibri"/>
-                        </a:rPr>
-                        <a:t>Correlation edges</a:t>
-                      </a:r>
-                    </a:p>
-                  </a:txBody>
-                  <a:tcPr anchor="ctr">
-                    <a:solidFill>
-                      <a:srgbClr val="EFF2FB"/>
-                    </a:solidFill>
-                  </a:tcPr>
-                </a:tc>
-                <a:tc>
-                  <a:txBody>
-                    <a:bodyPr/>
-                    <a:lstStyle/>
-                    <a:p>
-                      <a:pPr algn="ctr"/>
-                      <a:r>
-                        <a:rPr sz="1400" b="0" i="0">
-                          <a:solidFill>
-                            <a:srgbClr val="374151"/>
-                          </a:solidFill>
-                          <a:latin typeface="Calibri"/>
-                        </a:rPr>
-                        <a:t>BCR signed lead-lag, residualized</a:t>
-                      </a:r>
-                    </a:p>
-                  </a:txBody>
-                  <a:tcPr anchor="ctr">
-                    <a:solidFill>
-                      <a:srgbClr val="EFF2FB"/>
-                    </a:solidFill>
-                  </a:tcPr>
-                </a:tc>
-              </a:tr>
-              <a:tr h="457200">
-                <a:tc>
-                  <a:txBody>
-                    <a:bodyPr/>
-                    <a:lstStyle/>
-                    <a:p>
-                      <a:pPr algn="l"/>
-                      <a:r>
-                        <a:rPr sz="1400" b="0" i="0">
-                          <a:solidFill>
-                            <a:srgbClr val="374151"/>
-                          </a:solidFill>
-                          <a:latin typeface="Calibri"/>
-                        </a:rPr>
-                        <a:t>Ollivier-Ricci only</a:t>
-                      </a:r>
-                    </a:p>
-                  </a:txBody>
-                  <a:tcPr anchor="ctr">
-                    <a:solidFill>
-                      <a:srgbClr val="FFFFFF"/>
-                    </a:solidFill>
-                  </a:tcPr>
-                </a:tc>
-                <a:tc>
-                  <a:txBody>
-                    <a:bodyPr/>
-                    <a:lstStyle/>
-                    <a:p>
-                      <a:pPr algn="ctr"/>
-                      <a:r>
-                        <a:rPr sz="1400" b="0" i="0">
-                          <a:solidFill>
-                            <a:srgbClr val="374151"/>
-                          </a:solidFill>
-                          <a:latin typeface="Calibri"/>
-                        </a:rPr>
-                        <a:t>Forman-Ricci (cheap, directed) + Ollivier</a:t>
-                      </a:r>
-                    </a:p>
-                  </a:txBody>
-                  <a:tcPr anchor="ctr">
-                    <a:solidFill>
-                      <a:srgbClr val="FFFFFF"/>
-                    </a:solidFill>
-                  </a:tcPr>
-                </a:tc>
-              </a:tr>
-              <a:tr h="457200">
-                <a:tc>
-                  <a:txBody>
-                    <a:bodyPr/>
-                    <a:lstStyle/>
-                    <a:p>
-                      <a:pPr algn="l"/>
-                      <a:r>
-                        <a:rPr sz="1400" b="0" i="0">
-                          <a:solidFill>
-                            <a:srgbClr val="374151"/>
-                          </a:solidFill>
-                          <a:latin typeface="Calibri"/>
-                        </a:rPr>
-                        <a:t>Structural validation only</a:t>
-                      </a:r>
-                    </a:p>
-                  </a:txBody>
-                  <a:tcPr anchor="ctr">
-                    <a:solidFill>
-                      <a:srgbClr val="EFF2FB"/>
-                    </a:solidFill>
-                  </a:tcPr>
-                </a:tc>
-                <a:tc>
-                  <a:txBody>
-                    <a:bodyPr/>
-                    <a:lstStyle/>
-                    <a:p>
-                      <a:pPr algn="ctr"/>
-                      <a:r>
-                        <a:rPr sz="1400" b="0" i="0">
-                          <a:solidFill>
-                            <a:srgbClr val="374151"/>
-                          </a:solidFill>
-                          <a:latin typeface="Calibri"/>
-                        </a:rPr>
-                        <a:t>Structural cascade + (exploratory) test</a:t>
-                      </a:r>
-                    </a:p>
-                  </a:txBody>
-                  <a:tcPr anchor="ctr">
-                    <a:solidFill>
-                      <a:srgbClr val="EFF2FB"/>
-                    </a:solidFill>
-                  </a:tcPr>
-                </a:tc>
-              </a:tr>
-            </a:tbl>
-          </a:graphicData>
-        </a:graphic>
-      </p:graphicFrame>
-      <p:sp>
-        <p:nvSpPr>
-          <p:cNvPr id="5" name="TextBox 4"/>
+      <p:sp>
+        <p:nvSpPr>
+          <p:cNvPr id="4" name="TextBox 3"/>
           <p:cNvSpPr txBox="1"/>
           <p:nvPr/>
         </p:nvSpPr>
         <p:spPr>
           <a:xfrm>
-            <a:off x="777240" y="5715000"/>
-            <a:ext cx="10607040" cy="640080"/>
+            <a:off x="777240" y="1783080"/>
+            <a:ext cx="10607040" cy="731520"/>
           </a:xfrm>
           <a:prstGeom prst="rect">
             <a:avLst/>
@@ -6974,27 +6092,27 @@
           <a:lstStyle/>
           <a:p>
             <a:r>
-              <a:rPr sz="1400" b="0" i="1">
-                <a:solidFill>
-                  <a:srgbClr val="9CA3AF"/>
-                </a:solidFill>
-                <a:latin typeface="Calibri"/>
-              </a:rPr>
-              <a:t>Markets have direction. The symmetric correlation matrix destroys it by construction.</a:t>
-            </a:r>
-          </a:p>
-        </p:txBody>
-      </p:sp>
-      <p:sp>
-        <p:nvSpPr>
-          <p:cNvPr id="6" name="TextBox 5"/>
+              <a:rPr sz="1900" b="0" i="1">
+                <a:solidFill>
+                  <a:srgbClr val="2563EB"/>
+                </a:solidFill>
+                <a:latin typeface="Calibri"/>
+              </a:rPr>
+              <a:t>One thing their construction could not see: direction.</a:t>
+            </a:r>
+          </a:p>
+        </p:txBody>
+      </p:sp>
+      <p:sp>
+        <p:nvSpPr>
+          <p:cNvPr id="5" name="TextBox 4"/>
           <p:cNvSpPr txBox="1"/>
           <p:nvPr/>
         </p:nvSpPr>
         <p:spPr>
           <a:xfrm>
-            <a:off x="777240" y="6355080"/>
-            <a:ext cx="10607040" cy="365760"/>
+            <a:off x="777240" y="2514600"/>
+            <a:ext cx="10607040" cy="2743200"/>
           </a:xfrm>
           <a:prstGeom prst="rect">
             <a:avLst/>
@@ -7007,6 +6125,141 @@
           </a:bodyPr>
           <a:lstStyle/>
           <a:p>
+            <a:pPr>
+              <a:spcAft>
+                <a:spcPts val="1200"/>
+              </a:spcAft>
+            </a:pPr>
+            <a:r>
+              <a:rPr sz="2100" b="0" i="0">
+                <a:solidFill>
+                  <a:srgbClr val="374151"/>
+                </a:solidFill>
+                <a:latin typeface="Calibri"/>
+              </a:rPr>
+              <a:t>•  Sandhu et al. built the network on an undirected correlation graph.</a:t>
+            </a:r>
+          </a:p>
+          <a:p>
+            <a:pPr>
+              <a:spcAft>
+                <a:spcPts val="1200"/>
+              </a:spcAft>
+            </a:pPr>
+            <a:r>
+              <a:rPr sz="2100" b="0" i="0">
+                <a:solidFill>
+                  <a:srgbClr val="374151"/>
+                </a:solidFill>
+                <a:latin typeface="Calibri"/>
+              </a:rPr>
+              <a:t>•  But markets have direction — some names lead, others lag.</a:t>
+            </a:r>
+          </a:p>
+          <a:p>
+            <a:pPr lvl="1">
+              <a:spcAft>
+                <a:spcPts val="600"/>
+              </a:spcAft>
+            </a:pPr>
+            <a:r>
+              <a:rPr sz="1800" b="0" i="0">
+                <a:solidFill>
+                  <a:srgbClr val="9CA3AF"/>
+                </a:solidFill>
+                <a:latin typeface="Calibri"/>
+              </a:rPr>
+              <a:t>–  The symmetric correlation graph erases that asymmetry by construction.</a:t>
+            </a:r>
+          </a:p>
+        </p:txBody>
+      </p:sp>
+      <p:sp>
+        <p:nvSpPr>
+          <p:cNvPr id="6" name="Rounded Rectangle 5"/>
+          <p:cNvSpPr/>
+          <p:nvPr/>
+        </p:nvSpPr>
+        <p:spPr>
+          <a:xfrm>
+            <a:off x="777240" y="4983480"/>
+            <a:ext cx="10607040" cy="1051560"/>
+          </a:xfrm>
+          <a:prstGeom prst="roundRect">
+            <a:avLst/>
+          </a:prstGeom>
+          <a:solidFill>
+            <a:srgbClr val="EFF2FB"/>
+          </a:solidFill>
+          <a:ln w="15875">
+            <a:solidFill>
+              <a:srgbClr val="2563EB"/>
+            </a:solidFill>
+          </a:ln>
+          <a:effectLst/>
+        </p:spPr>
+        <p:style>
+          <a:lnRef idx="1">
+            <a:schemeClr val="accent1"/>
+          </a:lnRef>
+          <a:fillRef idx="3">
+            <a:schemeClr val="accent1"/>
+          </a:fillRef>
+          <a:effectRef idx="2">
+            <a:schemeClr val="accent1"/>
+          </a:effectRef>
+          <a:fontRef idx="minor">
+            <a:schemeClr val="lt1"/>
+          </a:fontRef>
+        </p:style>
+        <p:txBody>
+          <a:bodyPr rtlCol="0" anchor="ctr" wrap="square" lIns="228600" rIns="228600"/>
+          <a:lstStyle/>
+          <a:p>
+            <a:pPr algn="ctr"/>
+            <a:r>
+              <a:rPr sz="1400" b="1" i="0">
+                <a:solidFill>
+                  <a:srgbClr val="2563EB"/>
+                </a:solidFill>
+                <a:latin typeface="Calibri"/>
+              </a:rPr>
+              <a:t>Research question   </a:t>
+            </a:r>
+            <a:r>
+              <a:rPr sz="1800" b="1" i="0">
+                <a:solidFill>
+                  <a:srgbClr val="1F2937"/>
+                </a:solidFill>
+                <a:latin typeface="Calibri"/>
+              </a:rPr>
+              <a:t>Does Ricci curvature on the directed, residualized lead-lag network reveal structure the undirected correlation view cannot?</a:t>
+            </a:r>
+          </a:p>
+        </p:txBody>
+      </p:sp>
+      <p:sp>
+        <p:nvSpPr>
+          <p:cNvPr id="7" name="TextBox 6"/>
+          <p:cNvSpPr txBox="1"/>
+          <p:nvPr/>
+        </p:nvSpPr>
+        <p:spPr>
+          <a:xfrm>
+            <a:off x="777240" y="6355080"/>
+            <a:ext cx="10607040" cy="365760"/>
+          </a:xfrm>
+          <a:prstGeom prst="rect">
+            <a:avLst/>
+          </a:prstGeom>
+          <a:noFill/>
+        </p:spPr>
+        <p:txBody>
+          <a:bodyPr wrap="square">
+            <a:spAutoFit/>
+          </a:bodyPr>
+          <a:lstStyle/>
+          <a:p>
             <a:r>
               <a:rPr sz="1100" b="0" i="0">
                 <a:solidFill>
@@ -7021,7 +6274,7 @@
       </p:sp>
       <p:sp>
         <p:nvSpPr>
-          <p:cNvPr id="7" name="TextBox 6"/>
+          <p:cNvPr id="8" name="TextBox 7"/>
           <p:cNvSpPr txBox="1"/>
           <p:nvPr/>
         </p:nvSpPr>
@@ -7534,7 +6787,7 @@
                 </a:solidFill>
                 <a:latin typeface="Calibri"/>
               </a:rPr>
-              <a:t>•  Structural validation cascade  →  curvature ≠ correlation/degree?</a:t>
+              <a:t>•  Structural validation cascade  →  curvature ≠ correlation / degree?</a:t>
             </a:r>
           </a:p>
           <a:p>
@@ -7550,7 +6803,7 @@
                 </a:solidFill>
                 <a:latin typeface="Calibri"/>
               </a:rPr>
-              <a:t>•  Exploratory: out-of-sample directional IC vs baselines.</a:t>
+              <a:t>•  Select &amp; report the structurally isolated pairs.</a:t>
             </a:r>
           </a:p>
         </p:txBody>

</xml_diff>

<commit_message>
Deck: slide 8 — explain what each curvature object measures
Added a "What it measures" column to the four-objects slide with plain-language
intuition per object (only endpoint degrees / +3 per triangle / lead-lag strength
+ triangles + direction / transport cost between neighborhoods), formula on its
own line. Table renderer now supports multi-line cells and per-column alignment.

Co-Authored-By: Claude Opus 4.8 (1M context) <noreply@anthropic.com>
</commit_message>
<xml_diff>
--- a/slides/Ricci_Curvature_LeadLag.pptx
+++ b/slides/Ricci_Curvature_LeadLag.pptx
@@ -7241,16 +7241,50 @@
           </a:p>
         </p:txBody>
       </p:sp>
+      <p:sp>
+        <p:nvSpPr>
+          <p:cNvPr id="4" name="TextBox 3"/>
+          <p:cNvSpPr txBox="1"/>
+          <p:nvPr/>
+        </p:nvSpPr>
+        <p:spPr>
+          <a:xfrm>
+            <a:off x="777240" y="1783080"/>
+            <a:ext cx="10607040" cy="640080"/>
+          </a:xfrm>
+          <a:prstGeom prst="rect">
+            <a:avLst/>
+          </a:prstGeom>
+          <a:noFill/>
+        </p:spPr>
+        <p:txBody>
+          <a:bodyPr wrap="square">
+            <a:spAutoFit/>
+          </a:bodyPr>
+          <a:lstStyle/>
+          <a:p>
+            <a:r>
+              <a:rPr sz="1800" b="0" i="1">
+                <a:solidFill>
+                  <a:srgbClr val="2563EB"/>
+                </a:solidFill>
+                <a:latin typeface="Calibri"/>
+              </a:rPr>
+              <a:t>One ablation, from pure degree to full directed curvature.</a:t>
+            </a:r>
+          </a:p>
+        </p:txBody>
+      </p:sp>
       <p:graphicFrame>
         <p:nvGraphicFramePr>
-          <p:cNvPr id="4" name="Table 3"/>
+          <p:cNvPr id="5" name="Table 4"/>
           <p:cNvGraphicFramePr>
             <a:graphicFrameLocks noGrp="1"/>
           </p:cNvGraphicFramePr>
           <p:nvPr/>
         </p:nvGraphicFramePr>
         <p:xfrm>
-          <a:off x="777240" y="1783080"/>
+          <a:off x="777240" y="2377440"/>
           <a:ext cx="10607040" cy="2286000"/>
         </p:xfrm>
         <a:graphic>
@@ -7260,8 +7294,9 @@
                 <a:tableStyleId>{5C22544A-7EE6-4342-B048-85BDC9FD1C3A}</a:tableStyleId>
               </a:tblPr>
               <a:tblGrid>
-                <a:gridCol w="5852160"/>
-                <a:gridCol w="4754880"/>
+                <a:gridCol w="3291840"/>
+                <a:gridCol w="4297680"/>
+                <a:gridCol w="3017520"/>
               </a:tblGrid>
               <a:tr h="457200">
                 <a:tc>
@@ -7292,7 +7327,30 @@
                     <a:bodyPr/>
                     <a:lstStyle/>
                     <a:p>
-                      <a:pPr algn="ctr"/>
+                      <a:pPr algn="l"/>
+                      <a:r>
+                        <a:rPr sz="1500" b="1" i="0">
+                          <a:solidFill>
+                            <a:srgbClr val="FFFFFF"/>
+                          </a:solidFill>
+                          <a:latin typeface="Calibri"/>
+                        </a:rPr>
+                        <a:t>What it measures</a:t>
+                      </a:r>
+                    </a:p>
+                  </a:txBody>
+                  <a:tcPr anchor="ctr">
+                    <a:solidFill>
+                      <a:srgbClr val="2563EB"/>
+                    </a:solidFill>
+                  </a:tcPr>
+                </a:tc>
+                <a:tc>
+                  <a:txBody>
+                    <a:bodyPr/>
+                    <a:lstStyle/>
+                    <a:p>
+                      <a:pPr algn="l"/>
                       <a:r>
                         <a:rPr sz="1500" b="1" i="0">
                           <a:solidFill>
@@ -7325,7 +7383,19 @@
                           </a:solidFill>
                           <a:latin typeface="Calibri"/>
                         </a:rPr>
-                        <a:t>Plain directed Forman  (4 − deg − deg)</a:t>
+                        <a:t>Plain directed Forman</a:t>
+                      </a:r>
+                    </a:p>
+                    <a:p>
+                      <a:pPr algn="l"/>
+                      <a:r>
+                        <a:rPr sz="1400" b="0" i="0">
+                          <a:solidFill>
+                            <a:srgbClr val="374151"/>
+                          </a:solidFill>
+                          <a:latin typeface="Calibri"/>
+                        </a:rPr>
+                        <a:t>4 − deg_in − deg_out</a:t>
                       </a:r>
                     </a:p>
                   </a:txBody>
@@ -7340,7 +7410,7 @@
                     <a:bodyPr/>
                     <a:lstStyle/>
                     <a:p>
-                      <a:pPr algn="ctr"/>
+                      <a:pPr algn="l"/>
                       <a:r>
                         <a:rPr sz="1400" b="0" i="0">
                           <a:solidFill>
@@ -7348,7 +7418,42 @@
                           </a:solidFill>
                           <a:latin typeface="Calibri"/>
                         </a:rPr>
-                        <a:t>Degree BASELINE (signal ≡ 0 by design)</a:t>
+                        <a:t>only the two endpoints' link counts — pure connectivity</a:t>
+                      </a:r>
+                    </a:p>
+                  </a:txBody>
+                  <a:tcPr anchor="ctr">
+                    <a:solidFill>
+                      <a:srgbClr val="FFFFFF"/>
+                    </a:solidFill>
+                  </a:tcPr>
+                </a:tc>
+                <a:tc>
+                  <a:txBody>
+                    <a:bodyPr/>
+                    <a:lstStyle/>
+                    <a:p>
+                      <a:pPr algn="l"/>
+                      <a:r>
+                        <a:rPr sz="1400" b="0" i="0">
+                          <a:solidFill>
+                            <a:srgbClr val="374151"/>
+                          </a:solidFill>
+                          <a:latin typeface="Calibri"/>
+                        </a:rPr>
+                        <a:t>Degree BASELINE</a:t>
+                      </a:r>
+                    </a:p>
+                    <a:p>
+                      <a:pPr algn="l"/>
+                      <a:r>
+                        <a:rPr sz="1400" b="0" i="0">
+                          <a:solidFill>
+                            <a:srgbClr val="374151"/>
+                          </a:solidFill>
+                          <a:latin typeface="Calibri"/>
+                        </a:rPr>
+                        <a:t>(no higher-order signal)</a:t>
                       </a:r>
                     </a:p>
                   </a:txBody>
@@ -7373,7 +7478,19 @@
                           </a:solidFill>
                           <a:latin typeface="Calibri"/>
                         </a:rPr>
-                        <a:t>Triangle-augmented  F# = F + 3m</a:t>
+                        <a:t>Triangle-augmented</a:t>
+                      </a:r>
+                    </a:p>
+                    <a:p>
+                      <a:pPr algn="l"/>
+                      <a:r>
+                        <a:rPr sz="1400" b="0" i="0">
+                          <a:solidFill>
+                            <a:srgbClr val="374151"/>
+                          </a:solidFill>
+                          <a:latin typeface="Calibri"/>
+                        </a:rPr>
+                        <a:t>F# = F + 3m</a:t>
                       </a:r>
                     </a:p>
                   </a:txBody>
@@ -7388,7 +7505,7 @@
                     <a:bodyPr/>
                     <a:lstStyle/>
                     <a:p>
-                      <a:pPr algn="ctr"/>
+                      <a:pPr algn="l"/>
                       <a:r>
                         <a:rPr sz="1400" b="0" i="0">
                           <a:solidFill>
@@ -7396,7 +7513,42 @@
                           </a:solidFill>
                           <a:latin typeface="Calibri"/>
                         </a:rPr>
-                        <a:t>Higher-order: isolates 3m</a:t>
+                        <a:t>+3 for every triangle the edge sits inside</a:t>
+                      </a:r>
+                    </a:p>
+                  </a:txBody>
+                  <a:tcPr anchor="ctr">
+                    <a:solidFill>
+                      <a:srgbClr val="EFF2FB"/>
+                    </a:solidFill>
+                  </a:tcPr>
+                </a:tc>
+                <a:tc>
+                  <a:txBody>
+                    <a:bodyPr/>
+                    <a:lstStyle/>
+                    <a:p>
+                      <a:pPr algn="l"/>
+                      <a:r>
+                        <a:rPr sz="1400" b="0" i="0">
+                          <a:solidFill>
+                            <a:srgbClr val="374151"/>
+                          </a:solidFill>
+                          <a:latin typeface="Calibri"/>
+                        </a:rPr>
+                        <a:t>Higher-order:</a:t>
+                      </a:r>
+                    </a:p>
+                    <a:p>
+                      <a:pPr algn="l"/>
+                      <a:r>
+                        <a:rPr sz="1400" b="0" i="0">
+                          <a:solidFill>
+                            <a:srgbClr val="374151"/>
+                          </a:solidFill>
+                          <a:latin typeface="Calibri"/>
+                        </a:rPr>
+                        <a:t>isolates the 3m term</a:t>
                       </a:r>
                     </a:p>
                   </a:txBody>
@@ -7421,7 +7573,19 @@
                           </a:solidFill>
                           <a:latin typeface="Calibri"/>
                         </a:rPr>
-                        <a:t>Weighted augmented directed Forman</a:t>
+                        <a:t>Weighted augmented</a:t>
+                      </a:r>
+                    </a:p>
+                    <a:p>
+                      <a:pPr algn="l"/>
+                      <a:r>
+                        <a:rPr sz="1400" b="1" i="0">
+                          <a:solidFill>
+                            <a:srgbClr val="1F2937"/>
+                          </a:solidFill>
+                          <a:latin typeface="Calibri"/>
+                        </a:rPr>
+                        <a:t>directed Forman</a:t>
                       </a:r>
                     </a:p>
                   </a:txBody>
@@ -7436,7 +7600,30 @@
                     <a:bodyPr/>
                     <a:lstStyle/>
                     <a:p>
-                      <a:pPr algn="ctr"/>
+                      <a:pPr algn="l"/>
+                      <a:r>
+                        <a:rPr sz="1400" b="1" i="0">
+                          <a:solidFill>
+                            <a:srgbClr val="1F2937"/>
+                          </a:solidFill>
+                          <a:latin typeface="Calibri"/>
+                        </a:rPr>
+                        <a:t>lead-lag strength + triangles + edge direction</a:t>
+                      </a:r>
+                    </a:p>
+                  </a:txBody>
+                  <a:tcPr anchor="ctr">
+                    <a:solidFill>
+                      <a:srgbClr val="EFF2FB"/>
+                    </a:solidFill>
+                  </a:tcPr>
+                </a:tc>
+                <a:tc>
+                  <a:txBody>
+                    <a:bodyPr/>
+                    <a:lstStyle/>
+                    <a:p>
+                      <a:pPr algn="l"/>
                       <a:r>
                         <a:rPr sz="1400" b="1" i="0">
                           <a:solidFill>
@@ -7469,7 +7656,19 @@
                           </a:solidFill>
                           <a:latin typeface="Calibri"/>
                         </a:rPr>
-                        <a:t>Ollivier-Ricci  (optimal transport)</a:t>
+                        <a:t>Ollivier-Ricci</a:t>
+                      </a:r>
+                    </a:p>
+                    <a:p>
+                      <a:pPr algn="l"/>
+                      <a:r>
+                        <a:rPr sz="1400" b="0" i="0">
+                          <a:solidFill>
+                            <a:srgbClr val="374151"/>
+                          </a:solidFill>
+                          <a:latin typeface="Calibri"/>
+                        </a:rPr>
+                        <a:t>(optimal transport)</a:t>
                       </a:r>
                     </a:p>
                   </a:txBody>
@@ -7484,7 +7683,7 @@
                     <a:bodyPr/>
                     <a:lstStyle/>
                     <a:p>
-                      <a:pPr algn="ctr"/>
+                      <a:pPr algn="l"/>
                       <a:r>
                         <a:rPr sz="1400" b="0" i="0">
                           <a:solidFill>
@@ -7492,7 +7691,42 @@
                           </a:solidFill>
                           <a:latin typeface="Calibri"/>
                         </a:rPr>
-                        <a:t>Robustness / contrast (Sandhu's)</a:t>
+                        <a:t>cost to morph one node's neighborhood into the other's</a:t>
+                      </a:r>
+                    </a:p>
+                  </a:txBody>
+                  <a:tcPr anchor="ctr">
+                    <a:solidFill>
+                      <a:srgbClr val="EFF2FB"/>
+                    </a:solidFill>
+                  </a:tcPr>
+                </a:tc>
+                <a:tc>
+                  <a:txBody>
+                    <a:bodyPr/>
+                    <a:lstStyle/>
+                    <a:p>
+                      <a:pPr algn="l"/>
+                      <a:r>
+                        <a:rPr sz="1400" b="0" i="0">
+                          <a:solidFill>
+                            <a:srgbClr val="374151"/>
+                          </a:solidFill>
+                          <a:latin typeface="Calibri"/>
+                        </a:rPr>
+                        <a:t>Robustness / contrast</a:t>
+                      </a:r>
+                    </a:p>
+                    <a:p>
+                      <a:pPr algn="l"/>
+                      <a:r>
+                        <a:rPr sz="1400" b="0" i="0">
+                          <a:solidFill>
+                            <a:srgbClr val="374151"/>
+                          </a:solidFill>
+                          <a:latin typeface="Calibri"/>
+                        </a:rPr>
+                        <a:t>(Sandhu's)</a:t>
                       </a:r>
                     </a:p>
                   </a:txBody>
@@ -7509,7 +7743,7 @@
       </p:graphicFrame>
       <p:sp>
         <p:nvSpPr>
-          <p:cNvPr id="5" name="TextBox 4"/>
+          <p:cNvPr id="6" name="TextBox 5"/>
           <p:cNvSpPr txBox="1"/>
           <p:nvPr/>
         </p:nvSpPr>
@@ -7543,7 +7777,7 @@
       </p:sp>
       <p:sp>
         <p:nvSpPr>
-          <p:cNvPr id="6" name="TextBox 5"/>
+          <p:cNvPr id="7" name="TextBox 6"/>
           <p:cNvSpPr txBox="1"/>
           <p:nvPr/>
         </p:nvSpPr>
@@ -7577,7 +7811,7 @@
       </p:sp>
       <p:sp>
         <p:nvSpPr>
-          <p:cNvPr id="7" name="TextBox 6"/>
+          <p:cNvPr id="8" name="TextBox 7"/>
           <p:cNvSpPr txBox="1"/>
           <p:nvPr/>
         </p:nvSpPr>

</xml_diff>

<commit_message>
Deck: pipeline flow chart, data purposes, result significance, outlook
- Pipeline slide: replaced bullets with a six-stage snake flow chart (boxes +
  directional arrows; output box accented).
- Data slide: now a table — Source / What it is / What it's for — so each dataset's
  purpose is explicit (CRSP robustness, Compustat residualization, TAQ headline).
- Results slides (distinctness, degree ablation): "Reading" -> "What it means",
  plus a "Significance:" note spelling out what each number signifies.
- Outlook slide: dropped the thanks; reframed tentatively ("maybe not lead-lag at
  all — apply the directed-curvature tools elsewhere"); fixed right-edge overflow.

Co-Authored-By: Claude Opus 4.8 (1M context) <noreply@anthropic.com>
</commit_message>
<xml_diff>
--- a/slides/Ricci_Curvature_LeadLag.pptx
+++ b/slides/Ricci_Curvature_LeadLag.pptx
@@ -3358,7 +3358,7 @@
         <p:spPr>
           <a:xfrm>
             <a:off x="777240" y="1783080"/>
-            <a:ext cx="10607040" cy="3657600"/>
+            <a:ext cx="10607040" cy="640080"/>
           </a:xfrm>
           <a:prstGeom prst="rect">
             <a:avLst/>
@@ -3371,81 +3371,363 @@
           </a:bodyPr>
           <a:lstStyle/>
           <a:p>
-            <a:pPr>
-              <a:spcAft>
-                <a:spcPts val="1200"/>
-              </a:spcAft>
-            </a:pPr>
-            <a:r>
-              <a:rPr sz="2100" b="0" i="0">
-                <a:solidFill>
-                  <a:srgbClr val="374151"/>
-                </a:solidFill>
-                <a:latin typeface="Calibri"/>
-              </a:rPr>
-              <a:t>•  CRSP daily S&amp;P 500, 2000–2024 — survivorship-correct, delisting-adjusted.</a:t>
-            </a:r>
-          </a:p>
-          <a:p>
-            <a:pPr>
-              <a:spcAft>
-                <a:spcPts val="1200"/>
-              </a:spcAft>
-            </a:pPr>
-            <a:r>
-              <a:rPr sz="2100" b="0" i="0">
-                <a:solidFill>
-                  <a:srgbClr val="374151"/>
-                </a:solidFill>
-                <a:latin typeface="Calibri"/>
-              </a:rPr>
-              <a:t>•  Compustat GICS sectors — residualization &amp; community-boundary tests.</a:t>
-            </a:r>
-          </a:p>
-          <a:p>
-            <a:pPr>
-              <a:spcAft>
-                <a:spcPts val="1200"/>
-              </a:spcAft>
-            </a:pPr>
-            <a:r>
-              <a:rPr sz="2100" b="0" i="0">
-                <a:solidFill>
-                  <a:srgbClr val="374151"/>
-                </a:solidFill>
-                <a:latin typeface="Calibri"/>
-              </a:rPr>
-              <a:t>•  TAQ 30-min intraday — full-year 2019, ~155 large-caps (where lead-lag lives).</a:t>
-            </a:r>
-          </a:p>
-          <a:p>
-            <a:pPr>
-              <a:spcAft>
-                <a:spcPts val="1200"/>
-              </a:spcAft>
-            </a:pPr>
-            <a:r>
-              <a:rPr sz="2100" b="0" i="0">
-                <a:solidFill>
-                  <a:srgbClr val="374151"/>
-                </a:solidFill>
-                <a:latin typeface="Calibri"/>
-              </a:rPr>
-              <a:t>•  Every network is built on factor-residualized returns.</a:t>
-            </a:r>
-          </a:p>
-        </p:txBody>
-      </p:sp>
-      <p:sp>
-        <p:nvSpPr>
-          <p:cNvPr id="5" name="TextBox 4"/>
+            <a:r>
+              <a:rPr sz="1800" b="0" i="1">
+                <a:solidFill>
+                  <a:srgbClr val="2563EB"/>
+                </a:solidFill>
+                <a:latin typeface="Calibri"/>
+              </a:rPr>
+              <a:t>Every network is built on factor-residualized returns.</a:t>
+            </a:r>
+          </a:p>
+        </p:txBody>
+      </p:sp>
+      <p:graphicFrame>
+        <p:nvGraphicFramePr>
+          <p:cNvPr id="5" name="Table 4"/>
+          <p:cNvGraphicFramePr>
+            <a:graphicFrameLocks noGrp="1"/>
+          </p:cNvGraphicFramePr>
+          <p:nvPr/>
+        </p:nvGraphicFramePr>
+        <p:xfrm>
+          <a:off x="777240" y="2377440"/>
+          <a:ext cx="10607040" cy="1828800"/>
+        </p:xfrm>
+        <a:graphic>
+          <a:graphicData uri="http://schemas.openxmlformats.org/drawingml/2006/table">
+            <a:tbl>
+              <a:tblPr firstRow="1" bandRow="1">
+                <a:tableStyleId>{5C22544A-7EE6-4342-B048-85BDC9FD1C3A}</a:tableStyleId>
+              </a:tblPr>
+              <a:tblGrid>
+                <a:gridCol w="1828800"/>
+                <a:gridCol w="4937760"/>
+                <a:gridCol w="3840480"/>
+              </a:tblGrid>
+              <a:tr h="457200">
+                <a:tc>
+                  <a:txBody>
+                    <a:bodyPr/>
+                    <a:lstStyle/>
+                    <a:p>
+                      <a:pPr algn="l"/>
+                      <a:r>
+                        <a:rPr sz="1500" b="1" i="0">
+                          <a:solidFill>
+                            <a:srgbClr val="FFFFFF"/>
+                          </a:solidFill>
+                          <a:latin typeface="Calibri"/>
+                        </a:rPr>
+                        <a:t>Source</a:t>
+                      </a:r>
+                    </a:p>
+                  </a:txBody>
+                  <a:tcPr anchor="ctr">
+                    <a:solidFill>
+                      <a:srgbClr val="2563EB"/>
+                    </a:solidFill>
+                  </a:tcPr>
+                </a:tc>
+                <a:tc>
+                  <a:txBody>
+                    <a:bodyPr/>
+                    <a:lstStyle/>
+                    <a:p>
+                      <a:pPr algn="l"/>
+                      <a:r>
+                        <a:rPr sz="1500" b="1" i="0">
+                          <a:solidFill>
+                            <a:srgbClr val="FFFFFF"/>
+                          </a:solidFill>
+                          <a:latin typeface="Calibri"/>
+                        </a:rPr>
+                        <a:t>What it is</a:t>
+                      </a:r>
+                    </a:p>
+                  </a:txBody>
+                  <a:tcPr anchor="ctr">
+                    <a:solidFill>
+                      <a:srgbClr val="2563EB"/>
+                    </a:solidFill>
+                  </a:tcPr>
+                </a:tc>
+                <a:tc>
+                  <a:txBody>
+                    <a:bodyPr/>
+                    <a:lstStyle/>
+                    <a:p>
+                      <a:pPr algn="l"/>
+                      <a:r>
+                        <a:rPr sz="1500" b="1" i="0">
+                          <a:solidFill>
+                            <a:srgbClr val="FFFFFF"/>
+                          </a:solidFill>
+                          <a:latin typeface="Calibri"/>
+                        </a:rPr>
+                        <a:t>What it's for</a:t>
+                      </a:r>
+                    </a:p>
+                  </a:txBody>
+                  <a:tcPr anchor="ctr">
+                    <a:solidFill>
+                      <a:srgbClr val="2563EB"/>
+                    </a:solidFill>
+                  </a:tcPr>
+                </a:tc>
+              </a:tr>
+              <a:tr h="457200">
+                <a:tc>
+                  <a:txBody>
+                    <a:bodyPr/>
+                    <a:lstStyle/>
+                    <a:p>
+                      <a:pPr algn="l"/>
+                      <a:r>
+                        <a:rPr sz="1400" b="0" i="0">
+                          <a:solidFill>
+                            <a:srgbClr val="374151"/>
+                          </a:solidFill>
+                          <a:latin typeface="Calibri"/>
+                        </a:rPr>
+                        <a:t>CRSP</a:t>
+                      </a:r>
+                    </a:p>
+                  </a:txBody>
+                  <a:tcPr anchor="ctr">
+                    <a:solidFill>
+                      <a:srgbClr val="FFFFFF"/>
+                    </a:solidFill>
+                  </a:tcPr>
+                </a:tc>
+                <a:tc>
+                  <a:txBody>
+                    <a:bodyPr/>
+                    <a:lstStyle/>
+                    <a:p>
+                      <a:pPr algn="l"/>
+                      <a:r>
+                        <a:rPr sz="1400" b="0" i="0">
+                          <a:solidFill>
+                            <a:srgbClr val="374151"/>
+                          </a:solidFill>
+                          <a:latin typeface="Calibri"/>
+                        </a:rPr>
+                        <a:t>daily S&amp;P 500 returns, 2000–2024</a:t>
+                      </a:r>
+                    </a:p>
+                    <a:p>
+                      <a:pPr algn="l"/>
+                      <a:r>
+                        <a:rPr sz="1400" b="0" i="0">
+                          <a:solidFill>
+                            <a:srgbClr val="374151"/>
+                          </a:solidFill>
+                          <a:latin typeface="Calibri"/>
+                        </a:rPr>
+                        <a:t>(survivorship-correct)</a:t>
+                      </a:r>
+                    </a:p>
+                  </a:txBody>
+                  <a:tcPr anchor="ctr">
+                    <a:solidFill>
+                      <a:srgbClr val="FFFFFF"/>
+                    </a:solidFill>
+                  </a:tcPr>
+                </a:tc>
+                <a:tc>
+                  <a:txBody>
+                    <a:bodyPr/>
+                    <a:lstStyle/>
+                    <a:p>
+                      <a:pPr algn="l"/>
+                      <a:r>
+                        <a:rPr sz="1400" b="0" i="0">
+                          <a:solidFill>
+                            <a:srgbClr val="374151"/>
+                          </a:solidFill>
+                          <a:latin typeface="Calibri"/>
+                        </a:rPr>
+                        <a:t>daily-frequency robustness check</a:t>
+                      </a:r>
+                    </a:p>
+                  </a:txBody>
+                  <a:tcPr anchor="ctr">
+                    <a:solidFill>
+                      <a:srgbClr val="FFFFFF"/>
+                    </a:solidFill>
+                  </a:tcPr>
+                </a:tc>
+              </a:tr>
+              <a:tr h="457200">
+                <a:tc>
+                  <a:txBody>
+                    <a:bodyPr/>
+                    <a:lstStyle/>
+                    <a:p>
+                      <a:pPr algn="l"/>
+                      <a:r>
+                        <a:rPr sz="1400" b="0" i="0">
+                          <a:solidFill>
+                            <a:srgbClr val="374151"/>
+                          </a:solidFill>
+                          <a:latin typeface="Calibri"/>
+                        </a:rPr>
+                        <a:t>Compustat</a:t>
+                      </a:r>
+                    </a:p>
+                  </a:txBody>
+                  <a:tcPr anchor="ctr">
+                    <a:solidFill>
+                      <a:srgbClr val="EFF2FB"/>
+                    </a:solidFill>
+                  </a:tcPr>
+                </a:tc>
+                <a:tc>
+                  <a:txBody>
+                    <a:bodyPr/>
+                    <a:lstStyle/>
+                    <a:p>
+                      <a:pPr algn="l"/>
+                      <a:r>
+                        <a:rPr sz="1400" b="0" i="0">
+                          <a:solidFill>
+                            <a:srgbClr val="374151"/>
+                          </a:solidFill>
+                          <a:latin typeface="Calibri"/>
+                        </a:rPr>
+                        <a:t>GICS sector classifications</a:t>
+                      </a:r>
+                    </a:p>
+                  </a:txBody>
+                  <a:tcPr anchor="ctr">
+                    <a:solidFill>
+                      <a:srgbClr val="EFF2FB"/>
+                    </a:solidFill>
+                  </a:tcPr>
+                </a:tc>
+                <a:tc>
+                  <a:txBody>
+                    <a:bodyPr/>
+                    <a:lstStyle/>
+                    <a:p>
+                      <a:pPr algn="l"/>
+                      <a:r>
+                        <a:rPr sz="1400" b="0" i="0">
+                          <a:solidFill>
+                            <a:srgbClr val="374151"/>
+                          </a:solidFill>
+                          <a:latin typeface="Calibri"/>
+                        </a:rPr>
+                        <a:t>residualize returns; sector-boundary tests</a:t>
+                      </a:r>
+                    </a:p>
+                  </a:txBody>
+                  <a:tcPr anchor="ctr">
+                    <a:solidFill>
+                      <a:srgbClr val="EFF2FB"/>
+                    </a:solidFill>
+                  </a:tcPr>
+                </a:tc>
+              </a:tr>
+              <a:tr h="457200">
+                <a:tc>
+                  <a:txBody>
+                    <a:bodyPr/>
+                    <a:lstStyle/>
+                    <a:p>
+                      <a:pPr algn="l"/>
+                      <a:r>
+                        <a:rPr sz="1400" b="1" i="0">
+                          <a:solidFill>
+                            <a:srgbClr val="1F2937"/>
+                          </a:solidFill>
+                          <a:latin typeface="Calibri"/>
+                        </a:rPr>
+                        <a:t>TAQ</a:t>
+                      </a:r>
+                    </a:p>
+                  </a:txBody>
+                  <a:tcPr anchor="ctr">
+                    <a:solidFill>
+                      <a:srgbClr val="EFF2FB"/>
+                    </a:solidFill>
+                  </a:tcPr>
+                </a:tc>
+                <a:tc>
+                  <a:txBody>
+                    <a:bodyPr/>
+                    <a:lstStyle/>
+                    <a:p>
+                      <a:pPr algn="l"/>
+                      <a:r>
+                        <a:rPr sz="1400" b="1" i="0">
+                          <a:solidFill>
+                            <a:srgbClr val="1F2937"/>
+                          </a:solidFill>
+                          <a:latin typeface="Calibri"/>
+                        </a:rPr>
+                        <a:t>30-min intraday bars, full-year 2019</a:t>
+                      </a:r>
+                    </a:p>
+                    <a:p>
+                      <a:pPr algn="l"/>
+                      <a:r>
+                        <a:rPr sz="1400" b="1" i="0">
+                          <a:solidFill>
+                            <a:srgbClr val="1F2937"/>
+                          </a:solidFill>
+                          <a:latin typeface="Calibri"/>
+                        </a:rPr>
+                        <a:t>(~155 large-caps)</a:t>
+                      </a:r>
+                    </a:p>
+                  </a:txBody>
+                  <a:tcPr anchor="ctr">
+                    <a:solidFill>
+                      <a:srgbClr val="EFF2FB"/>
+                    </a:solidFill>
+                  </a:tcPr>
+                </a:tc>
+                <a:tc>
+                  <a:txBody>
+                    <a:bodyPr/>
+                    <a:lstStyle/>
+                    <a:p>
+                      <a:pPr algn="l"/>
+                      <a:r>
+                        <a:rPr sz="1400" b="1" i="0">
+                          <a:solidFill>
+                            <a:srgbClr val="1F2937"/>
+                          </a:solidFill>
+                          <a:latin typeface="Calibri"/>
+                        </a:rPr>
+                        <a:t>the HEADLINE network — where lead-lag lives</a:t>
+                      </a:r>
+                    </a:p>
+                  </a:txBody>
+                  <a:tcPr anchor="ctr">
+                    <a:solidFill>
+                      <a:srgbClr val="EFF2FB"/>
+                    </a:solidFill>
+                  </a:tcPr>
+                </a:tc>
+              </a:tr>
+            </a:tbl>
+          </a:graphicData>
+        </a:graphic>
+      </p:graphicFrame>
+      <p:sp>
+        <p:nvSpPr>
+          <p:cNvPr id="6" name="TextBox 5"/>
           <p:cNvSpPr txBox="1"/>
           <p:nvPr/>
         </p:nvSpPr>
         <p:spPr>
           <a:xfrm>
-            <a:off x="777240" y="6355080"/>
-            <a:ext cx="10607040" cy="365760"/>
+            <a:off x="777240" y="5715000"/>
+            <a:ext cx="10607040" cy="640080"/>
           </a:xfrm>
           <a:prstGeom prst="rect">
             <a:avLst/>
@@ -3459,6 +3741,40 @@
           <a:lstStyle/>
           <a:p>
             <a:r>
+              <a:rPr sz="1400" b="0" i="1">
+                <a:solidFill>
+                  <a:srgbClr val="9CA3AF"/>
+                </a:solidFill>
+                <a:latin typeface="Calibri"/>
+              </a:rPr>
+              <a:t>Intraday is the main result; daily is the robustness check.</a:t>
+            </a:r>
+          </a:p>
+        </p:txBody>
+      </p:sp>
+      <p:sp>
+        <p:nvSpPr>
+          <p:cNvPr id="7" name="TextBox 6"/>
+          <p:cNvSpPr txBox="1"/>
+          <p:nvPr/>
+        </p:nvSpPr>
+        <p:spPr>
+          <a:xfrm>
+            <a:off x="777240" y="6355080"/>
+            <a:ext cx="10607040" cy="365760"/>
+          </a:xfrm>
+          <a:prstGeom prst="rect">
+            <a:avLst/>
+          </a:prstGeom>
+          <a:noFill/>
+        </p:spPr>
+        <p:txBody>
+          <a:bodyPr wrap="square">
+            <a:spAutoFit/>
+          </a:bodyPr>
+          <a:lstStyle/>
+          <a:p>
+            <a:r>
               <a:rPr sz="1100" b="0" i="0">
                 <a:solidFill>
                   <a:srgbClr val="9CA3AF"/>
@@ -3472,7 +3788,7 @@
       </p:sp>
       <p:sp>
         <p:nvSpPr>
-          <p:cNvPr id="6" name="TextBox 5"/>
+          <p:cNvPr id="8" name="TextBox 7"/>
           <p:cNvSpPr txBox="1"/>
           <p:nvPr/>
         </p:nvSpPr>
@@ -3766,9 +4082,9 @@
                 <a:tableStyleId>{5C22544A-7EE6-4342-B048-85BDC9FD1C3A}</a:tableStyleId>
               </a:tblPr>
               <a:tblGrid>
-                <a:gridCol w="4572000"/>
-                <a:gridCol w="2194560"/>
-                <a:gridCol w="3840480"/>
+                <a:gridCol w="4023360"/>
+                <a:gridCol w="1737360"/>
+                <a:gridCol w="4846320"/>
               </a:tblGrid>
               <a:tr h="457200">
                 <a:tc>
@@ -3822,7 +4138,7 @@
                     <a:bodyPr/>
                     <a:lstStyle/>
                     <a:p>
-                      <a:pPr algn="ctr"/>
+                      <a:pPr algn="l"/>
                       <a:r>
                         <a:rPr sz="1500" b="1" i="0">
                           <a:solidFill>
@@ -3830,7 +4146,7 @@
                           </a:solidFill>
                           <a:latin typeface="Calibri"/>
                         </a:rPr>
-                        <a:t>Reading</a:t>
+                        <a:t>What it means</a:t>
                       </a:r>
                     </a:p>
                   </a:txBody>
@@ -3893,7 +4209,7 @@
                     <a:bodyPr/>
                     <a:lstStyle/>
                     <a:p>
-                      <a:pPr algn="ctr"/>
+                      <a:pPr algn="l"/>
                       <a:r>
                         <a:rPr sz="1400" b="1" i="0">
                           <a:solidFill>
@@ -3901,7 +4217,7 @@
                           </a:solidFill>
                           <a:latin typeface="Calibri"/>
                         </a:rPr>
-                        <a:t>near-disjoint pair sets</a:t>
+                        <a:t>the two methods pick almost no pairs in common</a:t>
                       </a:r>
                     </a:p>
                   </a:txBody>
@@ -3964,7 +4280,7 @@
                     <a:bodyPr/>
                     <a:lstStyle/>
                     <a:p>
-                      <a:pPr algn="ctr"/>
+                      <a:pPr algn="l"/>
                       <a:r>
                         <a:rPr sz="1400" b="1" i="0">
                           <a:solidFill>
@@ -3972,7 +4288,7 @@
                           </a:solidFill>
                           <a:latin typeface="Calibri"/>
                         </a:rPr>
-                        <a:t>weak (≪ 0.8 threshold)</a:t>
+                        <a:t>curvature rank barely tracks correlation (≪ 0.8)</a:t>
                       </a:r>
                     </a:p>
                   </a:txBody>
@@ -4016,7 +4332,7 @@
                 </a:solidFill>
                 <a:latin typeface="Calibri"/>
               </a:rPr>
-              <a:t>The directed graph carries lead-lag asymmetry the symmetric correlation graph cannot.</a:t>
+              <a:t>Significance: curvature is not a re-skin of correlation — it surfaces genuinely different structure. This distinctness IS the headline result.</a:t>
             </a:r>
           </a:p>
         </p:txBody>
@@ -4215,7 +4531,7 @@
                 </a:solidFill>
                 <a:latin typeface="Calibri"/>
               </a:rPr>
-              <a:t>The +3m triangle term is genuinely not explained by degree.</a:t>
+              <a:t>Does the curvature carry anything beyond node connectivity?</a:t>
             </a:r>
           </a:p>
         </p:txBody>
@@ -4239,9 +4555,9 @@
                 <a:tableStyleId>{5C22544A-7EE6-4342-B048-85BDC9FD1C3A}</a:tableStyleId>
               </a:tblPr>
               <a:tblGrid>
-                <a:gridCol w="3840480"/>
-                <a:gridCol w="2743200"/>
-                <a:gridCol w="4023360"/>
+                <a:gridCol w="3474720"/>
+                <a:gridCol w="2194560"/>
+                <a:gridCol w="4937760"/>
               </a:tblGrid>
               <a:tr h="457200">
                 <a:tc>
@@ -4295,7 +4611,7 @@
                     <a:bodyPr/>
                     <a:lstStyle/>
                     <a:p>
-                      <a:pPr algn="ctr"/>
+                      <a:pPr algn="l"/>
                       <a:r>
                         <a:rPr sz="1500" b="1" i="0">
                           <a:solidFill>
@@ -4303,7 +4619,7 @@
                           </a:solidFill>
                           <a:latin typeface="Calibri"/>
                         </a:rPr>
-                        <a:t>Reading</a:t>
+                        <a:t>What it means</a:t>
                       </a:r>
                     </a:p>
                   </a:txBody>
@@ -4366,7 +4682,7 @@
                     <a:bodyPr/>
                     <a:lstStyle/>
                     <a:p>
-                      <a:pPr algn="ctr"/>
+                      <a:pPr algn="l"/>
                       <a:r>
                         <a:rPr sz="1400" b="0" i="0">
                           <a:solidFill>
@@ -4374,7 +4690,7 @@
                           </a:solidFill>
                           <a:latin typeface="Calibri"/>
                         </a:rPr>
-                        <a:t>exact degree identity (calibration ✓)</a:t>
+                        <a:t>100% explained by degree — pure baseline, by design</a:t>
                       </a:r>
                     </a:p>
                   </a:txBody>
@@ -4437,7 +4753,7 @@
                     <a:bodyPr/>
                     <a:lstStyle/>
                     <a:p>
-                      <a:pPr algn="ctr"/>
+                      <a:pPr algn="l"/>
                       <a:r>
                         <a:rPr sz="1400" b="1" i="0">
                           <a:solidFill>
@@ -4445,7 +4761,7 @@
                           </a:solidFill>
                           <a:latin typeface="Calibri"/>
                         </a:rPr>
-                        <a:t>≈ 44% is NEW higher-order signal</a:t>
+                        <a:t>~44% is NOT degree → genuinely higher-order signal</a:t>
                       </a:r>
                     </a:p>
                   </a:txBody>
@@ -4489,7 +4805,7 @@
                 </a:solidFill>
                 <a:latin typeface="Calibri"/>
               </a:rPr>
-              <a:t>Plain Forman is rightly a baseline; the augmented object earns its place.</a:t>
+              <a:t>Significance: plain Forman = pure degree (proves the test is calibrated); the augmented object adds real higher-order structure the +3m triangle term captures.</a:t>
             </a:r>
           </a:p>
         </p:txBody>
@@ -5164,7 +5480,7 @@
                 </a:solidFill>
                 <a:latin typeface="Calibri"/>
               </a:rPr>
-              <a:t>Next steps &amp; thanks</a:t>
+              <a:t>Where this could go</a:t>
             </a:r>
           </a:p>
         </p:txBody>
@@ -5242,7 +5558,7 @@
                 </a:solidFill>
                 <a:latin typeface="Calibri"/>
               </a:rPr>
-              <a:t>The paper stands on the structural result.</a:t>
+              <a:t>The structural toolkit is not tied to one construction.</a:t>
             </a:r>
           </a:p>
         </p:txBody>
@@ -5281,7 +5597,7 @@
                 </a:solidFill>
                 <a:latin typeface="Calibri"/>
               </a:rPr>
-              <a:t>•  Directed line-graph &amp; directed AFRC-gap theory (possible Weber collaboration).</a:t>
+              <a:t>•  Maybe not lead-lag at all — apply the same directed-curvature tools to other market graphs and relations.</a:t>
             </a:r>
           </a:p>
           <a:p>
@@ -5297,7 +5613,7 @@
                 </a:solidFill>
                 <a:latin typeface="Calibri"/>
               </a:rPr>
-              <a:t>•  Multi-frequency replication and curvature dynamics through 2020 stress.</a:t>
+              <a:t>•  Directed line-graph &amp; directed AFRC-gap theory (open problems).</a:t>
             </a:r>
           </a:p>
           <a:p>
@@ -5313,7 +5629,7 @@
                 </a:solidFill>
                 <a:latin typeface="Calibri"/>
               </a:rPr>
-              <a:t>•  Write-up → 8-page ACM sigconf for ICAIF 2026.</a:t>
+              <a:t>•  Multi-frequency replication; curvature dynamics through 2020 stress.</a:t>
             </a:r>
           </a:p>
           <a:p>
@@ -5329,7 +5645,7 @@
                 </a:solidFill>
                 <a:latin typeface="Calibri"/>
               </a:rPr>
-              <a:t>•  Thanks to Prof. Mihai Cucuringu and the 285J group.</a:t>
+              <a:t>•  Write-up → 8-page ACM sigconf for ICAIF 2026.</a:t>
             </a:r>
           </a:p>
         </p:txBody>
@@ -5363,7 +5679,7 @@
                 </a:solidFill>
                 <a:latin typeface="Calibri"/>
               </a:rPr>
-              <a:t>Close</a:t>
+              <a:t>Outlook</a:t>
             </a:r>
           </a:p>
         </p:txBody>
@@ -6640,7 +6956,7 @@
                 </a:solidFill>
                 <a:latin typeface="Calibri"/>
               </a:rPr>
-              <a:t>An autonomous pipeline, six stages</a:t>
+              <a:t>The pipeline</a:t>
             </a:r>
           </a:p>
         </p:txBody>
@@ -6697,8 +7013,8 @@
         </p:nvSpPr>
         <p:spPr>
           <a:xfrm>
-            <a:off x="777240" y="1783080"/>
-            <a:ext cx="10607040" cy="3657600"/>
+            <a:off x="777240" y="1600200"/>
+            <a:ext cx="10607040" cy="548640"/>
           </a:xfrm>
           <a:prstGeom prst="rect">
             <a:avLst/>
@@ -6711,106 +7027,667 @@
           </a:bodyPr>
           <a:lstStyle/>
           <a:p>
-            <a:pPr>
-              <a:spcAft>
-                <a:spcPts val="1200"/>
-              </a:spcAft>
+            <a:r>
+              <a:rPr sz="1800" b="0" i="1">
+                <a:solidFill>
+                  <a:srgbClr val="2563EB"/>
+                </a:solidFill>
+                <a:latin typeface="Calibri"/>
+              </a:rPr>
+              <a:t>Six stages, fully automated.</a:t>
+            </a:r>
+          </a:p>
+        </p:txBody>
+      </p:sp>
+      <p:sp>
+        <p:nvSpPr>
+          <p:cNvPr id="5" name="Rounded Rectangle 4"/>
+          <p:cNvSpPr/>
+          <p:nvPr/>
+        </p:nvSpPr>
+        <p:spPr>
+          <a:xfrm>
+            <a:off x="777240" y="2331720"/>
+            <a:ext cx="3017520" cy="1005840"/>
+          </a:xfrm>
+          <a:prstGeom prst="roundRect">
+            <a:avLst/>
+          </a:prstGeom>
+          <a:solidFill>
+            <a:srgbClr val="EFF2FB"/>
+          </a:solidFill>
+          <a:ln w="15875">
+            <a:solidFill>
+              <a:srgbClr val="2563EB"/>
+            </a:solidFill>
+          </a:ln>
+          <a:effectLst/>
+        </p:spPr>
+        <p:style>
+          <a:lnRef idx="1">
+            <a:schemeClr val="accent1"/>
+          </a:lnRef>
+          <a:fillRef idx="3">
+            <a:schemeClr val="accent1"/>
+          </a:fillRef>
+          <a:effectRef idx="2">
+            <a:schemeClr val="accent1"/>
+          </a:effectRef>
+          <a:fontRef idx="minor">
+            <a:schemeClr val="lt1"/>
+          </a:fontRef>
+        </p:style>
+        <p:txBody>
+          <a:bodyPr rtlCol="0" anchor="ctr" wrap="square" lIns="73152" rIns="73152" tIns="27432" bIns="27432"/>
+          <a:lstStyle/>
+          <a:p>
+            <a:pPr algn="ctr"/>
+            <a:r>
+              <a:rPr sz="1400" b="1" i="0">
+                <a:solidFill>
+                  <a:srgbClr val="1F2937"/>
+                </a:solidFill>
+                <a:latin typeface="Calibri"/>
+              </a:rPr>
+              <a:t>Residualize returns</a:t>
+            </a:r>
+          </a:p>
+          <a:p>
+            <a:pPr algn="ctr">
+              <a:spcBef>
+                <a:spcPts val="200"/>
+              </a:spcBef>
             </a:pPr>
             <a:r>
-              <a:rPr sz="2100" b="0" i="0">
-                <a:solidFill>
-                  <a:srgbClr val="374151"/>
-                </a:solidFill>
-                <a:latin typeface="Calibri"/>
-              </a:rPr>
-              <a:t>•  Residualize returns — remove market + sector first.</a:t>
-            </a:r>
-          </a:p>
-          <a:p>
-            <a:pPr>
-              <a:spcAft>
-                <a:spcPts val="1200"/>
-              </a:spcAft>
+              <a:rPr sz="1000" b="0" i="0">
+                <a:solidFill>
+                  <a:srgbClr val="9CA3AF"/>
+                </a:solidFill>
+                <a:latin typeface="Calibri"/>
+              </a:rPr>
+              <a:t>remove market + sector</a:t>
+            </a:r>
+          </a:p>
+        </p:txBody>
+      </p:sp>
+      <p:sp>
+        <p:nvSpPr>
+          <p:cNvPr id="6" name="Rounded Rectangle 5"/>
+          <p:cNvSpPr/>
+          <p:nvPr/>
+        </p:nvSpPr>
+        <p:spPr>
+          <a:xfrm>
+            <a:off x="4206240" y="2331720"/>
+            <a:ext cx="3017520" cy="1005840"/>
+          </a:xfrm>
+          <a:prstGeom prst="roundRect">
+            <a:avLst/>
+          </a:prstGeom>
+          <a:solidFill>
+            <a:srgbClr val="EFF2FB"/>
+          </a:solidFill>
+          <a:ln w="15875">
+            <a:solidFill>
+              <a:srgbClr val="2563EB"/>
+            </a:solidFill>
+          </a:ln>
+          <a:effectLst/>
+        </p:spPr>
+        <p:style>
+          <a:lnRef idx="1">
+            <a:schemeClr val="accent1"/>
+          </a:lnRef>
+          <a:fillRef idx="3">
+            <a:schemeClr val="accent1"/>
+          </a:fillRef>
+          <a:effectRef idx="2">
+            <a:schemeClr val="accent1"/>
+          </a:effectRef>
+          <a:fontRef idx="minor">
+            <a:schemeClr val="lt1"/>
+          </a:fontRef>
+        </p:style>
+        <p:txBody>
+          <a:bodyPr rtlCol="0" anchor="ctr" wrap="square" lIns="73152" rIns="73152" tIns="27432" bIns="27432"/>
+          <a:lstStyle/>
+          <a:p>
+            <a:pPr algn="ctr"/>
+            <a:r>
+              <a:rPr sz="1400" b="1" i="0">
+                <a:solidFill>
+                  <a:srgbClr val="1F2937"/>
+                </a:solidFill>
+                <a:latin typeface="Calibri"/>
+              </a:rPr>
+              <a:t>Directed lead-lag network</a:t>
+            </a:r>
+          </a:p>
+          <a:p>
+            <a:pPr algn="ctr">
+              <a:spcBef>
+                <a:spcPts val="200"/>
+              </a:spcBef>
             </a:pPr>
             <a:r>
-              <a:rPr sz="2100" b="0" i="0">
-                <a:solidFill>
-                  <a:srgbClr val="374151"/>
-                </a:solidFill>
-                <a:latin typeface="Calibri"/>
-              </a:rPr>
-              <a:t>•  Build the directed lead-lag network (BCR signed statistic).</a:t>
-            </a:r>
-          </a:p>
-          <a:p>
-            <a:pPr>
-              <a:spcAft>
-                <a:spcPts val="1200"/>
-              </a:spcAft>
+              <a:rPr sz="1000" b="0" i="0">
+                <a:solidFill>
+                  <a:srgbClr val="9CA3AF"/>
+                </a:solidFill>
+                <a:latin typeface="Calibri"/>
+              </a:rPr>
+              <a:t>BCR signed statistic</a:t>
+            </a:r>
+          </a:p>
+        </p:txBody>
+      </p:sp>
+      <p:sp>
+        <p:nvSpPr>
+          <p:cNvPr id="7" name="Rounded Rectangle 6"/>
+          <p:cNvSpPr/>
+          <p:nvPr/>
+        </p:nvSpPr>
+        <p:spPr>
+          <a:xfrm>
+            <a:off x="7635240" y="2331720"/>
+            <a:ext cx="3017520" cy="1005840"/>
+          </a:xfrm>
+          <a:prstGeom prst="roundRect">
+            <a:avLst/>
+          </a:prstGeom>
+          <a:solidFill>
+            <a:srgbClr val="EFF2FB"/>
+          </a:solidFill>
+          <a:ln w="15875">
+            <a:solidFill>
+              <a:srgbClr val="2563EB"/>
+            </a:solidFill>
+          </a:ln>
+          <a:effectLst/>
+        </p:spPr>
+        <p:style>
+          <a:lnRef idx="1">
+            <a:schemeClr val="accent1"/>
+          </a:lnRef>
+          <a:fillRef idx="3">
+            <a:schemeClr val="accent1"/>
+          </a:fillRef>
+          <a:effectRef idx="2">
+            <a:schemeClr val="accent1"/>
+          </a:effectRef>
+          <a:fontRef idx="minor">
+            <a:schemeClr val="lt1"/>
+          </a:fontRef>
+        </p:style>
+        <p:txBody>
+          <a:bodyPr rtlCol="0" anchor="ctr" wrap="square" lIns="73152" rIns="73152" tIns="27432" bIns="27432"/>
+          <a:lstStyle/>
+          <a:p>
+            <a:pPr algn="ctr"/>
+            <a:r>
+              <a:rPr sz="1400" b="1" i="0">
+                <a:solidFill>
+                  <a:srgbClr val="1F2937"/>
+                </a:solidFill>
+                <a:latin typeface="Calibri"/>
+              </a:rPr>
+              <a:t>Four curvature objects</a:t>
+            </a:r>
+          </a:p>
+          <a:p>
+            <a:pPr algn="ctr">
+              <a:spcBef>
+                <a:spcPts val="200"/>
+              </a:spcBef>
             </a:pPr>
             <a:r>
-              <a:rPr sz="2100" b="0" i="0">
-                <a:solidFill>
-                  <a:srgbClr val="374151"/>
-                </a:solidFill>
-                <a:latin typeface="Calibri"/>
-              </a:rPr>
-              <a:t>•  Compute four curvature objects.</a:t>
-            </a:r>
-          </a:p>
-          <a:p>
-            <a:pPr>
-              <a:spcAft>
-                <a:spcPts val="1200"/>
-              </a:spcAft>
+              <a:rPr sz="1000" b="0" i="0">
+                <a:solidFill>
+                  <a:srgbClr val="9CA3AF"/>
+                </a:solidFill>
+                <a:latin typeface="Calibri"/>
+              </a:rPr>
+              <a:t>plain → weighted aug. directed</a:t>
+            </a:r>
+          </a:p>
+        </p:txBody>
+      </p:sp>
+      <p:sp>
+        <p:nvSpPr>
+          <p:cNvPr id="8" name="Right Arrow 7"/>
+          <p:cNvSpPr/>
+          <p:nvPr/>
+        </p:nvSpPr>
+        <p:spPr>
+          <a:xfrm>
+            <a:off x="3822191" y="2679192"/>
+            <a:ext cx="384048" cy="310896"/>
+          </a:xfrm>
+          <a:prstGeom prst="rightArrow">
+            <a:avLst/>
+          </a:prstGeom>
+          <a:solidFill>
+            <a:srgbClr val="2563EB"/>
+          </a:solidFill>
+          <a:ln>
+            <a:noFill/>
+          </a:ln>
+          <a:effectLst/>
+        </p:spPr>
+        <p:style>
+          <a:lnRef idx="1">
+            <a:schemeClr val="accent1"/>
+          </a:lnRef>
+          <a:fillRef idx="3">
+            <a:schemeClr val="accent1"/>
+          </a:fillRef>
+          <a:effectRef idx="2">
+            <a:schemeClr val="accent1"/>
+          </a:effectRef>
+          <a:fontRef idx="minor">
+            <a:schemeClr val="lt1"/>
+          </a:fontRef>
+        </p:style>
+        <p:txBody>
+          <a:bodyPr rtlCol="0" anchor="ctr"/>
+          <a:lstStyle/>
+          <a:p>
+            <a:pPr algn="ctr"/>
+          </a:p>
+        </p:txBody>
+      </p:sp>
+      <p:sp>
+        <p:nvSpPr>
+          <p:cNvPr id="9" name="Right Arrow 8"/>
+          <p:cNvSpPr/>
+          <p:nvPr/>
+        </p:nvSpPr>
+        <p:spPr>
+          <a:xfrm>
+            <a:off x="7251192" y="2679192"/>
+            <a:ext cx="384048" cy="310896"/>
+          </a:xfrm>
+          <a:prstGeom prst="rightArrow">
+            <a:avLst/>
+          </a:prstGeom>
+          <a:solidFill>
+            <a:srgbClr val="2563EB"/>
+          </a:solidFill>
+          <a:ln>
+            <a:noFill/>
+          </a:ln>
+          <a:effectLst/>
+        </p:spPr>
+        <p:style>
+          <a:lnRef idx="1">
+            <a:schemeClr val="accent1"/>
+          </a:lnRef>
+          <a:fillRef idx="3">
+            <a:schemeClr val="accent1"/>
+          </a:fillRef>
+          <a:effectRef idx="2">
+            <a:schemeClr val="accent1"/>
+          </a:effectRef>
+          <a:fontRef idx="minor">
+            <a:schemeClr val="lt1"/>
+          </a:fontRef>
+        </p:style>
+        <p:txBody>
+          <a:bodyPr rtlCol="0" anchor="ctr"/>
+          <a:lstStyle/>
+          <a:p>
+            <a:pPr algn="ctr"/>
+          </a:p>
+        </p:txBody>
+      </p:sp>
+      <p:sp>
+        <p:nvSpPr>
+          <p:cNvPr id="10" name="Down Arrow 9"/>
+          <p:cNvSpPr/>
+          <p:nvPr/>
+        </p:nvSpPr>
+        <p:spPr>
+          <a:xfrm>
+            <a:off x="8988552" y="3383280"/>
+            <a:ext cx="310896" cy="914400"/>
+          </a:xfrm>
+          <a:prstGeom prst="downArrow">
+            <a:avLst/>
+          </a:prstGeom>
+          <a:solidFill>
+            <a:srgbClr val="2563EB"/>
+          </a:solidFill>
+          <a:ln>
+            <a:noFill/>
+          </a:ln>
+          <a:effectLst/>
+        </p:spPr>
+        <p:style>
+          <a:lnRef idx="1">
+            <a:schemeClr val="accent1"/>
+          </a:lnRef>
+          <a:fillRef idx="3">
+            <a:schemeClr val="accent1"/>
+          </a:fillRef>
+          <a:effectRef idx="2">
+            <a:schemeClr val="accent1"/>
+          </a:effectRef>
+          <a:fontRef idx="minor">
+            <a:schemeClr val="lt1"/>
+          </a:fontRef>
+        </p:style>
+        <p:txBody>
+          <a:bodyPr rtlCol="0" anchor="ctr"/>
+          <a:lstStyle/>
+          <a:p>
+            <a:pPr algn="ctr"/>
+          </a:p>
+        </p:txBody>
+      </p:sp>
+      <p:sp>
+        <p:nvSpPr>
+          <p:cNvPr id="11" name="Rounded Rectangle 10"/>
+          <p:cNvSpPr/>
+          <p:nvPr/>
+        </p:nvSpPr>
+        <p:spPr>
+          <a:xfrm>
+            <a:off x="7635240" y="4343400"/>
+            <a:ext cx="3017520" cy="1005840"/>
+          </a:xfrm>
+          <a:prstGeom prst="roundRect">
+            <a:avLst/>
+          </a:prstGeom>
+          <a:solidFill>
+            <a:srgbClr val="EFF2FB"/>
+          </a:solidFill>
+          <a:ln w="15875">
+            <a:solidFill>
+              <a:srgbClr val="2563EB"/>
+            </a:solidFill>
+          </a:ln>
+          <a:effectLst/>
+        </p:spPr>
+        <p:style>
+          <a:lnRef idx="1">
+            <a:schemeClr val="accent1"/>
+          </a:lnRef>
+          <a:fillRef idx="3">
+            <a:schemeClr val="accent1"/>
+          </a:fillRef>
+          <a:effectRef idx="2">
+            <a:schemeClr val="accent1"/>
+          </a:effectRef>
+          <a:fontRef idx="minor">
+            <a:schemeClr val="lt1"/>
+          </a:fontRef>
+        </p:style>
+        <p:txBody>
+          <a:bodyPr rtlCol="0" anchor="ctr" wrap="square" lIns="73152" rIns="73152" tIns="27432" bIns="27432"/>
+          <a:lstStyle/>
+          <a:p>
+            <a:pPr algn="ctr"/>
+            <a:r>
+              <a:rPr sz="1400" b="1" i="0">
+                <a:solidFill>
+                  <a:srgbClr val="1F2937"/>
+                </a:solidFill>
+                <a:latin typeface="Calibri"/>
+              </a:rPr>
+              <a:t>Line graph  L(G)</a:t>
+            </a:r>
+          </a:p>
+          <a:p>
+            <a:pPr algn="ctr">
+              <a:spcBef>
+                <a:spcPts val="200"/>
+              </a:spcBef>
             </a:pPr>
             <a:r>
-              <a:rPr sz="2100" b="0" i="0">
-                <a:solidFill>
-                  <a:srgbClr val="374151"/>
-                </a:solidFill>
-                <a:latin typeface="Calibri"/>
-              </a:rPr>
-              <a:t>•  Line graph L(G) + curvature-based pair-communities.</a:t>
-            </a:r>
-          </a:p>
-          <a:p>
-            <a:pPr>
-              <a:spcAft>
-                <a:spcPts val="1200"/>
-              </a:spcAft>
+              <a:rPr sz="1000" b="0" i="0">
+                <a:solidFill>
+                  <a:srgbClr val="9CA3AF"/>
+                </a:solidFill>
+                <a:latin typeface="Calibri"/>
+              </a:rPr>
+              <a:t>curvature pair-communities</a:t>
+            </a:r>
+          </a:p>
+        </p:txBody>
+      </p:sp>
+      <p:sp>
+        <p:nvSpPr>
+          <p:cNvPr id="12" name="Rounded Rectangle 11"/>
+          <p:cNvSpPr/>
+          <p:nvPr/>
+        </p:nvSpPr>
+        <p:spPr>
+          <a:xfrm>
+            <a:off x="4206240" y="4343400"/>
+            <a:ext cx="3017520" cy="1005840"/>
+          </a:xfrm>
+          <a:prstGeom prst="roundRect">
+            <a:avLst/>
+          </a:prstGeom>
+          <a:solidFill>
+            <a:srgbClr val="EFF2FB"/>
+          </a:solidFill>
+          <a:ln w="15875">
+            <a:solidFill>
+              <a:srgbClr val="2563EB"/>
+            </a:solidFill>
+          </a:ln>
+          <a:effectLst/>
+        </p:spPr>
+        <p:style>
+          <a:lnRef idx="1">
+            <a:schemeClr val="accent1"/>
+          </a:lnRef>
+          <a:fillRef idx="3">
+            <a:schemeClr val="accent1"/>
+          </a:fillRef>
+          <a:effectRef idx="2">
+            <a:schemeClr val="accent1"/>
+          </a:effectRef>
+          <a:fontRef idx="minor">
+            <a:schemeClr val="lt1"/>
+          </a:fontRef>
+        </p:style>
+        <p:txBody>
+          <a:bodyPr rtlCol="0" anchor="ctr" wrap="square" lIns="73152" rIns="73152" tIns="27432" bIns="27432"/>
+          <a:lstStyle/>
+          <a:p>
+            <a:pPr algn="ctr"/>
+            <a:r>
+              <a:rPr sz="1400" b="1" i="0">
+                <a:solidFill>
+                  <a:srgbClr val="1F2937"/>
+                </a:solidFill>
+                <a:latin typeface="Calibri"/>
+              </a:rPr>
+              <a:t>Validation cascade</a:t>
+            </a:r>
+          </a:p>
+          <a:p>
+            <a:pPr algn="ctr">
+              <a:spcBef>
+                <a:spcPts val="200"/>
+              </a:spcBef>
             </a:pPr>
             <a:r>
-              <a:rPr sz="2100" b="0" i="0">
-                <a:solidFill>
-                  <a:srgbClr val="374151"/>
-                </a:solidFill>
-                <a:latin typeface="Calibri"/>
-              </a:rPr>
-              <a:t>•  Structural validation cascade  →  curvature ≠ correlation / degree?</a:t>
-            </a:r>
-          </a:p>
-          <a:p>
-            <a:pPr>
-              <a:spcAft>
-                <a:spcPts val="1200"/>
-              </a:spcAft>
+              <a:rPr sz="1000" b="0" i="0">
+                <a:solidFill>
+                  <a:srgbClr val="9CA3AF"/>
+                </a:solidFill>
+                <a:latin typeface="Calibri"/>
+              </a:rPr>
+              <a:t>curvature ≠ corr / degree?</a:t>
+            </a:r>
+          </a:p>
+        </p:txBody>
+      </p:sp>
+      <p:sp>
+        <p:nvSpPr>
+          <p:cNvPr id="13" name="Rounded Rectangle 12"/>
+          <p:cNvSpPr/>
+          <p:nvPr/>
+        </p:nvSpPr>
+        <p:spPr>
+          <a:xfrm>
+            <a:off x="777240" y="4343400"/>
+            <a:ext cx="3017520" cy="1005840"/>
+          </a:xfrm>
+          <a:prstGeom prst="roundRect">
+            <a:avLst/>
+          </a:prstGeom>
+          <a:solidFill>
+            <a:srgbClr val="2563EB"/>
+          </a:solidFill>
+          <a:ln w="15875">
+            <a:solidFill>
+              <a:srgbClr val="2563EB"/>
+            </a:solidFill>
+          </a:ln>
+          <a:effectLst/>
+        </p:spPr>
+        <p:style>
+          <a:lnRef idx="1">
+            <a:schemeClr val="accent1"/>
+          </a:lnRef>
+          <a:fillRef idx="3">
+            <a:schemeClr val="accent1"/>
+          </a:fillRef>
+          <a:effectRef idx="2">
+            <a:schemeClr val="accent1"/>
+          </a:effectRef>
+          <a:fontRef idx="minor">
+            <a:schemeClr val="lt1"/>
+          </a:fontRef>
+        </p:style>
+        <p:txBody>
+          <a:bodyPr rtlCol="0" anchor="ctr" wrap="square" lIns="73152" rIns="73152" tIns="27432" bIns="27432"/>
+          <a:lstStyle/>
+          <a:p>
+            <a:pPr algn="ctr"/>
+            <a:r>
+              <a:rPr sz="1400" b="1" i="0">
+                <a:solidFill>
+                  <a:srgbClr val="FFFFFF"/>
+                </a:solidFill>
+                <a:latin typeface="Calibri"/>
+              </a:rPr>
+              <a:t>Structurally isolated pairs</a:t>
+            </a:r>
+          </a:p>
+          <a:p>
+            <a:pPr algn="ctr">
+              <a:spcBef>
+                <a:spcPts val="200"/>
+              </a:spcBef>
             </a:pPr>
             <a:r>
-              <a:rPr sz="2100" b="0" i="0">
-                <a:solidFill>
-                  <a:srgbClr val="374151"/>
-                </a:solidFill>
-                <a:latin typeface="Calibri"/>
-              </a:rPr>
-              <a:t>•  Select &amp; report the structurally isolated pairs.</a:t>
-            </a:r>
-          </a:p>
-        </p:txBody>
-      </p:sp>
-      <p:sp>
-        <p:nvSpPr>
-          <p:cNvPr id="5" name="TextBox 4"/>
+              <a:rPr sz="1000" b="0" i="0">
+                <a:solidFill>
+                  <a:srgbClr val="E5EDFF"/>
+                </a:solidFill>
+                <a:latin typeface="Calibri"/>
+              </a:rPr>
+              <a:t>the structural output</a:t>
+            </a:r>
+          </a:p>
+        </p:txBody>
+      </p:sp>
+      <p:sp>
+        <p:nvSpPr>
+          <p:cNvPr id="14" name="Left Arrow 13"/>
+          <p:cNvSpPr/>
+          <p:nvPr/>
+        </p:nvSpPr>
+        <p:spPr>
+          <a:xfrm>
+            <a:off x="7251192" y="4690872"/>
+            <a:ext cx="384048" cy="310896"/>
+          </a:xfrm>
+          <a:prstGeom prst="leftArrow">
+            <a:avLst/>
+          </a:prstGeom>
+          <a:solidFill>
+            <a:srgbClr val="2563EB"/>
+          </a:solidFill>
+          <a:ln>
+            <a:noFill/>
+          </a:ln>
+          <a:effectLst/>
+        </p:spPr>
+        <p:style>
+          <a:lnRef idx="1">
+            <a:schemeClr val="accent1"/>
+          </a:lnRef>
+          <a:fillRef idx="3">
+            <a:schemeClr val="accent1"/>
+          </a:fillRef>
+          <a:effectRef idx="2">
+            <a:schemeClr val="accent1"/>
+          </a:effectRef>
+          <a:fontRef idx="minor">
+            <a:schemeClr val="lt1"/>
+          </a:fontRef>
+        </p:style>
+        <p:txBody>
+          <a:bodyPr rtlCol="0" anchor="ctr"/>
+          <a:lstStyle/>
+          <a:p>
+            <a:pPr algn="ctr"/>
+          </a:p>
+        </p:txBody>
+      </p:sp>
+      <p:sp>
+        <p:nvSpPr>
+          <p:cNvPr id="15" name="Left Arrow 14"/>
+          <p:cNvSpPr/>
+          <p:nvPr/>
+        </p:nvSpPr>
+        <p:spPr>
+          <a:xfrm>
+            <a:off x="3822191" y="4690872"/>
+            <a:ext cx="384048" cy="310896"/>
+          </a:xfrm>
+          <a:prstGeom prst="leftArrow">
+            <a:avLst/>
+          </a:prstGeom>
+          <a:solidFill>
+            <a:srgbClr val="2563EB"/>
+          </a:solidFill>
+          <a:ln>
+            <a:noFill/>
+          </a:ln>
+          <a:effectLst/>
+        </p:spPr>
+        <p:style>
+          <a:lnRef idx="1">
+            <a:schemeClr val="accent1"/>
+          </a:lnRef>
+          <a:fillRef idx="3">
+            <a:schemeClr val="accent1"/>
+          </a:fillRef>
+          <a:effectRef idx="2">
+            <a:schemeClr val="accent1"/>
+          </a:effectRef>
+          <a:fontRef idx="minor">
+            <a:schemeClr val="lt1"/>
+          </a:fontRef>
+        </p:style>
+        <p:txBody>
+          <a:bodyPr rtlCol="0" anchor="ctr"/>
+          <a:lstStyle/>
+          <a:p>
+            <a:pPr algn="ctr"/>
+          </a:p>
+        </p:txBody>
+      </p:sp>
+      <p:sp>
+        <p:nvSpPr>
+          <p:cNvPr id="16" name="TextBox 15"/>
           <p:cNvSpPr txBox="1"/>
           <p:nvPr/>
         </p:nvSpPr>
@@ -6844,7 +7721,7 @@
       </p:sp>
       <p:sp>
         <p:nvSpPr>
-          <p:cNvPr id="6" name="TextBox 5"/>
+          <p:cNvPr id="17" name="TextBox 16"/>
           <p:cNvSpPr txBox="1"/>
           <p:nvPr/>
         </p:nvSpPr>

</xml_diff>

<commit_message>
Deck + report: state the lead-lag time horizons explicitly
Step 1 slide now carries a "Horizons tried" call-out, and REPORT §4.2 spells it
out: daily τ = 1-5 trading days; intraday τ = 1-3 x 30-min bars (30/60/90 min,
within-day). No weekly or monthly horizons were tested — intraday 30-min is the
headline, daily is the robustness check. (Generalized the call-out box to take a
custom label.)

Co-Authored-By: Claude Opus 4.8 (1M context) <noreply@anthropic.com>
</commit_message>
<xml_diff>
--- a/slides/Ricci_Curvature_LeadLag.pptx
+++ b/slides/Ricci_Curvature_LeadLag.pptx
@@ -6543,7 +6543,7 @@
               <a:t>Research question   </a:t>
             </a:r>
             <a:r>
-              <a:rPr sz="1800" b="1" i="0">
+              <a:rPr sz="1700" b="1" i="0">
                 <a:solidFill>
                   <a:srgbClr val="1F2937"/>
                 </a:solidFill>
@@ -7859,7 +7859,7 @@
         <p:spPr>
           <a:xfrm>
             <a:off x="777240" y="1783080"/>
-            <a:ext cx="10607040" cy="3657600"/>
+            <a:ext cx="10607040" cy="2743200"/>
           </a:xfrm>
           <a:prstGeom prst="rect">
             <a:avLst/>
@@ -7932,30 +7932,78 @@
                 </a:solidFill>
                 <a:latin typeface="Calibri"/>
               </a:rPr>
-              <a:t>–  Antisymmetric → each pair is a directed edge in the sign direction.</a:t>
-            </a:r>
-          </a:p>
-          <a:p>
-            <a:pPr>
-              <a:spcAft>
-                <a:spcPts val="1200"/>
-              </a:spcAft>
-            </a:pPr>
-            <a:r>
-              <a:rPr sz="2100" b="0" i="0">
-                <a:solidFill>
-                  <a:srgbClr val="374151"/>
-                </a:solidFill>
-                <a:latin typeface="Calibri"/>
-              </a:rPr>
-              <a:t>•  Intraday: within-day estimator (lag pairs never cross the overnight gap).</a:t>
-            </a:r>
-          </a:p>
-        </p:txBody>
-      </p:sp>
-      <p:sp>
-        <p:nvSpPr>
-          <p:cNvPr id="5" name="TextBox 4"/>
+              <a:t>–  τ* = the lag of peak signal, picked per pair; intraday uses a within-day estimator (no overnight gap).</a:t>
+            </a:r>
+          </a:p>
+        </p:txBody>
+      </p:sp>
+      <p:sp>
+        <p:nvSpPr>
+          <p:cNvPr id="5" name="Rounded Rectangle 4"/>
+          <p:cNvSpPr/>
+          <p:nvPr/>
+        </p:nvSpPr>
+        <p:spPr>
+          <a:xfrm>
+            <a:off x="777240" y="4983480"/>
+            <a:ext cx="10607040" cy="1051560"/>
+          </a:xfrm>
+          <a:prstGeom prst="roundRect">
+            <a:avLst/>
+          </a:prstGeom>
+          <a:solidFill>
+            <a:srgbClr val="EFF2FB"/>
+          </a:solidFill>
+          <a:ln w="15875">
+            <a:solidFill>
+              <a:srgbClr val="2563EB"/>
+            </a:solidFill>
+          </a:ln>
+          <a:effectLst/>
+        </p:spPr>
+        <p:style>
+          <a:lnRef idx="1">
+            <a:schemeClr val="accent1"/>
+          </a:lnRef>
+          <a:fillRef idx="3">
+            <a:schemeClr val="accent1"/>
+          </a:fillRef>
+          <a:effectRef idx="2">
+            <a:schemeClr val="accent1"/>
+          </a:effectRef>
+          <a:fontRef idx="minor">
+            <a:schemeClr val="lt1"/>
+          </a:fontRef>
+        </p:style>
+        <p:txBody>
+          <a:bodyPr rtlCol="0" anchor="ctr" wrap="square" lIns="228600" rIns="228600"/>
+          <a:lstStyle/>
+          <a:p>
+            <a:pPr algn="ctr"/>
+            <a:r>
+              <a:rPr sz="1400" b="1" i="0">
+                <a:solidFill>
+                  <a:srgbClr val="2563EB"/>
+                </a:solidFill>
+                <a:latin typeface="Calibri"/>
+              </a:rPr>
+              <a:t>Horizons tried   </a:t>
+            </a:r>
+            <a:r>
+              <a:rPr sz="1700" b="1" i="0">
+                <a:solidFill>
+                  <a:srgbClr val="1F2937"/>
+                </a:solidFill>
+                <a:latin typeface="Calibri"/>
+              </a:rPr>
+              <a:t>Daily: τ = 1–5 trading days   ·   Intraday: τ = 1–3 × 30-min bars (30–90 min).   No weekly / monthly.</a:t>
+            </a:r>
+          </a:p>
+        </p:txBody>
+      </p:sp>
+      <p:sp>
+        <p:nvSpPr>
+          <p:cNvPr id="6" name="TextBox 5"/>
           <p:cNvSpPr txBox="1"/>
           <p:nvPr/>
         </p:nvSpPr>
@@ -7989,7 +8037,7 @@
       </p:sp>
       <p:sp>
         <p:nvSpPr>
-          <p:cNvPr id="6" name="TextBox 5"/>
+          <p:cNvPr id="7" name="TextBox 6"/>
           <p:cNvSpPr txBox="1"/>
           <p:nvPr/>
         </p:nvSpPr>

</xml_diff>

<commit_message>
Deck: dedicated "Two regimes — two time horizons" slide
The time horizons were only a one-liner on the methods slide; promote them to a
dedicated side-by-side slide (intraday headline vs daily robustness) with
frequency / lead-lag horizon τ / universe / window, horizon row highlighted.
Removed the now-redundant horizon call-out from Step 1 (points to the new slide).
Now 17 slides. (Outlook slide thanks-removal already shipped in a378bc7/earlier.)

Co-Authored-By: Claude Opus 4.8 (1M context) <noreply@anthropic.com>
</commit_message>
<xml_diff>
--- a/slides/Ricci_Curvature_LeadLag.pptx
+++ b/slides/Ricci_Curvature_LeadLag.pptx
@@ -21,6 +21,7 @@
     <p:sldId id="269" r:id="rId20"/>
     <p:sldId id="270" r:id="rId21"/>
     <p:sldId id="271" r:id="rId22"/>
+    <p:sldId id="272" r:id="rId23"/>
   </p:sldIdLst>
   <p:sldSz cx="12191695" cy="6858000" type="screen4x3"/>
   <p:notesSz cx="6858000" cy="9144000"/>
@@ -3841,14 +3842,48 @@
       <p:grpSpPr/>
       <p:sp>
         <p:nvSpPr>
-          <p:cNvPr id="2" name="Rectangle 1"/>
+          <p:cNvPr id="2" name="TextBox 1"/>
+          <p:cNvSpPr txBox="1"/>
+          <p:nvPr/>
+        </p:nvSpPr>
+        <p:spPr>
+          <a:xfrm>
+            <a:off x="777240" y="640080"/>
+            <a:ext cx="10607040" cy="822960"/>
+          </a:xfrm>
+          <a:prstGeom prst="rect">
+            <a:avLst/>
+          </a:prstGeom>
+          <a:noFill/>
+        </p:spPr>
+        <p:txBody>
+          <a:bodyPr wrap="square">
+            <a:spAutoFit/>
+          </a:bodyPr>
+          <a:lstStyle/>
+          <a:p>
+            <a:r>
+              <a:rPr sz="3000" b="1" i="0">
+                <a:solidFill>
+                  <a:srgbClr val="1F2937"/>
+                </a:solidFill>
+                <a:latin typeface="Calibri"/>
+              </a:rPr>
+              <a:t>Two regimes — two time horizons</a:t>
+            </a:r>
+          </a:p>
+        </p:txBody>
+      </p:sp>
+      <p:sp>
+        <p:nvSpPr>
+          <p:cNvPr id="3" name="Rectangle 2"/>
           <p:cNvSpPr/>
           <p:nvPr/>
         </p:nvSpPr>
         <p:spPr>
           <a:xfrm>
-            <a:off x="777240" y="2743200"/>
-            <a:ext cx="1645920" cy="50800"/>
+            <a:off x="777240" y="1417320"/>
+            <a:ext cx="1828800" cy="38100"/>
           </a:xfrm>
           <a:prstGeom prst="rect">
             <a:avLst/>
@@ -3885,14 +3920,14 @@
       </p:sp>
       <p:sp>
         <p:nvSpPr>
-          <p:cNvPr id="3" name="TextBox 2"/>
+          <p:cNvPr id="4" name="TextBox 3"/>
           <p:cNvSpPr txBox="1"/>
           <p:nvPr/>
         </p:nvSpPr>
         <p:spPr>
           <a:xfrm>
-            <a:off x="777240" y="2926080"/>
-            <a:ext cx="10607040" cy="1463040"/>
+            <a:off x="777240" y="1783080"/>
+            <a:ext cx="10607040" cy="640080"/>
           </a:xfrm>
           <a:prstGeom prst="rect">
             <a:avLst/>
@@ -3906,29 +3941,498 @@
           <a:lstStyle/>
           <a:p>
             <a:r>
-              <a:rPr sz="1600" b="1" i="0">
+              <a:rPr sz="1800" b="0" i="1">
                 <a:solidFill>
                   <a:srgbClr val="2563EB"/>
                 </a:solidFill>
                 <a:latin typeface="Calibri"/>
               </a:rPr>
-              <a:t>RESULTS</a:t>
-            </a:r>
-          </a:p>
-          <a:p>
-            <a:pPr>
-              <a:spcBef>
-                <a:spcPts val="600"/>
-              </a:spcBef>
-            </a:pPr>
-            <a:r>
-              <a:rPr sz="3400" b="1" i="0">
-                <a:solidFill>
-                  <a:srgbClr val="1F2937"/>
-                </a:solidFill>
-                <a:latin typeface="Calibri"/>
-              </a:rPr>
-              <a:t>The structural result holds.</a:t>
+              <a:t>The same method, run at two horizons — no weekly or monthly.</a:t>
+            </a:r>
+          </a:p>
+        </p:txBody>
+      </p:sp>
+      <p:graphicFrame>
+        <p:nvGraphicFramePr>
+          <p:cNvPr id="5" name="Table 4"/>
+          <p:cNvGraphicFramePr>
+            <a:graphicFrameLocks noGrp="1"/>
+          </p:cNvGraphicFramePr>
+          <p:nvPr/>
+        </p:nvGraphicFramePr>
+        <p:xfrm>
+          <a:off x="777240" y="2377440"/>
+          <a:ext cx="10607040" cy="2286000"/>
+        </p:xfrm>
+        <a:graphic>
+          <a:graphicData uri="http://schemas.openxmlformats.org/drawingml/2006/table">
+            <a:tbl>
+              <a:tblPr firstRow="1" bandRow="1">
+                <a:tableStyleId>{5C22544A-7EE6-4342-B048-85BDC9FD1C3A}</a:tableStyleId>
+              </a:tblPr>
+              <a:tblGrid>
+                <a:gridCol w="2651760"/>
+                <a:gridCol w="4114800"/>
+                <a:gridCol w="3840480"/>
+              </a:tblGrid>
+              <a:tr h="457200">
+                <a:tc>
+                  <a:txBody>
+                    <a:bodyPr/>
+                    <a:lstStyle/>
+                    <a:p>
+                      <a:pPr algn="l"/>
+                      <a:r>
+                        <a:rPr sz="1500" b="1" i="0">
+                          <a:solidFill>
+                            <a:srgbClr val="FFFFFF"/>
+                          </a:solidFill>
+                          <a:latin typeface="Calibri"/>
+                        </a:rPr>
+                        <a:t/>
+                      </a:r>
+                    </a:p>
+                  </a:txBody>
+                  <a:tcPr anchor="ctr">
+                    <a:solidFill>
+                      <a:srgbClr val="2563EB"/>
+                    </a:solidFill>
+                  </a:tcPr>
+                </a:tc>
+                <a:tc>
+                  <a:txBody>
+                    <a:bodyPr/>
+                    <a:lstStyle/>
+                    <a:p>
+                      <a:pPr algn="ctr"/>
+                      <a:r>
+                        <a:rPr sz="1500" b="1" i="0">
+                          <a:solidFill>
+                            <a:srgbClr val="FFFFFF"/>
+                          </a:solidFill>
+                          <a:latin typeface="Calibri"/>
+                        </a:rPr>
+                        <a:t>Intraday  (headline)</a:t>
+                      </a:r>
+                    </a:p>
+                  </a:txBody>
+                  <a:tcPr anchor="ctr">
+                    <a:solidFill>
+                      <a:srgbClr val="2563EB"/>
+                    </a:solidFill>
+                  </a:tcPr>
+                </a:tc>
+                <a:tc>
+                  <a:txBody>
+                    <a:bodyPr/>
+                    <a:lstStyle/>
+                    <a:p>
+                      <a:pPr algn="ctr"/>
+                      <a:r>
+                        <a:rPr sz="1500" b="1" i="0">
+                          <a:solidFill>
+                            <a:srgbClr val="FFFFFF"/>
+                          </a:solidFill>
+                          <a:latin typeface="Calibri"/>
+                        </a:rPr>
+                        <a:t>Daily  (robustness)</a:t>
+                      </a:r>
+                    </a:p>
+                  </a:txBody>
+                  <a:tcPr anchor="ctr">
+                    <a:solidFill>
+                      <a:srgbClr val="2563EB"/>
+                    </a:solidFill>
+                  </a:tcPr>
+                </a:tc>
+              </a:tr>
+              <a:tr h="457200">
+                <a:tc>
+                  <a:txBody>
+                    <a:bodyPr/>
+                    <a:lstStyle/>
+                    <a:p>
+                      <a:pPr algn="l"/>
+                      <a:r>
+                        <a:rPr sz="1400" b="0" i="0">
+                          <a:solidFill>
+                            <a:srgbClr val="374151"/>
+                          </a:solidFill>
+                          <a:latin typeface="Calibri"/>
+                        </a:rPr>
+                        <a:t>Frequency</a:t>
+                      </a:r>
+                    </a:p>
+                  </a:txBody>
+                  <a:tcPr anchor="ctr">
+                    <a:solidFill>
+                      <a:srgbClr val="FFFFFF"/>
+                    </a:solidFill>
+                  </a:tcPr>
+                </a:tc>
+                <a:tc>
+                  <a:txBody>
+                    <a:bodyPr/>
+                    <a:lstStyle/>
+                    <a:p>
+                      <a:pPr algn="ctr"/>
+                      <a:r>
+                        <a:rPr sz="1400" b="0" i="0">
+                          <a:solidFill>
+                            <a:srgbClr val="374151"/>
+                          </a:solidFill>
+                          <a:latin typeface="Calibri"/>
+                        </a:rPr>
+                        <a:t>30-min bars</a:t>
+                      </a:r>
+                    </a:p>
+                  </a:txBody>
+                  <a:tcPr anchor="ctr">
+                    <a:solidFill>
+                      <a:srgbClr val="FFFFFF"/>
+                    </a:solidFill>
+                  </a:tcPr>
+                </a:tc>
+                <a:tc>
+                  <a:txBody>
+                    <a:bodyPr/>
+                    <a:lstStyle/>
+                    <a:p>
+                      <a:pPr algn="ctr"/>
+                      <a:r>
+                        <a:rPr sz="1400" b="0" i="0">
+                          <a:solidFill>
+                            <a:srgbClr val="374151"/>
+                          </a:solidFill>
+                          <a:latin typeface="Calibri"/>
+                        </a:rPr>
+                        <a:t>close-to-close daily</a:t>
+                      </a:r>
+                    </a:p>
+                  </a:txBody>
+                  <a:tcPr anchor="ctr">
+                    <a:solidFill>
+                      <a:srgbClr val="FFFFFF"/>
+                    </a:solidFill>
+                  </a:tcPr>
+                </a:tc>
+              </a:tr>
+              <a:tr h="457200">
+                <a:tc>
+                  <a:txBody>
+                    <a:bodyPr/>
+                    <a:lstStyle/>
+                    <a:p>
+                      <a:pPr algn="l"/>
+                      <a:r>
+                        <a:rPr sz="1400" b="1" i="0">
+                          <a:solidFill>
+                            <a:srgbClr val="1F2937"/>
+                          </a:solidFill>
+                          <a:latin typeface="Calibri"/>
+                        </a:rPr>
+                        <a:t>Lead-lag horizon  τ</a:t>
+                      </a:r>
+                    </a:p>
+                  </a:txBody>
+                  <a:tcPr anchor="ctr">
+                    <a:solidFill>
+                      <a:srgbClr val="EFF2FB"/>
+                    </a:solidFill>
+                  </a:tcPr>
+                </a:tc>
+                <a:tc>
+                  <a:txBody>
+                    <a:bodyPr/>
+                    <a:lstStyle/>
+                    <a:p>
+                      <a:pPr algn="ctr"/>
+                      <a:r>
+                        <a:rPr sz="1400" b="1" i="0">
+                          <a:solidFill>
+                            <a:srgbClr val="1F2937"/>
+                          </a:solidFill>
+                          <a:latin typeface="Calibri"/>
+                        </a:rPr>
+                        <a:t>1–3 bars  =  30 / 60 / 90 min</a:t>
+                      </a:r>
+                    </a:p>
+                  </a:txBody>
+                  <a:tcPr anchor="ctr">
+                    <a:solidFill>
+                      <a:srgbClr val="EFF2FB"/>
+                    </a:solidFill>
+                  </a:tcPr>
+                </a:tc>
+                <a:tc>
+                  <a:txBody>
+                    <a:bodyPr/>
+                    <a:lstStyle/>
+                    <a:p>
+                      <a:pPr algn="ctr"/>
+                      <a:r>
+                        <a:rPr sz="1400" b="1" i="0">
+                          <a:solidFill>
+                            <a:srgbClr val="1F2937"/>
+                          </a:solidFill>
+                          <a:latin typeface="Calibri"/>
+                        </a:rPr>
+                        <a:t>1–5 trading days</a:t>
+                      </a:r>
+                    </a:p>
+                  </a:txBody>
+                  <a:tcPr anchor="ctr">
+                    <a:solidFill>
+                      <a:srgbClr val="EFF2FB"/>
+                    </a:solidFill>
+                  </a:tcPr>
+                </a:tc>
+              </a:tr>
+              <a:tr h="457200">
+                <a:tc>
+                  <a:txBody>
+                    <a:bodyPr/>
+                    <a:lstStyle/>
+                    <a:p>
+                      <a:pPr algn="l"/>
+                      <a:r>
+                        <a:rPr sz="1400" b="0" i="0">
+                          <a:solidFill>
+                            <a:srgbClr val="374151"/>
+                          </a:solidFill>
+                          <a:latin typeface="Calibri"/>
+                        </a:rPr>
+                        <a:t>Universe</a:t>
+                      </a:r>
+                    </a:p>
+                  </a:txBody>
+                  <a:tcPr anchor="ctr">
+                    <a:solidFill>
+                      <a:srgbClr val="FFFFFF"/>
+                    </a:solidFill>
+                  </a:tcPr>
+                </a:tc>
+                <a:tc>
+                  <a:txBody>
+                    <a:bodyPr/>
+                    <a:lstStyle/>
+                    <a:p>
+                      <a:pPr algn="ctr"/>
+                      <a:r>
+                        <a:rPr sz="1400" b="0" i="0">
+                          <a:solidFill>
+                            <a:srgbClr val="374151"/>
+                          </a:solidFill>
+                          <a:latin typeface="Calibri"/>
+                        </a:rPr>
+                        <a:t>~155 large-caps</a:t>
+                      </a:r>
+                    </a:p>
+                  </a:txBody>
+                  <a:tcPr anchor="ctr">
+                    <a:solidFill>
+                      <a:srgbClr val="FFFFFF"/>
+                    </a:solidFill>
+                  </a:tcPr>
+                </a:tc>
+                <a:tc>
+                  <a:txBody>
+                    <a:bodyPr/>
+                    <a:lstStyle/>
+                    <a:p>
+                      <a:pPr algn="ctr"/>
+                      <a:r>
+                        <a:rPr sz="1400" b="0" i="0">
+                          <a:solidFill>
+                            <a:srgbClr val="374151"/>
+                          </a:solidFill>
+                          <a:latin typeface="Calibri"/>
+                        </a:rPr>
+                        <a:t>S&amp;P 500 (point-in-time)</a:t>
+                      </a:r>
+                    </a:p>
+                  </a:txBody>
+                  <a:tcPr anchor="ctr">
+                    <a:solidFill>
+                      <a:srgbClr val="FFFFFF"/>
+                    </a:solidFill>
+                  </a:tcPr>
+                </a:tc>
+              </a:tr>
+              <a:tr h="457200">
+                <a:tc>
+                  <a:txBody>
+                    <a:bodyPr/>
+                    <a:lstStyle/>
+                    <a:p>
+                      <a:pPr algn="l"/>
+                      <a:r>
+                        <a:rPr sz="1400" b="0" i="0">
+                          <a:solidFill>
+                            <a:srgbClr val="374151"/>
+                          </a:solidFill>
+                          <a:latin typeface="Calibri"/>
+                        </a:rPr>
+                        <a:t>Window</a:t>
+                      </a:r>
+                    </a:p>
+                  </a:txBody>
+                  <a:tcPr anchor="ctr">
+                    <a:solidFill>
+                      <a:srgbClr val="EFF2FB"/>
+                    </a:solidFill>
+                  </a:tcPr>
+                </a:tc>
+                <a:tc>
+                  <a:txBody>
+                    <a:bodyPr/>
+                    <a:lstStyle/>
+                    <a:p>
+                      <a:pPr algn="ctr"/>
+                      <a:r>
+                        <a:rPr sz="1400" b="0" i="0">
+                          <a:solidFill>
+                            <a:srgbClr val="374151"/>
+                          </a:solidFill>
+                          <a:latin typeface="Calibri"/>
+                        </a:rPr>
+                        <a:t>full-year 2019</a:t>
+                      </a:r>
+                    </a:p>
+                  </a:txBody>
+                  <a:tcPr anchor="ctr">
+                    <a:solidFill>
+                      <a:srgbClr val="EFF2FB"/>
+                    </a:solidFill>
+                  </a:tcPr>
+                </a:tc>
+                <a:tc>
+                  <a:txBody>
+                    <a:bodyPr/>
+                    <a:lstStyle/>
+                    <a:p>
+                      <a:pPr algn="ctr"/>
+                      <a:r>
+                        <a:rPr sz="1400" b="0" i="0">
+                          <a:solidFill>
+                            <a:srgbClr val="374151"/>
+                          </a:solidFill>
+                          <a:latin typeface="Calibri"/>
+                        </a:rPr>
+                        <a:t>2000–2024</a:t>
+                      </a:r>
+                    </a:p>
+                  </a:txBody>
+                  <a:tcPr anchor="ctr">
+                    <a:solidFill>
+                      <a:srgbClr val="EFF2FB"/>
+                    </a:solidFill>
+                  </a:tcPr>
+                </a:tc>
+              </a:tr>
+            </a:tbl>
+          </a:graphicData>
+        </a:graphic>
+      </p:graphicFrame>
+      <p:sp>
+        <p:nvSpPr>
+          <p:cNvPr id="6" name="TextBox 5"/>
+          <p:cNvSpPr txBox="1"/>
+          <p:nvPr/>
+        </p:nvSpPr>
+        <p:spPr>
+          <a:xfrm>
+            <a:off x="777240" y="5715000"/>
+            <a:ext cx="10607040" cy="640080"/>
+          </a:xfrm>
+          <a:prstGeom prst="rect">
+            <a:avLst/>
+          </a:prstGeom>
+          <a:noFill/>
+        </p:spPr>
+        <p:txBody>
+          <a:bodyPr wrap="square">
+            <a:spAutoFit/>
+          </a:bodyPr>
+          <a:lstStyle/>
+          <a:p>
+            <a:r>
+              <a:rPr sz="1400" b="0" i="1">
+                <a:solidFill>
+                  <a:srgbClr val="9CA3AF"/>
+                </a:solidFill>
+                <a:latin typeface="Calibri"/>
+              </a:rPr>
+              <a:t>Intraday is where lead-lag is strongest, so it carries the headline; daily is the robustness check.</a:t>
+            </a:r>
+          </a:p>
+        </p:txBody>
+      </p:sp>
+      <p:sp>
+        <p:nvSpPr>
+          <p:cNvPr id="7" name="TextBox 6"/>
+          <p:cNvSpPr txBox="1"/>
+          <p:nvPr/>
+        </p:nvSpPr>
+        <p:spPr>
+          <a:xfrm>
+            <a:off x="777240" y="6355080"/>
+            <a:ext cx="10607040" cy="365760"/>
+          </a:xfrm>
+          <a:prstGeom prst="rect">
+            <a:avLst/>
+          </a:prstGeom>
+          <a:noFill/>
+        </p:spPr>
+        <p:txBody>
+          <a:bodyPr wrap="square">
+            <a:spAutoFit/>
+          </a:bodyPr>
+          <a:lstStyle/>
+          <a:p>
+            <a:r>
+              <a:rPr sz="1100" b="0" i="0">
+                <a:solidFill>
+                  <a:srgbClr val="9CA3AF"/>
+                </a:solidFill>
+                <a:latin typeface="Calibri"/>
+              </a:rPr>
+              <a:t>What I did</a:t>
+            </a:r>
+          </a:p>
+        </p:txBody>
+      </p:sp>
+      <p:sp>
+        <p:nvSpPr>
+          <p:cNvPr id="8" name="TextBox 7"/>
+          <p:cNvSpPr txBox="1"/>
+          <p:nvPr/>
+        </p:nvSpPr>
+        <p:spPr>
+          <a:xfrm>
+            <a:off x="10789920" y="6355080"/>
+            <a:ext cx="1280160" cy="365760"/>
+          </a:xfrm>
+          <a:prstGeom prst="rect">
+            <a:avLst/>
+          </a:prstGeom>
+          <a:noFill/>
+        </p:spPr>
+        <p:txBody>
+          <a:bodyPr wrap="square">
+            <a:spAutoFit/>
+          </a:bodyPr>
+          <a:lstStyle/>
+          <a:p>
+            <a:pPr algn="r"/>
+            <a:r>
+              <a:rPr sz="1100" b="0" i="0">
+                <a:solidFill>
+                  <a:srgbClr val="9CA3AF"/>
+                </a:solidFill>
+                <a:latin typeface="Calibri"/>
+              </a:rPr>
+              <a:t>10</a:t>
             </a:r>
           </a:p>
         </p:txBody>
@@ -3942,6 +4446,118 @@
 </file>
 
 <file path=ppt/slides/slide12.xml><?xml version="1.0" encoding="utf-8"?>
+<p:sld xmlns:a="http://schemas.openxmlformats.org/drawingml/2006/main" xmlns:p="http://schemas.openxmlformats.org/presentationml/2006/main" xmlns:r="http://schemas.openxmlformats.org/officeDocument/2006/relationships">
+  <p:cSld>
+    <p:spTree>
+      <p:nvGrpSpPr>
+        <p:cNvPr id="1" name=""/>
+        <p:cNvGrpSpPr/>
+        <p:nvPr/>
+      </p:nvGrpSpPr>
+      <p:grpSpPr/>
+      <p:sp>
+        <p:nvSpPr>
+          <p:cNvPr id="2" name="Rectangle 1"/>
+          <p:cNvSpPr/>
+          <p:nvPr/>
+        </p:nvSpPr>
+        <p:spPr>
+          <a:xfrm>
+            <a:off x="777240" y="2743200"/>
+            <a:ext cx="1645920" cy="50800"/>
+          </a:xfrm>
+          <a:prstGeom prst="rect">
+            <a:avLst/>
+          </a:prstGeom>
+          <a:solidFill>
+            <a:srgbClr val="2563EB"/>
+          </a:solidFill>
+          <a:ln>
+            <a:noFill/>
+          </a:ln>
+          <a:effectLst/>
+        </p:spPr>
+        <p:style>
+          <a:lnRef idx="1">
+            <a:schemeClr val="accent1"/>
+          </a:lnRef>
+          <a:fillRef idx="3">
+            <a:schemeClr val="accent1"/>
+          </a:fillRef>
+          <a:effectRef idx="2">
+            <a:schemeClr val="accent1"/>
+          </a:effectRef>
+          <a:fontRef idx="minor">
+            <a:schemeClr val="lt1"/>
+          </a:fontRef>
+        </p:style>
+        <p:txBody>
+          <a:bodyPr rtlCol="0" anchor="ctr"/>
+          <a:lstStyle/>
+          <a:p>
+            <a:pPr algn="ctr"/>
+          </a:p>
+        </p:txBody>
+      </p:sp>
+      <p:sp>
+        <p:nvSpPr>
+          <p:cNvPr id="3" name="TextBox 2"/>
+          <p:cNvSpPr txBox="1"/>
+          <p:nvPr/>
+        </p:nvSpPr>
+        <p:spPr>
+          <a:xfrm>
+            <a:off x="777240" y="2926080"/>
+            <a:ext cx="10607040" cy="1463040"/>
+          </a:xfrm>
+          <a:prstGeom prst="rect">
+            <a:avLst/>
+          </a:prstGeom>
+          <a:noFill/>
+        </p:spPr>
+        <p:txBody>
+          <a:bodyPr wrap="square">
+            <a:spAutoFit/>
+          </a:bodyPr>
+          <a:lstStyle/>
+          <a:p>
+            <a:r>
+              <a:rPr sz="1600" b="1" i="0">
+                <a:solidFill>
+                  <a:srgbClr val="2563EB"/>
+                </a:solidFill>
+                <a:latin typeface="Calibri"/>
+              </a:rPr>
+              <a:t>RESULTS</a:t>
+            </a:r>
+          </a:p>
+          <a:p>
+            <a:pPr>
+              <a:spcBef>
+                <a:spcPts val="600"/>
+              </a:spcBef>
+            </a:pPr>
+            <a:r>
+              <a:rPr sz="3400" b="1" i="0">
+                <a:solidFill>
+                  <a:srgbClr val="1F2937"/>
+                </a:solidFill>
+                <a:latin typeface="Calibri"/>
+              </a:rPr>
+              <a:t>The structural result holds.</a:t>
+            </a:r>
+          </a:p>
+        </p:txBody>
+      </p:sp>
+    </p:spTree>
+  </p:cSld>
+  <p:clrMapOvr>
+    <a:masterClrMapping/>
+  </p:clrMapOvr>
+</p:sld>
+</file>
+
+<file path=ppt/slides/slide13.xml><?xml version="1.0" encoding="utf-8"?>
 <p:sld xmlns:a="http://schemas.openxmlformats.org/drawingml/2006/main" xmlns:p="http://schemas.openxmlformats.org/presentationml/2006/main" xmlns:r="http://schemas.openxmlformats.org/officeDocument/2006/relationships">
   <p:cSld>
     <p:spTree>
@@ -4401,7 +5017,7 @@
                 </a:solidFill>
                 <a:latin typeface="Calibri"/>
               </a:rPr>
-              <a:t>11</a:t>
+              <a:t>12</a:t>
             </a:r>
           </a:p>
         </p:txBody>
@@ -4414,7 +5030,7 @@
 </p:sld>
 </file>
 
-<file path=ppt/slides/slide13.xml><?xml version="1.0" encoding="utf-8"?>
+<file path=ppt/slides/slide14.xml><?xml version="1.0" encoding="utf-8"?>
 <p:sld xmlns:a="http://schemas.openxmlformats.org/drawingml/2006/main" xmlns:p="http://schemas.openxmlformats.org/presentationml/2006/main" xmlns:r="http://schemas.openxmlformats.org/officeDocument/2006/relationships">
   <p:cSld>
     <p:spTree>
@@ -4874,308 +5490,6 @@
                 </a:solidFill>
                 <a:latin typeface="Calibri"/>
               </a:rPr>
-              <a:t>12</a:t>
-            </a:r>
-          </a:p>
-        </p:txBody>
-      </p:sp>
-    </p:spTree>
-  </p:cSld>
-  <p:clrMapOvr>
-    <a:masterClrMapping/>
-  </p:clrMapOvr>
-</p:sld>
-</file>
-
-<file path=ppt/slides/slide14.xml><?xml version="1.0" encoding="utf-8"?>
-<p:sld xmlns:a="http://schemas.openxmlformats.org/drawingml/2006/main" xmlns:p="http://schemas.openxmlformats.org/presentationml/2006/main" xmlns:r="http://schemas.openxmlformats.org/officeDocument/2006/relationships">
-  <p:cSld>
-    <p:spTree>
-      <p:nvGrpSpPr>
-        <p:cNvPr id="1" name=""/>
-        <p:cNvGrpSpPr/>
-        <p:nvPr/>
-      </p:nvGrpSpPr>
-      <p:grpSpPr/>
-      <p:sp>
-        <p:nvSpPr>
-          <p:cNvPr id="2" name="TextBox 1"/>
-          <p:cNvSpPr txBox="1"/>
-          <p:nvPr/>
-        </p:nvSpPr>
-        <p:spPr>
-          <a:xfrm>
-            <a:off x="777240" y="640080"/>
-            <a:ext cx="10607040" cy="822960"/>
-          </a:xfrm>
-          <a:prstGeom prst="rect">
-            <a:avLst/>
-          </a:prstGeom>
-          <a:noFill/>
-        </p:spPr>
-        <p:txBody>
-          <a:bodyPr wrap="square">
-            <a:spAutoFit/>
-          </a:bodyPr>
-          <a:lstStyle/>
-          <a:p>
-            <a:r>
-              <a:rPr sz="3000" b="1" i="0">
-                <a:solidFill>
-                  <a:srgbClr val="1F2937"/>
-                </a:solidFill>
-                <a:latin typeface="Calibri"/>
-              </a:rPr>
-              <a:t>The network is triangle-sparse</a:t>
-            </a:r>
-          </a:p>
-        </p:txBody>
-      </p:sp>
-      <p:sp>
-        <p:nvSpPr>
-          <p:cNvPr id="3" name="Rectangle 2"/>
-          <p:cNvSpPr/>
-          <p:nvPr/>
-        </p:nvSpPr>
-        <p:spPr>
-          <a:xfrm>
-            <a:off x="777240" y="1417320"/>
-            <a:ext cx="1828800" cy="38100"/>
-          </a:xfrm>
-          <a:prstGeom prst="rect">
-            <a:avLst/>
-          </a:prstGeom>
-          <a:solidFill>
-            <a:srgbClr val="2563EB"/>
-          </a:solidFill>
-          <a:ln>
-            <a:noFill/>
-          </a:ln>
-          <a:effectLst/>
-        </p:spPr>
-        <p:style>
-          <a:lnRef idx="1">
-            <a:schemeClr val="accent1"/>
-          </a:lnRef>
-          <a:fillRef idx="3">
-            <a:schemeClr val="accent1"/>
-          </a:fillRef>
-          <a:effectRef idx="2">
-            <a:schemeClr val="accent1"/>
-          </a:effectRef>
-          <a:fontRef idx="minor">
-            <a:schemeClr val="lt1"/>
-          </a:fontRef>
-        </p:style>
-        <p:txBody>
-          <a:bodyPr rtlCol="0" anchor="ctr"/>
-          <a:lstStyle/>
-          <a:p>
-            <a:pPr algn="ctr"/>
-          </a:p>
-        </p:txBody>
-      </p:sp>
-      <p:sp>
-        <p:nvSpPr>
-          <p:cNvPr id="4" name="TextBox 3"/>
-          <p:cNvSpPr txBox="1"/>
-          <p:nvPr/>
-        </p:nvSpPr>
-        <p:spPr>
-          <a:xfrm>
-            <a:off x="777240" y="1783080"/>
-            <a:ext cx="10607040" cy="731520"/>
-          </a:xfrm>
-          <a:prstGeom prst="rect">
-            <a:avLst/>
-          </a:prstGeom>
-          <a:noFill/>
-        </p:spPr>
-        <p:txBody>
-          <a:bodyPr wrap="square">
-            <a:spAutoFit/>
-          </a:bodyPr>
-          <a:lstStyle/>
-          <a:p>
-            <a:r>
-              <a:rPr sz="1900" b="0" i="1">
-                <a:solidFill>
-                  <a:srgbClr val="2563EB"/>
-                </a:solidFill>
-                <a:latin typeface="Calibri"/>
-              </a:rPr>
-              <a:t>A finding, not a bug.</a:t>
-            </a:r>
-          </a:p>
-        </p:txBody>
-      </p:sp>
-      <p:sp>
-        <p:nvSpPr>
-          <p:cNvPr id="5" name="TextBox 4"/>
-          <p:cNvSpPr txBox="1"/>
-          <p:nvPr/>
-        </p:nvSpPr>
-        <p:spPr>
-          <a:xfrm>
-            <a:off x="777240" y="2514600"/>
-            <a:ext cx="10607040" cy="3657600"/>
-          </a:xfrm>
-          <a:prstGeom prst="rect">
-            <a:avLst/>
-          </a:prstGeom>
-          <a:noFill/>
-        </p:spPr>
-        <p:txBody>
-          <a:bodyPr wrap="square">
-            <a:spAutoFit/>
-          </a:bodyPr>
-          <a:lstStyle/>
-          <a:p>
-            <a:pPr>
-              <a:spcAft>
-                <a:spcPts val="1200"/>
-              </a:spcAft>
-            </a:pPr>
-            <a:r>
-              <a:rPr sz="2100" b="0" i="0">
-                <a:solidFill>
-                  <a:srgbClr val="374151"/>
-                </a:solidFill>
-                <a:latin typeface="Calibri"/>
-              </a:rPr>
-              <a:t>•  Most edges have few common-neighbor triangles; strict cyclic triangles ≈ 0.</a:t>
-            </a:r>
-          </a:p>
-          <a:p>
-            <a:pPr>
-              <a:spcAft>
-                <a:spcPts val="1200"/>
-              </a:spcAft>
-            </a:pPr>
-            <a:r>
-              <a:rPr sz="2100" b="0" i="0">
-                <a:solidFill>
-                  <a:srgbClr val="374151"/>
-                </a:solidFill>
-                <a:latin typeface="Calibri"/>
-              </a:rPr>
-              <a:t>•  Only ~1% of triangles fall within a GICS sector.</a:t>
-            </a:r>
-          </a:p>
-          <a:p>
-            <a:pPr>
-              <a:spcAft>
-                <a:spcPts val="1200"/>
-              </a:spcAft>
-            </a:pPr>
-            <a:r>
-              <a:rPr sz="2100" b="0" i="0">
-                <a:solidFill>
-                  <a:srgbClr val="374151"/>
-                </a:solidFill>
-                <a:latin typeface="Calibri"/>
-              </a:rPr>
-              <a:t>•  Two honest consequences:</a:t>
-            </a:r>
-          </a:p>
-          <a:p>
-            <a:pPr lvl="1">
-              <a:spcAft>
-                <a:spcPts val="600"/>
-              </a:spcAft>
-            </a:pPr>
-            <a:r>
-              <a:rPr sz="1800" b="0" i="0">
-                <a:solidFill>
-                  <a:srgbClr val="9CA3AF"/>
-                </a:solidFill>
-                <a:latin typeface="Calibri"/>
-              </a:rPr>
-              <a:t>–  AFRC community separability is intrinsically limited (Fesser–Weber–Lambiotte).</a:t>
-            </a:r>
-          </a:p>
-          <a:p>
-            <a:pPr lvl="1">
-              <a:spcAft>
-                <a:spcPts val="600"/>
-              </a:spcAft>
-            </a:pPr>
-            <a:r>
-              <a:rPr sz="1800" b="0" i="0">
-                <a:solidFill>
-                  <a:srgbClr val="9CA3AF"/>
-                </a:solidFill>
-                <a:latin typeface="Calibri"/>
-              </a:rPr>
-              <a:t>–  The structure curvature surfaces is cross-sector — not aligned with GICS.</a:t>
-            </a:r>
-          </a:p>
-        </p:txBody>
-      </p:sp>
-      <p:sp>
-        <p:nvSpPr>
-          <p:cNvPr id="6" name="TextBox 5"/>
-          <p:cNvSpPr txBox="1"/>
-          <p:nvPr/>
-        </p:nvSpPr>
-        <p:spPr>
-          <a:xfrm>
-            <a:off x="777240" y="6355080"/>
-            <a:ext cx="10607040" cy="365760"/>
-          </a:xfrm>
-          <a:prstGeom prst="rect">
-            <a:avLst/>
-          </a:prstGeom>
-          <a:noFill/>
-        </p:spPr>
-        <p:txBody>
-          <a:bodyPr wrap="square">
-            <a:spAutoFit/>
-          </a:bodyPr>
-          <a:lstStyle/>
-          <a:p>
-            <a:r>
-              <a:rPr sz="1100" b="0" i="0">
-                <a:solidFill>
-                  <a:srgbClr val="9CA3AF"/>
-                </a:solidFill>
-                <a:latin typeface="Calibri"/>
-              </a:rPr>
-              <a:t>Results</a:t>
-            </a:r>
-          </a:p>
-        </p:txBody>
-      </p:sp>
-      <p:sp>
-        <p:nvSpPr>
-          <p:cNvPr id="7" name="TextBox 6"/>
-          <p:cNvSpPr txBox="1"/>
-          <p:nvPr/>
-        </p:nvSpPr>
-        <p:spPr>
-          <a:xfrm>
-            <a:off x="10789920" y="6355080"/>
-            <a:ext cx="1280160" cy="365760"/>
-          </a:xfrm>
-          <a:prstGeom prst="rect">
-            <a:avLst/>
-          </a:prstGeom>
-          <a:noFill/>
-        </p:spPr>
-        <p:txBody>
-          <a:bodyPr wrap="square">
-            <a:spAutoFit/>
-          </a:bodyPr>
-          <a:lstStyle/>
-          <a:p>
-            <a:pPr algn="r"/>
-            <a:r>
-              <a:rPr sz="1100" b="0" i="0">
-                <a:solidFill>
-                  <a:srgbClr val="9CA3AF"/>
-                </a:solidFill>
-                <a:latin typeface="Calibri"/>
-              </a:rPr>
               <a:t>13</a:t>
             </a:r>
           </a:p>
@@ -5228,7 +5542,7 @@
                 </a:solidFill>
                 <a:latin typeface="Calibri"/>
               </a:rPr>
-              <a:t>What it means</a:t>
+              <a:t>The network is triangle-sparse</a:t>
             </a:r>
           </a:p>
         </p:txBody>
@@ -5286,6 +5600,40 @@
         <p:spPr>
           <a:xfrm>
             <a:off x="777240" y="1783080"/>
+            <a:ext cx="10607040" cy="731520"/>
+          </a:xfrm>
+          <a:prstGeom prst="rect">
+            <a:avLst/>
+          </a:prstGeom>
+          <a:noFill/>
+        </p:spPr>
+        <p:txBody>
+          <a:bodyPr wrap="square">
+            <a:spAutoFit/>
+          </a:bodyPr>
+          <a:lstStyle/>
+          <a:p>
+            <a:r>
+              <a:rPr sz="1900" b="0" i="1">
+                <a:solidFill>
+                  <a:srgbClr val="2563EB"/>
+                </a:solidFill>
+                <a:latin typeface="Calibri"/>
+              </a:rPr>
+              <a:t>A finding, not a bug.</a:t>
+            </a:r>
+          </a:p>
+        </p:txBody>
+      </p:sp>
+      <p:sp>
+        <p:nvSpPr>
+          <p:cNvPr id="5" name="TextBox 4"/>
+          <p:cNvSpPr txBox="1"/>
+          <p:nvPr/>
+        </p:nvSpPr>
+        <p:spPr>
+          <a:xfrm>
+            <a:off x="777240" y="2514600"/>
             <a:ext cx="10607040" cy="3657600"/>
           </a:xfrm>
           <a:prstGeom prst="rect">
@@ -5311,7 +5659,7 @@
                 </a:solidFill>
                 <a:latin typeface="Calibri"/>
               </a:rPr>
-              <a:t>•  A new structural lens: directed, residualized curvature surfaces pair structure correlation / degree / undirected methods miss.</a:t>
+              <a:t>•  Most edges have few common-neighbor triangles; strict cyclic triangles ≈ 0.</a:t>
             </a:r>
           </a:p>
           <a:p>
@@ -5327,7 +5675,7 @@
                 </a:solidFill>
                 <a:latin typeface="Calibri"/>
               </a:rPr>
-              <a:t>•  Directedness changes the geometry — the directed graph is provably distinct from its symmetrized version.</a:t>
+              <a:t>•  Only ~1% of triangles fall within a GICS sector.</a:t>
             </a:r>
           </a:p>
           <a:p>
@@ -5343,30 +5691,46 @@
                 </a:solidFill>
                 <a:latin typeface="Calibri"/>
               </a:rPr>
-              <a:t>•  Triangle sparsity is a first-class constraint for curvature methods in finance.</a:t>
-            </a:r>
-          </a:p>
-          <a:p>
-            <a:pPr>
+              <a:t>•  Two honest consequences:</a:t>
+            </a:r>
+          </a:p>
+          <a:p>
+            <a:pPr lvl="1">
               <a:spcAft>
-                <a:spcPts val="1200"/>
+                <a:spcPts val="600"/>
               </a:spcAft>
             </a:pPr>
             <a:r>
-              <a:rPr sz="2100" b="0" i="0">
-                <a:solidFill>
-                  <a:srgbClr val="374151"/>
-                </a:solidFill>
-                <a:latin typeface="Calibri"/>
-              </a:rPr>
-              <a:t>•  This is a structural study — we make no predictive claim (Sandhu's precedent: structural-only is publishable).</a:t>
-            </a:r>
-          </a:p>
-        </p:txBody>
-      </p:sp>
-      <p:sp>
-        <p:nvSpPr>
-          <p:cNvPr id="5" name="TextBox 4"/>
+              <a:rPr sz="1800" b="0" i="0">
+                <a:solidFill>
+                  <a:srgbClr val="9CA3AF"/>
+                </a:solidFill>
+                <a:latin typeface="Calibri"/>
+              </a:rPr>
+              <a:t>–  AFRC community separability is intrinsically limited (Fesser–Weber–Lambiotte).</a:t>
+            </a:r>
+          </a:p>
+          <a:p>
+            <a:pPr lvl="1">
+              <a:spcAft>
+                <a:spcPts val="600"/>
+              </a:spcAft>
+            </a:pPr>
+            <a:r>
+              <a:rPr sz="1800" b="0" i="0">
+                <a:solidFill>
+                  <a:srgbClr val="9CA3AF"/>
+                </a:solidFill>
+                <a:latin typeface="Calibri"/>
+              </a:rPr>
+              <a:t>–  The structure curvature surfaces is cross-sector — not aligned with GICS.</a:t>
+            </a:r>
+          </a:p>
+        </p:txBody>
+      </p:sp>
+      <p:sp>
+        <p:nvSpPr>
+          <p:cNvPr id="6" name="TextBox 5"/>
           <p:cNvSpPr txBox="1"/>
           <p:nvPr/>
         </p:nvSpPr>
@@ -5393,14 +5757,14 @@
                 </a:solidFill>
                 <a:latin typeface="Calibri"/>
               </a:rPr>
-              <a:t>Implications</a:t>
-            </a:r>
-          </a:p>
-        </p:txBody>
-      </p:sp>
-      <p:sp>
-        <p:nvSpPr>
-          <p:cNvPr id="6" name="TextBox 5"/>
+              <a:t>Results</a:t>
+            </a:r>
+          </a:p>
+        </p:txBody>
+      </p:sp>
+      <p:sp>
+        <p:nvSpPr>
+          <p:cNvPr id="7" name="TextBox 6"/>
           <p:cNvSpPr txBox="1"/>
           <p:nvPr/>
         </p:nvSpPr>
@@ -5480,7 +5844,7 @@
                 </a:solidFill>
                 <a:latin typeface="Calibri"/>
               </a:rPr>
-              <a:t>Where this could go</a:t>
+              <a:t>What it means</a:t>
             </a:r>
           </a:p>
         </p:txBody>
@@ -5538,40 +5902,6 @@
         <p:spPr>
           <a:xfrm>
             <a:off x="777240" y="1783080"/>
-            <a:ext cx="10607040" cy="731520"/>
-          </a:xfrm>
-          <a:prstGeom prst="rect">
-            <a:avLst/>
-          </a:prstGeom>
-          <a:noFill/>
-        </p:spPr>
-        <p:txBody>
-          <a:bodyPr wrap="square">
-            <a:spAutoFit/>
-          </a:bodyPr>
-          <a:lstStyle/>
-          <a:p>
-            <a:r>
-              <a:rPr sz="1900" b="0" i="1">
-                <a:solidFill>
-                  <a:srgbClr val="2563EB"/>
-                </a:solidFill>
-                <a:latin typeface="Calibri"/>
-              </a:rPr>
-              <a:t>The structural toolkit is not tied to one construction.</a:t>
-            </a:r>
-          </a:p>
-        </p:txBody>
-      </p:sp>
-      <p:sp>
-        <p:nvSpPr>
-          <p:cNvPr id="5" name="TextBox 4"/>
-          <p:cNvSpPr txBox="1"/>
-          <p:nvPr/>
-        </p:nvSpPr>
-        <p:spPr>
-          <a:xfrm>
-            <a:off x="777240" y="2514600"/>
             <a:ext cx="10607040" cy="3657600"/>
           </a:xfrm>
           <a:prstGeom prst="rect">
@@ -5597,7 +5927,7 @@
                 </a:solidFill>
                 <a:latin typeface="Calibri"/>
               </a:rPr>
-              <a:t>•  Maybe not lead-lag at all — apply the same directed-curvature tools to other market graphs and relations.</a:t>
+              <a:t>•  A new structural lens: directed, residualized curvature surfaces pair structure correlation / degree / undirected methods miss.</a:t>
             </a:r>
           </a:p>
           <a:p>
@@ -5613,7 +5943,7 @@
                 </a:solidFill>
                 <a:latin typeface="Calibri"/>
               </a:rPr>
-              <a:t>•  Directed line-graph &amp; directed AFRC-gap theory (open problems).</a:t>
+              <a:t>•  Directedness changes the geometry — the directed graph is provably distinct from its symmetrized version.</a:t>
             </a:r>
           </a:p>
           <a:p>
@@ -5629,7 +5959,7 @@
                 </a:solidFill>
                 <a:latin typeface="Calibri"/>
               </a:rPr>
-              <a:t>•  Multi-frequency replication; curvature dynamics through 2020 stress.</a:t>
+              <a:t>•  Triangle sparsity is a first-class constraint for curvature methods in finance.</a:t>
             </a:r>
           </a:p>
           <a:p>
@@ -5645,14 +5975,14 @@
                 </a:solidFill>
                 <a:latin typeface="Calibri"/>
               </a:rPr>
-              <a:t>•  Write-up → 8-page ACM sigconf for ICAIF 2026.</a:t>
-            </a:r>
-          </a:p>
-        </p:txBody>
-      </p:sp>
-      <p:sp>
-        <p:nvSpPr>
-          <p:cNvPr id="6" name="TextBox 5"/>
+              <a:t>•  This is a structural study — we make no predictive claim (Sandhu's precedent: structural-only is publishable).</a:t>
+            </a:r>
+          </a:p>
+        </p:txBody>
+      </p:sp>
+      <p:sp>
+        <p:nvSpPr>
+          <p:cNvPr id="5" name="TextBox 4"/>
           <p:cNvSpPr txBox="1"/>
           <p:nvPr/>
         </p:nvSpPr>
@@ -5679,14 +6009,14 @@
                 </a:solidFill>
                 <a:latin typeface="Calibri"/>
               </a:rPr>
-              <a:t>Outlook</a:t>
-            </a:r>
-          </a:p>
-        </p:txBody>
-      </p:sp>
-      <p:sp>
-        <p:nvSpPr>
-          <p:cNvPr id="7" name="TextBox 6"/>
+              <a:t>Implications</a:t>
+            </a:r>
+          </a:p>
+        </p:txBody>
+      </p:sp>
+      <p:sp>
+        <p:nvSpPr>
+          <p:cNvPr id="6" name="TextBox 5"/>
           <p:cNvSpPr txBox="1"/>
           <p:nvPr/>
         </p:nvSpPr>
@@ -5715,6 +6045,292 @@
                 <a:latin typeface="Calibri"/>
               </a:rPr>
               <a:t>15</a:t>
+            </a:r>
+          </a:p>
+        </p:txBody>
+      </p:sp>
+    </p:spTree>
+  </p:cSld>
+  <p:clrMapOvr>
+    <a:masterClrMapping/>
+  </p:clrMapOvr>
+</p:sld>
+</file>
+
+<file path=ppt/slides/slide17.xml><?xml version="1.0" encoding="utf-8"?>
+<p:sld xmlns:a="http://schemas.openxmlformats.org/drawingml/2006/main" xmlns:p="http://schemas.openxmlformats.org/presentationml/2006/main" xmlns:r="http://schemas.openxmlformats.org/officeDocument/2006/relationships">
+  <p:cSld>
+    <p:spTree>
+      <p:nvGrpSpPr>
+        <p:cNvPr id="1" name=""/>
+        <p:cNvGrpSpPr/>
+        <p:nvPr/>
+      </p:nvGrpSpPr>
+      <p:grpSpPr/>
+      <p:sp>
+        <p:nvSpPr>
+          <p:cNvPr id="2" name="TextBox 1"/>
+          <p:cNvSpPr txBox="1"/>
+          <p:nvPr/>
+        </p:nvSpPr>
+        <p:spPr>
+          <a:xfrm>
+            <a:off x="777240" y="640080"/>
+            <a:ext cx="10607040" cy="822960"/>
+          </a:xfrm>
+          <a:prstGeom prst="rect">
+            <a:avLst/>
+          </a:prstGeom>
+          <a:noFill/>
+        </p:spPr>
+        <p:txBody>
+          <a:bodyPr wrap="square">
+            <a:spAutoFit/>
+          </a:bodyPr>
+          <a:lstStyle/>
+          <a:p>
+            <a:r>
+              <a:rPr sz="3000" b="1" i="0">
+                <a:solidFill>
+                  <a:srgbClr val="1F2937"/>
+                </a:solidFill>
+                <a:latin typeface="Calibri"/>
+              </a:rPr>
+              <a:t>Where this could go</a:t>
+            </a:r>
+          </a:p>
+        </p:txBody>
+      </p:sp>
+      <p:sp>
+        <p:nvSpPr>
+          <p:cNvPr id="3" name="Rectangle 2"/>
+          <p:cNvSpPr/>
+          <p:nvPr/>
+        </p:nvSpPr>
+        <p:spPr>
+          <a:xfrm>
+            <a:off x="777240" y="1417320"/>
+            <a:ext cx="1828800" cy="38100"/>
+          </a:xfrm>
+          <a:prstGeom prst="rect">
+            <a:avLst/>
+          </a:prstGeom>
+          <a:solidFill>
+            <a:srgbClr val="2563EB"/>
+          </a:solidFill>
+          <a:ln>
+            <a:noFill/>
+          </a:ln>
+          <a:effectLst/>
+        </p:spPr>
+        <p:style>
+          <a:lnRef idx="1">
+            <a:schemeClr val="accent1"/>
+          </a:lnRef>
+          <a:fillRef idx="3">
+            <a:schemeClr val="accent1"/>
+          </a:fillRef>
+          <a:effectRef idx="2">
+            <a:schemeClr val="accent1"/>
+          </a:effectRef>
+          <a:fontRef idx="minor">
+            <a:schemeClr val="lt1"/>
+          </a:fontRef>
+        </p:style>
+        <p:txBody>
+          <a:bodyPr rtlCol="0" anchor="ctr"/>
+          <a:lstStyle/>
+          <a:p>
+            <a:pPr algn="ctr"/>
+          </a:p>
+        </p:txBody>
+      </p:sp>
+      <p:sp>
+        <p:nvSpPr>
+          <p:cNvPr id="4" name="TextBox 3"/>
+          <p:cNvSpPr txBox="1"/>
+          <p:nvPr/>
+        </p:nvSpPr>
+        <p:spPr>
+          <a:xfrm>
+            <a:off x="777240" y="1783080"/>
+            <a:ext cx="10607040" cy="731520"/>
+          </a:xfrm>
+          <a:prstGeom prst="rect">
+            <a:avLst/>
+          </a:prstGeom>
+          <a:noFill/>
+        </p:spPr>
+        <p:txBody>
+          <a:bodyPr wrap="square">
+            <a:spAutoFit/>
+          </a:bodyPr>
+          <a:lstStyle/>
+          <a:p>
+            <a:r>
+              <a:rPr sz="1900" b="0" i="1">
+                <a:solidFill>
+                  <a:srgbClr val="2563EB"/>
+                </a:solidFill>
+                <a:latin typeface="Calibri"/>
+              </a:rPr>
+              <a:t>The structural toolkit is not tied to one construction.</a:t>
+            </a:r>
+          </a:p>
+        </p:txBody>
+      </p:sp>
+      <p:sp>
+        <p:nvSpPr>
+          <p:cNvPr id="5" name="TextBox 4"/>
+          <p:cNvSpPr txBox="1"/>
+          <p:nvPr/>
+        </p:nvSpPr>
+        <p:spPr>
+          <a:xfrm>
+            <a:off x="777240" y="2514600"/>
+            <a:ext cx="10607040" cy="3657600"/>
+          </a:xfrm>
+          <a:prstGeom prst="rect">
+            <a:avLst/>
+          </a:prstGeom>
+          <a:noFill/>
+        </p:spPr>
+        <p:txBody>
+          <a:bodyPr wrap="square">
+            <a:spAutoFit/>
+          </a:bodyPr>
+          <a:lstStyle/>
+          <a:p>
+            <a:pPr>
+              <a:spcAft>
+                <a:spcPts val="1200"/>
+              </a:spcAft>
+            </a:pPr>
+            <a:r>
+              <a:rPr sz="2100" b="0" i="0">
+                <a:solidFill>
+                  <a:srgbClr val="374151"/>
+                </a:solidFill>
+                <a:latin typeface="Calibri"/>
+              </a:rPr>
+              <a:t>•  Maybe not lead-lag at all — apply the same directed-curvature tools to other market graphs and relations.</a:t>
+            </a:r>
+          </a:p>
+          <a:p>
+            <a:pPr>
+              <a:spcAft>
+                <a:spcPts val="1200"/>
+              </a:spcAft>
+            </a:pPr>
+            <a:r>
+              <a:rPr sz="2100" b="0" i="0">
+                <a:solidFill>
+                  <a:srgbClr val="374151"/>
+                </a:solidFill>
+                <a:latin typeface="Calibri"/>
+              </a:rPr>
+              <a:t>•  Directed line-graph &amp; directed AFRC-gap theory (open problems).</a:t>
+            </a:r>
+          </a:p>
+          <a:p>
+            <a:pPr>
+              <a:spcAft>
+                <a:spcPts val="1200"/>
+              </a:spcAft>
+            </a:pPr>
+            <a:r>
+              <a:rPr sz="2100" b="0" i="0">
+                <a:solidFill>
+                  <a:srgbClr val="374151"/>
+                </a:solidFill>
+                <a:latin typeface="Calibri"/>
+              </a:rPr>
+              <a:t>•  Multi-frequency replication; curvature dynamics through 2020 stress.</a:t>
+            </a:r>
+          </a:p>
+          <a:p>
+            <a:pPr>
+              <a:spcAft>
+                <a:spcPts val="1200"/>
+              </a:spcAft>
+            </a:pPr>
+            <a:r>
+              <a:rPr sz="2100" b="0" i="0">
+                <a:solidFill>
+                  <a:srgbClr val="374151"/>
+                </a:solidFill>
+                <a:latin typeface="Calibri"/>
+              </a:rPr>
+              <a:t>•  Write-up → 8-page ACM sigconf for ICAIF 2026.</a:t>
+            </a:r>
+          </a:p>
+        </p:txBody>
+      </p:sp>
+      <p:sp>
+        <p:nvSpPr>
+          <p:cNvPr id="6" name="TextBox 5"/>
+          <p:cNvSpPr txBox="1"/>
+          <p:nvPr/>
+        </p:nvSpPr>
+        <p:spPr>
+          <a:xfrm>
+            <a:off x="777240" y="6355080"/>
+            <a:ext cx="10607040" cy="365760"/>
+          </a:xfrm>
+          <a:prstGeom prst="rect">
+            <a:avLst/>
+          </a:prstGeom>
+          <a:noFill/>
+        </p:spPr>
+        <p:txBody>
+          <a:bodyPr wrap="square">
+            <a:spAutoFit/>
+          </a:bodyPr>
+          <a:lstStyle/>
+          <a:p>
+            <a:r>
+              <a:rPr sz="1100" b="0" i="0">
+                <a:solidFill>
+                  <a:srgbClr val="9CA3AF"/>
+                </a:solidFill>
+                <a:latin typeface="Calibri"/>
+              </a:rPr>
+              <a:t>Outlook</a:t>
+            </a:r>
+          </a:p>
+        </p:txBody>
+      </p:sp>
+      <p:sp>
+        <p:nvSpPr>
+          <p:cNvPr id="7" name="TextBox 6"/>
+          <p:cNvSpPr txBox="1"/>
+          <p:nvPr/>
+        </p:nvSpPr>
+        <p:spPr>
+          <a:xfrm>
+            <a:off x="10789920" y="6355080"/>
+            <a:ext cx="1280160" cy="365760"/>
+          </a:xfrm>
+          <a:prstGeom prst="rect">
+            <a:avLst/>
+          </a:prstGeom>
+          <a:noFill/>
+        </p:spPr>
+        <p:txBody>
+          <a:bodyPr wrap="square">
+            <a:spAutoFit/>
+          </a:bodyPr>
+          <a:lstStyle/>
+          <a:p>
+            <a:pPr algn="r"/>
+            <a:r>
+              <a:rPr sz="1100" b="0" i="0">
+                <a:solidFill>
+                  <a:srgbClr val="9CA3AF"/>
+                </a:solidFill>
+                <a:latin typeface="Calibri"/>
+              </a:rPr>
+              <a:t>16</a:t>
             </a:r>
           </a:p>
         </p:txBody>
@@ -7859,7 +8475,7 @@
         <p:spPr>
           <a:xfrm>
             <a:off x="777240" y="1783080"/>
-            <a:ext cx="10607040" cy="2743200"/>
+            <a:ext cx="10607040" cy="3657600"/>
           </a:xfrm>
           <a:prstGeom prst="rect">
             <a:avLst/>
@@ -7932,78 +8548,30 @@
                 </a:solidFill>
                 <a:latin typeface="Calibri"/>
               </a:rPr>
-              <a:t>–  τ* = the lag of peak signal, picked per pair; intraday uses a within-day estimator (no overnight gap).</a:t>
-            </a:r>
-          </a:p>
-        </p:txBody>
-      </p:sp>
-      <p:sp>
-        <p:nvSpPr>
-          <p:cNvPr id="5" name="Rounded Rectangle 4"/>
-          <p:cNvSpPr/>
-          <p:nvPr/>
-        </p:nvSpPr>
-        <p:spPr>
-          <a:xfrm>
-            <a:off x="777240" y="4983480"/>
-            <a:ext cx="10607040" cy="1051560"/>
-          </a:xfrm>
-          <a:prstGeom prst="roundRect">
-            <a:avLst/>
-          </a:prstGeom>
-          <a:solidFill>
-            <a:srgbClr val="EFF2FB"/>
-          </a:solidFill>
-          <a:ln w="15875">
-            <a:solidFill>
-              <a:srgbClr val="2563EB"/>
-            </a:solidFill>
-          </a:ln>
-          <a:effectLst/>
-        </p:spPr>
-        <p:style>
-          <a:lnRef idx="1">
-            <a:schemeClr val="accent1"/>
-          </a:lnRef>
-          <a:fillRef idx="3">
-            <a:schemeClr val="accent1"/>
-          </a:fillRef>
-          <a:effectRef idx="2">
-            <a:schemeClr val="accent1"/>
-          </a:effectRef>
-          <a:fontRef idx="minor">
-            <a:schemeClr val="lt1"/>
-          </a:fontRef>
-        </p:style>
-        <p:txBody>
-          <a:bodyPr rtlCol="0" anchor="ctr" wrap="square" lIns="228600" rIns="228600"/>
-          <a:lstStyle/>
-          <a:p>
-            <a:pPr algn="ctr"/>
-            <a:r>
-              <a:rPr sz="1400" b="1" i="0">
-                <a:solidFill>
-                  <a:srgbClr val="2563EB"/>
-                </a:solidFill>
-                <a:latin typeface="Calibri"/>
-              </a:rPr>
-              <a:t>Horizons tried   </a:t>
-            </a:r>
-            <a:r>
-              <a:rPr sz="1700" b="1" i="0">
-                <a:solidFill>
-                  <a:srgbClr val="1F2937"/>
-                </a:solidFill>
-                <a:latin typeface="Calibri"/>
-              </a:rPr>
-              <a:t>Daily: τ = 1–5 trading days   ·   Intraday: τ = 1–3 × 30-min bars (30–90 min).   No weekly / monthly.</a:t>
-            </a:r>
-          </a:p>
-        </p:txBody>
-      </p:sp>
-      <p:sp>
-        <p:nvSpPr>
-          <p:cNvPr id="6" name="TextBox 5"/>
+              <a:t>–  τ* = the lag of peak signal, picked per pair; the candidate horizons are on the next slide.</a:t>
+            </a:r>
+          </a:p>
+          <a:p>
+            <a:pPr>
+              <a:spcAft>
+                <a:spcPts val="1200"/>
+              </a:spcAft>
+            </a:pPr>
+            <a:r>
+              <a:rPr sz="2100" b="0" i="0">
+                <a:solidFill>
+                  <a:srgbClr val="374151"/>
+                </a:solidFill>
+                <a:latin typeface="Calibri"/>
+              </a:rPr>
+              <a:t>•  Intraday: within-day estimator (lag pairs never cross the overnight gap).</a:t>
+            </a:r>
+          </a:p>
+        </p:txBody>
+      </p:sp>
+      <p:sp>
+        <p:nvSpPr>
+          <p:cNvPr id="5" name="TextBox 4"/>
           <p:cNvSpPr txBox="1"/>
           <p:nvPr/>
         </p:nvSpPr>
@@ -8037,7 +8605,7 @@
       </p:sp>
       <p:sp>
         <p:nvSpPr>
-          <p:cNvPr id="7" name="TextBox 6"/>
+          <p:cNvPr id="6" name="TextBox 5"/>
           <p:cNvSpPr txBox="1"/>
           <p:nvPr/>
         </p:nvSpPr>

</xml_diff>

<commit_message>
Deck: two hypotheses + two-column verdict; IC back as H2; agent angle
- Hypothesis slide -> "Two hypotheses": H1 structural (primary) and H2 predictive
  (secondary), side by side.
- Re-added the IC results slide as the H2 evidence (within-day 2019 table), so the
  results section answers both hypotheses, not just structure.
- New two-column VERDICT slide responding to both: H1 ✓ CONFIRMED (green),
  H2 ✗ NOT SUPPORTED (amber, honest null) — replaces the directionless
  "what it means" slide.
- Results divider -> "Two hypotheses, two answers."
- Outlook: added the autonomous-agent point (an agent ran the full research loop —
  hypothesize, build, test, honestly reject — a template for agentic quant-finance
  research), per the course framing.
Now 18 slides.

Co-Authored-By: Claude Opus 4.8 (1M context) <noreply@anthropic.com>
</commit_message>
<xml_diff>
--- a/slides/Ricci_Curvature_LeadLag.pptx
+++ b/slides/Ricci_Curvature_LeadLag.pptx
@@ -22,6 +22,7 @@
     <p:sldId id="270" r:id="rId21"/>
     <p:sldId id="271" r:id="rId22"/>
     <p:sldId id="272" r:id="rId23"/>
+    <p:sldId id="273" r:id="rId24"/>
   </p:sldIdLst>
   <p:sldSz cx="12191695" cy="6858000" type="screen4x3"/>
   <p:notesSz cx="6858000" cy="9144000"/>
@@ -4544,7 +4545,7 @@
                 </a:solidFill>
                 <a:latin typeface="Calibri"/>
               </a:rPr>
-              <a:t>The structural result holds.</a:t>
+              <a:t>Two hypotheses, two answers.</a:t>
             </a:r>
           </a:p>
         </p:txBody>
@@ -5757,7 +5758,7 @@
                 </a:solidFill>
                 <a:latin typeface="Calibri"/>
               </a:rPr>
-              <a:t>Results</a:t>
+              <a:t>Results — H1</a:t>
             </a:r>
           </a:p>
         </p:txBody>
@@ -5844,7 +5845,7 @@
                 </a:solidFill>
                 <a:latin typeface="Calibri"/>
               </a:rPr>
-              <a:t>What it means</a:t>
+              <a:t>The predictive test</a:t>
             </a:r>
           </a:p>
         </p:txBody>
@@ -5902,7 +5903,7 @@
         <p:spPr>
           <a:xfrm>
             <a:off x="777240" y="1783080"/>
-            <a:ext cx="10607040" cy="3657600"/>
+            <a:ext cx="10607040" cy="640080"/>
           </a:xfrm>
           <a:prstGeom prst="rect">
             <a:avLst/>
@@ -5915,81 +5916,410 @@
           </a:bodyPr>
           <a:lstStyle/>
           <a:p>
-            <a:pPr>
-              <a:spcAft>
-                <a:spcPts val="1200"/>
-              </a:spcAft>
-            </a:pPr>
-            <a:r>
-              <a:rPr sz="2100" b="0" i="0">
-                <a:solidFill>
-                  <a:srgbClr val="374151"/>
-                </a:solidFill>
-                <a:latin typeface="Calibri"/>
-              </a:rPr>
-              <a:t>•  A new structural lens: directed, residualized curvature surfaces pair structure correlation / degree / undirected methods miss.</a:t>
-            </a:r>
-          </a:p>
-          <a:p>
-            <a:pPr>
-              <a:spcAft>
-                <a:spcPts val="1200"/>
-              </a:spcAft>
-            </a:pPr>
-            <a:r>
-              <a:rPr sz="2100" b="0" i="0">
-                <a:solidFill>
-                  <a:srgbClr val="374151"/>
-                </a:solidFill>
-                <a:latin typeface="Calibri"/>
-              </a:rPr>
-              <a:t>•  Directedness changes the geometry — the directed graph is provably distinct from its symmetrized version.</a:t>
-            </a:r>
-          </a:p>
-          <a:p>
-            <a:pPr>
-              <a:spcAft>
-                <a:spcPts val="1200"/>
-              </a:spcAft>
-            </a:pPr>
-            <a:r>
-              <a:rPr sz="2100" b="0" i="0">
-                <a:solidFill>
-                  <a:srgbClr val="374151"/>
-                </a:solidFill>
-                <a:latin typeface="Calibri"/>
-              </a:rPr>
-              <a:t>•  Triangle sparsity is a first-class constraint for curvature methods in finance.</a:t>
-            </a:r>
-          </a:p>
-          <a:p>
-            <a:pPr>
-              <a:spcAft>
-                <a:spcPts val="1200"/>
-              </a:spcAft>
-            </a:pPr>
-            <a:r>
-              <a:rPr sz="2100" b="0" i="0">
-                <a:solidFill>
-                  <a:srgbClr val="374151"/>
-                </a:solidFill>
-                <a:latin typeface="Calibri"/>
-              </a:rPr>
-              <a:t>•  This is a structural study — we make no predictive claim (Sandhu's precedent: structural-only is publishable).</a:t>
-            </a:r>
-          </a:p>
-        </p:txBody>
-      </p:sp>
-      <p:sp>
-        <p:nvSpPr>
-          <p:cNvPr id="5" name="TextBox 4"/>
+            <a:r>
+              <a:rPr sz="1800" b="0" i="1">
+                <a:solidFill>
+                  <a:srgbClr val="2563EB"/>
+                </a:solidFill>
+                <a:latin typeface="Calibri"/>
+              </a:rPr>
+              <a:t>Out-of-sample directional IC — full-year 2019, within-day horizon.</a:t>
+            </a:r>
+          </a:p>
+        </p:txBody>
+      </p:sp>
+      <p:graphicFrame>
+        <p:nvGraphicFramePr>
+          <p:cNvPr id="5" name="Table 4"/>
+          <p:cNvGraphicFramePr>
+            <a:graphicFrameLocks noGrp="1"/>
+          </p:cNvGraphicFramePr>
+          <p:nvPr/>
+        </p:nvGraphicFramePr>
+        <p:xfrm>
+          <a:off x="777240" y="2377440"/>
+          <a:ext cx="10607040" cy="2286000"/>
+        </p:xfrm>
+        <a:graphic>
+          <a:graphicData uri="http://schemas.openxmlformats.org/drawingml/2006/table">
+            <a:tbl>
+              <a:tblPr firstRow="1" bandRow="1">
+                <a:tableStyleId>{5C22544A-7EE6-4342-B048-85BDC9FD1C3A}</a:tableStyleId>
+              </a:tblPr>
+              <a:tblGrid>
+                <a:gridCol w="4389120"/>
+                <a:gridCol w="2377440"/>
+                <a:gridCol w="3840480"/>
+              </a:tblGrid>
+              <a:tr h="457200">
+                <a:tc>
+                  <a:txBody>
+                    <a:bodyPr/>
+                    <a:lstStyle/>
+                    <a:p>
+                      <a:pPr algn="l"/>
+                      <a:r>
+                        <a:rPr sz="1500" b="1" i="0">
+                          <a:solidFill>
+                            <a:srgbClr val="FFFFFF"/>
+                          </a:solidFill>
+                          <a:latin typeface="Calibri"/>
+                        </a:rPr>
+                        <a:t>Method</a:t>
+                      </a:r>
+                    </a:p>
+                  </a:txBody>
+                  <a:tcPr anchor="ctr">
+                    <a:solidFill>
+                      <a:srgbClr val="2563EB"/>
+                    </a:solidFill>
+                  </a:tcPr>
+                </a:tc>
+                <a:tc>
+                  <a:txBody>
+                    <a:bodyPr/>
+                    <a:lstStyle/>
+                    <a:p>
+                      <a:pPr algn="ctr"/>
+                      <a:r>
+                        <a:rPr sz="1500" b="1" i="0">
+                          <a:solidFill>
+                            <a:srgbClr val="FFFFFF"/>
+                          </a:solidFill>
+                          <a:latin typeface="Calibri"/>
+                        </a:rPr>
+                        <a:t>Mean IC</a:t>
+                      </a:r>
+                    </a:p>
+                  </a:txBody>
+                  <a:tcPr anchor="ctr">
+                    <a:solidFill>
+                      <a:srgbClr val="2563EB"/>
+                    </a:solidFill>
+                  </a:tcPr>
+                </a:tc>
+                <a:tc>
+                  <a:txBody>
+                    <a:bodyPr/>
+                    <a:lstStyle/>
+                    <a:p>
+                      <a:pPr algn="ctr"/>
+                      <a:r>
+                        <a:rPr sz="1500" b="1" i="0">
+                          <a:solidFill>
+                            <a:srgbClr val="FFFFFF"/>
+                          </a:solidFill>
+                          <a:latin typeface="Calibri"/>
+                        </a:rPr>
+                        <a:t>95% CI</a:t>
+                      </a:r>
+                    </a:p>
+                  </a:txBody>
+                  <a:tcPr anchor="ctr">
+                    <a:solidFill>
+                      <a:srgbClr val="2563EB"/>
+                    </a:solidFill>
+                  </a:tcPr>
+                </a:tc>
+              </a:tr>
+              <a:tr h="457200">
+                <a:tc>
+                  <a:txBody>
+                    <a:bodyPr/>
+                    <a:lstStyle/>
+                    <a:p>
+                      <a:pPr algn="l"/>
+                      <a:r>
+                        <a:rPr sz="1400" b="1" i="0">
+                          <a:solidFill>
+                            <a:srgbClr val="1F2937"/>
+                          </a:solidFill>
+                          <a:latin typeface="Calibri"/>
+                        </a:rPr>
+                        <a:t>Undirected Forman</a:t>
+                      </a:r>
+                    </a:p>
+                  </a:txBody>
+                  <a:tcPr anchor="ctr">
+                    <a:solidFill>
+                      <a:srgbClr val="EFF2FB"/>
+                    </a:solidFill>
+                  </a:tcPr>
+                </a:tc>
+                <a:tc>
+                  <a:txBody>
+                    <a:bodyPr/>
+                    <a:lstStyle/>
+                    <a:p>
+                      <a:pPr algn="ctr"/>
+                      <a:r>
+                        <a:rPr sz="1400" b="1" i="0">
+                          <a:solidFill>
+                            <a:srgbClr val="1F2937"/>
+                          </a:solidFill>
+                          <a:latin typeface="Calibri"/>
+                        </a:rPr>
+                        <a:t>+0.013</a:t>
+                      </a:r>
+                    </a:p>
+                  </a:txBody>
+                  <a:tcPr anchor="ctr">
+                    <a:solidFill>
+                      <a:srgbClr val="EFF2FB"/>
+                    </a:solidFill>
+                  </a:tcPr>
+                </a:tc>
+                <a:tc>
+                  <a:txBody>
+                    <a:bodyPr/>
+                    <a:lstStyle/>
+                    <a:p>
+                      <a:pPr algn="ctr"/>
+                      <a:r>
+                        <a:rPr sz="1400" b="1" i="0">
+                          <a:solidFill>
+                            <a:srgbClr val="1F2937"/>
+                          </a:solidFill>
+                          <a:latin typeface="Calibri"/>
+                        </a:rPr>
+                        <a:t>[−0.016, +0.040]</a:t>
+                      </a:r>
+                    </a:p>
+                  </a:txBody>
+                  <a:tcPr anchor="ctr">
+                    <a:solidFill>
+                      <a:srgbClr val="EFF2FB"/>
+                    </a:solidFill>
+                  </a:tcPr>
+                </a:tc>
+              </a:tr>
+              <a:tr h="457200">
+                <a:tc>
+                  <a:txBody>
+                    <a:bodyPr/>
+                    <a:lstStyle/>
+                    <a:p>
+                      <a:pPr algn="l"/>
+                      <a:r>
+                        <a:rPr sz="1400" b="1" i="0">
+                          <a:solidFill>
+                            <a:srgbClr val="1F2937"/>
+                          </a:solidFill>
+                          <a:latin typeface="Calibri"/>
+                        </a:rPr>
+                        <a:t>Curvature (aug, directed)</a:t>
+                      </a:r>
+                    </a:p>
+                  </a:txBody>
+                  <a:tcPr anchor="ctr">
+                    <a:solidFill>
+                      <a:srgbClr val="EFF2FB"/>
+                    </a:solidFill>
+                  </a:tcPr>
+                </a:tc>
+                <a:tc>
+                  <a:txBody>
+                    <a:bodyPr/>
+                    <a:lstStyle/>
+                    <a:p>
+                      <a:pPr algn="ctr"/>
+                      <a:r>
+                        <a:rPr sz="1400" b="1" i="0">
+                          <a:solidFill>
+                            <a:srgbClr val="1F2937"/>
+                          </a:solidFill>
+                          <a:latin typeface="Calibri"/>
+                        </a:rPr>
+                        <a:t>+0.005</a:t>
+                      </a:r>
+                    </a:p>
+                  </a:txBody>
+                  <a:tcPr anchor="ctr">
+                    <a:solidFill>
+                      <a:srgbClr val="EFF2FB"/>
+                    </a:solidFill>
+                  </a:tcPr>
+                </a:tc>
+                <a:tc>
+                  <a:txBody>
+                    <a:bodyPr/>
+                    <a:lstStyle/>
+                    <a:p>
+                      <a:pPr algn="ctr"/>
+                      <a:r>
+                        <a:rPr sz="1400" b="1" i="0">
+                          <a:solidFill>
+                            <a:srgbClr val="1F2937"/>
+                          </a:solidFill>
+                          <a:latin typeface="Calibri"/>
+                        </a:rPr>
+                        <a:t>[−0.016, +0.026]</a:t>
+                      </a:r>
+                    </a:p>
+                  </a:txBody>
+                  <a:tcPr anchor="ctr">
+                    <a:solidFill>
+                      <a:srgbClr val="EFF2FB"/>
+                    </a:solidFill>
+                  </a:tcPr>
+                </a:tc>
+              </a:tr>
+              <a:tr h="457200">
+                <a:tc>
+                  <a:txBody>
+                    <a:bodyPr/>
+                    <a:lstStyle/>
+                    <a:p>
+                      <a:pPr algn="l"/>
+                      <a:r>
+                        <a:rPr sz="1400" b="0" i="0">
+                          <a:solidFill>
+                            <a:srgbClr val="374151"/>
+                          </a:solidFill>
+                          <a:latin typeface="Calibri"/>
+                        </a:rPr>
+                        <a:t>Correlation</a:t>
+                      </a:r>
+                    </a:p>
+                  </a:txBody>
+                  <a:tcPr anchor="ctr">
+                    <a:solidFill>
+                      <a:srgbClr val="FFFFFF"/>
+                    </a:solidFill>
+                  </a:tcPr>
+                </a:tc>
+                <a:tc>
+                  <a:txBody>
+                    <a:bodyPr/>
+                    <a:lstStyle/>
+                    <a:p>
+                      <a:pPr algn="ctr"/>
+                      <a:r>
+                        <a:rPr sz="1400" b="0" i="0">
+                          <a:solidFill>
+                            <a:srgbClr val="374151"/>
+                          </a:solidFill>
+                          <a:latin typeface="Calibri"/>
+                        </a:rPr>
+                        <a:t>−0.003</a:t>
+                      </a:r>
+                    </a:p>
+                  </a:txBody>
+                  <a:tcPr anchor="ctr">
+                    <a:solidFill>
+                      <a:srgbClr val="FFFFFF"/>
+                    </a:solidFill>
+                  </a:tcPr>
+                </a:tc>
+                <a:tc>
+                  <a:txBody>
+                    <a:bodyPr/>
+                    <a:lstStyle/>
+                    <a:p>
+                      <a:pPr algn="ctr"/>
+                      <a:r>
+                        <a:rPr sz="1400" b="0" i="0">
+                          <a:solidFill>
+                            <a:srgbClr val="374151"/>
+                          </a:solidFill>
+                          <a:latin typeface="Calibri"/>
+                        </a:rPr>
+                        <a:t>[−0.027, +0.024]</a:t>
+                      </a:r>
+                    </a:p>
+                  </a:txBody>
+                  <a:tcPr anchor="ctr">
+                    <a:solidFill>
+                      <a:srgbClr val="FFFFFF"/>
+                    </a:solidFill>
+                  </a:tcPr>
+                </a:tc>
+              </a:tr>
+              <a:tr h="457200">
+                <a:tc>
+                  <a:txBody>
+                    <a:bodyPr/>
+                    <a:lstStyle/>
+                    <a:p>
+                      <a:pPr algn="l"/>
+                      <a:r>
+                        <a:rPr sz="1400" b="0" i="0">
+                          <a:solidFill>
+                            <a:srgbClr val="374151"/>
+                          </a:solidFill>
+                          <a:latin typeface="Calibri"/>
+                        </a:rPr>
+                        <a:t>Random</a:t>
+                      </a:r>
+                    </a:p>
+                  </a:txBody>
+                  <a:tcPr anchor="ctr">
+                    <a:solidFill>
+                      <a:srgbClr val="EFF2FB"/>
+                    </a:solidFill>
+                  </a:tcPr>
+                </a:tc>
+                <a:tc>
+                  <a:txBody>
+                    <a:bodyPr/>
+                    <a:lstStyle/>
+                    <a:p>
+                      <a:pPr algn="ctr"/>
+                      <a:r>
+                        <a:rPr sz="1400" b="0" i="0">
+                          <a:solidFill>
+                            <a:srgbClr val="374151"/>
+                          </a:solidFill>
+                          <a:latin typeface="Calibri"/>
+                        </a:rPr>
+                        <a:t>−0.015</a:t>
+                      </a:r>
+                    </a:p>
+                  </a:txBody>
+                  <a:tcPr anchor="ctr">
+                    <a:solidFill>
+                      <a:srgbClr val="EFF2FB"/>
+                    </a:solidFill>
+                  </a:tcPr>
+                </a:tc>
+                <a:tc>
+                  <a:txBody>
+                    <a:bodyPr/>
+                    <a:lstStyle/>
+                    <a:p>
+                      <a:pPr algn="ctr"/>
+                      <a:r>
+                        <a:rPr sz="1400" b="0" i="0">
+                          <a:solidFill>
+                            <a:srgbClr val="374151"/>
+                          </a:solidFill>
+                          <a:latin typeface="Calibri"/>
+                        </a:rPr>
+                        <a:t>[−0.031, +0.006]</a:t>
+                      </a:r>
+                    </a:p>
+                  </a:txBody>
+                  <a:tcPr anchor="ctr">
+                    <a:solidFill>
+                      <a:srgbClr val="EFF2FB"/>
+                    </a:solidFill>
+                  </a:tcPr>
+                </a:tc>
+              </a:tr>
+            </a:tbl>
+          </a:graphicData>
+        </a:graphic>
+      </p:graphicFrame>
+      <p:sp>
+        <p:nvSpPr>
+          <p:cNvPr id="6" name="TextBox 5"/>
           <p:cNvSpPr txBox="1"/>
           <p:nvPr/>
         </p:nvSpPr>
         <p:spPr>
           <a:xfrm>
-            <a:off x="777240" y="6355080"/>
-            <a:ext cx="10607040" cy="365760"/>
+            <a:off x="777240" y="5715000"/>
+            <a:ext cx="10607040" cy="640080"/>
           </a:xfrm>
           <a:prstGeom prst="rect">
             <a:avLst/>
@@ -6003,20 +6333,54 @@
           <a:lstStyle/>
           <a:p>
             <a:r>
+              <a:rPr sz="1400" b="0" i="1">
+                <a:solidFill>
+                  <a:srgbClr val="9CA3AF"/>
+                </a:solidFill>
+                <a:latin typeface="Calibri"/>
+              </a:rPr>
+              <a:t>Forman leads every baseline — but every CI spans zero, and undirected ties directed. No significant predictive edge.</a:t>
+            </a:r>
+          </a:p>
+        </p:txBody>
+      </p:sp>
+      <p:sp>
+        <p:nvSpPr>
+          <p:cNvPr id="7" name="TextBox 6"/>
+          <p:cNvSpPr txBox="1"/>
+          <p:nvPr/>
+        </p:nvSpPr>
+        <p:spPr>
+          <a:xfrm>
+            <a:off x="777240" y="6355080"/>
+            <a:ext cx="10607040" cy="365760"/>
+          </a:xfrm>
+          <a:prstGeom prst="rect">
+            <a:avLst/>
+          </a:prstGeom>
+          <a:noFill/>
+        </p:spPr>
+        <p:txBody>
+          <a:bodyPr wrap="square">
+            <a:spAutoFit/>
+          </a:bodyPr>
+          <a:lstStyle/>
+          <a:p>
+            <a:r>
               <a:rPr sz="1100" b="0" i="0">
                 <a:solidFill>
                   <a:srgbClr val="9CA3AF"/>
                 </a:solidFill>
                 <a:latin typeface="Calibri"/>
               </a:rPr>
-              <a:t>Implications</a:t>
-            </a:r>
-          </a:p>
-        </p:txBody>
-      </p:sp>
-      <p:sp>
-        <p:nvSpPr>
-          <p:cNvPr id="6" name="TextBox 5"/>
+              <a:t>Results — H2</a:t>
+            </a:r>
+          </a:p>
+        </p:txBody>
+      </p:sp>
+      <p:sp>
+        <p:nvSpPr>
+          <p:cNvPr id="8" name="TextBox 7"/>
           <p:cNvSpPr txBox="1"/>
           <p:nvPr/>
         </p:nvSpPr>
@@ -6096,7 +6460,7 @@
                 </a:solidFill>
                 <a:latin typeface="Calibri"/>
               </a:rPr>
-              <a:t>Where this could go</a:t>
+              <a:t>Did the two hypotheses hold?</a:t>
             </a:r>
           </a:p>
         </p:txBody>
@@ -6153,6 +6517,517 @@
         </p:nvSpPr>
         <p:spPr>
           <a:xfrm>
+            <a:off x="777240" y="1600200"/>
+            <a:ext cx="10607040" cy="457200"/>
+          </a:xfrm>
+          <a:prstGeom prst="rect">
+            <a:avLst/>
+          </a:prstGeom>
+          <a:noFill/>
+        </p:spPr>
+        <p:txBody>
+          <a:bodyPr wrap="square">
+            <a:spAutoFit/>
+          </a:bodyPr>
+          <a:lstStyle/>
+          <a:p>
+            <a:r>
+              <a:rPr sz="1700" b="0" i="1">
+                <a:solidFill>
+                  <a:srgbClr val="2563EB"/>
+                </a:solidFill>
+                <a:latin typeface="Calibri"/>
+              </a:rPr>
+              <a:t>The paper stands on H1. H2 is reported transparently.</a:t>
+            </a:r>
+          </a:p>
+        </p:txBody>
+      </p:sp>
+      <p:sp>
+        <p:nvSpPr>
+          <p:cNvPr id="5" name="Rounded Rectangle 4"/>
+          <p:cNvSpPr/>
+          <p:nvPr/>
+        </p:nvSpPr>
+        <p:spPr>
+          <a:xfrm>
+            <a:off x="777240" y="2240280"/>
+            <a:ext cx="5074920" cy="640080"/>
+          </a:xfrm>
+          <a:prstGeom prst="roundRect">
+            <a:avLst/>
+          </a:prstGeom>
+          <a:solidFill>
+            <a:srgbClr val="159E5B"/>
+          </a:solidFill>
+          <a:ln>
+            <a:noFill/>
+          </a:ln>
+          <a:effectLst/>
+        </p:spPr>
+        <p:style>
+          <a:lnRef idx="1">
+            <a:schemeClr val="accent1"/>
+          </a:lnRef>
+          <a:fillRef idx="3">
+            <a:schemeClr val="accent1"/>
+          </a:fillRef>
+          <a:effectRef idx="2">
+            <a:schemeClr val="accent1"/>
+          </a:effectRef>
+          <a:fontRef idx="minor">
+            <a:schemeClr val="lt1"/>
+          </a:fontRef>
+        </p:style>
+        <p:txBody>
+          <a:bodyPr rtlCol="0" anchor="ctr" wrap="square"/>
+          <a:lstStyle/>
+          <a:p>
+            <a:pPr algn="ctr"/>
+            <a:r>
+              <a:rPr sz="1600" b="1" i="0">
+                <a:solidFill>
+                  <a:srgbClr val="FFFFFF"/>
+                </a:solidFill>
+                <a:latin typeface="Calibri"/>
+              </a:rPr>
+              <a:t>H1 — Structural distinctness</a:t>
+            </a:r>
+          </a:p>
+        </p:txBody>
+      </p:sp>
+      <p:sp>
+        <p:nvSpPr>
+          <p:cNvPr id="6" name="Rounded Rectangle 5"/>
+          <p:cNvSpPr/>
+          <p:nvPr/>
+        </p:nvSpPr>
+        <p:spPr>
+          <a:xfrm>
+            <a:off x="777240" y="3017520"/>
+            <a:ext cx="5074920" cy="2926080"/>
+          </a:xfrm>
+          <a:prstGeom prst="roundRect">
+            <a:avLst/>
+          </a:prstGeom>
+          <a:solidFill>
+            <a:srgbClr val="ECFBF2"/>
+          </a:solidFill>
+          <a:ln w="12700">
+            <a:solidFill>
+              <a:srgbClr val="159E5B"/>
+            </a:solidFill>
+          </a:ln>
+          <a:effectLst/>
+        </p:spPr>
+        <p:style>
+          <a:lnRef idx="1">
+            <a:schemeClr val="accent1"/>
+          </a:lnRef>
+          <a:fillRef idx="3">
+            <a:schemeClr val="accent1"/>
+          </a:fillRef>
+          <a:effectRef idx="2">
+            <a:schemeClr val="accent1"/>
+          </a:effectRef>
+          <a:fontRef idx="minor">
+            <a:schemeClr val="lt1"/>
+          </a:fontRef>
+        </p:style>
+        <p:txBody>
+          <a:bodyPr rtlCol="0" anchor="ctr" wrap="square" lIns="274320" rIns="274320" tIns="228600"/>
+          <a:lstStyle/>
+          <a:p>
+            <a:pPr algn="ctr"/>
+            <a:r>
+              <a:rPr sz="2200" b="1" i="0">
+                <a:solidFill>
+                  <a:srgbClr val="159E5B"/>
+                </a:solidFill>
+                <a:latin typeface="Calibri"/>
+              </a:rPr>
+              <a:t>✓  CONFIRMED</a:t>
+            </a:r>
+          </a:p>
+          <a:p>
+            <a:pPr>
+              <a:spcBef>
+                <a:spcPts val="1000"/>
+              </a:spcBef>
+            </a:pPr>
+            <a:r>
+              <a:rPr sz="1500" b="0" i="0">
+                <a:solidFill>
+                  <a:srgbClr val="374151"/>
+                </a:solidFill>
+                <a:latin typeface="Calibri"/>
+              </a:rPr>
+              <a:t>•  Jaccard ≈ 0, Spearman 0.18 vs correlation</a:t>
+            </a:r>
+          </a:p>
+          <a:p>
+            <a:pPr>
+              <a:spcBef>
+                <a:spcPts val="1000"/>
+              </a:spcBef>
+            </a:pPr>
+            <a:r>
+              <a:rPr sz="1500" b="0" i="0">
+                <a:solidFill>
+                  <a:srgbClr val="374151"/>
+                </a:solidFill>
+                <a:latin typeface="Calibri"/>
+              </a:rPr>
+              <a:t>•  augmented Forman: ~44% non-degree signal</a:t>
+            </a:r>
+          </a:p>
+          <a:p>
+            <a:pPr>
+              <a:spcBef>
+                <a:spcPts val="1000"/>
+              </a:spcBef>
+            </a:pPr>
+            <a:r>
+              <a:rPr sz="1500" b="0" i="0">
+                <a:solidFill>
+                  <a:srgbClr val="374151"/>
+                </a:solidFill>
+                <a:latin typeface="Calibri"/>
+              </a:rPr>
+              <a:t>•  curvature finds structure others miss</a:t>
+            </a:r>
+          </a:p>
+        </p:txBody>
+      </p:sp>
+      <p:sp>
+        <p:nvSpPr>
+          <p:cNvPr id="7" name="Rounded Rectangle 6"/>
+          <p:cNvSpPr/>
+          <p:nvPr/>
+        </p:nvSpPr>
+        <p:spPr>
+          <a:xfrm>
+            <a:off x="6309360" y="2240280"/>
+            <a:ext cx="5074920" cy="640080"/>
+          </a:xfrm>
+          <a:prstGeom prst="roundRect">
+            <a:avLst/>
+          </a:prstGeom>
+          <a:solidFill>
+            <a:srgbClr val="D97706"/>
+          </a:solidFill>
+          <a:ln>
+            <a:noFill/>
+          </a:ln>
+          <a:effectLst/>
+        </p:spPr>
+        <p:style>
+          <a:lnRef idx="1">
+            <a:schemeClr val="accent1"/>
+          </a:lnRef>
+          <a:fillRef idx="3">
+            <a:schemeClr val="accent1"/>
+          </a:fillRef>
+          <a:effectRef idx="2">
+            <a:schemeClr val="accent1"/>
+          </a:effectRef>
+          <a:fontRef idx="minor">
+            <a:schemeClr val="lt1"/>
+          </a:fontRef>
+        </p:style>
+        <p:txBody>
+          <a:bodyPr rtlCol="0" anchor="ctr" wrap="square"/>
+          <a:lstStyle/>
+          <a:p>
+            <a:pPr algn="ctr"/>
+            <a:r>
+              <a:rPr sz="1600" b="1" i="0">
+                <a:solidFill>
+                  <a:srgbClr val="FFFFFF"/>
+                </a:solidFill>
+                <a:latin typeface="Calibri"/>
+              </a:rPr>
+              <a:t>H2 — Predictive edge</a:t>
+            </a:r>
+          </a:p>
+        </p:txBody>
+      </p:sp>
+      <p:sp>
+        <p:nvSpPr>
+          <p:cNvPr id="8" name="Rounded Rectangle 7"/>
+          <p:cNvSpPr/>
+          <p:nvPr/>
+        </p:nvSpPr>
+        <p:spPr>
+          <a:xfrm>
+            <a:off x="6309360" y="3017520"/>
+            <a:ext cx="5074920" cy="2926080"/>
+          </a:xfrm>
+          <a:prstGeom prst="roundRect">
+            <a:avLst/>
+          </a:prstGeom>
+          <a:solidFill>
+            <a:srgbClr val="FDF4E6"/>
+          </a:solidFill>
+          <a:ln w="12700">
+            <a:solidFill>
+              <a:srgbClr val="D97706"/>
+            </a:solidFill>
+          </a:ln>
+          <a:effectLst/>
+        </p:spPr>
+        <p:style>
+          <a:lnRef idx="1">
+            <a:schemeClr val="accent1"/>
+          </a:lnRef>
+          <a:fillRef idx="3">
+            <a:schemeClr val="accent1"/>
+          </a:fillRef>
+          <a:effectRef idx="2">
+            <a:schemeClr val="accent1"/>
+          </a:effectRef>
+          <a:fontRef idx="minor">
+            <a:schemeClr val="lt1"/>
+          </a:fontRef>
+        </p:style>
+        <p:txBody>
+          <a:bodyPr rtlCol="0" anchor="ctr" wrap="square" lIns="274320" rIns="274320" tIns="228600"/>
+          <a:lstStyle/>
+          <a:p>
+            <a:pPr algn="ctr"/>
+            <a:r>
+              <a:rPr sz="2200" b="1" i="0">
+                <a:solidFill>
+                  <a:srgbClr val="D97706"/>
+                </a:solidFill>
+                <a:latin typeface="Calibri"/>
+              </a:rPr>
+              <a:t>✗  NOT SUPPORTED</a:t>
+            </a:r>
+          </a:p>
+          <a:p>
+            <a:pPr>
+              <a:spcBef>
+                <a:spcPts val="1000"/>
+              </a:spcBef>
+            </a:pPr>
+            <a:r>
+              <a:rPr sz="1500" b="0" i="0">
+                <a:solidFill>
+                  <a:srgbClr val="374151"/>
+                </a:solidFill>
+                <a:latin typeface="Calibri"/>
+              </a:rPr>
+              <a:t>•  Forman leads on OOS IC, but every CI spans zero</a:t>
+            </a:r>
+          </a:p>
+          <a:p>
+            <a:pPr>
+              <a:spcBef>
+                <a:spcPts val="1000"/>
+              </a:spcBef>
+            </a:pPr>
+            <a:r>
+              <a:rPr sz="1500" b="0" i="0">
+                <a:solidFill>
+                  <a:srgbClr val="374151"/>
+                </a:solidFill>
+                <a:latin typeface="Calibri"/>
+              </a:rPr>
+              <a:t>•  undirected ties directed — no edge from direction</a:t>
+            </a:r>
+          </a:p>
+          <a:p>
+            <a:pPr>
+              <a:spcBef>
+                <a:spcPts val="1000"/>
+              </a:spcBef>
+            </a:pPr>
+            <a:r>
+              <a:rPr sz="1500" b="0" i="0">
+                <a:solidFill>
+                  <a:srgbClr val="374151"/>
+                </a:solidFill>
+                <a:latin typeface="Calibri"/>
+              </a:rPr>
+              <a:t>•  an honest null; the claim rests on H1</a:t>
+            </a:r>
+          </a:p>
+        </p:txBody>
+      </p:sp>
+      <p:sp>
+        <p:nvSpPr>
+          <p:cNvPr id="9" name="TextBox 8"/>
+          <p:cNvSpPr txBox="1"/>
+          <p:nvPr/>
+        </p:nvSpPr>
+        <p:spPr>
+          <a:xfrm>
+            <a:off x="777240" y="6355080"/>
+            <a:ext cx="10607040" cy="365760"/>
+          </a:xfrm>
+          <a:prstGeom prst="rect">
+            <a:avLst/>
+          </a:prstGeom>
+          <a:noFill/>
+        </p:spPr>
+        <p:txBody>
+          <a:bodyPr wrap="square">
+            <a:spAutoFit/>
+          </a:bodyPr>
+          <a:lstStyle/>
+          <a:p>
+            <a:r>
+              <a:rPr sz="1100" b="0" i="0">
+                <a:solidFill>
+                  <a:srgbClr val="9CA3AF"/>
+                </a:solidFill>
+                <a:latin typeface="Calibri"/>
+              </a:rPr>
+              <a:t>Verdict</a:t>
+            </a:r>
+          </a:p>
+        </p:txBody>
+      </p:sp>
+      <p:sp>
+        <p:nvSpPr>
+          <p:cNvPr id="10" name="TextBox 9"/>
+          <p:cNvSpPr txBox="1"/>
+          <p:nvPr/>
+        </p:nvSpPr>
+        <p:spPr>
+          <a:xfrm>
+            <a:off x="10789920" y="6355080"/>
+            <a:ext cx="1280160" cy="365760"/>
+          </a:xfrm>
+          <a:prstGeom prst="rect">
+            <a:avLst/>
+          </a:prstGeom>
+          <a:noFill/>
+        </p:spPr>
+        <p:txBody>
+          <a:bodyPr wrap="square">
+            <a:spAutoFit/>
+          </a:bodyPr>
+          <a:lstStyle/>
+          <a:p>
+            <a:pPr algn="r"/>
+            <a:r>
+              <a:rPr sz="1100" b="0" i="0">
+                <a:solidFill>
+                  <a:srgbClr val="9CA3AF"/>
+                </a:solidFill>
+                <a:latin typeface="Calibri"/>
+              </a:rPr>
+              <a:t>16</a:t>
+            </a:r>
+          </a:p>
+        </p:txBody>
+      </p:sp>
+    </p:spTree>
+  </p:cSld>
+  <p:clrMapOvr>
+    <a:masterClrMapping/>
+  </p:clrMapOvr>
+</p:sld>
+</file>
+
+<file path=ppt/slides/slide18.xml><?xml version="1.0" encoding="utf-8"?>
+<p:sld xmlns:a="http://schemas.openxmlformats.org/drawingml/2006/main" xmlns:p="http://schemas.openxmlformats.org/presentationml/2006/main" xmlns:r="http://schemas.openxmlformats.org/officeDocument/2006/relationships">
+  <p:cSld>
+    <p:spTree>
+      <p:nvGrpSpPr>
+        <p:cNvPr id="1" name=""/>
+        <p:cNvGrpSpPr/>
+        <p:nvPr/>
+      </p:nvGrpSpPr>
+      <p:grpSpPr/>
+      <p:sp>
+        <p:nvSpPr>
+          <p:cNvPr id="2" name="TextBox 1"/>
+          <p:cNvSpPr txBox="1"/>
+          <p:nvPr/>
+        </p:nvSpPr>
+        <p:spPr>
+          <a:xfrm>
+            <a:off x="777240" y="640080"/>
+            <a:ext cx="10607040" cy="822960"/>
+          </a:xfrm>
+          <a:prstGeom prst="rect">
+            <a:avLst/>
+          </a:prstGeom>
+          <a:noFill/>
+        </p:spPr>
+        <p:txBody>
+          <a:bodyPr wrap="square">
+            <a:spAutoFit/>
+          </a:bodyPr>
+          <a:lstStyle/>
+          <a:p>
+            <a:r>
+              <a:rPr sz="3000" b="1" i="0">
+                <a:solidFill>
+                  <a:srgbClr val="1F2937"/>
+                </a:solidFill>
+                <a:latin typeface="Calibri"/>
+              </a:rPr>
+              <a:t>Where this could go</a:t>
+            </a:r>
+          </a:p>
+        </p:txBody>
+      </p:sp>
+      <p:sp>
+        <p:nvSpPr>
+          <p:cNvPr id="3" name="Rectangle 2"/>
+          <p:cNvSpPr/>
+          <p:nvPr/>
+        </p:nvSpPr>
+        <p:spPr>
+          <a:xfrm>
+            <a:off x="777240" y="1417320"/>
+            <a:ext cx="1828800" cy="38100"/>
+          </a:xfrm>
+          <a:prstGeom prst="rect">
+            <a:avLst/>
+          </a:prstGeom>
+          <a:solidFill>
+            <a:srgbClr val="2563EB"/>
+          </a:solidFill>
+          <a:ln>
+            <a:noFill/>
+          </a:ln>
+          <a:effectLst/>
+        </p:spPr>
+        <p:style>
+          <a:lnRef idx="1">
+            <a:schemeClr val="accent1"/>
+          </a:lnRef>
+          <a:fillRef idx="3">
+            <a:schemeClr val="accent1"/>
+          </a:fillRef>
+          <a:effectRef idx="2">
+            <a:schemeClr val="accent1"/>
+          </a:effectRef>
+          <a:fontRef idx="minor">
+            <a:schemeClr val="lt1"/>
+          </a:fontRef>
+        </p:style>
+        <p:txBody>
+          <a:bodyPr rtlCol="0" anchor="ctr"/>
+          <a:lstStyle/>
+          <a:p>
+            <a:pPr algn="ctr"/>
+          </a:p>
+        </p:txBody>
+      </p:sp>
+      <p:sp>
+        <p:nvSpPr>
+          <p:cNvPr id="4" name="TextBox 3"/>
+          <p:cNvSpPr txBox="1"/>
+          <p:nvPr/>
+        </p:nvSpPr>
+        <p:spPr>
+          <a:xfrm>
             <a:off x="777240" y="1783080"/>
             <a:ext cx="10607040" cy="731520"/>
           </a:xfrm>
@@ -6245,7 +7120,7 @@
                 </a:solidFill>
                 <a:latin typeface="Calibri"/>
               </a:rPr>
-              <a:t>•  Multi-frequency replication; curvature dynamics through 2020 stress.</a:t>
+              <a:t>•  A template for autonomous, agent-driven research in quant finance: an agent ran the full loop — hypothesize, build, test, honestly reject.</a:t>
             </a:r>
           </a:p>
           <a:p>
@@ -6330,7 +7205,7 @@
                 </a:solidFill>
                 <a:latin typeface="Calibri"/>
               </a:rPr>
-              <a:t>16</a:t>
+              <a:t>17</a:t>
             </a:r>
           </a:p>
         </p:txBody>
@@ -7286,7 +8161,7 @@
                 </a:solidFill>
                 <a:latin typeface="Calibri"/>
               </a:rPr>
-              <a:t>The hypothesis</a:t>
+              <a:t>Two hypotheses</a:t>
             </a:r>
           </a:p>
         </p:txBody>
@@ -7344,7 +8219,7 @@
         <p:spPr>
           <a:xfrm>
             <a:off x="777240" y="1783080"/>
-            <a:ext cx="10607040" cy="731520"/>
+            <a:ext cx="10607040" cy="640080"/>
           </a:xfrm>
           <a:prstGeom prst="rect">
             <a:avLst/>
@@ -7358,27 +8233,149 @@
           <a:lstStyle/>
           <a:p>
             <a:r>
-              <a:rPr sz="1900" b="0" i="1">
+              <a:rPr sz="1800" b="0" i="1">
                 <a:solidFill>
                   <a:srgbClr val="2563EB"/>
                 </a:solidFill>
                 <a:latin typeface="Calibri"/>
               </a:rPr>
-              <a:t>The claim is structural and falsifiable.</a:t>
-            </a:r>
-          </a:p>
-        </p:txBody>
-      </p:sp>
-      <p:sp>
-        <p:nvSpPr>
-          <p:cNvPr id="5" name="TextBox 4"/>
+              <a:t>Both falsifiable. The paper's claim rests on H1; H2 is exploratory.</a:t>
+            </a:r>
+          </a:p>
+        </p:txBody>
+      </p:sp>
+      <p:graphicFrame>
+        <p:nvGraphicFramePr>
+          <p:cNvPr id="5" name="Table 4"/>
+          <p:cNvGraphicFramePr>
+            <a:graphicFrameLocks noGrp="1"/>
+          </p:cNvGraphicFramePr>
+          <p:nvPr/>
+        </p:nvGraphicFramePr>
+        <p:xfrm>
+          <a:off x="777240" y="2377440"/>
+          <a:ext cx="10424160" cy="914400"/>
+        </p:xfrm>
+        <a:graphic>
+          <a:graphicData uri="http://schemas.openxmlformats.org/drawingml/2006/table">
+            <a:tbl>
+              <a:tblPr firstRow="1" bandRow="1">
+                <a:tableStyleId>{5C22544A-7EE6-4342-B048-85BDC9FD1C3A}</a:tableStyleId>
+              </a:tblPr>
+              <a:tblGrid>
+                <a:gridCol w="5212080"/>
+                <a:gridCol w="5212080"/>
+              </a:tblGrid>
+              <a:tr h="457200">
+                <a:tc>
+                  <a:txBody>
+                    <a:bodyPr/>
+                    <a:lstStyle/>
+                    <a:p>
+                      <a:pPr algn="l"/>
+                      <a:r>
+                        <a:rPr sz="1500" b="1" i="0">
+                          <a:solidFill>
+                            <a:srgbClr val="FFFFFF"/>
+                          </a:solidFill>
+                          <a:latin typeface="Calibri"/>
+                        </a:rPr>
+                        <a:t>H1 — Structural  (primary)</a:t>
+                      </a:r>
+                    </a:p>
+                  </a:txBody>
+                  <a:tcPr anchor="ctr">
+                    <a:solidFill>
+                      <a:srgbClr val="2563EB"/>
+                    </a:solidFill>
+                  </a:tcPr>
+                </a:tc>
+                <a:tc>
+                  <a:txBody>
+                    <a:bodyPr/>
+                    <a:lstStyle/>
+                    <a:p>
+                      <a:pPr algn="l"/>
+                      <a:r>
+                        <a:rPr sz="1500" b="1" i="0">
+                          <a:solidFill>
+                            <a:srgbClr val="FFFFFF"/>
+                          </a:solidFill>
+                          <a:latin typeface="Calibri"/>
+                        </a:rPr>
+                        <a:t>H2 — Predictive  (secondary)</a:t>
+                      </a:r>
+                    </a:p>
+                  </a:txBody>
+                  <a:tcPr anchor="ctr">
+                    <a:solidFill>
+                      <a:srgbClr val="2563EB"/>
+                    </a:solidFill>
+                  </a:tcPr>
+                </a:tc>
+              </a:tr>
+              <a:tr h="457200">
+                <a:tc>
+                  <a:txBody>
+                    <a:bodyPr/>
+                    <a:lstStyle/>
+                    <a:p>
+                      <a:pPr algn="l"/>
+                      <a:r>
+                        <a:rPr sz="1400" b="0" i="0">
+                          <a:solidFill>
+                            <a:srgbClr val="374151"/>
+                          </a:solidFill>
+                          <a:latin typeface="Calibri"/>
+                        </a:rPr>
+                        <a:t>Negatively-curved pairs in the directed, residualized lead-lag network are structurally distinct — bridges that correlation, degree, and undirected curvature do not recover.</a:t>
+                      </a:r>
+                    </a:p>
+                  </a:txBody>
+                  <a:tcPr anchor="ctr">
+                    <a:solidFill>
+                      <a:srgbClr val="FFFFFF"/>
+                    </a:solidFill>
+                  </a:tcPr>
+                </a:tc>
+                <a:tc>
+                  <a:txBody>
+                    <a:bodyPr/>
+                    <a:lstStyle/>
+                    <a:p>
+                      <a:pPr algn="l"/>
+                      <a:r>
+                        <a:rPr sz="1400" b="0" i="0">
+                          <a:solidFill>
+                            <a:srgbClr val="374151"/>
+                          </a:solidFill>
+                          <a:latin typeface="Calibri"/>
+                        </a:rPr>
+                        <a:t>Those same pairs also carry out-of-sample directional information: today's leader predicts tomorrow's lagger, beyond the baselines.</a:t>
+                      </a:r>
+                    </a:p>
+                  </a:txBody>
+                  <a:tcPr anchor="ctr">
+                    <a:solidFill>
+                      <a:srgbClr val="FFFFFF"/>
+                    </a:solidFill>
+                  </a:tcPr>
+                </a:tc>
+              </a:tr>
+            </a:tbl>
+          </a:graphicData>
+        </a:graphic>
+      </p:graphicFrame>
+      <p:sp>
+        <p:nvSpPr>
+          <p:cNvPr id="6" name="TextBox 5"/>
           <p:cNvSpPr txBox="1"/>
           <p:nvPr/>
         </p:nvSpPr>
         <p:spPr>
           <a:xfrm>
-            <a:off x="777240" y="2514600"/>
-            <a:ext cx="10607040" cy="3657600"/>
+            <a:off x="777240" y="5715000"/>
+            <a:ext cx="10607040" cy="640080"/>
           </a:xfrm>
           <a:prstGeom prst="rect">
             <a:avLst/>
@@ -7391,74 +8388,21 @@
           </a:bodyPr>
           <a:lstStyle/>
           <a:p>
-            <a:pPr>
-              <a:spcAft>
-                <a:spcPts val="1200"/>
-              </a:spcAft>
-            </a:pPr>
-            <a:r>
-              <a:rPr sz="2100" b="0" i="0">
-                <a:solidFill>
-                  <a:srgbClr val="374151"/>
-                </a:solidFill>
-                <a:latin typeface="Calibri"/>
-              </a:rPr>
-              <a:t>•  Negatively-curved edges in the directed, factor-residualized lead-lag network mark structurally isolated pairs —</a:t>
-            </a:r>
-          </a:p>
-          <a:p>
-            <a:pPr lvl="1">
-              <a:spcAft>
-                <a:spcPts val="600"/>
-              </a:spcAft>
-            </a:pPr>
-            <a:r>
-              <a:rPr sz="1800" b="0" i="0">
+            <a:r>
+              <a:rPr sz="1400" b="0" i="1">
                 <a:solidFill>
                   <a:srgbClr val="9CA3AF"/>
                 </a:solidFill>
                 <a:latin typeface="Calibri"/>
               </a:rPr>
-              <a:t>–  bridges between otherwise separated regions of the market —</a:t>
-            </a:r>
-          </a:p>
-          <a:p>
-            <a:pPr lvl="1">
-              <a:spcAft>
-                <a:spcPts val="600"/>
-              </a:spcAft>
-            </a:pPr>
-            <a:r>
-              <a:rPr sz="1800" b="0" i="0">
-                <a:solidFill>
-                  <a:srgbClr val="9CA3AF"/>
-                </a:solidFill>
-                <a:latin typeface="Calibri"/>
-              </a:rPr>
-              <a:t>–  that correlation-, degree-, and undirected-curvature methods do not recover.</a:t>
-            </a:r>
-          </a:p>
-          <a:p>
-            <a:pPr>
-              <a:spcAft>
-                <a:spcPts val="1200"/>
-              </a:spcAft>
-            </a:pPr>
-            <a:r>
-              <a:rPr sz="2100" b="0" i="0">
-                <a:solidFill>
-                  <a:srgbClr val="374151"/>
-                </a:solidFill>
-                <a:latin typeface="Calibri"/>
-              </a:rPr>
-              <a:t>•  Lead-lag asymmetry encodes structure the symmetric correlation graph destroys.</a:t>
-            </a:r>
-          </a:p>
-        </p:txBody>
-      </p:sp>
-      <p:sp>
-        <p:nvSpPr>
-          <p:cNvPr id="6" name="TextBox 5"/>
+              <a:t>We answer both at the end.</a:t>
+            </a:r>
+          </a:p>
+        </p:txBody>
+      </p:sp>
+      <p:sp>
+        <p:nvSpPr>
+          <p:cNvPr id="7" name="TextBox 6"/>
           <p:cNvSpPr txBox="1"/>
           <p:nvPr/>
         </p:nvSpPr>
@@ -7492,7 +8436,7 @@
       </p:sp>
       <p:sp>
         <p:nvSpPr>
-          <p:cNvPr id="7" name="TextBox 6"/>
+          <p:cNvPr id="8" name="TextBox 7"/>
           <p:cNvSpPr txBox="1"/>
           <p:nvPr/>
         </p:nvSpPr>

</xml_diff>

<commit_message>
Deck: collapse agentic AI into one concise slide
Replaced the two agentic slides (where-used table + worked/needed-human verdict)
with a single honest slide: agentic AI helped research the idea and, crucially,
link curvature to lead-lag networks; framing stayed human. Talk script updated and
renumbered (now 23 slides).

Co-Authored-By: Claude Opus 4.8 (1M context) <noreply@anthropic.com>
</commit_message>
<xml_diff>
--- a/slides/Ricci_Curvature_LeadLag.pptx
+++ b/slides/Ricci_Curvature_LeadLag.pptx
@@ -28,7 +28,6 @@
     <p:sldId id="276" r:id="rId27"/>
     <p:sldId id="277" r:id="rId28"/>
     <p:sldId id="278" r:id="rId29"/>
-    <p:sldId id="279" r:id="rId30"/>
   </p:sldIdLst>
   <p:sldSz cx="12191695" cy="6858000" type="screen4x3"/>
   <p:notesSz cx="6858000" cy="9144000"/>
@@ -8111,7 +8110,7 @@
                 </a:solidFill>
                 <a:latin typeface="Calibri"/>
               </a:rPr>
-              <a:t>Agentic AI workflow — where it was used</a:t>
+              <a:t>Agentic AI workflow</a:t>
             </a:r>
           </a:p>
         </p:txBody>
@@ -8169,7 +8168,7 @@
         <p:spPr>
           <a:xfrm>
             <a:off x="777240" y="1783080"/>
-            <a:ext cx="10607040" cy="640080"/>
+            <a:ext cx="10607040" cy="731520"/>
           </a:xfrm>
           <a:prstGeom prst="rect">
             <a:avLst/>
@@ -8183,341 +8182,27 @@
           <a:lstStyle/>
           <a:p>
             <a:r>
-              <a:rPr sz="1800" b="0" i="1">
+              <a:rPr sz="1900" b="0" i="1">
                 <a:solidFill>
                   <a:srgbClr val="2563EB"/>
                 </a:solidFill>
                 <a:latin typeface="Calibri"/>
               </a:rPr>
-              <a:t>An agent ran most of the research loop.</a:t>
-            </a:r>
-          </a:p>
-        </p:txBody>
-      </p:sp>
-      <p:graphicFrame>
-        <p:nvGraphicFramePr>
-          <p:cNvPr id="5" name="Table 4"/>
-          <p:cNvGraphicFramePr>
-            <a:graphicFrameLocks noGrp="1"/>
-          </p:cNvGraphicFramePr>
-          <p:nvPr/>
-        </p:nvGraphicFramePr>
-        <p:xfrm>
-          <a:off x="777240" y="2377440"/>
-          <a:ext cx="10607040" cy="2743200"/>
-        </p:xfrm>
-        <a:graphic>
-          <a:graphicData uri="http://schemas.openxmlformats.org/drawingml/2006/table">
-            <a:tbl>
-              <a:tblPr firstRow="1" bandRow="1">
-                <a:tableStyleId>{5C22544A-7EE6-4342-B048-85BDC9FD1C3A}</a:tableStyleId>
-              </a:tblPr>
-              <a:tblGrid>
-                <a:gridCol w="2743200"/>
-                <a:gridCol w="7863840"/>
-              </a:tblGrid>
-              <a:tr h="457200">
-                <a:tc>
-                  <a:txBody>
-                    <a:bodyPr/>
-                    <a:lstStyle/>
-                    <a:p>
-                      <a:pPr algn="l"/>
-                      <a:r>
-                        <a:rPr sz="1500" b="1" i="0">
-                          <a:solidFill>
-                            <a:srgbClr val="FFFFFF"/>
-                          </a:solidFill>
-                          <a:latin typeface="Calibri"/>
-                        </a:rPr>
-                        <a:t>Stage</a:t>
-                      </a:r>
-                    </a:p>
-                  </a:txBody>
-                  <a:tcPr anchor="ctr">
-                    <a:solidFill>
-                      <a:srgbClr val="2563EB"/>
-                    </a:solidFill>
-                  </a:tcPr>
-                </a:tc>
-                <a:tc>
-                  <a:txBody>
-                    <a:bodyPr/>
-                    <a:lstStyle/>
-                    <a:p>
-                      <a:pPr algn="l"/>
-                      <a:r>
-                        <a:rPr sz="1500" b="1" i="0">
-                          <a:solidFill>
-                            <a:srgbClr val="FFFFFF"/>
-                          </a:solidFill>
-                          <a:latin typeface="Calibri"/>
-                        </a:rPr>
-                        <a:t>How agentic AI was used</a:t>
-                      </a:r>
-                    </a:p>
-                  </a:txBody>
-                  <a:tcPr anchor="ctr">
-                    <a:solidFill>
-                      <a:srgbClr val="2563EB"/>
-                    </a:solidFill>
-                  </a:tcPr>
-                </a:tc>
-              </a:tr>
-              <a:tr h="457200">
-                <a:tc>
-                  <a:txBody>
-                    <a:bodyPr/>
-                    <a:lstStyle/>
-                    <a:p>
-                      <a:pPr algn="l"/>
-                      <a:r>
-                        <a:rPr sz="1400" b="0" i="0">
-                          <a:solidFill>
-                            <a:srgbClr val="374151"/>
-                          </a:solidFill>
-                          <a:latin typeface="Calibri"/>
-                        </a:rPr>
-                        <a:t>Coding &amp; tests</a:t>
-                      </a:r>
-                    </a:p>
-                  </a:txBody>
-                  <a:tcPr anchor="ctr">
-                    <a:solidFill>
-                      <a:srgbClr val="FFFFFF"/>
-                    </a:solidFill>
-                  </a:tcPr>
-                </a:tc>
-                <a:tc>
-                  <a:txBody>
-                    <a:bodyPr/>
-                    <a:lstStyle/>
-                    <a:p>
-                      <a:pPr algn="l"/>
-                      <a:r>
-                        <a:rPr sz="1400" b="0" i="0">
-                          <a:solidFill>
-                            <a:srgbClr val="374151"/>
-                          </a:solidFill>
-                          <a:latin typeface="Calibri"/>
-                        </a:rPr>
-                        <a:t>built the 6-module pipeline + 50 tests end-to-end</a:t>
-                      </a:r>
-                    </a:p>
-                  </a:txBody>
-                  <a:tcPr anchor="ctr">
-                    <a:solidFill>
-                      <a:srgbClr val="FFFFFF"/>
-                    </a:solidFill>
-                  </a:tcPr>
-                </a:tc>
-              </a:tr>
-              <a:tr h="457200">
-                <a:tc>
-                  <a:txBody>
-                    <a:bodyPr/>
-                    <a:lstStyle/>
-                    <a:p>
-                      <a:pPr algn="l"/>
-                      <a:r>
-                        <a:rPr sz="1400" b="0" i="0">
-                          <a:solidFill>
-                            <a:srgbClr val="374151"/>
-                          </a:solidFill>
-                          <a:latin typeface="Calibri"/>
-                        </a:rPr>
-                        <a:t>Data acquisition</a:t>
-                      </a:r>
-                    </a:p>
-                  </a:txBody>
-                  <a:tcPr anchor="ctr">
-                    <a:solidFill>
-                      <a:srgbClr val="EFF2FB"/>
-                    </a:solidFill>
-                  </a:tcPr>
-                </a:tc>
-                <a:tc>
-                  <a:txBody>
-                    <a:bodyPr/>
-                    <a:lstStyle/>
-                    <a:p>
-                      <a:pPr algn="l"/>
-                      <a:r>
-                        <a:rPr sz="1400" b="0" i="0">
-                          <a:solidFill>
-                            <a:srgbClr val="374151"/>
-                          </a:solidFill>
-                          <a:latin typeface="Calibri"/>
-                        </a:rPr>
-                        <a:t>autonomous WRDS pulls (CRSP, Compustat, TAQ); resumable loader</a:t>
-                      </a:r>
-                    </a:p>
-                  </a:txBody>
-                  <a:tcPr anchor="ctr">
-                    <a:solidFill>
-                      <a:srgbClr val="EFF2FB"/>
-                    </a:solidFill>
-                  </a:tcPr>
-                </a:tc>
-              </a:tr>
-              <a:tr h="457200">
-                <a:tc>
-                  <a:txBody>
-                    <a:bodyPr/>
-                    <a:lstStyle/>
-                    <a:p>
-                      <a:pPr algn="l"/>
-                      <a:r>
-                        <a:rPr sz="1400" b="0" i="0">
-                          <a:solidFill>
-                            <a:srgbClr val="374151"/>
-                          </a:solidFill>
-                          <a:latin typeface="Calibri"/>
-                        </a:rPr>
-                        <a:t>Debugging</a:t>
-                      </a:r>
-                    </a:p>
-                  </a:txBody>
-                  <a:tcPr anchor="ctr">
-                    <a:solidFill>
-                      <a:srgbClr val="FFFFFF"/>
-                    </a:solidFill>
-                  </a:tcPr>
-                </a:tc>
-                <a:tc>
-                  <a:txBody>
-                    <a:bodyPr/>
-                    <a:lstStyle/>
-                    <a:p>
-                      <a:pPr algn="l"/>
-                      <a:r>
-                        <a:rPr sz="1400" b="0" i="0">
-                          <a:solidFill>
-                            <a:srgbClr val="374151"/>
-                          </a:solidFill>
-                          <a:latin typeface="Calibri"/>
-                        </a:rPr>
-                        <a:t>caught a TAQ memory bug, a gitignore data-loss bug, a NaN-graph hang</a:t>
-                      </a:r>
-                    </a:p>
-                  </a:txBody>
-                  <a:tcPr anchor="ctr">
-                    <a:solidFill>
-                      <a:srgbClr val="FFFFFF"/>
-                    </a:solidFill>
-                  </a:tcPr>
-                </a:tc>
-              </a:tr>
-              <a:tr h="457200">
-                <a:tc>
-                  <a:txBody>
-                    <a:bodyPr/>
-                    <a:lstStyle/>
-                    <a:p>
-                      <a:pPr algn="l"/>
-                      <a:r>
-                        <a:rPr sz="1400" b="0" i="0">
-                          <a:solidFill>
-                            <a:srgbClr val="374151"/>
-                          </a:solidFill>
-                          <a:latin typeface="Calibri"/>
-                        </a:rPr>
-                        <a:t>Experiment design</a:t>
-                      </a:r>
-                    </a:p>
-                  </a:txBody>
-                  <a:tcPr anchor="ctr">
-                    <a:solidFill>
-                      <a:srgbClr val="EFF2FB"/>
-                    </a:solidFill>
-                  </a:tcPr>
-                </a:tc>
-                <a:tc>
-                  <a:txBody>
-                    <a:bodyPr/>
-                    <a:lstStyle/>
-                    <a:p>
-                      <a:pPr algn="l"/>
-                      <a:r>
-                        <a:rPr sz="1400" b="0" i="0">
-                          <a:solidFill>
-                            <a:srgbClr val="374151"/>
-                          </a:solidFill>
-                          <a:latin typeface="Calibri"/>
-                        </a:rPr>
-                        <a:t>within-day estimator, walk-forward, two-horizon test</a:t>
-                      </a:r>
-                    </a:p>
-                  </a:txBody>
-                  <a:tcPr anchor="ctr">
-                    <a:solidFill>
-                      <a:srgbClr val="EFF2FB"/>
-                    </a:solidFill>
-                  </a:tcPr>
-                </a:tc>
-              </a:tr>
-              <a:tr h="457200">
-                <a:tc>
-                  <a:txBody>
-                    <a:bodyPr/>
-                    <a:lstStyle/>
-                    <a:p>
-                      <a:pPr algn="l"/>
-                      <a:r>
-                        <a:rPr sz="1400" b="0" i="0">
-                          <a:solidFill>
-                            <a:srgbClr val="374151"/>
-                          </a:solidFill>
-                          <a:latin typeface="Calibri"/>
-                        </a:rPr>
-                        <a:t>Writing &amp; visuals</a:t>
-                      </a:r>
-                    </a:p>
-                  </a:txBody>
-                  <a:tcPr anchor="ctr">
-                    <a:solidFill>
-                      <a:srgbClr val="FFFFFF"/>
-                    </a:solidFill>
-                  </a:tcPr>
-                </a:tc>
-                <a:tc>
-                  <a:txBody>
-                    <a:bodyPr/>
-                    <a:lstStyle/>
-                    <a:p>
-                      <a:pPr algn="l"/>
-                      <a:r>
-                        <a:rPr sz="1400" b="0" i="0">
-                          <a:solidFill>
-                            <a:srgbClr val="374151"/>
-                          </a:solidFill>
-                          <a:latin typeface="Calibri"/>
-                        </a:rPr>
-                        <a:t>this deck (python-pptx), the report, the talk script</a:t>
-                      </a:r>
-                    </a:p>
-                  </a:txBody>
-                  <a:tcPr anchor="ctr">
-                    <a:solidFill>
-                      <a:srgbClr val="FFFFFF"/>
-                    </a:solidFill>
-                  </a:tcPr>
-                </a:tc>
-              </a:tr>
-            </a:tbl>
-          </a:graphicData>
-        </a:graphic>
-      </p:graphicFrame>
-      <p:sp>
-        <p:nvSpPr>
-          <p:cNvPr id="6" name="TextBox 5"/>
+              <a:t>What agentic AI did here.</a:t>
+            </a:r>
+          </a:p>
+        </p:txBody>
+      </p:sp>
+      <p:sp>
+        <p:nvSpPr>
+          <p:cNvPr id="5" name="TextBox 4"/>
           <p:cNvSpPr txBox="1"/>
           <p:nvPr/>
         </p:nvSpPr>
         <p:spPr>
           <a:xfrm>
-            <a:off x="777240" y="5715000"/>
-            <a:ext cx="10607040" cy="640080"/>
+            <a:off x="777240" y="2514600"/>
+            <a:ext cx="10607040" cy="3657600"/>
           </a:xfrm>
           <a:prstGeom prst="rect">
             <a:avLst/>
@@ -8530,21 +8215,58 @@
           </a:bodyPr>
           <a:lstStyle/>
           <a:p>
-            <a:r>
-              <a:rPr sz="1400" b="0" i="1">
-                <a:solidFill>
-                  <a:srgbClr val="9CA3AF"/>
-                </a:solidFill>
-                <a:latin typeface="Calibri"/>
-              </a:rPr>
-              <a:t>Impossible / far slower without it: build+test a 6-module pipeline, pull 25 yrs of WRDS + intraday TAQ, run a 21-window walk-forward, AND write it up — in days, not months.</a:t>
-            </a:r>
-          </a:p>
-        </p:txBody>
-      </p:sp>
-      <p:sp>
-        <p:nvSpPr>
-          <p:cNvPr id="7" name="TextBox 6"/>
+            <a:pPr>
+              <a:spcAft>
+                <a:spcPts val="1200"/>
+              </a:spcAft>
+            </a:pPr>
+            <a:r>
+              <a:rPr sz="2100" b="0" i="0">
+                <a:solidFill>
+                  <a:srgbClr val="374151"/>
+                </a:solidFill>
+                <a:latin typeface="Calibri"/>
+              </a:rPr>
+              <a:t>•  Helped me research the idea — surveying the curvature and lead-lag literature, and coding the pipeline.</a:t>
+            </a:r>
+          </a:p>
+          <a:p>
+            <a:pPr>
+              <a:spcAft>
+                <a:spcPts val="1200"/>
+              </a:spcAft>
+            </a:pPr>
+            <a:r>
+              <a:rPr sz="2100" b="0" i="0">
+                <a:solidFill>
+                  <a:srgbClr val="374151"/>
+                </a:solidFill>
+                <a:latin typeface="Calibri"/>
+              </a:rPr>
+              <a:t>•  Its core role: linking curvature (graph geometry) to directed lead-lag networks (the finance side).</a:t>
+            </a:r>
+          </a:p>
+          <a:p>
+            <a:pPr>
+              <a:spcAft>
+                <a:spcPts val="1200"/>
+              </a:spcAft>
+            </a:pPr>
+            <a:r>
+              <a:rPr sz="2100" b="0" i="0">
+                <a:solidFill>
+                  <a:srgbClr val="374151"/>
+                </a:solidFill>
+                <a:latin typeface="Calibri"/>
+              </a:rPr>
+              <a:t>•  Framing and judgment stayed human.</a:t>
+            </a:r>
+          </a:p>
+        </p:txBody>
+      </p:sp>
+      <p:sp>
+        <p:nvSpPr>
+          <p:cNvPr id="6" name="TextBox 5"/>
           <p:cNvSpPr txBox="1"/>
           <p:nvPr/>
         </p:nvSpPr>
@@ -8578,7 +8300,7 @@
       </p:sp>
       <p:sp>
         <p:nvSpPr>
-          <p:cNvPr id="8" name="TextBox 7"/>
+          <p:cNvPr id="7" name="TextBox 6"/>
           <p:cNvSpPr txBox="1"/>
           <p:nvPr/>
         </p:nvSpPr>
@@ -8658,7 +8380,7 @@
                 </a:solidFill>
                 <a:latin typeface="Calibri"/>
               </a:rPr>
-              <a:t>What worked vs. what needed a human</a:t>
+              <a:t>Limitations</a:t>
             </a:r>
           </a:p>
         </p:txBody>
@@ -8715,8 +8437,8 @@
         </p:nvSpPr>
         <p:spPr>
           <a:xfrm>
-            <a:off x="777240" y="1600200"/>
-            <a:ext cx="10607040" cy="457200"/>
+            <a:off x="777240" y="1783080"/>
+            <a:ext cx="10607040" cy="731520"/>
           </a:xfrm>
           <a:prstGeom prst="rect">
             <a:avLst/>
@@ -8730,339 +8452,27 @@
           <a:lstStyle/>
           <a:p>
             <a:r>
-              <a:rPr sz="1700" b="0" i="1">
+              <a:rPr sz="1900" b="0" i="1">
                 <a:solidFill>
                   <a:srgbClr val="2563EB"/>
                 </a:solidFill>
                 <a:latin typeface="Calibri"/>
               </a:rPr>
-              <a:t>Agentic AI did the building; human judgment set the framing.</a:t>
-            </a:r>
-          </a:p>
-        </p:txBody>
-      </p:sp>
-      <p:sp>
-        <p:nvSpPr>
-          <p:cNvPr id="5" name="Rounded Rectangle 4"/>
-          <p:cNvSpPr/>
-          <p:nvPr/>
-        </p:nvSpPr>
-        <p:spPr>
-          <a:xfrm>
-            <a:off x="777240" y="2240280"/>
-            <a:ext cx="5074920" cy="640080"/>
-          </a:xfrm>
-          <a:prstGeom prst="roundRect">
-            <a:avLst/>
-          </a:prstGeom>
-          <a:solidFill>
-            <a:srgbClr val="159E5B"/>
-          </a:solidFill>
-          <a:ln>
-            <a:noFill/>
-          </a:ln>
-          <a:effectLst/>
-        </p:spPr>
-        <p:style>
-          <a:lnRef idx="1">
-            <a:schemeClr val="accent1"/>
-          </a:lnRef>
-          <a:fillRef idx="3">
-            <a:schemeClr val="accent1"/>
-          </a:fillRef>
-          <a:effectRef idx="2">
-            <a:schemeClr val="accent1"/>
-          </a:effectRef>
-          <a:fontRef idx="minor">
-            <a:schemeClr val="lt1"/>
-          </a:fontRef>
-        </p:style>
-        <p:txBody>
-          <a:bodyPr rtlCol="0" anchor="ctr" wrap="square"/>
-          <a:lstStyle/>
-          <a:p>
-            <a:pPr algn="ctr"/>
-            <a:r>
-              <a:rPr sz="1600" b="1" i="0">
-                <a:solidFill>
-                  <a:srgbClr val="FFFFFF"/>
-                </a:solidFill>
-                <a:latin typeface="Calibri"/>
-              </a:rPr>
-              <a:t>Autonomous (worked well)</a:t>
-            </a:r>
-          </a:p>
-        </p:txBody>
-      </p:sp>
-      <p:sp>
-        <p:nvSpPr>
-          <p:cNvPr id="6" name="Rounded Rectangle 5"/>
-          <p:cNvSpPr/>
-          <p:nvPr/>
-        </p:nvSpPr>
-        <p:spPr>
-          <a:xfrm>
-            <a:off x="777240" y="3017520"/>
-            <a:ext cx="5074920" cy="2926080"/>
-          </a:xfrm>
-          <a:prstGeom prst="roundRect">
-            <a:avLst/>
-          </a:prstGeom>
-          <a:solidFill>
-            <a:srgbClr val="ECFBF2"/>
-          </a:solidFill>
-          <a:ln w="12700">
-            <a:solidFill>
-              <a:srgbClr val="159E5B"/>
-            </a:solidFill>
-          </a:ln>
-          <a:effectLst/>
-        </p:spPr>
-        <p:style>
-          <a:lnRef idx="1">
-            <a:schemeClr val="accent1"/>
-          </a:lnRef>
-          <a:fillRef idx="3">
-            <a:schemeClr val="accent1"/>
-          </a:fillRef>
-          <a:effectRef idx="2">
-            <a:schemeClr val="accent1"/>
-          </a:effectRef>
-          <a:fontRef idx="minor">
-            <a:schemeClr val="lt1"/>
-          </a:fontRef>
-        </p:style>
-        <p:txBody>
-          <a:bodyPr rtlCol="0" anchor="ctr" wrap="square" lIns="274320" rIns="274320" tIns="228600"/>
-          <a:lstStyle/>
-          <a:p>
-            <a:pPr algn="ctr"/>
-            <a:r>
-              <a:rPr sz="2200" b="1" i="0">
-                <a:solidFill>
-                  <a:srgbClr val="159E5B"/>
-                </a:solidFill>
-                <a:latin typeface="Calibri"/>
-              </a:rPr>
-              <a:t>The machine</a:t>
-            </a:r>
-          </a:p>
-          <a:p>
-            <a:pPr>
-              <a:spcBef>
-                <a:spcPts val="1000"/>
-              </a:spcBef>
-            </a:pPr>
-            <a:r>
-              <a:rPr sz="1500" b="0" i="0">
-                <a:solidFill>
-                  <a:srgbClr val="374151"/>
-                </a:solidFill>
-                <a:latin typeface="Calibri"/>
-              </a:rPr>
-              <a:t>•  full pipeline build, tests, refactors</a:t>
-            </a:r>
-          </a:p>
-          <a:p>
-            <a:pPr>
-              <a:spcBef>
-                <a:spcPts val="1000"/>
-              </a:spcBef>
-            </a:pPr>
-            <a:r>
-              <a:rPr sz="1500" b="0" i="0">
-                <a:solidFill>
-                  <a:srgbClr val="374151"/>
-                </a:solidFill>
-                <a:latin typeface="Calibri"/>
-              </a:rPr>
-              <a:t>•  WRDS data pulls + self-caught bugs</a:t>
-            </a:r>
-          </a:p>
-          <a:p>
-            <a:pPr>
-              <a:spcBef>
-                <a:spcPts val="1000"/>
-              </a:spcBef>
-            </a:pPr>
-            <a:r>
-              <a:rPr sz="1500" b="0" i="0">
-                <a:solidFill>
-                  <a:srgbClr val="374151"/>
-                </a:solidFill>
-                <a:latin typeface="Calibri"/>
-              </a:rPr>
-              <a:t>•  21-window walk-forward + cascade</a:t>
-            </a:r>
-          </a:p>
-        </p:txBody>
-      </p:sp>
-      <p:sp>
-        <p:nvSpPr>
-          <p:cNvPr id="7" name="Rounded Rectangle 6"/>
-          <p:cNvSpPr/>
-          <p:nvPr/>
-        </p:nvSpPr>
-        <p:spPr>
-          <a:xfrm>
-            <a:off x="6309360" y="2240280"/>
-            <a:ext cx="5074920" cy="640080"/>
-          </a:xfrm>
-          <a:prstGeom prst="roundRect">
-            <a:avLst/>
-          </a:prstGeom>
-          <a:solidFill>
-            <a:srgbClr val="2563EB"/>
-          </a:solidFill>
-          <a:ln>
-            <a:noFill/>
-          </a:ln>
-          <a:effectLst/>
-        </p:spPr>
-        <p:style>
-          <a:lnRef idx="1">
-            <a:schemeClr val="accent1"/>
-          </a:lnRef>
-          <a:fillRef idx="3">
-            <a:schemeClr val="accent1"/>
-          </a:fillRef>
-          <a:effectRef idx="2">
-            <a:schemeClr val="accent1"/>
-          </a:effectRef>
-          <a:fontRef idx="minor">
-            <a:schemeClr val="lt1"/>
-          </a:fontRef>
-        </p:style>
-        <p:txBody>
-          <a:bodyPr rtlCol="0" anchor="ctr" wrap="square"/>
-          <a:lstStyle/>
-          <a:p>
-            <a:pPr algn="ctr"/>
-            <a:r>
-              <a:rPr sz="1600" b="1" i="0">
-                <a:solidFill>
-                  <a:srgbClr val="FFFFFF"/>
-                </a:solidFill>
-                <a:latin typeface="Calibri"/>
-              </a:rPr>
-              <a:t>Human-in-the-loop (judgment)</a:t>
-            </a:r>
-          </a:p>
-        </p:txBody>
-      </p:sp>
-      <p:sp>
-        <p:nvSpPr>
-          <p:cNvPr id="8" name="Rounded Rectangle 7"/>
-          <p:cNvSpPr/>
-          <p:nvPr/>
-        </p:nvSpPr>
-        <p:spPr>
-          <a:xfrm>
-            <a:off x="6309360" y="3017520"/>
-            <a:ext cx="5074920" cy="2926080"/>
-          </a:xfrm>
-          <a:prstGeom prst="roundRect">
-            <a:avLst/>
-          </a:prstGeom>
-          <a:solidFill>
-            <a:srgbClr val="EFF2FB"/>
-          </a:solidFill>
-          <a:ln w="12700">
-            <a:solidFill>
-              <a:srgbClr val="2563EB"/>
-            </a:solidFill>
-          </a:ln>
-          <a:effectLst/>
-        </p:spPr>
-        <p:style>
-          <a:lnRef idx="1">
-            <a:schemeClr val="accent1"/>
-          </a:lnRef>
-          <a:fillRef idx="3">
-            <a:schemeClr val="accent1"/>
-          </a:fillRef>
-          <a:effectRef idx="2">
-            <a:schemeClr val="accent1"/>
-          </a:effectRef>
-          <a:fontRef idx="minor">
-            <a:schemeClr val="lt1"/>
-          </a:fontRef>
-        </p:style>
-        <p:txBody>
-          <a:bodyPr rtlCol="0" anchor="ctr" wrap="square" lIns="274320" rIns="274320" tIns="228600"/>
-          <a:lstStyle/>
-          <a:p>
-            <a:pPr algn="ctr"/>
-            <a:r>
-              <a:rPr sz="2200" b="1" i="0">
-                <a:solidFill>
-                  <a:srgbClr val="2563EB"/>
-                </a:solidFill>
-                <a:latin typeface="Calibri"/>
-              </a:rPr>
-              <a:t>The researcher</a:t>
-            </a:r>
-          </a:p>
-          <a:p>
-            <a:pPr>
-              <a:spcBef>
-                <a:spcPts val="1000"/>
-              </a:spcBef>
-            </a:pPr>
-            <a:r>
-              <a:rPr sz="1500" b="0" i="0">
-                <a:solidFill>
-                  <a:srgbClr val="374151"/>
-                </a:solidFill>
-                <a:latin typeface="Calibri"/>
-              </a:rPr>
-              <a:t>•  the structural-vs-predictive reframe</a:t>
-            </a:r>
-          </a:p>
-          <a:p>
-            <a:pPr>
-              <a:spcBef>
-                <a:spcPts val="1000"/>
-              </a:spcBef>
-            </a:pPr>
-            <a:r>
-              <a:rPr sz="1500" b="0" i="0">
-                <a:solidFill>
-                  <a:srgbClr val="374151"/>
-                </a:solidFill>
-                <a:latin typeface="Calibri"/>
-              </a:rPr>
-              <a:t>•  deciding NOT to p-hack for significance</a:t>
-            </a:r>
-          </a:p>
-          <a:p>
-            <a:pPr>
-              <a:spcBef>
-                <a:spcPts val="1000"/>
-              </a:spcBef>
-            </a:pPr>
-            <a:r>
-              <a:rPr sz="1500" b="0" i="0">
-                <a:solidFill>
-                  <a:srgbClr val="374151"/>
-                </a:solidFill>
-                <a:latin typeface="Calibri"/>
-              </a:rPr>
-              <a:t>•  horizon / coverage / honest-null calls</a:t>
-            </a:r>
-          </a:p>
-        </p:txBody>
-      </p:sp>
-      <p:sp>
-        <p:nvSpPr>
-          <p:cNvPr id="9" name="TextBox 8"/>
+              <a:t>Stated plainly — these shape what we can and can't claim.</a:t>
+            </a:r>
+          </a:p>
+        </p:txBody>
+      </p:sp>
+      <p:sp>
+        <p:nvSpPr>
+          <p:cNvPr id="5" name="TextBox 4"/>
           <p:cNvSpPr txBox="1"/>
           <p:nvPr/>
         </p:nvSpPr>
         <p:spPr>
           <a:xfrm>
-            <a:off x="777240" y="6355080"/>
-            <a:ext cx="10607040" cy="365760"/>
+            <a:off x="777240" y="2514600"/>
+            <a:ext cx="10607040" cy="3657600"/>
           </a:xfrm>
           <a:prstGeom prst="rect">
             <a:avLst/>
@@ -9075,6 +8485,109 @@
           </a:bodyPr>
           <a:lstStyle/>
           <a:p>
+            <a:pPr>
+              <a:spcAft>
+                <a:spcPts val="1200"/>
+              </a:spcAft>
+            </a:pPr>
+            <a:r>
+              <a:rPr sz="2100" b="0" i="0">
+                <a:solidFill>
+                  <a:srgbClr val="374151"/>
+                </a:solidFill>
+                <a:latin typeface="Calibri"/>
+              </a:rPr>
+              <a:t>•  Intraday is 2019 only (TAQ cost) — not a 25-year intraday panel.</a:t>
+            </a:r>
+          </a:p>
+          <a:p>
+            <a:pPr>
+              <a:spcAft>
+                <a:spcPts val="1200"/>
+              </a:spcAft>
+            </a:pPr>
+            <a:r>
+              <a:rPr sz="2100" b="0" i="0">
+                <a:solidFill>
+                  <a:srgbClr val="374151"/>
+                </a:solidFill>
+                <a:latin typeface="Calibri"/>
+              </a:rPr>
+              <a:t>•  Triangle-sparse network limits AFRC community separability (Fesser–Weber–Lambiotte).</a:t>
+            </a:r>
+          </a:p>
+          <a:p>
+            <a:pPr>
+              <a:spcAft>
+                <a:spcPts val="1200"/>
+              </a:spcAft>
+            </a:pPr>
+            <a:r>
+              <a:rPr sz="2100" b="0" i="0">
+                <a:solidFill>
+                  <a:srgbClr val="374151"/>
+                </a:solidFill>
+                <a:latin typeface="Calibri"/>
+              </a:rPr>
+              <a:t>•  Directed line-graph &amp; directed curvature-gap are theoretically open — undirected reduction used.</a:t>
+            </a:r>
+          </a:p>
+          <a:p>
+            <a:pPr>
+              <a:spcAft>
+                <a:spcPts val="1200"/>
+              </a:spcAft>
+            </a:pPr>
+            <a:r>
+              <a:rPr sz="2100" b="0" i="0">
+                <a:solidFill>
+                  <a:srgbClr val="374151"/>
+                </a:solidFill>
+                <a:latin typeface="Calibri"/>
+              </a:rPr>
+              <a:t>•  Predictive IC evaluated at fixed k = 20; not pre-registered.</a:t>
+            </a:r>
+          </a:p>
+          <a:p>
+            <a:pPr>
+              <a:spcAft>
+                <a:spcPts val="1200"/>
+              </a:spcAft>
+            </a:pPr>
+            <a:r>
+              <a:rPr sz="2100" b="0" i="0">
+                <a:solidFill>
+                  <a:srgbClr val="374151"/>
+                </a:solidFill>
+                <a:latin typeface="Calibri"/>
+              </a:rPr>
+              <a:t>•  Daily universe is survivor-biased within each window (continuous-presence filter).</a:t>
+            </a:r>
+          </a:p>
+        </p:txBody>
+      </p:sp>
+      <p:sp>
+        <p:nvSpPr>
+          <p:cNvPr id="6" name="TextBox 5"/>
+          <p:cNvSpPr txBox="1"/>
+          <p:nvPr/>
+        </p:nvSpPr>
+        <p:spPr>
+          <a:xfrm>
+            <a:off x="777240" y="6355080"/>
+            <a:ext cx="10607040" cy="365760"/>
+          </a:xfrm>
+          <a:prstGeom prst="rect">
+            <a:avLst/>
+          </a:prstGeom>
+          <a:noFill/>
+        </p:spPr>
+        <p:txBody>
+          <a:bodyPr wrap="square">
+            <a:spAutoFit/>
+          </a:bodyPr>
+          <a:lstStyle/>
+          <a:p>
             <a:r>
               <a:rPr sz="1100" b="0" i="0">
                 <a:solidFill>
@@ -9082,14 +8595,14 @@
                 </a:solidFill>
                 <a:latin typeface="Calibri"/>
               </a:rPr>
-              <a:t>Agentic AI</a:t>
-            </a:r>
-          </a:p>
-        </p:txBody>
-      </p:sp>
-      <p:sp>
-        <p:nvSpPr>
-          <p:cNvPr id="10" name="TextBox 9"/>
+              <a:t>Limitations</a:t>
+            </a:r>
+          </a:p>
+        </p:txBody>
+      </p:sp>
+      <p:sp>
+        <p:nvSpPr>
+          <p:cNvPr id="7" name="TextBox 6"/>
           <p:cNvSpPr txBox="1"/>
           <p:nvPr/>
         </p:nvSpPr>
@@ -9169,7 +8682,7 @@
                 </a:solidFill>
                 <a:latin typeface="Calibri"/>
               </a:rPr>
-              <a:t>Limitations</a:t>
+              <a:t>Future work &amp; submission</a:t>
             </a:r>
           </a:p>
         </p:txBody>
@@ -9247,7 +8760,7 @@
                 </a:solidFill>
                 <a:latin typeface="Calibri"/>
               </a:rPr>
-              <a:t>Stated plainly — these shape what we can and can't claim.</a:t>
+              <a:t>Target: extend to an 8-page ACM sigconf — ICAIF 2026, deadline Aug 2.</a:t>
             </a:r>
           </a:p>
         </p:txBody>
@@ -9286,7 +8799,7 @@
                 </a:solidFill>
                 <a:latin typeface="Calibri"/>
               </a:rPr>
-              <a:t>•  Intraday is 2019 only (TAQ cost) — not a 25-year intraday panel.</a:t>
+              <a:t>•  Apply the directed-curvature tools beyond lead-lag — other market graphs and relations.</a:t>
             </a:r>
           </a:p>
           <a:p>
@@ -9302,7 +8815,7 @@
                 </a:solidFill>
                 <a:latin typeface="Calibri"/>
               </a:rPr>
-              <a:t>•  Triangle-sparse network limits AFRC community separability (Fesser–Weber–Lambiotte).</a:t>
+              <a:t>•  Directed line-graph &amp; directed AFRC-gap theory (possible Weber collaboration).</a:t>
             </a:r>
           </a:p>
           <a:p>
@@ -9318,7 +8831,7 @@
                 </a:solidFill>
                 <a:latin typeface="Calibri"/>
               </a:rPr>
-              <a:t>•  Directed line-graph &amp; directed curvature-gap are theoretically open — undirected reduction used.</a:t>
+              <a:t>•  If predictive is revisited: a pre-registered, confirmatory test — not an exploratory sweep.</a:t>
             </a:r>
           </a:p>
           <a:p>
@@ -9334,23 +8847,7 @@
                 </a:solidFill>
                 <a:latin typeface="Calibri"/>
               </a:rPr>
-              <a:t>•  Predictive IC evaluated at fixed k = 20; not pre-registered.</a:t>
-            </a:r>
-          </a:p>
-          <a:p>
-            <a:pPr>
-              <a:spcAft>
-                <a:spcPts val="1200"/>
-              </a:spcAft>
-            </a:pPr>
-            <a:r>
-              <a:rPr sz="2100" b="0" i="0">
-                <a:solidFill>
-                  <a:srgbClr val="374151"/>
-                </a:solidFill>
-                <a:latin typeface="Calibri"/>
-              </a:rPr>
-              <a:t>•  Daily universe is survivor-biased within each window (continuous-presence filter).</a:t>
+              <a:t>•  Multi-year intraday with a larger TAQ budget (the main deferred-by-cost experiment).</a:t>
             </a:r>
           </a:p>
         </p:txBody>
@@ -9384,7 +8881,7 @@
                 </a:solidFill>
                 <a:latin typeface="Calibri"/>
               </a:rPr>
-              <a:t>Limitations</a:t>
+              <a:t>Future work</a:t>
             </a:r>
           </a:p>
         </p:txBody>
@@ -9433,292 +8930,6 @@
 </file>
 
 <file path=ppt/slides/slide23.xml><?xml version="1.0" encoding="utf-8"?>
-<p:sld xmlns:a="http://schemas.openxmlformats.org/drawingml/2006/main" xmlns:p="http://schemas.openxmlformats.org/presentationml/2006/main" xmlns:r="http://schemas.openxmlformats.org/officeDocument/2006/relationships">
-  <p:cSld>
-    <p:spTree>
-      <p:nvGrpSpPr>
-        <p:cNvPr id="1" name=""/>
-        <p:cNvGrpSpPr/>
-        <p:nvPr/>
-      </p:nvGrpSpPr>
-      <p:grpSpPr/>
-      <p:sp>
-        <p:nvSpPr>
-          <p:cNvPr id="2" name="TextBox 1"/>
-          <p:cNvSpPr txBox="1"/>
-          <p:nvPr/>
-        </p:nvSpPr>
-        <p:spPr>
-          <a:xfrm>
-            <a:off x="777240" y="640080"/>
-            <a:ext cx="10607040" cy="822960"/>
-          </a:xfrm>
-          <a:prstGeom prst="rect">
-            <a:avLst/>
-          </a:prstGeom>
-          <a:noFill/>
-        </p:spPr>
-        <p:txBody>
-          <a:bodyPr wrap="square">
-            <a:spAutoFit/>
-          </a:bodyPr>
-          <a:lstStyle/>
-          <a:p>
-            <a:r>
-              <a:rPr sz="3000" b="1" i="0">
-                <a:solidFill>
-                  <a:srgbClr val="1F2937"/>
-                </a:solidFill>
-                <a:latin typeface="Calibri"/>
-              </a:rPr>
-              <a:t>Future work &amp; submission</a:t>
-            </a:r>
-          </a:p>
-        </p:txBody>
-      </p:sp>
-      <p:sp>
-        <p:nvSpPr>
-          <p:cNvPr id="3" name="Rectangle 2"/>
-          <p:cNvSpPr/>
-          <p:nvPr/>
-        </p:nvSpPr>
-        <p:spPr>
-          <a:xfrm>
-            <a:off x="777240" y="1417320"/>
-            <a:ext cx="1828800" cy="38100"/>
-          </a:xfrm>
-          <a:prstGeom prst="rect">
-            <a:avLst/>
-          </a:prstGeom>
-          <a:solidFill>
-            <a:srgbClr val="2563EB"/>
-          </a:solidFill>
-          <a:ln>
-            <a:noFill/>
-          </a:ln>
-          <a:effectLst/>
-        </p:spPr>
-        <p:style>
-          <a:lnRef idx="1">
-            <a:schemeClr val="accent1"/>
-          </a:lnRef>
-          <a:fillRef idx="3">
-            <a:schemeClr val="accent1"/>
-          </a:fillRef>
-          <a:effectRef idx="2">
-            <a:schemeClr val="accent1"/>
-          </a:effectRef>
-          <a:fontRef idx="minor">
-            <a:schemeClr val="lt1"/>
-          </a:fontRef>
-        </p:style>
-        <p:txBody>
-          <a:bodyPr rtlCol="0" anchor="ctr"/>
-          <a:lstStyle/>
-          <a:p>
-            <a:pPr algn="ctr"/>
-          </a:p>
-        </p:txBody>
-      </p:sp>
-      <p:sp>
-        <p:nvSpPr>
-          <p:cNvPr id="4" name="TextBox 3"/>
-          <p:cNvSpPr txBox="1"/>
-          <p:nvPr/>
-        </p:nvSpPr>
-        <p:spPr>
-          <a:xfrm>
-            <a:off x="777240" y="1783080"/>
-            <a:ext cx="10607040" cy="731520"/>
-          </a:xfrm>
-          <a:prstGeom prst="rect">
-            <a:avLst/>
-          </a:prstGeom>
-          <a:noFill/>
-        </p:spPr>
-        <p:txBody>
-          <a:bodyPr wrap="square">
-            <a:spAutoFit/>
-          </a:bodyPr>
-          <a:lstStyle/>
-          <a:p>
-            <a:r>
-              <a:rPr sz="1900" b="0" i="1">
-                <a:solidFill>
-                  <a:srgbClr val="2563EB"/>
-                </a:solidFill>
-                <a:latin typeface="Calibri"/>
-              </a:rPr>
-              <a:t>Target: extend to an 8-page ACM sigconf — ICAIF 2026, deadline Aug 2.</a:t>
-            </a:r>
-          </a:p>
-        </p:txBody>
-      </p:sp>
-      <p:sp>
-        <p:nvSpPr>
-          <p:cNvPr id="5" name="TextBox 4"/>
-          <p:cNvSpPr txBox="1"/>
-          <p:nvPr/>
-        </p:nvSpPr>
-        <p:spPr>
-          <a:xfrm>
-            <a:off x="777240" y="2514600"/>
-            <a:ext cx="10607040" cy="3657600"/>
-          </a:xfrm>
-          <a:prstGeom prst="rect">
-            <a:avLst/>
-          </a:prstGeom>
-          <a:noFill/>
-        </p:spPr>
-        <p:txBody>
-          <a:bodyPr wrap="square">
-            <a:spAutoFit/>
-          </a:bodyPr>
-          <a:lstStyle/>
-          <a:p>
-            <a:pPr>
-              <a:spcAft>
-                <a:spcPts val="1200"/>
-              </a:spcAft>
-            </a:pPr>
-            <a:r>
-              <a:rPr sz="2100" b="0" i="0">
-                <a:solidFill>
-                  <a:srgbClr val="374151"/>
-                </a:solidFill>
-                <a:latin typeface="Calibri"/>
-              </a:rPr>
-              <a:t>•  Apply the directed-curvature tools beyond lead-lag — other market graphs and relations.</a:t>
-            </a:r>
-          </a:p>
-          <a:p>
-            <a:pPr>
-              <a:spcAft>
-                <a:spcPts val="1200"/>
-              </a:spcAft>
-            </a:pPr>
-            <a:r>
-              <a:rPr sz="2100" b="0" i="0">
-                <a:solidFill>
-                  <a:srgbClr val="374151"/>
-                </a:solidFill>
-                <a:latin typeface="Calibri"/>
-              </a:rPr>
-              <a:t>•  Directed line-graph &amp; directed AFRC-gap theory (possible Weber collaboration).</a:t>
-            </a:r>
-          </a:p>
-          <a:p>
-            <a:pPr>
-              <a:spcAft>
-                <a:spcPts val="1200"/>
-              </a:spcAft>
-            </a:pPr>
-            <a:r>
-              <a:rPr sz="2100" b="0" i="0">
-                <a:solidFill>
-                  <a:srgbClr val="374151"/>
-                </a:solidFill>
-                <a:latin typeface="Calibri"/>
-              </a:rPr>
-              <a:t>•  If predictive is revisited: a pre-registered, confirmatory test — not an exploratory sweep.</a:t>
-            </a:r>
-          </a:p>
-          <a:p>
-            <a:pPr>
-              <a:spcAft>
-                <a:spcPts val="1200"/>
-              </a:spcAft>
-            </a:pPr>
-            <a:r>
-              <a:rPr sz="2100" b="0" i="0">
-                <a:solidFill>
-                  <a:srgbClr val="374151"/>
-                </a:solidFill>
-                <a:latin typeface="Calibri"/>
-              </a:rPr>
-              <a:t>•  Multi-year intraday with a larger TAQ budget (the main deferred-by-cost experiment).</a:t>
-            </a:r>
-          </a:p>
-        </p:txBody>
-      </p:sp>
-      <p:sp>
-        <p:nvSpPr>
-          <p:cNvPr id="6" name="TextBox 5"/>
-          <p:cNvSpPr txBox="1"/>
-          <p:nvPr/>
-        </p:nvSpPr>
-        <p:spPr>
-          <a:xfrm>
-            <a:off x="777240" y="6355080"/>
-            <a:ext cx="10607040" cy="365760"/>
-          </a:xfrm>
-          <a:prstGeom prst="rect">
-            <a:avLst/>
-          </a:prstGeom>
-          <a:noFill/>
-        </p:spPr>
-        <p:txBody>
-          <a:bodyPr wrap="square">
-            <a:spAutoFit/>
-          </a:bodyPr>
-          <a:lstStyle/>
-          <a:p>
-            <a:r>
-              <a:rPr sz="1100" b="0" i="0">
-                <a:solidFill>
-                  <a:srgbClr val="9CA3AF"/>
-                </a:solidFill>
-                <a:latin typeface="Calibri"/>
-              </a:rPr>
-              <a:t>Future work</a:t>
-            </a:r>
-          </a:p>
-        </p:txBody>
-      </p:sp>
-      <p:sp>
-        <p:nvSpPr>
-          <p:cNvPr id="7" name="TextBox 6"/>
-          <p:cNvSpPr txBox="1"/>
-          <p:nvPr/>
-        </p:nvSpPr>
-        <p:spPr>
-          <a:xfrm>
-            <a:off x="10789920" y="6355080"/>
-            <a:ext cx="1280160" cy="365760"/>
-          </a:xfrm>
-          <a:prstGeom prst="rect">
-            <a:avLst/>
-          </a:prstGeom>
-          <a:noFill/>
-        </p:spPr>
-        <p:txBody>
-          <a:bodyPr wrap="square">
-            <a:spAutoFit/>
-          </a:bodyPr>
-          <a:lstStyle/>
-          <a:p>
-            <a:pPr algn="r"/>
-            <a:r>
-              <a:rPr sz="1100" b="0" i="0">
-                <a:solidFill>
-                  <a:srgbClr val="9CA3AF"/>
-                </a:solidFill>
-                <a:latin typeface="Calibri"/>
-              </a:rPr>
-              <a:t>22</a:t>
-            </a:r>
-          </a:p>
-        </p:txBody>
-      </p:sp>
-    </p:spTree>
-  </p:cSld>
-  <p:clrMapOvr>
-    <a:masterClrMapping/>
-  </p:clrMapOvr>
-</p:sld>
-</file>
-
-<file path=ppt/slides/slide24.xml><?xml version="1.0" encoding="utf-8"?>
 <p:sld xmlns:a="http://schemas.openxmlformats.org/drawingml/2006/main" xmlns:p="http://schemas.openxmlformats.org/presentationml/2006/main" xmlns:r="http://schemas.openxmlformats.org/officeDocument/2006/relationships">
   <p:cSld>
     <p:spTree>
@@ -10205,7 +9416,7 @@
                 </a:solidFill>
                 <a:latin typeface="Calibri"/>
               </a:rPr>
-              <a:t>23</a:t>
+              <a:t>22</a:t>
             </a:r>
           </a:p>
         </p:txBody>

</xml_diff>

<commit_message>
Deck: Step 1 names both time horizons (daily + intraday), not just intraday
Co-Authored-By: Claude Opus 4.8 (1M context) <noreply@anthropic.com>
</commit_message>
<xml_diff>
--- a/slides/Ricci_Curvature_LeadLag.pptx
+++ b/slides/Ricci_Curvature_LeadLag.pptx
@@ -12032,7 +12032,23 @@
                 </a:solidFill>
                 <a:latin typeface="Calibri"/>
               </a:rPr>
-              <a:t>•  Intraday: within-day estimator (lag pairs never cross the overnight gap).</a:t>
+              <a:t>•  Two time horizons: daily close-to-close, and intraday 30-min.</a:t>
+            </a:r>
+          </a:p>
+          <a:p>
+            <a:pPr lvl="1">
+              <a:spcAft>
+                <a:spcPts val="600"/>
+              </a:spcAft>
+            </a:pPr>
+            <a:r>
+              <a:rPr sz="1800" b="0" i="0">
+                <a:solidFill>
+                  <a:srgbClr val="9CA3AF"/>
+                </a:solidFill>
+                <a:latin typeface="Calibri"/>
+              </a:rPr>
+              <a:t>–  Intraday uses a within-day estimator — lag pairs never cross the overnight gap.</a:t>
             </a:r>
           </a:p>
         </p:txBody>

</xml_diff>

<commit_message>
Deck: Data slide explains why TAQ is 2019 only (cost) + CRSP's full role
TAQ cell/note now state the reason (25y of 30-min TAQ ~ 100+ h of pulls; ~15B
rows/yr); CRSP "what it's for" updated to structural cascade + 25-yr predictive
walk-forward, so daily's full-coverage role is explicit.

Co-Authored-By: Claude Opus 4.8 (1M context) <noreply@anthropic.com>
</commit_message>
<xml_diff>
--- a/slides/Ricci_Curvature_LeadLag.pptx
+++ b/slides/Ricci_Curvature_LeadLag.pptx
@@ -3874,7 +3874,7 @@
                           </a:solidFill>
                           <a:latin typeface="Calibri"/>
                         </a:rPr>
-                        <a:t>daily-frequency robustness check</a:t>
+                        <a:t>structural cascade + 25-yr predictive walk-forward</a:t>
                       </a:r>
                     </a:p>
                   </a:txBody>
@@ -3993,7 +3993,7 @@
                           </a:solidFill>
                           <a:latin typeface="Calibri"/>
                         </a:rPr>
-                        <a:t>30-min intraday bars, full-year 2019</a:t>
+                        <a:t>30-min intraday bars, 2019 only</a:t>
                       </a:r>
                     </a:p>
                     <a:p>
@@ -4028,7 +4028,7 @@
                           </a:solidFill>
                           <a:latin typeface="Calibri"/>
                         </a:rPr>
-                        <a:t>the HEADLINE network — where lead-lag lives</a:t>
+                        <a:t>high-frequency cross-check (lead-lag is strongest)</a:t>
                       </a:r>
                     </a:p>
                   </a:txBody>
@@ -4072,7 +4072,7 @@
                 </a:solidFill>
                 <a:latin typeface="Calibri"/>
               </a:rPr>
-              <a:t>Intraday is the main result; daily is the robustness check.</a:t>
+              <a:t>Why TAQ is 2019 only: 25 years of 30-min TAQ ≈ 100+ hours of pulls (TAQ is ~15B rows/year). Daily covers the full 2000–2024; intraday 2019 is the cross-check.</a:t>
             </a:r>
           </a:p>
         </p:txBody>

</xml_diff>

<commit_message>
Results: add four-object comparison (the missing ablation grid)
scripts/run_four_objects.py computes, per curvature object (plain / weighted /
weighted-augmented-directed / Ollivier), the cascade (Spearman, Jaccard, R²-on-
degree), OOS IC, and compute time on intraday 2019. New deck slide 15 "The four
objects, compared": all four are distinct from correlation (Jaccard~0); higher-
order signal grows plain(R²deg 1.00)→weighted(0.97)→augmented(0.56)→Ollivier(0.14);
Forman family computes in 0.03s vs Ollivier 15.9s (~600x). MAIN object is the
best signal/cost tradeoff; none predicts (IC~0). Deck now 24 slides.

Co-Authored-By: Claude Opus 4.8 (1M context) <noreply@anthropic.com>
</commit_message>
<xml_diff>
--- a/slides/Ricci_Curvature_LeadLag.pptx
+++ b/slides/Ricci_Curvature_LeadLag.pptx
@@ -28,6 +28,7 @@
     <p:sldId id="276" r:id="rId27"/>
     <p:sldId id="277" r:id="rId28"/>
     <p:sldId id="278" r:id="rId29"/>
+    <p:sldId id="279" r:id="rId30"/>
   </p:sldIdLst>
   <p:sldSz cx="12191695" cy="6858000" type="screen4x3"/>
   <p:notesSz cx="6858000" cy="9144000"/>
@@ -5487,6 +5488,853 @@
                 </a:solidFill>
                 <a:latin typeface="Calibri"/>
               </a:rPr>
+              <a:t>The four objects, compared</a:t>
+            </a:r>
+          </a:p>
+        </p:txBody>
+      </p:sp>
+      <p:sp>
+        <p:nvSpPr>
+          <p:cNvPr id="3" name="Rectangle 2"/>
+          <p:cNvSpPr/>
+          <p:nvPr/>
+        </p:nvSpPr>
+        <p:spPr>
+          <a:xfrm>
+            <a:off x="777240" y="1417320"/>
+            <a:ext cx="1828800" cy="38100"/>
+          </a:xfrm>
+          <a:prstGeom prst="rect">
+            <a:avLst/>
+          </a:prstGeom>
+          <a:solidFill>
+            <a:srgbClr val="2563EB"/>
+          </a:solidFill>
+          <a:ln>
+            <a:noFill/>
+          </a:ln>
+          <a:effectLst/>
+        </p:spPr>
+        <p:style>
+          <a:lnRef idx="1">
+            <a:schemeClr val="accent1"/>
+          </a:lnRef>
+          <a:fillRef idx="3">
+            <a:schemeClr val="accent1"/>
+          </a:fillRef>
+          <a:effectRef idx="2">
+            <a:schemeClr val="accent1"/>
+          </a:effectRef>
+          <a:fontRef idx="minor">
+            <a:schemeClr val="lt1"/>
+          </a:fontRef>
+        </p:style>
+        <p:txBody>
+          <a:bodyPr rtlCol="0" anchor="ctr"/>
+          <a:lstStyle/>
+          <a:p>
+            <a:pPr algn="ctr"/>
+          </a:p>
+        </p:txBody>
+      </p:sp>
+      <p:sp>
+        <p:nvSpPr>
+          <p:cNvPr id="4" name="TextBox 3"/>
+          <p:cNvSpPr txBox="1"/>
+          <p:nvPr/>
+        </p:nvSpPr>
+        <p:spPr>
+          <a:xfrm>
+            <a:off x="777240" y="1783080"/>
+            <a:ext cx="10607040" cy="640080"/>
+          </a:xfrm>
+          <a:prstGeom prst="rect">
+            <a:avLst/>
+          </a:prstGeom>
+          <a:noFill/>
+        </p:spPr>
+        <p:txBody>
+          <a:bodyPr wrap="square">
+            <a:spAutoFit/>
+          </a:bodyPr>
+          <a:lstStyle/>
+          <a:p>
+            <a:r>
+              <a:rPr sz="1800" b="0" i="1">
+                <a:solidFill>
+                  <a:srgbClr val="2563EB"/>
+                </a:solidFill>
+                <a:latin typeface="Calibri"/>
+              </a:rPr>
+              <a:t>All four pick pairs disjoint from correlation (Jaccard ≈ 0).</a:t>
+            </a:r>
+          </a:p>
+        </p:txBody>
+      </p:sp>
+      <p:graphicFrame>
+        <p:nvGraphicFramePr>
+          <p:cNvPr id="5" name="Table 4"/>
+          <p:cNvGraphicFramePr>
+            <a:graphicFrameLocks noGrp="1"/>
+          </p:cNvGraphicFramePr>
+          <p:nvPr/>
+        </p:nvGraphicFramePr>
+        <p:xfrm>
+          <a:off x="777240" y="2377440"/>
+          <a:ext cx="10607040" cy="2286000"/>
+        </p:xfrm>
+        <a:graphic>
+          <a:graphicData uri="http://schemas.openxmlformats.org/drawingml/2006/table">
+            <a:tbl>
+              <a:tblPr firstRow="1" bandRow="1">
+                <a:tableStyleId>{5C22544A-7EE6-4342-B048-85BDC9FD1C3A}</a:tableStyleId>
+              </a:tblPr>
+              <a:tblGrid>
+                <a:gridCol w="4023360"/>
+                <a:gridCol w="1554480"/>
+                <a:gridCol w="1920240"/>
+                <a:gridCol w="1554480"/>
+                <a:gridCol w="1554480"/>
+              </a:tblGrid>
+              <a:tr h="457200">
+                <a:tc>
+                  <a:txBody>
+                    <a:bodyPr/>
+                    <a:lstStyle/>
+                    <a:p>
+                      <a:pPr algn="l"/>
+                      <a:r>
+                        <a:rPr sz="1500" b="1" i="0">
+                          <a:solidFill>
+                            <a:srgbClr val="FFFFFF"/>
+                          </a:solidFill>
+                          <a:latin typeface="Calibri"/>
+                        </a:rPr>
+                        <a:t>Object</a:t>
+                      </a:r>
+                    </a:p>
+                  </a:txBody>
+                  <a:tcPr anchor="ctr">
+                    <a:solidFill>
+                      <a:srgbClr val="2563EB"/>
+                    </a:solidFill>
+                  </a:tcPr>
+                </a:tc>
+                <a:tc>
+                  <a:txBody>
+                    <a:bodyPr/>
+                    <a:lstStyle/>
+                    <a:p>
+                      <a:pPr algn="ctr"/>
+                      <a:r>
+                        <a:rPr sz="1500" b="1" i="0">
+                          <a:solidFill>
+                            <a:srgbClr val="FFFFFF"/>
+                          </a:solidFill>
+                          <a:latin typeface="Calibri"/>
+                        </a:rPr>
+                        <a:t>Spearman</a:t>
+                      </a:r>
+                    </a:p>
+                  </a:txBody>
+                  <a:tcPr anchor="ctr">
+                    <a:solidFill>
+                      <a:srgbClr val="2563EB"/>
+                    </a:solidFill>
+                  </a:tcPr>
+                </a:tc>
+                <a:tc>
+                  <a:txBody>
+                    <a:bodyPr/>
+                    <a:lstStyle/>
+                    <a:p>
+                      <a:pPr algn="ctr"/>
+                      <a:r>
+                        <a:rPr sz="1500" b="1" i="0">
+                          <a:solidFill>
+                            <a:srgbClr val="FFFFFF"/>
+                          </a:solidFill>
+                          <a:latin typeface="Calibri"/>
+                        </a:rPr>
+                        <a:t>R² on degree</a:t>
+                      </a:r>
+                    </a:p>
+                  </a:txBody>
+                  <a:tcPr anchor="ctr">
+                    <a:solidFill>
+                      <a:srgbClr val="2563EB"/>
+                    </a:solidFill>
+                  </a:tcPr>
+                </a:tc>
+                <a:tc>
+                  <a:txBody>
+                    <a:bodyPr/>
+                    <a:lstStyle/>
+                    <a:p>
+                      <a:pPr algn="ctr"/>
+                      <a:r>
+                        <a:rPr sz="1500" b="1" i="0">
+                          <a:solidFill>
+                            <a:srgbClr val="FFFFFF"/>
+                          </a:solidFill>
+                          <a:latin typeface="Calibri"/>
+                        </a:rPr>
+                        <a:t>mean IC</a:t>
+                      </a:r>
+                    </a:p>
+                  </a:txBody>
+                  <a:tcPr anchor="ctr">
+                    <a:solidFill>
+                      <a:srgbClr val="2563EB"/>
+                    </a:solidFill>
+                  </a:tcPr>
+                </a:tc>
+                <a:tc>
+                  <a:txBody>
+                    <a:bodyPr/>
+                    <a:lstStyle/>
+                    <a:p>
+                      <a:pPr algn="ctr"/>
+                      <a:r>
+                        <a:rPr sz="1500" b="1" i="0">
+                          <a:solidFill>
+                            <a:srgbClr val="FFFFFF"/>
+                          </a:solidFill>
+                          <a:latin typeface="Calibri"/>
+                        </a:rPr>
+                        <a:t>compute</a:t>
+                      </a:r>
+                    </a:p>
+                  </a:txBody>
+                  <a:tcPr anchor="ctr">
+                    <a:solidFill>
+                      <a:srgbClr val="2563EB"/>
+                    </a:solidFill>
+                  </a:tcPr>
+                </a:tc>
+              </a:tr>
+              <a:tr h="457200">
+                <a:tc>
+                  <a:txBody>
+                    <a:bodyPr/>
+                    <a:lstStyle/>
+                    <a:p>
+                      <a:pPr algn="l"/>
+                      <a:r>
+                        <a:rPr sz="1400" b="0" i="0">
+                          <a:solidFill>
+                            <a:srgbClr val="374151"/>
+                          </a:solidFill>
+                          <a:latin typeface="Calibri"/>
+                        </a:rPr>
+                        <a:t>Plain directed Forman  (baseline)</a:t>
+                      </a:r>
+                    </a:p>
+                  </a:txBody>
+                  <a:tcPr anchor="ctr">
+                    <a:solidFill>
+                      <a:srgbClr val="FFFFFF"/>
+                    </a:solidFill>
+                  </a:tcPr>
+                </a:tc>
+                <a:tc>
+                  <a:txBody>
+                    <a:bodyPr/>
+                    <a:lstStyle/>
+                    <a:p>
+                      <a:pPr algn="ctr"/>
+                      <a:r>
+                        <a:rPr sz="1400" b="0" i="0">
+                          <a:solidFill>
+                            <a:srgbClr val="374151"/>
+                          </a:solidFill>
+                          <a:latin typeface="Calibri"/>
+                        </a:rPr>
+                        <a:t>0.09</a:t>
+                      </a:r>
+                    </a:p>
+                  </a:txBody>
+                  <a:tcPr anchor="ctr">
+                    <a:solidFill>
+                      <a:srgbClr val="FFFFFF"/>
+                    </a:solidFill>
+                  </a:tcPr>
+                </a:tc>
+                <a:tc>
+                  <a:txBody>
+                    <a:bodyPr/>
+                    <a:lstStyle/>
+                    <a:p>
+                      <a:pPr algn="ctr"/>
+                      <a:r>
+                        <a:rPr sz="1400" b="0" i="0">
+                          <a:solidFill>
+                            <a:srgbClr val="374151"/>
+                          </a:solidFill>
+                          <a:latin typeface="Calibri"/>
+                        </a:rPr>
+                        <a:t>1.00</a:t>
+                      </a:r>
+                    </a:p>
+                  </a:txBody>
+                  <a:tcPr anchor="ctr">
+                    <a:solidFill>
+                      <a:srgbClr val="FFFFFF"/>
+                    </a:solidFill>
+                  </a:tcPr>
+                </a:tc>
+                <a:tc>
+                  <a:txBody>
+                    <a:bodyPr/>
+                    <a:lstStyle/>
+                    <a:p>
+                      <a:pPr algn="ctr"/>
+                      <a:r>
+                        <a:rPr sz="1400" b="0" i="0">
+                          <a:solidFill>
+                            <a:srgbClr val="374151"/>
+                          </a:solidFill>
+                          <a:latin typeface="Calibri"/>
+                        </a:rPr>
+                        <a:t>+0.014</a:t>
+                      </a:r>
+                    </a:p>
+                  </a:txBody>
+                  <a:tcPr anchor="ctr">
+                    <a:solidFill>
+                      <a:srgbClr val="FFFFFF"/>
+                    </a:solidFill>
+                  </a:tcPr>
+                </a:tc>
+                <a:tc>
+                  <a:txBody>
+                    <a:bodyPr/>
+                    <a:lstStyle/>
+                    <a:p>
+                      <a:pPr algn="ctr"/>
+                      <a:r>
+                        <a:rPr sz="1400" b="0" i="0">
+                          <a:solidFill>
+                            <a:srgbClr val="374151"/>
+                          </a:solidFill>
+                          <a:latin typeface="Calibri"/>
+                        </a:rPr>
+                        <a:t>0.03 s</a:t>
+                      </a:r>
+                    </a:p>
+                  </a:txBody>
+                  <a:tcPr anchor="ctr">
+                    <a:solidFill>
+                      <a:srgbClr val="FFFFFF"/>
+                    </a:solidFill>
+                  </a:tcPr>
+                </a:tc>
+              </a:tr>
+              <a:tr h="457200">
+                <a:tc>
+                  <a:txBody>
+                    <a:bodyPr/>
+                    <a:lstStyle/>
+                    <a:p>
+                      <a:pPr algn="l"/>
+                      <a:r>
+                        <a:rPr sz="1400" b="0" i="0">
+                          <a:solidFill>
+                            <a:srgbClr val="374151"/>
+                          </a:solidFill>
+                          <a:latin typeface="Calibri"/>
+                        </a:rPr>
+                        <a:t>Weighted Forman</a:t>
+                      </a:r>
+                    </a:p>
+                  </a:txBody>
+                  <a:tcPr anchor="ctr">
+                    <a:solidFill>
+                      <a:srgbClr val="EFF2FB"/>
+                    </a:solidFill>
+                  </a:tcPr>
+                </a:tc>
+                <a:tc>
+                  <a:txBody>
+                    <a:bodyPr/>
+                    <a:lstStyle/>
+                    <a:p>
+                      <a:pPr algn="ctr"/>
+                      <a:r>
+                        <a:rPr sz="1400" b="0" i="0">
+                          <a:solidFill>
+                            <a:srgbClr val="374151"/>
+                          </a:solidFill>
+                          <a:latin typeface="Calibri"/>
+                        </a:rPr>
+                        <a:t>0.08</a:t>
+                      </a:r>
+                    </a:p>
+                  </a:txBody>
+                  <a:tcPr anchor="ctr">
+                    <a:solidFill>
+                      <a:srgbClr val="EFF2FB"/>
+                    </a:solidFill>
+                  </a:tcPr>
+                </a:tc>
+                <a:tc>
+                  <a:txBody>
+                    <a:bodyPr/>
+                    <a:lstStyle/>
+                    <a:p>
+                      <a:pPr algn="ctr"/>
+                      <a:r>
+                        <a:rPr sz="1400" b="0" i="0">
+                          <a:solidFill>
+                            <a:srgbClr val="374151"/>
+                          </a:solidFill>
+                          <a:latin typeface="Calibri"/>
+                        </a:rPr>
+                        <a:t>0.97</a:t>
+                      </a:r>
+                    </a:p>
+                  </a:txBody>
+                  <a:tcPr anchor="ctr">
+                    <a:solidFill>
+                      <a:srgbClr val="EFF2FB"/>
+                    </a:solidFill>
+                  </a:tcPr>
+                </a:tc>
+                <a:tc>
+                  <a:txBody>
+                    <a:bodyPr/>
+                    <a:lstStyle/>
+                    <a:p>
+                      <a:pPr algn="ctr"/>
+                      <a:r>
+                        <a:rPr sz="1400" b="0" i="0">
+                          <a:solidFill>
+                            <a:srgbClr val="374151"/>
+                          </a:solidFill>
+                          <a:latin typeface="Calibri"/>
+                        </a:rPr>
+                        <a:t>+0.007</a:t>
+                      </a:r>
+                    </a:p>
+                  </a:txBody>
+                  <a:tcPr anchor="ctr">
+                    <a:solidFill>
+                      <a:srgbClr val="EFF2FB"/>
+                    </a:solidFill>
+                  </a:tcPr>
+                </a:tc>
+                <a:tc>
+                  <a:txBody>
+                    <a:bodyPr/>
+                    <a:lstStyle/>
+                    <a:p>
+                      <a:pPr algn="ctr"/>
+                      <a:r>
+                        <a:rPr sz="1400" b="0" i="0">
+                          <a:solidFill>
+                            <a:srgbClr val="374151"/>
+                          </a:solidFill>
+                          <a:latin typeface="Calibri"/>
+                        </a:rPr>
+                        <a:t>0.03 s</a:t>
+                      </a:r>
+                    </a:p>
+                  </a:txBody>
+                  <a:tcPr anchor="ctr">
+                    <a:solidFill>
+                      <a:srgbClr val="EFF2FB"/>
+                    </a:solidFill>
+                  </a:tcPr>
+                </a:tc>
+              </a:tr>
+              <a:tr h="457200">
+                <a:tc>
+                  <a:txBody>
+                    <a:bodyPr/>
+                    <a:lstStyle/>
+                    <a:p>
+                      <a:pPr algn="l"/>
+                      <a:r>
+                        <a:rPr sz="1400" b="1" i="0">
+                          <a:solidFill>
+                            <a:srgbClr val="1F2937"/>
+                          </a:solidFill>
+                          <a:latin typeface="Calibri"/>
+                        </a:rPr>
+                        <a:t>Weighted augmented directed  (MAIN)</a:t>
+                      </a:r>
+                    </a:p>
+                  </a:txBody>
+                  <a:tcPr anchor="ctr">
+                    <a:solidFill>
+                      <a:srgbClr val="EFF2FB"/>
+                    </a:solidFill>
+                  </a:tcPr>
+                </a:tc>
+                <a:tc>
+                  <a:txBody>
+                    <a:bodyPr/>
+                    <a:lstStyle/>
+                    <a:p>
+                      <a:pPr algn="ctr"/>
+                      <a:r>
+                        <a:rPr sz="1400" b="1" i="0">
+                          <a:solidFill>
+                            <a:srgbClr val="1F2937"/>
+                          </a:solidFill>
+                          <a:latin typeface="Calibri"/>
+                        </a:rPr>
+                        <a:t>0.18</a:t>
+                      </a:r>
+                    </a:p>
+                  </a:txBody>
+                  <a:tcPr anchor="ctr">
+                    <a:solidFill>
+                      <a:srgbClr val="EFF2FB"/>
+                    </a:solidFill>
+                  </a:tcPr>
+                </a:tc>
+                <a:tc>
+                  <a:txBody>
+                    <a:bodyPr/>
+                    <a:lstStyle/>
+                    <a:p>
+                      <a:pPr algn="ctr"/>
+                      <a:r>
+                        <a:rPr sz="1400" b="1" i="0">
+                          <a:solidFill>
+                            <a:srgbClr val="1F2937"/>
+                          </a:solidFill>
+                          <a:latin typeface="Calibri"/>
+                        </a:rPr>
+                        <a:t>0.56</a:t>
+                      </a:r>
+                    </a:p>
+                  </a:txBody>
+                  <a:tcPr anchor="ctr">
+                    <a:solidFill>
+                      <a:srgbClr val="EFF2FB"/>
+                    </a:solidFill>
+                  </a:tcPr>
+                </a:tc>
+                <a:tc>
+                  <a:txBody>
+                    <a:bodyPr/>
+                    <a:lstStyle/>
+                    <a:p>
+                      <a:pPr algn="ctr"/>
+                      <a:r>
+                        <a:rPr sz="1400" b="1" i="0">
+                          <a:solidFill>
+                            <a:srgbClr val="1F2937"/>
+                          </a:solidFill>
+                          <a:latin typeface="Calibri"/>
+                        </a:rPr>
+                        <a:t>+0.005</a:t>
+                      </a:r>
+                    </a:p>
+                  </a:txBody>
+                  <a:tcPr anchor="ctr">
+                    <a:solidFill>
+                      <a:srgbClr val="EFF2FB"/>
+                    </a:solidFill>
+                  </a:tcPr>
+                </a:tc>
+                <a:tc>
+                  <a:txBody>
+                    <a:bodyPr/>
+                    <a:lstStyle/>
+                    <a:p>
+                      <a:pPr algn="ctr"/>
+                      <a:r>
+                        <a:rPr sz="1400" b="1" i="0">
+                          <a:solidFill>
+                            <a:srgbClr val="1F2937"/>
+                          </a:solidFill>
+                          <a:latin typeface="Calibri"/>
+                        </a:rPr>
+                        <a:t>0.03 s</a:t>
+                      </a:r>
+                    </a:p>
+                  </a:txBody>
+                  <a:tcPr anchor="ctr">
+                    <a:solidFill>
+                      <a:srgbClr val="EFF2FB"/>
+                    </a:solidFill>
+                  </a:tcPr>
+                </a:tc>
+              </a:tr>
+              <a:tr h="457200">
+                <a:tc>
+                  <a:txBody>
+                    <a:bodyPr/>
+                    <a:lstStyle/>
+                    <a:p>
+                      <a:pPr algn="l"/>
+                      <a:r>
+                        <a:rPr sz="1400" b="0" i="0">
+                          <a:solidFill>
+                            <a:srgbClr val="374151"/>
+                          </a:solidFill>
+                          <a:latin typeface="Calibri"/>
+                        </a:rPr>
+                        <a:t>Ollivier-Ricci</a:t>
+                      </a:r>
+                    </a:p>
+                  </a:txBody>
+                  <a:tcPr anchor="ctr">
+                    <a:solidFill>
+                      <a:srgbClr val="EFF2FB"/>
+                    </a:solidFill>
+                  </a:tcPr>
+                </a:tc>
+                <a:tc>
+                  <a:txBody>
+                    <a:bodyPr/>
+                    <a:lstStyle/>
+                    <a:p>
+                      <a:pPr algn="ctr"/>
+                      <a:r>
+                        <a:rPr sz="1400" b="0" i="0">
+                          <a:solidFill>
+                            <a:srgbClr val="374151"/>
+                          </a:solidFill>
+                          <a:latin typeface="Calibri"/>
+                        </a:rPr>
+                        <a:t>0.24</a:t>
+                      </a:r>
+                    </a:p>
+                  </a:txBody>
+                  <a:tcPr anchor="ctr">
+                    <a:solidFill>
+                      <a:srgbClr val="EFF2FB"/>
+                    </a:solidFill>
+                  </a:tcPr>
+                </a:tc>
+                <a:tc>
+                  <a:txBody>
+                    <a:bodyPr/>
+                    <a:lstStyle/>
+                    <a:p>
+                      <a:pPr algn="ctr"/>
+                      <a:r>
+                        <a:rPr sz="1400" b="0" i="0">
+                          <a:solidFill>
+                            <a:srgbClr val="374151"/>
+                          </a:solidFill>
+                          <a:latin typeface="Calibri"/>
+                        </a:rPr>
+                        <a:t>0.14</a:t>
+                      </a:r>
+                    </a:p>
+                  </a:txBody>
+                  <a:tcPr anchor="ctr">
+                    <a:solidFill>
+                      <a:srgbClr val="EFF2FB"/>
+                    </a:solidFill>
+                  </a:tcPr>
+                </a:tc>
+                <a:tc>
+                  <a:txBody>
+                    <a:bodyPr/>
+                    <a:lstStyle/>
+                    <a:p>
+                      <a:pPr algn="ctr"/>
+                      <a:r>
+                        <a:rPr sz="1400" b="0" i="0">
+                          <a:solidFill>
+                            <a:srgbClr val="374151"/>
+                          </a:solidFill>
+                          <a:latin typeface="Calibri"/>
+                        </a:rPr>
+                        <a:t>−0.006</a:t>
+                      </a:r>
+                    </a:p>
+                  </a:txBody>
+                  <a:tcPr anchor="ctr">
+                    <a:solidFill>
+                      <a:srgbClr val="EFF2FB"/>
+                    </a:solidFill>
+                  </a:tcPr>
+                </a:tc>
+                <a:tc>
+                  <a:txBody>
+                    <a:bodyPr/>
+                    <a:lstStyle/>
+                    <a:p>
+                      <a:pPr algn="ctr"/>
+                      <a:r>
+                        <a:rPr sz="1400" b="0" i="0">
+                          <a:solidFill>
+                            <a:srgbClr val="374151"/>
+                          </a:solidFill>
+                          <a:latin typeface="Calibri"/>
+                        </a:rPr>
+                        <a:t>15.9 s</a:t>
+                      </a:r>
+                    </a:p>
+                  </a:txBody>
+                  <a:tcPr anchor="ctr">
+                    <a:solidFill>
+                      <a:srgbClr val="EFF2FB"/>
+                    </a:solidFill>
+                  </a:tcPr>
+                </a:tc>
+              </a:tr>
+            </a:tbl>
+          </a:graphicData>
+        </a:graphic>
+      </p:graphicFrame>
+      <p:sp>
+        <p:nvSpPr>
+          <p:cNvPr id="6" name="TextBox 5"/>
+          <p:cNvSpPr txBox="1"/>
+          <p:nvPr/>
+        </p:nvSpPr>
+        <p:spPr>
+          <a:xfrm>
+            <a:off x="777240" y="5715000"/>
+            <a:ext cx="10607040" cy="640080"/>
+          </a:xfrm>
+          <a:prstGeom prst="rect">
+            <a:avLst/>
+          </a:prstGeom>
+          <a:noFill/>
+        </p:spPr>
+        <p:txBody>
+          <a:bodyPr wrap="square">
+            <a:spAutoFit/>
+          </a:bodyPr>
+          <a:lstStyle/>
+          <a:p>
+            <a:r>
+              <a:rPr sz="1400" b="0" i="1">
+                <a:solidFill>
+                  <a:srgbClr val="9CA3AF"/>
+                </a:solidFill>
+                <a:latin typeface="Calibri"/>
+              </a:rPr>
+              <a:t>Best tradeoff = weighted-augmented Forman: real higher-order signal (44% non-degree) at ~0 cost. Ollivier carries the most non-degree signal but at ~600× the compute and no IC gain. None predicts (IC ≈ 0).</a:t>
+            </a:r>
+          </a:p>
+        </p:txBody>
+      </p:sp>
+      <p:sp>
+        <p:nvSpPr>
+          <p:cNvPr id="7" name="TextBox 6"/>
+          <p:cNvSpPr txBox="1"/>
+          <p:nvPr/>
+        </p:nvSpPr>
+        <p:spPr>
+          <a:xfrm>
+            <a:off x="777240" y="6355080"/>
+            <a:ext cx="10607040" cy="365760"/>
+          </a:xfrm>
+          <a:prstGeom prst="rect">
+            <a:avLst/>
+          </a:prstGeom>
+          <a:noFill/>
+        </p:spPr>
+        <p:txBody>
+          <a:bodyPr wrap="square">
+            <a:spAutoFit/>
+          </a:bodyPr>
+          <a:lstStyle/>
+          <a:p>
+            <a:r>
+              <a:rPr sz="1100" b="0" i="0">
+                <a:solidFill>
+                  <a:srgbClr val="9CA3AF"/>
+                </a:solidFill>
+                <a:latin typeface="Calibri"/>
+              </a:rPr>
+              <a:t>Results — H1</a:t>
+            </a:r>
+          </a:p>
+        </p:txBody>
+      </p:sp>
+      <p:sp>
+        <p:nvSpPr>
+          <p:cNvPr id="8" name="TextBox 7"/>
+          <p:cNvSpPr txBox="1"/>
+          <p:nvPr/>
+        </p:nvSpPr>
+        <p:spPr>
+          <a:xfrm>
+            <a:off x="10789920" y="6355080"/>
+            <a:ext cx="1280160" cy="365760"/>
+          </a:xfrm>
+          <a:prstGeom prst="rect">
+            <a:avLst/>
+          </a:prstGeom>
+          <a:noFill/>
+        </p:spPr>
+        <p:txBody>
+          <a:bodyPr wrap="square">
+            <a:spAutoFit/>
+          </a:bodyPr>
+          <a:lstStyle/>
+          <a:p>
+            <a:pPr algn="r"/>
+            <a:r>
+              <a:rPr sz="1100" b="0" i="0">
+                <a:solidFill>
+                  <a:srgbClr val="9CA3AF"/>
+                </a:solidFill>
+                <a:latin typeface="Calibri"/>
+              </a:rPr>
+              <a:t>14</a:t>
+            </a:r>
+          </a:p>
+        </p:txBody>
+      </p:sp>
+    </p:spTree>
+  </p:cSld>
+  <p:clrMapOvr>
+    <a:masterClrMapping/>
+  </p:clrMapOvr>
+</p:sld>
+</file>
+
+<file path=ppt/slides/slide16.xml><?xml version="1.0" encoding="utf-8"?>
+<p:sld xmlns:a="http://schemas.openxmlformats.org/drawingml/2006/main" xmlns:p="http://schemas.openxmlformats.org/presentationml/2006/main" xmlns:r="http://schemas.openxmlformats.org/officeDocument/2006/relationships">
+  <p:cSld>
+    <p:spTree>
+      <p:nvGrpSpPr>
+        <p:cNvPr id="1" name=""/>
+        <p:cNvGrpSpPr/>
+        <p:nvPr/>
+      </p:nvGrpSpPr>
+      <p:grpSpPr/>
+      <p:sp>
+        <p:nvSpPr>
+          <p:cNvPr id="2" name="TextBox 1"/>
+          <p:cNvSpPr txBox="1"/>
+          <p:nvPr/>
+        </p:nvSpPr>
+        <p:spPr>
+          <a:xfrm>
+            <a:off x="777240" y="640080"/>
+            <a:ext cx="10607040" cy="822960"/>
+          </a:xfrm>
+          <a:prstGeom prst="rect">
+            <a:avLst/>
+          </a:prstGeom>
+          <a:noFill/>
+        </p:spPr>
+        <p:txBody>
+          <a:bodyPr wrap="square">
+            <a:spAutoFit/>
+          </a:bodyPr>
+          <a:lstStyle/>
+          <a:p>
+            <a:r>
+              <a:rPr sz="3000" b="1" i="0">
+                <a:solidFill>
+                  <a:srgbClr val="1F2937"/>
+                </a:solidFill>
+                <a:latin typeface="Calibri"/>
+              </a:rPr>
               <a:t>A clean degree ablation</a:t>
             </a:r>
           </a:p>
@@ -6002,7 +6850,7 @@
                 </a:solidFill>
                 <a:latin typeface="Calibri"/>
               </a:rPr>
-              <a:t>14</a:t>
+              <a:t>15</a:t>
             </a:r>
           </a:p>
         </p:txBody>
@@ -6015,7 +6863,7 @@
 </p:sld>
 </file>
 
-<file path=ppt/slides/slide16.xml><?xml version="1.0" encoding="utf-8"?>
+<file path=ppt/slides/slide17.xml><?xml version="1.0" encoding="utf-8"?>
 <p:sld xmlns:a="http://schemas.openxmlformats.org/drawingml/2006/main" xmlns:p="http://schemas.openxmlformats.org/presentationml/2006/main" xmlns:r="http://schemas.openxmlformats.org/officeDocument/2006/relationships">
   <p:cSld>
     <p:spTree>
@@ -6304,7 +7152,7 @@
                 </a:solidFill>
                 <a:latin typeface="Calibri"/>
               </a:rPr>
-              <a:t>15</a:t>
+              <a:t>16</a:t>
             </a:r>
           </a:p>
         </p:txBody>
@@ -6317,7 +7165,7 @@
 </p:sld>
 </file>
 
-<file path=ppt/slides/slide17.xml><?xml version="1.0" encoding="utf-8"?>
+<file path=ppt/slides/slide18.xml><?xml version="1.0" encoding="utf-8"?>
 <p:sld xmlns:a="http://schemas.openxmlformats.org/drawingml/2006/main" xmlns:p="http://schemas.openxmlformats.org/presentationml/2006/main" xmlns:r="http://schemas.openxmlformats.org/officeDocument/2006/relationships">
   <p:cSld>
     <p:spTree>
@@ -6943,517 +7791,6 @@
                 </a:solidFill>
                 <a:latin typeface="Calibri"/>
               </a:rPr>
-              <a:t>16</a:t>
-            </a:r>
-          </a:p>
-        </p:txBody>
-      </p:sp>
-    </p:spTree>
-  </p:cSld>
-  <p:clrMapOvr>
-    <a:masterClrMapping/>
-  </p:clrMapOvr>
-</p:sld>
-</file>
-
-<file path=ppt/slides/slide18.xml><?xml version="1.0" encoding="utf-8"?>
-<p:sld xmlns:a="http://schemas.openxmlformats.org/drawingml/2006/main" xmlns:p="http://schemas.openxmlformats.org/presentationml/2006/main" xmlns:r="http://schemas.openxmlformats.org/officeDocument/2006/relationships">
-  <p:cSld>
-    <p:spTree>
-      <p:nvGrpSpPr>
-        <p:cNvPr id="1" name=""/>
-        <p:cNvGrpSpPr/>
-        <p:nvPr/>
-      </p:nvGrpSpPr>
-      <p:grpSpPr/>
-      <p:sp>
-        <p:nvSpPr>
-          <p:cNvPr id="2" name="TextBox 1"/>
-          <p:cNvSpPr txBox="1"/>
-          <p:nvPr/>
-        </p:nvSpPr>
-        <p:spPr>
-          <a:xfrm>
-            <a:off x="777240" y="640080"/>
-            <a:ext cx="10607040" cy="822960"/>
-          </a:xfrm>
-          <a:prstGeom prst="rect">
-            <a:avLst/>
-          </a:prstGeom>
-          <a:noFill/>
-        </p:spPr>
-        <p:txBody>
-          <a:bodyPr wrap="square">
-            <a:spAutoFit/>
-          </a:bodyPr>
-          <a:lstStyle/>
-          <a:p>
-            <a:r>
-              <a:rPr sz="3000" b="1" i="0">
-                <a:solidFill>
-                  <a:srgbClr val="1F2937"/>
-                </a:solidFill>
-                <a:latin typeface="Calibri"/>
-              </a:rPr>
-              <a:t>Did the two hypotheses hold?</a:t>
-            </a:r>
-          </a:p>
-        </p:txBody>
-      </p:sp>
-      <p:sp>
-        <p:nvSpPr>
-          <p:cNvPr id="3" name="Rectangle 2"/>
-          <p:cNvSpPr/>
-          <p:nvPr/>
-        </p:nvSpPr>
-        <p:spPr>
-          <a:xfrm>
-            <a:off x="777240" y="1417320"/>
-            <a:ext cx="1828800" cy="38100"/>
-          </a:xfrm>
-          <a:prstGeom prst="rect">
-            <a:avLst/>
-          </a:prstGeom>
-          <a:solidFill>
-            <a:srgbClr val="2563EB"/>
-          </a:solidFill>
-          <a:ln>
-            <a:noFill/>
-          </a:ln>
-          <a:effectLst/>
-        </p:spPr>
-        <p:style>
-          <a:lnRef idx="1">
-            <a:schemeClr val="accent1"/>
-          </a:lnRef>
-          <a:fillRef idx="3">
-            <a:schemeClr val="accent1"/>
-          </a:fillRef>
-          <a:effectRef idx="2">
-            <a:schemeClr val="accent1"/>
-          </a:effectRef>
-          <a:fontRef idx="minor">
-            <a:schemeClr val="lt1"/>
-          </a:fontRef>
-        </p:style>
-        <p:txBody>
-          <a:bodyPr rtlCol="0" anchor="ctr"/>
-          <a:lstStyle/>
-          <a:p>
-            <a:pPr algn="ctr"/>
-          </a:p>
-        </p:txBody>
-      </p:sp>
-      <p:sp>
-        <p:nvSpPr>
-          <p:cNvPr id="4" name="TextBox 3"/>
-          <p:cNvSpPr txBox="1"/>
-          <p:nvPr/>
-        </p:nvSpPr>
-        <p:spPr>
-          <a:xfrm>
-            <a:off x="777240" y="1600200"/>
-            <a:ext cx="10607040" cy="457200"/>
-          </a:xfrm>
-          <a:prstGeom prst="rect">
-            <a:avLst/>
-          </a:prstGeom>
-          <a:noFill/>
-        </p:spPr>
-        <p:txBody>
-          <a:bodyPr wrap="square">
-            <a:spAutoFit/>
-          </a:bodyPr>
-          <a:lstStyle/>
-          <a:p>
-            <a:r>
-              <a:rPr sz="1700" b="0" i="1">
-                <a:solidFill>
-                  <a:srgbClr val="2563EB"/>
-                </a:solidFill>
-                <a:latin typeface="Calibri"/>
-              </a:rPr>
-              <a:t>The paper stands on H1. H2 is reported transparently — across 25 years.</a:t>
-            </a:r>
-          </a:p>
-        </p:txBody>
-      </p:sp>
-      <p:sp>
-        <p:nvSpPr>
-          <p:cNvPr id="5" name="Rounded Rectangle 4"/>
-          <p:cNvSpPr/>
-          <p:nvPr/>
-        </p:nvSpPr>
-        <p:spPr>
-          <a:xfrm>
-            <a:off x="777240" y="2240280"/>
-            <a:ext cx="5074920" cy="640080"/>
-          </a:xfrm>
-          <a:prstGeom prst="roundRect">
-            <a:avLst/>
-          </a:prstGeom>
-          <a:solidFill>
-            <a:srgbClr val="159E5B"/>
-          </a:solidFill>
-          <a:ln>
-            <a:noFill/>
-          </a:ln>
-          <a:effectLst/>
-        </p:spPr>
-        <p:style>
-          <a:lnRef idx="1">
-            <a:schemeClr val="accent1"/>
-          </a:lnRef>
-          <a:fillRef idx="3">
-            <a:schemeClr val="accent1"/>
-          </a:fillRef>
-          <a:effectRef idx="2">
-            <a:schemeClr val="accent1"/>
-          </a:effectRef>
-          <a:fontRef idx="minor">
-            <a:schemeClr val="lt1"/>
-          </a:fontRef>
-        </p:style>
-        <p:txBody>
-          <a:bodyPr rtlCol="0" anchor="ctr" wrap="square"/>
-          <a:lstStyle/>
-          <a:p>
-            <a:pPr algn="ctr"/>
-            <a:r>
-              <a:rPr sz="1600" b="1" i="0">
-                <a:solidFill>
-                  <a:srgbClr val="FFFFFF"/>
-                </a:solidFill>
-                <a:latin typeface="Calibri"/>
-              </a:rPr>
-              <a:t>H1 — Structural distinctness</a:t>
-            </a:r>
-          </a:p>
-        </p:txBody>
-      </p:sp>
-      <p:sp>
-        <p:nvSpPr>
-          <p:cNvPr id="6" name="Rounded Rectangle 5"/>
-          <p:cNvSpPr/>
-          <p:nvPr/>
-        </p:nvSpPr>
-        <p:spPr>
-          <a:xfrm>
-            <a:off x="777240" y="3017520"/>
-            <a:ext cx="5074920" cy="2926080"/>
-          </a:xfrm>
-          <a:prstGeom prst="roundRect">
-            <a:avLst/>
-          </a:prstGeom>
-          <a:solidFill>
-            <a:srgbClr val="ECFBF2"/>
-          </a:solidFill>
-          <a:ln w="12700">
-            <a:solidFill>
-              <a:srgbClr val="159E5B"/>
-            </a:solidFill>
-          </a:ln>
-          <a:effectLst/>
-        </p:spPr>
-        <p:style>
-          <a:lnRef idx="1">
-            <a:schemeClr val="accent1"/>
-          </a:lnRef>
-          <a:fillRef idx="3">
-            <a:schemeClr val="accent1"/>
-          </a:fillRef>
-          <a:effectRef idx="2">
-            <a:schemeClr val="accent1"/>
-          </a:effectRef>
-          <a:fontRef idx="minor">
-            <a:schemeClr val="lt1"/>
-          </a:fontRef>
-        </p:style>
-        <p:txBody>
-          <a:bodyPr rtlCol="0" anchor="ctr" wrap="square" lIns="274320" rIns="274320" tIns="228600"/>
-          <a:lstStyle/>
-          <a:p>
-            <a:pPr algn="ctr"/>
-            <a:r>
-              <a:rPr sz="2200" b="1" i="0">
-                <a:solidFill>
-                  <a:srgbClr val="159E5B"/>
-                </a:solidFill>
-                <a:latin typeface="Calibri"/>
-              </a:rPr>
-              <a:t>✓  CONFIRMED</a:t>
-            </a:r>
-          </a:p>
-          <a:p>
-            <a:pPr>
-              <a:spcBef>
-                <a:spcPts val="1000"/>
-              </a:spcBef>
-            </a:pPr>
-            <a:r>
-              <a:rPr sz="1500" b="0" i="0">
-                <a:solidFill>
-                  <a:srgbClr val="374151"/>
-                </a:solidFill>
-                <a:latin typeface="Calibri"/>
-              </a:rPr>
-              <a:t>•  Jaccard 0, Spearman 0.07–0.18 vs correlation</a:t>
-            </a:r>
-          </a:p>
-          <a:p>
-            <a:pPr>
-              <a:spcBef>
-                <a:spcPts val="1000"/>
-              </a:spcBef>
-            </a:pPr>
-            <a:r>
-              <a:rPr sz="1500" b="0" i="0">
-                <a:solidFill>
-                  <a:srgbClr val="374151"/>
-                </a:solidFill>
-                <a:latin typeface="Calibri"/>
-              </a:rPr>
-              <a:t>•  augmented Forman: 44–82% non-degree signal</a:t>
-            </a:r>
-          </a:p>
-          <a:p>
-            <a:pPr>
-              <a:spcBef>
-                <a:spcPts val="1000"/>
-              </a:spcBef>
-            </a:pPr>
-            <a:r>
-              <a:rPr sz="1500" b="0" i="0">
-                <a:solidFill>
-                  <a:srgbClr val="374151"/>
-                </a:solidFill>
-                <a:latin typeface="Calibri"/>
-              </a:rPr>
-              <a:t>•  robust across 2019 intraday &amp; 25-yr daily</a:t>
-            </a:r>
-          </a:p>
-        </p:txBody>
-      </p:sp>
-      <p:sp>
-        <p:nvSpPr>
-          <p:cNvPr id="7" name="Rounded Rectangle 6"/>
-          <p:cNvSpPr/>
-          <p:nvPr/>
-        </p:nvSpPr>
-        <p:spPr>
-          <a:xfrm>
-            <a:off x="6309360" y="2240280"/>
-            <a:ext cx="5074920" cy="640080"/>
-          </a:xfrm>
-          <a:prstGeom prst="roundRect">
-            <a:avLst/>
-          </a:prstGeom>
-          <a:solidFill>
-            <a:srgbClr val="D97706"/>
-          </a:solidFill>
-          <a:ln>
-            <a:noFill/>
-          </a:ln>
-          <a:effectLst/>
-        </p:spPr>
-        <p:style>
-          <a:lnRef idx="1">
-            <a:schemeClr val="accent1"/>
-          </a:lnRef>
-          <a:fillRef idx="3">
-            <a:schemeClr val="accent1"/>
-          </a:fillRef>
-          <a:effectRef idx="2">
-            <a:schemeClr val="accent1"/>
-          </a:effectRef>
-          <a:fontRef idx="minor">
-            <a:schemeClr val="lt1"/>
-          </a:fontRef>
-        </p:style>
-        <p:txBody>
-          <a:bodyPr rtlCol="0" anchor="ctr" wrap="square"/>
-          <a:lstStyle/>
-          <a:p>
-            <a:pPr algn="ctr"/>
-            <a:r>
-              <a:rPr sz="1600" b="1" i="0">
-                <a:solidFill>
-                  <a:srgbClr val="FFFFFF"/>
-                </a:solidFill>
-                <a:latin typeface="Calibri"/>
-              </a:rPr>
-              <a:t>H2 — Predictive edge</a:t>
-            </a:r>
-          </a:p>
-        </p:txBody>
-      </p:sp>
-      <p:sp>
-        <p:nvSpPr>
-          <p:cNvPr id="8" name="Rounded Rectangle 7"/>
-          <p:cNvSpPr/>
-          <p:nvPr/>
-        </p:nvSpPr>
-        <p:spPr>
-          <a:xfrm>
-            <a:off x="6309360" y="3017520"/>
-            <a:ext cx="5074920" cy="2926080"/>
-          </a:xfrm>
-          <a:prstGeom prst="roundRect">
-            <a:avLst/>
-          </a:prstGeom>
-          <a:solidFill>
-            <a:srgbClr val="FDF4E6"/>
-          </a:solidFill>
-          <a:ln w="12700">
-            <a:solidFill>
-              <a:srgbClr val="D97706"/>
-            </a:solidFill>
-          </a:ln>
-          <a:effectLst/>
-        </p:spPr>
-        <p:style>
-          <a:lnRef idx="1">
-            <a:schemeClr val="accent1"/>
-          </a:lnRef>
-          <a:fillRef idx="3">
-            <a:schemeClr val="accent1"/>
-          </a:fillRef>
-          <a:effectRef idx="2">
-            <a:schemeClr val="accent1"/>
-          </a:effectRef>
-          <a:fontRef idx="minor">
-            <a:schemeClr val="lt1"/>
-          </a:fontRef>
-        </p:style>
-        <p:txBody>
-          <a:bodyPr rtlCol="0" anchor="ctr" wrap="square" lIns="274320" rIns="274320" tIns="228600"/>
-          <a:lstStyle/>
-          <a:p>
-            <a:pPr algn="ctr"/>
-            <a:r>
-              <a:rPr sz="2200" b="1" i="0">
-                <a:solidFill>
-                  <a:srgbClr val="D97706"/>
-                </a:solidFill>
-                <a:latin typeface="Calibri"/>
-              </a:rPr>
-              <a:t>✗  NOT SUPPORTED</a:t>
-            </a:r>
-          </a:p>
-          <a:p>
-            <a:pPr>
-              <a:spcBef>
-                <a:spcPts val="1000"/>
-              </a:spcBef>
-            </a:pPr>
-            <a:r>
-              <a:rPr sz="1500" b="0" i="0">
-                <a:solidFill>
-                  <a:srgbClr val="374151"/>
-                </a:solidFill>
-                <a:latin typeface="Calibri"/>
-              </a:rPr>
-              <a:t>•  Intraday 2019: Forman leads, but CIs span zero</a:t>
-            </a:r>
-          </a:p>
-          <a:p>
-            <a:pPr>
-              <a:spcBef>
-                <a:spcPts val="1000"/>
-              </a:spcBef>
-            </a:pPr>
-            <a:r>
-              <a:rPr sz="1500" b="0" i="0">
-                <a:solidFill>
-                  <a:srgbClr val="374151"/>
-                </a:solidFill>
-                <a:latin typeface="Calibri"/>
-              </a:rPr>
-              <a:t>•  Daily 25-yr: curvature negative, correlation best</a:t>
-            </a:r>
-          </a:p>
-          <a:p>
-            <a:pPr>
-              <a:spcBef>
-                <a:spcPts val="1000"/>
-              </a:spcBef>
-            </a:pPr>
-            <a:r>
-              <a:rPr sz="1500" b="0" i="0">
-                <a:solidFill>
-                  <a:srgbClr val="374151"/>
-                </a:solidFill>
-                <a:latin typeface="Calibri"/>
-              </a:rPr>
-              <a:t>•  no predictive edge; the claim rests on H1</a:t>
-            </a:r>
-          </a:p>
-        </p:txBody>
-      </p:sp>
-      <p:sp>
-        <p:nvSpPr>
-          <p:cNvPr id="9" name="TextBox 8"/>
-          <p:cNvSpPr txBox="1"/>
-          <p:nvPr/>
-        </p:nvSpPr>
-        <p:spPr>
-          <a:xfrm>
-            <a:off x="777240" y="6355080"/>
-            <a:ext cx="10607040" cy="365760"/>
-          </a:xfrm>
-          <a:prstGeom prst="rect">
-            <a:avLst/>
-          </a:prstGeom>
-          <a:noFill/>
-        </p:spPr>
-        <p:txBody>
-          <a:bodyPr wrap="square">
-            <a:spAutoFit/>
-          </a:bodyPr>
-          <a:lstStyle/>
-          <a:p>
-            <a:r>
-              <a:rPr sz="1100" b="0" i="0">
-                <a:solidFill>
-                  <a:srgbClr val="9CA3AF"/>
-                </a:solidFill>
-                <a:latin typeface="Calibri"/>
-              </a:rPr>
-              <a:t>Verdict</a:t>
-            </a:r>
-          </a:p>
-        </p:txBody>
-      </p:sp>
-      <p:sp>
-        <p:nvSpPr>
-          <p:cNvPr id="10" name="TextBox 9"/>
-          <p:cNvSpPr txBox="1"/>
-          <p:nvPr/>
-        </p:nvSpPr>
-        <p:spPr>
-          <a:xfrm>
-            <a:off x="10789920" y="6355080"/>
-            <a:ext cx="1280160" cy="365760"/>
-          </a:xfrm>
-          <a:prstGeom prst="rect">
-            <a:avLst/>
-          </a:prstGeom>
-          <a:noFill/>
-        </p:spPr>
-        <p:txBody>
-          <a:bodyPr wrap="square">
-            <a:spAutoFit/>
-          </a:bodyPr>
-          <a:lstStyle/>
-          <a:p>
-            <a:pPr algn="r"/>
-            <a:r>
-              <a:rPr sz="1100" b="0" i="0">
-                <a:solidFill>
-                  <a:srgbClr val="9CA3AF"/>
-                </a:solidFill>
-                <a:latin typeface="Calibri"/>
-              </a:rPr>
               <a:t>17</a:t>
             </a:r>
           </a:p>
@@ -7506,7 +7843,7 @@
                 </a:solidFill>
                 <a:latin typeface="Calibri"/>
               </a:rPr>
-              <a:t>Robustness &amp; ablations</a:t>
+              <a:t>Did the two hypotheses hold?</a:t>
             </a:r>
           </a:p>
         </p:txBody>
@@ -7563,8 +7900,8 @@
         </p:nvSpPr>
         <p:spPr>
           <a:xfrm>
-            <a:off x="777240" y="1783080"/>
-            <a:ext cx="10607040" cy="731520"/>
+            <a:off x="777240" y="1600200"/>
+            <a:ext cx="10607040" cy="457200"/>
           </a:xfrm>
           <a:prstGeom prst="rect">
             <a:avLst/>
@@ -7578,27 +7915,339 @@
           <a:lstStyle/>
           <a:p>
             <a:r>
-              <a:rPr sz="1900" b="0" i="1">
+              <a:rPr sz="1700" b="0" i="1">
                 <a:solidFill>
                   <a:srgbClr val="2563EB"/>
                 </a:solidFill>
                 <a:latin typeface="Calibri"/>
               </a:rPr>
-              <a:t>The result is stress-tested, not cherry-picked.</a:t>
-            </a:r>
-          </a:p>
-        </p:txBody>
-      </p:sp>
-      <p:sp>
-        <p:nvSpPr>
-          <p:cNvPr id="5" name="TextBox 4"/>
+              <a:t>The paper stands on H1. H2 is reported transparently — across 25 years.</a:t>
+            </a:r>
+          </a:p>
+        </p:txBody>
+      </p:sp>
+      <p:sp>
+        <p:nvSpPr>
+          <p:cNvPr id="5" name="Rounded Rectangle 4"/>
+          <p:cNvSpPr/>
+          <p:nvPr/>
+        </p:nvSpPr>
+        <p:spPr>
+          <a:xfrm>
+            <a:off x="777240" y="2240280"/>
+            <a:ext cx="5074920" cy="640080"/>
+          </a:xfrm>
+          <a:prstGeom prst="roundRect">
+            <a:avLst/>
+          </a:prstGeom>
+          <a:solidFill>
+            <a:srgbClr val="159E5B"/>
+          </a:solidFill>
+          <a:ln>
+            <a:noFill/>
+          </a:ln>
+          <a:effectLst/>
+        </p:spPr>
+        <p:style>
+          <a:lnRef idx="1">
+            <a:schemeClr val="accent1"/>
+          </a:lnRef>
+          <a:fillRef idx="3">
+            <a:schemeClr val="accent1"/>
+          </a:fillRef>
+          <a:effectRef idx="2">
+            <a:schemeClr val="accent1"/>
+          </a:effectRef>
+          <a:fontRef idx="minor">
+            <a:schemeClr val="lt1"/>
+          </a:fontRef>
+        </p:style>
+        <p:txBody>
+          <a:bodyPr rtlCol="0" anchor="ctr" wrap="square"/>
+          <a:lstStyle/>
+          <a:p>
+            <a:pPr algn="ctr"/>
+            <a:r>
+              <a:rPr sz="1600" b="1" i="0">
+                <a:solidFill>
+                  <a:srgbClr val="FFFFFF"/>
+                </a:solidFill>
+                <a:latin typeface="Calibri"/>
+              </a:rPr>
+              <a:t>H1 — Structural distinctness</a:t>
+            </a:r>
+          </a:p>
+        </p:txBody>
+      </p:sp>
+      <p:sp>
+        <p:nvSpPr>
+          <p:cNvPr id="6" name="Rounded Rectangle 5"/>
+          <p:cNvSpPr/>
+          <p:nvPr/>
+        </p:nvSpPr>
+        <p:spPr>
+          <a:xfrm>
+            <a:off x="777240" y="3017520"/>
+            <a:ext cx="5074920" cy="2926080"/>
+          </a:xfrm>
+          <a:prstGeom prst="roundRect">
+            <a:avLst/>
+          </a:prstGeom>
+          <a:solidFill>
+            <a:srgbClr val="ECFBF2"/>
+          </a:solidFill>
+          <a:ln w="12700">
+            <a:solidFill>
+              <a:srgbClr val="159E5B"/>
+            </a:solidFill>
+          </a:ln>
+          <a:effectLst/>
+        </p:spPr>
+        <p:style>
+          <a:lnRef idx="1">
+            <a:schemeClr val="accent1"/>
+          </a:lnRef>
+          <a:fillRef idx="3">
+            <a:schemeClr val="accent1"/>
+          </a:fillRef>
+          <a:effectRef idx="2">
+            <a:schemeClr val="accent1"/>
+          </a:effectRef>
+          <a:fontRef idx="minor">
+            <a:schemeClr val="lt1"/>
+          </a:fontRef>
+        </p:style>
+        <p:txBody>
+          <a:bodyPr rtlCol="0" anchor="ctr" wrap="square" lIns="274320" rIns="274320" tIns="228600"/>
+          <a:lstStyle/>
+          <a:p>
+            <a:pPr algn="ctr"/>
+            <a:r>
+              <a:rPr sz="2200" b="1" i="0">
+                <a:solidFill>
+                  <a:srgbClr val="159E5B"/>
+                </a:solidFill>
+                <a:latin typeface="Calibri"/>
+              </a:rPr>
+              <a:t>✓  CONFIRMED</a:t>
+            </a:r>
+          </a:p>
+          <a:p>
+            <a:pPr>
+              <a:spcBef>
+                <a:spcPts val="1000"/>
+              </a:spcBef>
+            </a:pPr>
+            <a:r>
+              <a:rPr sz="1500" b="0" i="0">
+                <a:solidFill>
+                  <a:srgbClr val="374151"/>
+                </a:solidFill>
+                <a:latin typeface="Calibri"/>
+              </a:rPr>
+              <a:t>•  Jaccard 0, Spearman 0.07–0.18 vs correlation</a:t>
+            </a:r>
+          </a:p>
+          <a:p>
+            <a:pPr>
+              <a:spcBef>
+                <a:spcPts val="1000"/>
+              </a:spcBef>
+            </a:pPr>
+            <a:r>
+              <a:rPr sz="1500" b="0" i="0">
+                <a:solidFill>
+                  <a:srgbClr val="374151"/>
+                </a:solidFill>
+                <a:latin typeface="Calibri"/>
+              </a:rPr>
+              <a:t>•  augmented Forman: 44–82% non-degree signal</a:t>
+            </a:r>
+          </a:p>
+          <a:p>
+            <a:pPr>
+              <a:spcBef>
+                <a:spcPts val="1000"/>
+              </a:spcBef>
+            </a:pPr>
+            <a:r>
+              <a:rPr sz="1500" b="0" i="0">
+                <a:solidFill>
+                  <a:srgbClr val="374151"/>
+                </a:solidFill>
+                <a:latin typeface="Calibri"/>
+              </a:rPr>
+              <a:t>•  robust across 2019 intraday &amp; 25-yr daily</a:t>
+            </a:r>
+          </a:p>
+        </p:txBody>
+      </p:sp>
+      <p:sp>
+        <p:nvSpPr>
+          <p:cNvPr id="7" name="Rounded Rectangle 6"/>
+          <p:cNvSpPr/>
+          <p:nvPr/>
+        </p:nvSpPr>
+        <p:spPr>
+          <a:xfrm>
+            <a:off x="6309360" y="2240280"/>
+            <a:ext cx="5074920" cy="640080"/>
+          </a:xfrm>
+          <a:prstGeom prst="roundRect">
+            <a:avLst/>
+          </a:prstGeom>
+          <a:solidFill>
+            <a:srgbClr val="D97706"/>
+          </a:solidFill>
+          <a:ln>
+            <a:noFill/>
+          </a:ln>
+          <a:effectLst/>
+        </p:spPr>
+        <p:style>
+          <a:lnRef idx="1">
+            <a:schemeClr val="accent1"/>
+          </a:lnRef>
+          <a:fillRef idx="3">
+            <a:schemeClr val="accent1"/>
+          </a:fillRef>
+          <a:effectRef idx="2">
+            <a:schemeClr val="accent1"/>
+          </a:effectRef>
+          <a:fontRef idx="minor">
+            <a:schemeClr val="lt1"/>
+          </a:fontRef>
+        </p:style>
+        <p:txBody>
+          <a:bodyPr rtlCol="0" anchor="ctr" wrap="square"/>
+          <a:lstStyle/>
+          <a:p>
+            <a:pPr algn="ctr"/>
+            <a:r>
+              <a:rPr sz="1600" b="1" i="0">
+                <a:solidFill>
+                  <a:srgbClr val="FFFFFF"/>
+                </a:solidFill>
+                <a:latin typeface="Calibri"/>
+              </a:rPr>
+              <a:t>H2 — Predictive edge</a:t>
+            </a:r>
+          </a:p>
+        </p:txBody>
+      </p:sp>
+      <p:sp>
+        <p:nvSpPr>
+          <p:cNvPr id="8" name="Rounded Rectangle 7"/>
+          <p:cNvSpPr/>
+          <p:nvPr/>
+        </p:nvSpPr>
+        <p:spPr>
+          <a:xfrm>
+            <a:off x="6309360" y="3017520"/>
+            <a:ext cx="5074920" cy="2926080"/>
+          </a:xfrm>
+          <a:prstGeom prst="roundRect">
+            <a:avLst/>
+          </a:prstGeom>
+          <a:solidFill>
+            <a:srgbClr val="FDF4E6"/>
+          </a:solidFill>
+          <a:ln w="12700">
+            <a:solidFill>
+              <a:srgbClr val="D97706"/>
+            </a:solidFill>
+          </a:ln>
+          <a:effectLst/>
+        </p:spPr>
+        <p:style>
+          <a:lnRef idx="1">
+            <a:schemeClr val="accent1"/>
+          </a:lnRef>
+          <a:fillRef idx="3">
+            <a:schemeClr val="accent1"/>
+          </a:fillRef>
+          <a:effectRef idx="2">
+            <a:schemeClr val="accent1"/>
+          </a:effectRef>
+          <a:fontRef idx="minor">
+            <a:schemeClr val="lt1"/>
+          </a:fontRef>
+        </p:style>
+        <p:txBody>
+          <a:bodyPr rtlCol="0" anchor="ctr" wrap="square" lIns="274320" rIns="274320" tIns="228600"/>
+          <a:lstStyle/>
+          <a:p>
+            <a:pPr algn="ctr"/>
+            <a:r>
+              <a:rPr sz="2200" b="1" i="0">
+                <a:solidFill>
+                  <a:srgbClr val="D97706"/>
+                </a:solidFill>
+                <a:latin typeface="Calibri"/>
+              </a:rPr>
+              <a:t>✗  NOT SUPPORTED</a:t>
+            </a:r>
+          </a:p>
+          <a:p>
+            <a:pPr>
+              <a:spcBef>
+                <a:spcPts val="1000"/>
+              </a:spcBef>
+            </a:pPr>
+            <a:r>
+              <a:rPr sz="1500" b="0" i="0">
+                <a:solidFill>
+                  <a:srgbClr val="374151"/>
+                </a:solidFill>
+                <a:latin typeface="Calibri"/>
+              </a:rPr>
+              <a:t>•  Intraday 2019: Forman leads, but CIs span zero</a:t>
+            </a:r>
+          </a:p>
+          <a:p>
+            <a:pPr>
+              <a:spcBef>
+                <a:spcPts val="1000"/>
+              </a:spcBef>
+            </a:pPr>
+            <a:r>
+              <a:rPr sz="1500" b="0" i="0">
+                <a:solidFill>
+                  <a:srgbClr val="374151"/>
+                </a:solidFill>
+                <a:latin typeface="Calibri"/>
+              </a:rPr>
+              <a:t>•  Daily 25-yr: curvature negative, correlation best</a:t>
+            </a:r>
+          </a:p>
+          <a:p>
+            <a:pPr>
+              <a:spcBef>
+                <a:spcPts val="1000"/>
+              </a:spcBef>
+            </a:pPr>
+            <a:r>
+              <a:rPr sz="1500" b="0" i="0">
+                <a:solidFill>
+                  <a:srgbClr val="374151"/>
+                </a:solidFill>
+                <a:latin typeface="Calibri"/>
+              </a:rPr>
+              <a:t>•  no predictive edge; the claim rests on H1</a:t>
+            </a:r>
+          </a:p>
+        </p:txBody>
+      </p:sp>
+      <p:sp>
+        <p:nvSpPr>
+          <p:cNvPr id="9" name="TextBox 8"/>
           <p:cNvSpPr txBox="1"/>
           <p:nvPr/>
         </p:nvSpPr>
         <p:spPr>
           <a:xfrm>
-            <a:off x="777240" y="2514600"/>
-            <a:ext cx="10607040" cy="3657600"/>
+            <a:off x="777240" y="6355080"/>
+            <a:ext cx="10607040" cy="365760"/>
           </a:xfrm>
           <a:prstGeom prst="rect">
             <a:avLst/>
@@ -7611,109 +8260,6 @@
           </a:bodyPr>
           <a:lstStyle/>
           <a:p>
-            <a:pPr>
-              <a:spcAft>
-                <a:spcPts val="1200"/>
-              </a:spcAft>
-            </a:pPr>
-            <a:r>
-              <a:rPr sz="2100" b="0" i="0">
-                <a:solidFill>
-                  <a:srgbClr val="374151"/>
-                </a:solidFill>
-                <a:latin typeface="Calibri"/>
-              </a:rPr>
-              <a:t>•  Four-object ablation: plain (degree baseline) → augmented → weighted-directed → Ollivier.</a:t>
-            </a:r>
-          </a:p>
-          <a:p>
-            <a:pPr>
-              <a:spcAft>
-                <a:spcPts val="1200"/>
-              </a:spcAft>
-            </a:pPr>
-            <a:r>
-              <a:rPr sz="2100" b="0" i="0">
-                <a:solidFill>
-                  <a:srgbClr val="374151"/>
-                </a:solidFill>
-                <a:latin typeface="Calibri"/>
-              </a:rPr>
-              <a:t>•  Two horizons: intraday 30-min (2019) and daily close-to-close (2000–2024).</a:t>
-            </a:r>
-          </a:p>
-          <a:p>
-            <a:pPr>
-              <a:spcAft>
-                <a:spcPts val="1200"/>
-              </a:spcAft>
-            </a:pPr>
-            <a:r>
-              <a:rPr sz="2100" b="0" i="0">
-                <a:solidFill>
-                  <a:srgbClr val="374151"/>
-                </a:solidFill>
-                <a:latin typeface="Calibri"/>
-              </a:rPr>
-              <a:t>•  25-year walk-forward: 21 rolling windows, not a single train/test split.</a:t>
-            </a:r>
-          </a:p>
-          <a:p>
-            <a:pPr>
-              <a:spcAft>
-                <a:spcPts val="1200"/>
-              </a:spcAft>
-            </a:pPr>
-            <a:r>
-              <a:rPr sz="2100" b="0" i="0">
-                <a:solidFill>
-                  <a:srgbClr val="374151"/>
-                </a:solidFill>
-                <a:latin typeface="Calibri"/>
-              </a:rPr>
-              <a:t>•  Five baselines: correlation, cointegration, random, undirected Forman, Ollivier.</a:t>
-            </a:r>
-          </a:p>
-          <a:p>
-            <a:pPr>
-              <a:spcAft>
-                <a:spcPts val="1200"/>
-              </a:spcAft>
-            </a:pPr>
-            <a:r>
-              <a:rPr sz="2100" b="0" i="0">
-                <a:solidFill>
-                  <a:srgbClr val="374151"/>
-                </a:solidFill>
-                <a:latin typeface="Calibri"/>
-              </a:rPr>
-              <a:t>•  Triangle convention (common-neighbor vs strict-cyclic) settled by the data.</a:t>
-            </a:r>
-          </a:p>
-        </p:txBody>
-      </p:sp>
-      <p:sp>
-        <p:nvSpPr>
-          <p:cNvPr id="6" name="TextBox 5"/>
-          <p:cNvSpPr txBox="1"/>
-          <p:nvPr/>
-        </p:nvSpPr>
-        <p:spPr>
-          <a:xfrm>
-            <a:off x="777240" y="6355080"/>
-            <a:ext cx="10607040" cy="365760"/>
-          </a:xfrm>
-          <a:prstGeom prst="rect">
-            <a:avLst/>
-          </a:prstGeom>
-          <a:noFill/>
-        </p:spPr>
-        <p:txBody>
-          <a:bodyPr wrap="square">
-            <a:spAutoFit/>
-          </a:bodyPr>
-          <a:lstStyle/>
-          <a:p>
             <a:r>
               <a:rPr sz="1100" b="0" i="0">
                 <a:solidFill>
@@ -7721,14 +8267,14 @@
                 </a:solidFill>
                 <a:latin typeface="Calibri"/>
               </a:rPr>
-              <a:t>Robustness</a:t>
-            </a:r>
-          </a:p>
-        </p:txBody>
-      </p:sp>
-      <p:sp>
-        <p:nvSpPr>
-          <p:cNvPr id="7" name="TextBox 6"/>
+              <a:t>Verdict</a:t>
+            </a:r>
+          </a:p>
+        </p:txBody>
+      </p:sp>
+      <p:sp>
+        <p:nvSpPr>
+          <p:cNvPr id="10" name="TextBox 9"/>
           <p:cNvSpPr txBox="1"/>
           <p:nvPr/>
         </p:nvSpPr>
@@ -8110,7 +8656,7 @@
                 </a:solidFill>
                 <a:latin typeface="Calibri"/>
               </a:rPr>
-              <a:t>Agentic AI workflow</a:t>
+              <a:t>Robustness &amp; ablations</a:t>
             </a:r>
           </a:p>
         </p:txBody>
@@ -8188,7 +8734,7 @@
                 </a:solidFill>
                 <a:latin typeface="Calibri"/>
               </a:rPr>
-              <a:t>What agentic AI did here.</a:t>
+              <a:t>The result is stress-tested, not cherry-picked.</a:t>
             </a:r>
           </a:p>
         </p:txBody>
@@ -8227,7 +8773,7 @@
                 </a:solidFill>
                 <a:latin typeface="Calibri"/>
               </a:rPr>
-              <a:t>•  Helped me research the idea — surveying the curvature and lead-lag literature, and coding the pipeline.</a:t>
+              <a:t>•  Four-object ablation: plain (degree baseline) → augmented → weighted-directed → Ollivier.</a:t>
             </a:r>
           </a:p>
           <a:p>
@@ -8243,7 +8789,7 @@
                 </a:solidFill>
                 <a:latin typeface="Calibri"/>
               </a:rPr>
-              <a:t>•  Its core role: linking curvature (graph geometry) to directed lead-lag networks (the finance side).</a:t>
+              <a:t>•  Two horizons: intraday 30-min (2019) and daily close-to-close (2000–2024).</a:t>
             </a:r>
           </a:p>
           <a:p>
@@ -8259,7 +8805,39 @@
                 </a:solidFill>
                 <a:latin typeface="Calibri"/>
               </a:rPr>
-              <a:t>•  Framing and judgment stayed human.</a:t>
+              <a:t>•  25-year walk-forward: 21 rolling windows, not a single train/test split.</a:t>
+            </a:r>
+          </a:p>
+          <a:p>
+            <a:pPr>
+              <a:spcAft>
+                <a:spcPts val="1200"/>
+              </a:spcAft>
+            </a:pPr>
+            <a:r>
+              <a:rPr sz="2100" b="0" i="0">
+                <a:solidFill>
+                  <a:srgbClr val="374151"/>
+                </a:solidFill>
+                <a:latin typeface="Calibri"/>
+              </a:rPr>
+              <a:t>•  Five baselines: correlation, cointegration, random, undirected Forman, Ollivier.</a:t>
+            </a:r>
+          </a:p>
+          <a:p>
+            <a:pPr>
+              <a:spcAft>
+                <a:spcPts val="1200"/>
+              </a:spcAft>
+            </a:pPr>
+            <a:r>
+              <a:rPr sz="2100" b="0" i="0">
+                <a:solidFill>
+                  <a:srgbClr val="374151"/>
+                </a:solidFill>
+                <a:latin typeface="Calibri"/>
+              </a:rPr>
+              <a:t>•  Triangle convention (common-neighbor vs strict-cyclic) settled by the data.</a:t>
             </a:r>
           </a:p>
         </p:txBody>
@@ -8293,7 +8871,7 @@
                 </a:solidFill>
                 <a:latin typeface="Calibri"/>
               </a:rPr>
-              <a:t>Agentic AI</a:t>
+              <a:t>Robustness</a:t>
             </a:r>
           </a:p>
         </p:txBody>
@@ -8380,7 +8958,7 @@
                 </a:solidFill>
                 <a:latin typeface="Calibri"/>
               </a:rPr>
-              <a:t>Limitations</a:t>
+              <a:t>Agentic AI workflow</a:t>
             </a:r>
           </a:p>
         </p:txBody>
@@ -8458,7 +9036,7 @@
                 </a:solidFill>
                 <a:latin typeface="Calibri"/>
               </a:rPr>
-              <a:t>Stated plainly — these shape what we can and can't claim.</a:t>
+              <a:t>What agentic AI did here.</a:t>
             </a:r>
           </a:p>
         </p:txBody>
@@ -8497,7 +9075,7 @@
                 </a:solidFill>
                 <a:latin typeface="Calibri"/>
               </a:rPr>
-              <a:t>•  Intraday is 2019 only (TAQ cost) — not a 25-year intraday panel.</a:t>
+              <a:t>•  Helped me research the idea — surveying the curvature and lead-lag literature, and coding the pipeline.</a:t>
             </a:r>
           </a:p>
           <a:p>
@@ -8513,7 +9091,7 @@
                 </a:solidFill>
                 <a:latin typeface="Calibri"/>
               </a:rPr>
-              <a:t>•  Triangle-sparse network limits AFRC community separability (Fesser–Weber–Lambiotte).</a:t>
+              <a:t>•  Its core role: linking curvature (graph geometry) to directed lead-lag networks (the finance side).</a:t>
             </a:r>
           </a:p>
           <a:p>
@@ -8529,39 +9107,7 @@
                 </a:solidFill>
                 <a:latin typeface="Calibri"/>
               </a:rPr>
-              <a:t>•  Directed line-graph &amp; directed curvature-gap are theoretically open — undirected reduction used.</a:t>
-            </a:r>
-          </a:p>
-          <a:p>
-            <a:pPr>
-              <a:spcAft>
-                <a:spcPts val="1200"/>
-              </a:spcAft>
-            </a:pPr>
-            <a:r>
-              <a:rPr sz="2100" b="0" i="0">
-                <a:solidFill>
-                  <a:srgbClr val="374151"/>
-                </a:solidFill>
-                <a:latin typeface="Calibri"/>
-              </a:rPr>
-              <a:t>•  Predictive IC evaluated at fixed k = 20; not pre-registered.</a:t>
-            </a:r>
-          </a:p>
-          <a:p>
-            <a:pPr>
-              <a:spcAft>
-                <a:spcPts val="1200"/>
-              </a:spcAft>
-            </a:pPr>
-            <a:r>
-              <a:rPr sz="2100" b="0" i="0">
-                <a:solidFill>
-                  <a:srgbClr val="374151"/>
-                </a:solidFill>
-                <a:latin typeface="Calibri"/>
-              </a:rPr>
-              <a:t>•  Daily universe is survivor-biased within each window (continuous-presence filter).</a:t>
+              <a:t>•  Framing and judgment stayed human.</a:t>
             </a:r>
           </a:p>
         </p:txBody>
@@ -8595,7 +9141,7 @@
                 </a:solidFill>
                 <a:latin typeface="Calibri"/>
               </a:rPr>
-              <a:t>Limitations</a:t>
+              <a:t>Agentic AI</a:t>
             </a:r>
           </a:p>
         </p:txBody>
@@ -8682,7 +9228,7 @@
                 </a:solidFill>
                 <a:latin typeface="Calibri"/>
               </a:rPr>
-              <a:t>What's next</a:t>
+              <a:t>Limitations</a:t>
             </a:r>
           </a:p>
         </p:txBody>
@@ -8760,7 +9306,7 @@
                 </a:solidFill>
                 <a:latin typeface="Calibri"/>
               </a:rPr>
-              <a:t>Underway now.</a:t>
+              <a:t>Stated plainly — these shape what we can and can't claim.</a:t>
             </a:r>
           </a:p>
         </p:txBody>
@@ -8799,7 +9345,7 @@
                 </a:solidFill>
                 <a:latin typeface="Calibri"/>
               </a:rPr>
-              <a:t>•  Multi-regime intraday robustness — pulling 2008 / 2015 / 2020 to join 2019 (crash, calm, COVID).</a:t>
+              <a:t>•  Intraday is 2019 only (TAQ cost) — not a 25-year intraday panel.</a:t>
             </a:r>
           </a:p>
           <a:p>
@@ -8815,7 +9361,7 @@
                 </a:solidFill>
                 <a:latin typeface="Calibri"/>
               </a:rPr>
-              <a:t>•  Agentic propose→test→reject orchestrator (built) — logs every accept/reject; the residualization ladder (market / sector / PCA) runs through it.</a:t>
+              <a:t>•  Triangle-sparse network limits AFRC community separability (Fesser–Weber–Lambiotte).</a:t>
             </a:r>
           </a:p>
           <a:p>
@@ -8831,7 +9377,7 @@
                 </a:solidFill>
                 <a:latin typeface="Calibri"/>
               </a:rPr>
-              <a:t>•  Directed line-graph &amp; directed curvature-gap theory (open; possible Weber collaboration).</a:t>
+              <a:t>•  Directed line-graph &amp; directed curvature-gap are theoretically open — undirected reduction used.</a:t>
             </a:r>
           </a:p>
           <a:p>
@@ -8847,7 +9393,23 @@
                 </a:solidFill>
                 <a:latin typeface="Calibri"/>
               </a:rPr>
-              <a:t>•  Extend to an 8-page ACM sigconf — ICAIF 2026, deadline Aug 2.</a:t>
+              <a:t>•  Predictive IC evaluated at fixed k = 20; not pre-registered.</a:t>
+            </a:r>
+          </a:p>
+          <a:p>
+            <a:pPr>
+              <a:spcAft>
+                <a:spcPts val="1200"/>
+              </a:spcAft>
+            </a:pPr>
+            <a:r>
+              <a:rPr sz="2100" b="0" i="0">
+                <a:solidFill>
+                  <a:srgbClr val="374151"/>
+                </a:solidFill>
+                <a:latin typeface="Calibri"/>
+              </a:rPr>
+              <a:t>•  Daily universe is survivor-biased within each window (continuous-presence filter).</a:t>
             </a:r>
           </a:p>
         </p:txBody>
@@ -8881,7 +9443,7 @@
                 </a:solidFill>
                 <a:latin typeface="Calibri"/>
               </a:rPr>
-              <a:t>What's next</a:t>
+              <a:t>Limitations</a:t>
             </a:r>
           </a:p>
         </p:txBody>
@@ -8930,6 +9492,292 @@
 </file>
 
 <file path=ppt/slides/slide23.xml><?xml version="1.0" encoding="utf-8"?>
+<p:sld xmlns:a="http://schemas.openxmlformats.org/drawingml/2006/main" xmlns:p="http://schemas.openxmlformats.org/presentationml/2006/main" xmlns:r="http://schemas.openxmlformats.org/officeDocument/2006/relationships">
+  <p:cSld>
+    <p:spTree>
+      <p:nvGrpSpPr>
+        <p:cNvPr id="1" name=""/>
+        <p:cNvGrpSpPr/>
+        <p:nvPr/>
+      </p:nvGrpSpPr>
+      <p:grpSpPr/>
+      <p:sp>
+        <p:nvSpPr>
+          <p:cNvPr id="2" name="TextBox 1"/>
+          <p:cNvSpPr txBox="1"/>
+          <p:nvPr/>
+        </p:nvSpPr>
+        <p:spPr>
+          <a:xfrm>
+            <a:off x="777240" y="640080"/>
+            <a:ext cx="10607040" cy="822960"/>
+          </a:xfrm>
+          <a:prstGeom prst="rect">
+            <a:avLst/>
+          </a:prstGeom>
+          <a:noFill/>
+        </p:spPr>
+        <p:txBody>
+          <a:bodyPr wrap="square">
+            <a:spAutoFit/>
+          </a:bodyPr>
+          <a:lstStyle/>
+          <a:p>
+            <a:r>
+              <a:rPr sz="3000" b="1" i="0">
+                <a:solidFill>
+                  <a:srgbClr val="1F2937"/>
+                </a:solidFill>
+                <a:latin typeface="Calibri"/>
+              </a:rPr>
+              <a:t>What's next</a:t>
+            </a:r>
+          </a:p>
+        </p:txBody>
+      </p:sp>
+      <p:sp>
+        <p:nvSpPr>
+          <p:cNvPr id="3" name="Rectangle 2"/>
+          <p:cNvSpPr/>
+          <p:nvPr/>
+        </p:nvSpPr>
+        <p:spPr>
+          <a:xfrm>
+            <a:off x="777240" y="1417320"/>
+            <a:ext cx="1828800" cy="38100"/>
+          </a:xfrm>
+          <a:prstGeom prst="rect">
+            <a:avLst/>
+          </a:prstGeom>
+          <a:solidFill>
+            <a:srgbClr val="2563EB"/>
+          </a:solidFill>
+          <a:ln>
+            <a:noFill/>
+          </a:ln>
+          <a:effectLst/>
+        </p:spPr>
+        <p:style>
+          <a:lnRef idx="1">
+            <a:schemeClr val="accent1"/>
+          </a:lnRef>
+          <a:fillRef idx="3">
+            <a:schemeClr val="accent1"/>
+          </a:fillRef>
+          <a:effectRef idx="2">
+            <a:schemeClr val="accent1"/>
+          </a:effectRef>
+          <a:fontRef idx="minor">
+            <a:schemeClr val="lt1"/>
+          </a:fontRef>
+        </p:style>
+        <p:txBody>
+          <a:bodyPr rtlCol="0" anchor="ctr"/>
+          <a:lstStyle/>
+          <a:p>
+            <a:pPr algn="ctr"/>
+          </a:p>
+        </p:txBody>
+      </p:sp>
+      <p:sp>
+        <p:nvSpPr>
+          <p:cNvPr id="4" name="TextBox 3"/>
+          <p:cNvSpPr txBox="1"/>
+          <p:nvPr/>
+        </p:nvSpPr>
+        <p:spPr>
+          <a:xfrm>
+            <a:off x="777240" y="1783080"/>
+            <a:ext cx="10607040" cy="731520"/>
+          </a:xfrm>
+          <a:prstGeom prst="rect">
+            <a:avLst/>
+          </a:prstGeom>
+          <a:noFill/>
+        </p:spPr>
+        <p:txBody>
+          <a:bodyPr wrap="square">
+            <a:spAutoFit/>
+          </a:bodyPr>
+          <a:lstStyle/>
+          <a:p>
+            <a:r>
+              <a:rPr sz="1900" b="0" i="1">
+                <a:solidFill>
+                  <a:srgbClr val="2563EB"/>
+                </a:solidFill>
+                <a:latin typeface="Calibri"/>
+              </a:rPr>
+              <a:t>Underway now.</a:t>
+            </a:r>
+          </a:p>
+        </p:txBody>
+      </p:sp>
+      <p:sp>
+        <p:nvSpPr>
+          <p:cNvPr id="5" name="TextBox 4"/>
+          <p:cNvSpPr txBox="1"/>
+          <p:nvPr/>
+        </p:nvSpPr>
+        <p:spPr>
+          <a:xfrm>
+            <a:off x="777240" y="2514600"/>
+            <a:ext cx="10607040" cy="3657600"/>
+          </a:xfrm>
+          <a:prstGeom prst="rect">
+            <a:avLst/>
+          </a:prstGeom>
+          <a:noFill/>
+        </p:spPr>
+        <p:txBody>
+          <a:bodyPr wrap="square">
+            <a:spAutoFit/>
+          </a:bodyPr>
+          <a:lstStyle/>
+          <a:p>
+            <a:pPr>
+              <a:spcAft>
+                <a:spcPts val="1200"/>
+              </a:spcAft>
+            </a:pPr>
+            <a:r>
+              <a:rPr sz="2100" b="0" i="0">
+                <a:solidFill>
+                  <a:srgbClr val="374151"/>
+                </a:solidFill>
+                <a:latin typeface="Calibri"/>
+              </a:rPr>
+              <a:t>•  Multi-regime intraday robustness — pulling 2008 / 2015 / 2020 to join 2019 (crash, calm, COVID).</a:t>
+            </a:r>
+          </a:p>
+          <a:p>
+            <a:pPr>
+              <a:spcAft>
+                <a:spcPts val="1200"/>
+              </a:spcAft>
+            </a:pPr>
+            <a:r>
+              <a:rPr sz="2100" b="0" i="0">
+                <a:solidFill>
+                  <a:srgbClr val="374151"/>
+                </a:solidFill>
+                <a:latin typeface="Calibri"/>
+              </a:rPr>
+              <a:t>•  Agentic propose→test→reject orchestrator (built) — logs every accept/reject; the residualization ladder (market / sector / PCA) runs through it.</a:t>
+            </a:r>
+          </a:p>
+          <a:p>
+            <a:pPr>
+              <a:spcAft>
+                <a:spcPts val="1200"/>
+              </a:spcAft>
+            </a:pPr>
+            <a:r>
+              <a:rPr sz="2100" b="0" i="0">
+                <a:solidFill>
+                  <a:srgbClr val="374151"/>
+                </a:solidFill>
+                <a:latin typeface="Calibri"/>
+              </a:rPr>
+              <a:t>•  Directed line-graph &amp; directed curvature-gap theory (open; possible Weber collaboration).</a:t>
+            </a:r>
+          </a:p>
+          <a:p>
+            <a:pPr>
+              <a:spcAft>
+                <a:spcPts val="1200"/>
+              </a:spcAft>
+            </a:pPr>
+            <a:r>
+              <a:rPr sz="2100" b="0" i="0">
+                <a:solidFill>
+                  <a:srgbClr val="374151"/>
+                </a:solidFill>
+                <a:latin typeface="Calibri"/>
+              </a:rPr>
+              <a:t>•  Extend to an 8-page ACM sigconf — ICAIF 2026, deadline Aug 2.</a:t>
+            </a:r>
+          </a:p>
+        </p:txBody>
+      </p:sp>
+      <p:sp>
+        <p:nvSpPr>
+          <p:cNvPr id="6" name="TextBox 5"/>
+          <p:cNvSpPr txBox="1"/>
+          <p:nvPr/>
+        </p:nvSpPr>
+        <p:spPr>
+          <a:xfrm>
+            <a:off x="777240" y="6355080"/>
+            <a:ext cx="10607040" cy="365760"/>
+          </a:xfrm>
+          <a:prstGeom prst="rect">
+            <a:avLst/>
+          </a:prstGeom>
+          <a:noFill/>
+        </p:spPr>
+        <p:txBody>
+          <a:bodyPr wrap="square">
+            <a:spAutoFit/>
+          </a:bodyPr>
+          <a:lstStyle/>
+          <a:p>
+            <a:r>
+              <a:rPr sz="1100" b="0" i="0">
+                <a:solidFill>
+                  <a:srgbClr val="9CA3AF"/>
+                </a:solidFill>
+                <a:latin typeface="Calibri"/>
+              </a:rPr>
+              <a:t>What's next</a:t>
+            </a:r>
+          </a:p>
+        </p:txBody>
+      </p:sp>
+      <p:sp>
+        <p:nvSpPr>
+          <p:cNvPr id="7" name="TextBox 6"/>
+          <p:cNvSpPr txBox="1"/>
+          <p:nvPr/>
+        </p:nvSpPr>
+        <p:spPr>
+          <a:xfrm>
+            <a:off x="10789920" y="6355080"/>
+            <a:ext cx="1280160" cy="365760"/>
+          </a:xfrm>
+          <a:prstGeom prst="rect">
+            <a:avLst/>
+          </a:prstGeom>
+          <a:noFill/>
+        </p:spPr>
+        <p:txBody>
+          <a:bodyPr wrap="square">
+            <a:spAutoFit/>
+          </a:bodyPr>
+          <a:lstStyle/>
+          <a:p>
+            <a:pPr algn="r"/>
+            <a:r>
+              <a:rPr sz="1100" b="0" i="0">
+                <a:solidFill>
+                  <a:srgbClr val="9CA3AF"/>
+                </a:solidFill>
+                <a:latin typeface="Calibri"/>
+              </a:rPr>
+              <a:t>22</a:t>
+            </a:r>
+          </a:p>
+        </p:txBody>
+      </p:sp>
+    </p:spTree>
+  </p:cSld>
+  <p:clrMapOvr>
+    <a:masterClrMapping/>
+  </p:clrMapOvr>
+</p:sld>
+</file>
+
+<file path=ppt/slides/slide24.xml><?xml version="1.0" encoding="utf-8"?>
 <p:sld xmlns:a="http://schemas.openxmlformats.org/drawingml/2006/main" xmlns:p="http://schemas.openxmlformats.org/presentationml/2006/main" xmlns:r="http://schemas.openxmlformats.org/officeDocument/2006/relationships">
   <p:cSld>
     <p:spTree>
@@ -9416,7 +10264,7 @@
                 </a:solidFill>
                 <a:latin typeface="Calibri"/>
               </a:rPr>
-              <a:t>22</a:t>
+              <a:t>23</a:t>
             </a:r>
           </a:p>
         </p:txBody>

</xml_diff>

<commit_message>
Deck: refocus triangle slide as "The structure is cross-sector"
Lead with the finding (curvature's pairs are cross-sector links a sector/correlation
view misses — ties back to H1), with the ~1%-within-sector-triangle stat as support
and a one-line honest caveat on the community step. Dropped the gratuitous theorem
name-drop. Talk script entry updated to match.

Co-Authored-By: Claude Opus 4.8 (1M context) <noreply@anthropic.com>
</commit_message>
<xml_diff>
--- a/slides/Ricci_Curvature_LeadLag.pptx
+++ b/slides/Ricci_Curvature_LeadLag.pptx
@@ -6902,7 +6902,7 @@
                 </a:solidFill>
                 <a:latin typeface="Calibri"/>
               </a:rPr>
-              <a:t>The network is triangle-sparse</a:t>
+              <a:t>The structure is cross-sector</a:t>
             </a:r>
           </a:p>
         </p:txBody>
@@ -6980,7 +6980,7 @@
                 </a:solidFill>
                 <a:latin typeface="Calibri"/>
               </a:rPr>
-              <a:t>A finding, not a bug.</a:t>
+              <a:t>Where do the pairs curvature picks actually live?</a:t>
             </a:r>
           </a:p>
         </p:txBody>
@@ -7019,7 +7019,23 @@
                 </a:solidFill>
                 <a:latin typeface="Calibri"/>
               </a:rPr>
-              <a:t>•  Most edges have few common-neighbor triangles; strict cyclic triangles ≈ 0.</a:t>
+              <a:t>•  Almost all of the network's triangle structure spans sectors —</a:t>
+            </a:r>
+          </a:p>
+          <a:p>
+            <a:pPr lvl="1">
+              <a:spcAft>
+                <a:spcPts val="600"/>
+              </a:spcAft>
+            </a:pPr>
+            <a:r>
+              <a:rPr sz="1800" b="0" i="0">
+                <a:solidFill>
+                  <a:srgbClr val="9CA3AF"/>
+                </a:solidFill>
+                <a:latin typeface="Calibri"/>
+              </a:rPr>
+              <a:t>–  only ~1% of triangles sit within a single GICS sector.</a:t>
             </a:r>
           </a:p>
           <a:p>
@@ -7035,7 +7051,7 @@
                 </a:solidFill>
                 <a:latin typeface="Calibri"/>
               </a:rPr>
-              <a:t>•  Only ~1% of triangles fall within a GICS sector.</a:t>
+              <a:t>•  So the relationships curvature highlights are cross-sector links — exactly what a sector- or correlation-based grouping would not surface.</a:t>
             </a:r>
           </a:p>
           <a:p>
@@ -7051,39 +7067,7 @@
                 </a:solidFill>
                 <a:latin typeface="Calibri"/>
               </a:rPr>
-              <a:t>•  Two honest consequences:</a:t>
-            </a:r>
-          </a:p>
-          <a:p>
-            <a:pPr lvl="1">
-              <a:spcAft>
-                <a:spcPts val="600"/>
-              </a:spcAft>
-            </a:pPr>
-            <a:r>
-              <a:rPr sz="1800" b="0" i="0">
-                <a:solidFill>
-                  <a:srgbClr val="9CA3AF"/>
-                </a:solidFill>
-                <a:latin typeface="Calibri"/>
-              </a:rPr>
-              <a:t>–  AFRC community separability is intrinsically limited (Fesser–Weber–Lambiotte).</a:t>
-            </a:r>
-          </a:p>
-          <a:p>
-            <a:pPr lvl="1">
-              <a:spcAft>
-                <a:spcPts val="600"/>
-              </a:spcAft>
-            </a:pPr>
-            <a:r>
-              <a:rPr sz="1800" b="0" i="0">
-                <a:solidFill>
-                  <a:srgbClr val="9CA3AF"/>
-                </a:solidFill>
-                <a:latin typeface="Calibri"/>
-              </a:rPr>
-              <a:t>–  The structure curvature surfaces is cross-sector — not aligned with GICS.</a:t>
+              <a:t>•  Honest caveat: with so few within-group triangles, the community step can't cleanly carve out clusters.</a:t>
             </a:r>
           </a:p>
         </p:txBody>

</xml_diff>

<commit_message>
Deck: define 'triangle' on the cross-sector slide for context
Co-Authored-By: Claude Opus 4.8 (1M context) <noreply@anthropic.com>
</commit_message>
<xml_diff>
--- a/slides/Ricci_Curvature_LeadLag.pptx
+++ b/slides/Ricci_Curvature_LeadLag.pptx
@@ -7019,23 +7019,7 @@
                 </a:solidFill>
                 <a:latin typeface="Calibri"/>
               </a:rPr>
-              <a:t>•  Almost all of the network's triangle structure spans sectors —</a:t>
-            </a:r>
-          </a:p>
-          <a:p>
-            <a:pPr lvl="1">
-              <a:spcAft>
-                <a:spcPts val="600"/>
-              </a:spcAft>
-            </a:pPr>
-            <a:r>
-              <a:rPr sz="1800" b="0" i="0">
-                <a:solidFill>
-                  <a:srgbClr val="9CA3AF"/>
-                </a:solidFill>
-                <a:latin typeface="Calibri"/>
-              </a:rPr>
-              <a:t>–  only ~1% of triangles sit within a single GICS sector.</a:t>
+              <a:t>•  A 'triangle' = three stocks each linked to the other two — a tight local cluster, and what the curvature augmentation counts.</a:t>
             </a:r>
           </a:p>
           <a:p>
@@ -7051,7 +7035,7 @@
                 </a:solidFill>
                 <a:latin typeface="Calibri"/>
               </a:rPr>
-              <a:t>•  So the relationships curvature highlights are cross-sector links — exactly what a sector- or correlation-based grouping would not surface.</a:t>
+              <a:t>•  Almost all of these triangles span sectors — only ~1% sit within a single GICS sector.</a:t>
             </a:r>
           </a:p>
           <a:p>
@@ -7067,7 +7051,23 @@
                 </a:solidFill>
                 <a:latin typeface="Calibri"/>
               </a:rPr>
-              <a:t>•  Honest caveat: with so few within-group triangles, the community step can't cleanly carve out clusters.</a:t>
+              <a:t>•  So curvature highlights cross-sector links that a sector- or correlation-based grouping would never put together.</a:t>
+            </a:r>
+          </a:p>
+          <a:p>
+            <a:pPr>
+              <a:spcAft>
+                <a:spcPts val="1200"/>
+              </a:spcAft>
+            </a:pPr>
+            <a:r>
+              <a:rPr sz="2100" b="0" i="0">
+                <a:solidFill>
+                  <a:srgbClr val="374151"/>
+                </a:solidFill>
+                <a:latin typeface="Calibri"/>
+              </a:rPr>
+              <a:t>•  Honest caveat: so few within-group triangles → the community step can't cleanly carve out clusters.</a:t>
             </a:r>
           </a:p>
         </p:txBody>

</xml_diff>

<commit_message>
Deck: drop redundant Robustness slide; pivot What's-next off return prediction
- Removed "Robustness & ablations" recap slide — all of it is shown in situ
  (four-object ablation = slide 15, horizons = regimes slide, walk-forward =
  predictive slide, baselines = result tables).
- "What's next" pivots away from forecasting returns (H2 failed) toward where
  curvature is strong: fragility/systemic-risk monitoring (Sandhu's original) and
  regime-shift detection (the 2008/2020 pulls feed this), + theory + ICAIF.
- Slide 14 now labels its object (F = main weighted-augmented directed Forman) and
  points to the four-object slide. Talk script synced.

Co-Authored-By: Claude Opus 4.8 (1M context) <noreply@anthropic.com>
</commit_message>
<xml_diff>
--- a/slides/Ricci_Curvature_LeadLag.pptx
+++ b/slides/Ricci_Curvature_LeadLag.pptx
@@ -28,7 +28,6 @@
     <p:sldId id="276" r:id="rId27"/>
     <p:sldId id="277" r:id="rId28"/>
     <p:sldId id="278" r:id="rId29"/>
-    <p:sldId id="279" r:id="rId30"/>
   </p:sldIdLst>
   <p:sldSz cx="12191695" cy="6858000" type="screen4x3"/>
   <p:notesSz cx="6858000" cy="9144000"/>
@@ -4999,7 +4998,7 @@
                 </a:solidFill>
                 <a:latin typeface="Calibri"/>
               </a:rPr>
-              <a:t>The pairs curvature flags are not the pairs correlation flags — at both horizons.</a:t>
+              <a:t>Our main object (weighted augmented directed Forman) vs. correlation — both horizons.</a:t>
             </a:r>
           </a:p>
         </p:txBody>
@@ -5367,7 +5366,7 @@
                 </a:solidFill>
                 <a:latin typeface="Calibri"/>
               </a:rPr>
-              <a:t>Significance: curvature is not a re-skin of correlation. Holds on the 2019 intraday graph AND the full 2000–2024 daily span. This distinctness IS the headline result.</a:t>
+              <a:t>F = the main object. Significance: curvature is not a re-skin of correlation — it holds on the 2019 intraday graph AND the full 2000–2024 daily span. This distinctness IS the headline result. (The next slide compares all four objects to each other.)</a:t>
             </a:r>
           </a:p>
         </p:txBody>
@@ -8640,7 +8639,7 @@
                 </a:solidFill>
                 <a:latin typeface="Calibri"/>
               </a:rPr>
-              <a:t>Robustness &amp; ablations</a:t>
+              <a:t>Agentic AI workflow</a:t>
             </a:r>
           </a:p>
         </p:txBody>
@@ -8718,7 +8717,7 @@
                 </a:solidFill>
                 <a:latin typeface="Calibri"/>
               </a:rPr>
-              <a:t>The result is stress-tested, not cherry-picked.</a:t>
+              <a:t>What agentic AI did here.</a:t>
             </a:r>
           </a:p>
         </p:txBody>
@@ -8757,7 +8756,7 @@
                 </a:solidFill>
                 <a:latin typeface="Calibri"/>
               </a:rPr>
-              <a:t>•  Four-object ablation: plain (degree baseline) → augmented → weighted-directed → Ollivier.</a:t>
+              <a:t>•  Helped me research the idea — surveying the curvature and lead-lag literature, and coding the pipeline.</a:t>
             </a:r>
           </a:p>
           <a:p>
@@ -8773,7 +8772,7 @@
                 </a:solidFill>
                 <a:latin typeface="Calibri"/>
               </a:rPr>
-              <a:t>•  Two horizons: intraday 30-min (2019) and daily close-to-close (2000–2024).</a:t>
+              <a:t>•  Its core role: linking curvature (graph geometry) to directed lead-lag networks (the finance side).</a:t>
             </a:r>
           </a:p>
           <a:p>
@@ -8789,39 +8788,7 @@
                 </a:solidFill>
                 <a:latin typeface="Calibri"/>
               </a:rPr>
-              <a:t>•  25-year walk-forward: 21 rolling windows, not a single train/test split.</a:t>
-            </a:r>
-          </a:p>
-          <a:p>
-            <a:pPr>
-              <a:spcAft>
-                <a:spcPts val="1200"/>
-              </a:spcAft>
-            </a:pPr>
-            <a:r>
-              <a:rPr sz="2100" b="0" i="0">
-                <a:solidFill>
-                  <a:srgbClr val="374151"/>
-                </a:solidFill>
-                <a:latin typeface="Calibri"/>
-              </a:rPr>
-              <a:t>•  Five baselines: correlation, cointegration, random, undirected Forman, Ollivier.</a:t>
-            </a:r>
-          </a:p>
-          <a:p>
-            <a:pPr>
-              <a:spcAft>
-                <a:spcPts val="1200"/>
-              </a:spcAft>
-            </a:pPr>
-            <a:r>
-              <a:rPr sz="2100" b="0" i="0">
-                <a:solidFill>
-                  <a:srgbClr val="374151"/>
-                </a:solidFill>
-                <a:latin typeface="Calibri"/>
-              </a:rPr>
-              <a:t>•  Triangle convention (common-neighbor vs strict-cyclic) settled by the data.</a:t>
+              <a:t>•  Framing and judgment stayed human.</a:t>
             </a:r>
           </a:p>
         </p:txBody>
@@ -8855,7 +8822,7 @@
                 </a:solidFill>
                 <a:latin typeface="Calibri"/>
               </a:rPr>
-              <a:t>Robustness</a:t>
+              <a:t>Agentic AI</a:t>
             </a:r>
           </a:p>
         </p:txBody>
@@ -8942,7 +8909,7 @@
                 </a:solidFill>
                 <a:latin typeface="Calibri"/>
               </a:rPr>
-              <a:t>Agentic AI workflow</a:t>
+              <a:t>Limitations</a:t>
             </a:r>
           </a:p>
         </p:txBody>
@@ -9020,7 +8987,7 @@
                 </a:solidFill>
                 <a:latin typeface="Calibri"/>
               </a:rPr>
-              <a:t>What agentic AI did here.</a:t>
+              <a:t>Stated plainly — these shape what we can and can't claim.</a:t>
             </a:r>
           </a:p>
         </p:txBody>
@@ -9059,7 +9026,7 @@
                 </a:solidFill>
                 <a:latin typeface="Calibri"/>
               </a:rPr>
-              <a:t>•  Helped me research the idea — surveying the curvature and lead-lag literature, and coding the pipeline.</a:t>
+              <a:t>•  Intraday is 2019 only (TAQ cost) — not a 25-year intraday panel.</a:t>
             </a:r>
           </a:p>
           <a:p>
@@ -9075,7 +9042,7 @@
                 </a:solidFill>
                 <a:latin typeface="Calibri"/>
               </a:rPr>
-              <a:t>•  Its core role: linking curvature (graph geometry) to directed lead-lag networks (the finance side).</a:t>
+              <a:t>•  Triangle-sparse network limits AFRC community separability (Fesser–Weber–Lambiotte).</a:t>
             </a:r>
           </a:p>
           <a:p>
@@ -9091,7 +9058,39 @@
                 </a:solidFill>
                 <a:latin typeface="Calibri"/>
               </a:rPr>
-              <a:t>•  Framing and judgment stayed human.</a:t>
+              <a:t>•  Directed line-graph &amp; directed curvature-gap are theoretically open — undirected reduction used.</a:t>
+            </a:r>
+          </a:p>
+          <a:p>
+            <a:pPr>
+              <a:spcAft>
+                <a:spcPts val="1200"/>
+              </a:spcAft>
+            </a:pPr>
+            <a:r>
+              <a:rPr sz="2100" b="0" i="0">
+                <a:solidFill>
+                  <a:srgbClr val="374151"/>
+                </a:solidFill>
+                <a:latin typeface="Calibri"/>
+              </a:rPr>
+              <a:t>•  Predictive IC evaluated at fixed k = 20; not pre-registered.</a:t>
+            </a:r>
+          </a:p>
+          <a:p>
+            <a:pPr>
+              <a:spcAft>
+                <a:spcPts val="1200"/>
+              </a:spcAft>
+            </a:pPr>
+            <a:r>
+              <a:rPr sz="2100" b="0" i="0">
+                <a:solidFill>
+                  <a:srgbClr val="374151"/>
+                </a:solidFill>
+                <a:latin typeface="Calibri"/>
+              </a:rPr>
+              <a:t>•  Daily universe is survivor-biased within each window (continuous-presence filter).</a:t>
             </a:r>
           </a:p>
         </p:txBody>
@@ -9125,7 +9124,7 @@
                 </a:solidFill>
                 <a:latin typeface="Calibri"/>
               </a:rPr>
-              <a:t>Agentic AI</a:t>
+              <a:t>Limitations</a:t>
             </a:r>
           </a:p>
         </p:txBody>
@@ -9212,7 +9211,7 @@
                 </a:solidFill>
                 <a:latin typeface="Calibri"/>
               </a:rPr>
-              <a:t>Limitations</a:t>
+              <a:t>What's next</a:t>
             </a:r>
           </a:p>
         </p:txBody>
@@ -9290,7 +9289,7 @@
                 </a:solidFill>
                 <a:latin typeface="Calibri"/>
               </a:rPr>
-              <a:t>Stated plainly — these shape what we can and can't claim.</a:t>
+              <a:t>H2 failed — so pivot from forecasting returns to what curvature is strong at: structure.</a:t>
             </a:r>
           </a:p>
         </p:txBody>
@@ -9329,7 +9328,7 @@
                 </a:solidFill>
                 <a:latin typeface="Calibri"/>
               </a:rPr>
-              <a:t>•  Intraday is 2019 only (TAQ cost) — not a 25-year intraday panel.</a:t>
+              <a:t>•  Curvature as a fragility / systemic-risk signal — Sandhu's original result was curvature rising before crashes; bring that to the directed graph.</a:t>
             </a:r>
           </a:p>
           <a:p>
@@ -9345,7 +9344,7 @@
                 </a:solidFill>
                 <a:latin typeface="Calibri"/>
               </a:rPr>
-              <a:t>•  Triangle-sparse network limits AFRC community separability (Fesser–Weber–Lambiotte).</a:t>
+              <a:t>•  Regime shifts: does the cross-sector structure change around stress? The 2008 &amp; 2020 intraday pulls feed exactly this.</a:t>
             </a:r>
           </a:p>
           <a:p>
@@ -9361,7 +9360,7 @@
                 </a:solidFill>
                 <a:latin typeface="Calibri"/>
               </a:rPr>
-              <a:t>•  Directed line-graph &amp; directed curvature-gap are theoretically open — undirected reduction used.</a:t>
+              <a:t>•  Directed line-graph &amp; curvature-gap theory (open; possible Weber collaboration).</a:t>
             </a:r>
           </a:p>
           <a:p>
@@ -9377,23 +9376,7 @@
                 </a:solidFill>
                 <a:latin typeface="Calibri"/>
               </a:rPr>
-              <a:t>•  Predictive IC evaluated at fixed k = 20; not pre-registered.</a:t>
-            </a:r>
-          </a:p>
-          <a:p>
-            <a:pPr>
-              <a:spcAft>
-                <a:spcPts val="1200"/>
-              </a:spcAft>
-            </a:pPr>
-            <a:r>
-              <a:rPr sz="2100" b="0" i="0">
-                <a:solidFill>
-                  <a:srgbClr val="374151"/>
-                </a:solidFill>
-                <a:latin typeface="Calibri"/>
-              </a:rPr>
-              <a:t>•  Daily universe is survivor-biased within each window (continuous-presence filter).</a:t>
+              <a:t>•  Extend to an 8-page ACM sigconf — ICAIF 2026, deadline Aug 2.</a:t>
             </a:r>
           </a:p>
         </p:txBody>
@@ -9427,7 +9410,7 @@
                 </a:solidFill>
                 <a:latin typeface="Calibri"/>
               </a:rPr>
-              <a:t>Limitations</a:t>
+              <a:t>What's next</a:t>
             </a:r>
           </a:p>
         </p:txBody>
@@ -9476,292 +9459,6 @@
 </file>
 
 <file path=ppt/slides/slide23.xml><?xml version="1.0" encoding="utf-8"?>
-<p:sld xmlns:a="http://schemas.openxmlformats.org/drawingml/2006/main" xmlns:p="http://schemas.openxmlformats.org/presentationml/2006/main" xmlns:r="http://schemas.openxmlformats.org/officeDocument/2006/relationships">
-  <p:cSld>
-    <p:spTree>
-      <p:nvGrpSpPr>
-        <p:cNvPr id="1" name=""/>
-        <p:cNvGrpSpPr/>
-        <p:nvPr/>
-      </p:nvGrpSpPr>
-      <p:grpSpPr/>
-      <p:sp>
-        <p:nvSpPr>
-          <p:cNvPr id="2" name="TextBox 1"/>
-          <p:cNvSpPr txBox="1"/>
-          <p:nvPr/>
-        </p:nvSpPr>
-        <p:spPr>
-          <a:xfrm>
-            <a:off x="777240" y="640080"/>
-            <a:ext cx="10607040" cy="822960"/>
-          </a:xfrm>
-          <a:prstGeom prst="rect">
-            <a:avLst/>
-          </a:prstGeom>
-          <a:noFill/>
-        </p:spPr>
-        <p:txBody>
-          <a:bodyPr wrap="square">
-            <a:spAutoFit/>
-          </a:bodyPr>
-          <a:lstStyle/>
-          <a:p>
-            <a:r>
-              <a:rPr sz="3000" b="1" i="0">
-                <a:solidFill>
-                  <a:srgbClr val="1F2937"/>
-                </a:solidFill>
-                <a:latin typeface="Calibri"/>
-              </a:rPr>
-              <a:t>What's next</a:t>
-            </a:r>
-          </a:p>
-        </p:txBody>
-      </p:sp>
-      <p:sp>
-        <p:nvSpPr>
-          <p:cNvPr id="3" name="Rectangle 2"/>
-          <p:cNvSpPr/>
-          <p:nvPr/>
-        </p:nvSpPr>
-        <p:spPr>
-          <a:xfrm>
-            <a:off x="777240" y="1417320"/>
-            <a:ext cx="1828800" cy="38100"/>
-          </a:xfrm>
-          <a:prstGeom prst="rect">
-            <a:avLst/>
-          </a:prstGeom>
-          <a:solidFill>
-            <a:srgbClr val="2563EB"/>
-          </a:solidFill>
-          <a:ln>
-            <a:noFill/>
-          </a:ln>
-          <a:effectLst/>
-        </p:spPr>
-        <p:style>
-          <a:lnRef idx="1">
-            <a:schemeClr val="accent1"/>
-          </a:lnRef>
-          <a:fillRef idx="3">
-            <a:schemeClr val="accent1"/>
-          </a:fillRef>
-          <a:effectRef idx="2">
-            <a:schemeClr val="accent1"/>
-          </a:effectRef>
-          <a:fontRef idx="minor">
-            <a:schemeClr val="lt1"/>
-          </a:fontRef>
-        </p:style>
-        <p:txBody>
-          <a:bodyPr rtlCol="0" anchor="ctr"/>
-          <a:lstStyle/>
-          <a:p>
-            <a:pPr algn="ctr"/>
-          </a:p>
-        </p:txBody>
-      </p:sp>
-      <p:sp>
-        <p:nvSpPr>
-          <p:cNvPr id="4" name="TextBox 3"/>
-          <p:cNvSpPr txBox="1"/>
-          <p:nvPr/>
-        </p:nvSpPr>
-        <p:spPr>
-          <a:xfrm>
-            <a:off x="777240" y="1783080"/>
-            <a:ext cx="10607040" cy="731520"/>
-          </a:xfrm>
-          <a:prstGeom prst="rect">
-            <a:avLst/>
-          </a:prstGeom>
-          <a:noFill/>
-        </p:spPr>
-        <p:txBody>
-          <a:bodyPr wrap="square">
-            <a:spAutoFit/>
-          </a:bodyPr>
-          <a:lstStyle/>
-          <a:p>
-            <a:r>
-              <a:rPr sz="1900" b="0" i="1">
-                <a:solidFill>
-                  <a:srgbClr val="2563EB"/>
-                </a:solidFill>
-                <a:latin typeface="Calibri"/>
-              </a:rPr>
-              <a:t>Underway now.</a:t>
-            </a:r>
-          </a:p>
-        </p:txBody>
-      </p:sp>
-      <p:sp>
-        <p:nvSpPr>
-          <p:cNvPr id="5" name="TextBox 4"/>
-          <p:cNvSpPr txBox="1"/>
-          <p:nvPr/>
-        </p:nvSpPr>
-        <p:spPr>
-          <a:xfrm>
-            <a:off x="777240" y="2514600"/>
-            <a:ext cx="10607040" cy="3657600"/>
-          </a:xfrm>
-          <a:prstGeom prst="rect">
-            <a:avLst/>
-          </a:prstGeom>
-          <a:noFill/>
-        </p:spPr>
-        <p:txBody>
-          <a:bodyPr wrap="square">
-            <a:spAutoFit/>
-          </a:bodyPr>
-          <a:lstStyle/>
-          <a:p>
-            <a:pPr>
-              <a:spcAft>
-                <a:spcPts val="1200"/>
-              </a:spcAft>
-            </a:pPr>
-            <a:r>
-              <a:rPr sz="2100" b="0" i="0">
-                <a:solidFill>
-                  <a:srgbClr val="374151"/>
-                </a:solidFill>
-                <a:latin typeface="Calibri"/>
-              </a:rPr>
-              <a:t>•  Multi-regime intraday robustness — pulling 2008 / 2015 / 2020 to join 2019 (crash, calm, COVID).</a:t>
-            </a:r>
-          </a:p>
-          <a:p>
-            <a:pPr>
-              <a:spcAft>
-                <a:spcPts val="1200"/>
-              </a:spcAft>
-            </a:pPr>
-            <a:r>
-              <a:rPr sz="2100" b="0" i="0">
-                <a:solidFill>
-                  <a:srgbClr val="374151"/>
-                </a:solidFill>
-                <a:latin typeface="Calibri"/>
-              </a:rPr>
-              <a:t>•  Agentic propose→test→reject orchestrator (built) — logs every accept/reject; the residualization ladder (market / sector / PCA) runs through it.</a:t>
-            </a:r>
-          </a:p>
-          <a:p>
-            <a:pPr>
-              <a:spcAft>
-                <a:spcPts val="1200"/>
-              </a:spcAft>
-            </a:pPr>
-            <a:r>
-              <a:rPr sz="2100" b="0" i="0">
-                <a:solidFill>
-                  <a:srgbClr val="374151"/>
-                </a:solidFill>
-                <a:latin typeface="Calibri"/>
-              </a:rPr>
-              <a:t>•  Directed line-graph &amp; directed curvature-gap theory (open; possible Weber collaboration).</a:t>
-            </a:r>
-          </a:p>
-          <a:p>
-            <a:pPr>
-              <a:spcAft>
-                <a:spcPts val="1200"/>
-              </a:spcAft>
-            </a:pPr>
-            <a:r>
-              <a:rPr sz="2100" b="0" i="0">
-                <a:solidFill>
-                  <a:srgbClr val="374151"/>
-                </a:solidFill>
-                <a:latin typeface="Calibri"/>
-              </a:rPr>
-              <a:t>•  Extend to an 8-page ACM sigconf — ICAIF 2026, deadline Aug 2.</a:t>
-            </a:r>
-          </a:p>
-        </p:txBody>
-      </p:sp>
-      <p:sp>
-        <p:nvSpPr>
-          <p:cNvPr id="6" name="TextBox 5"/>
-          <p:cNvSpPr txBox="1"/>
-          <p:nvPr/>
-        </p:nvSpPr>
-        <p:spPr>
-          <a:xfrm>
-            <a:off x="777240" y="6355080"/>
-            <a:ext cx="10607040" cy="365760"/>
-          </a:xfrm>
-          <a:prstGeom prst="rect">
-            <a:avLst/>
-          </a:prstGeom>
-          <a:noFill/>
-        </p:spPr>
-        <p:txBody>
-          <a:bodyPr wrap="square">
-            <a:spAutoFit/>
-          </a:bodyPr>
-          <a:lstStyle/>
-          <a:p>
-            <a:r>
-              <a:rPr sz="1100" b="0" i="0">
-                <a:solidFill>
-                  <a:srgbClr val="9CA3AF"/>
-                </a:solidFill>
-                <a:latin typeface="Calibri"/>
-              </a:rPr>
-              <a:t>What's next</a:t>
-            </a:r>
-          </a:p>
-        </p:txBody>
-      </p:sp>
-      <p:sp>
-        <p:nvSpPr>
-          <p:cNvPr id="7" name="TextBox 6"/>
-          <p:cNvSpPr txBox="1"/>
-          <p:nvPr/>
-        </p:nvSpPr>
-        <p:spPr>
-          <a:xfrm>
-            <a:off x="10789920" y="6355080"/>
-            <a:ext cx="1280160" cy="365760"/>
-          </a:xfrm>
-          <a:prstGeom prst="rect">
-            <a:avLst/>
-          </a:prstGeom>
-          <a:noFill/>
-        </p:spPr>
-        <p:txBody>
-          <a:bodyPr wrap="square">
-            <a:spAutoFit/>
-          </a:bodyPr>
-          <a:lstStyle/>
-          <a:p>
-            <a:pPr algn="r"/>
-            <a:r>
-              <a:rPr sz="1100" b="0" i="0">
-                <a:solidFill>
-                  <a:srgbClr val="9CA3AF"/>
-                </a:solidFill>
-                <a:latin typeface="Calibri"/>
-              </a:rPr>
-              <a:t>22</a:t>
-            </a:r>
-          </a:p>
-        </p:txBody>
-      </p:sp>
-    </p:spTree>
-  </p:cSld>
-  <p:clrMapOvr>
-    <a:masterClrMapping/>
-  </p:clrMapOvr>
-</p:sld>
-</file>
-
-<file path=ppt/slides/slide24.xml><?xml version="1.0" encoding="utf-8"?>
 <p:sld xmlns:a="http://schemas.openxmlformats.org/drawingml/2006/main" xmlns:p="http://schemas.openxmlformats.org/presentationml/2006/main" xmlns:r="http://schemas.openxmlformats.org/officeDocument/2006/relationships">
   <p:cSld>
     <p:spTree>
@@ -10248,7 +9945,7 @@
                 </a:solidFill>
                 <a:latin typeface="Calibri"/>
               </a:rPr>
-              <a:t>23</a:t>
+              <a:t>22</a:t>
             </a:r>
           </a:p>
         </p:txBody>

</xml_diff>

<commit_message>
Deck: merge H1 structural slides into one table (no IC)
Folded "Curvature is not correlation" + "four objects compared" + "degree
ablation" into a single H1 table — "Distinct from correlation — and from degree"
(four objects × Spearman / Jaccard / R²-on-degree / compute). Dropped the IC
column: IC is discussed on the predictive-test slide, not here (H1 vs H2 cleanly
separated). Deck now 21 slides. Talk script merged to match.

Co-Authored-By: Claude Opus 4.8 (1M context) <noreply@anthropic.com>
</commit_message>
<xml_diff>
--- a/slides/Ricci_Curvature_LeadLag.pptx
+++ b/slides/Ricci_Curvature_LeadLag.pptx
@@ -26,8 +26,6 @@
     <p:sldId id="274" r:id="rId25"/>
     <p:sldId id="275" r:id="rId26"/>
     <p:sldId id="276" r:id="rId27"/>
-    <p:sldId id="277" r:id="rId28"/>
-    <p:sldId id="278" r:id="rId29"/>
   </p:sldIdLst>
   <p:sldSz cx="12191695" cy="6858000" type="screen4x3"/>
   <p:notesSz cx="6858000" cy="9144000"/>
@@ -4920,7 +4918,7 @@
                 </a:solidFill>
                 <a:latin typeface="Calibri"/>
               </a:rPr>
-              <a:t>Curvature is not correlation</a:t>
+              <a:t>Distinct from correlation — and from degree</a:t>
             </a:r>
           </a:p>
         </p:txBody>
@@ -4998,7 +4996,7 @@
                 </a:solidFill>
                 <a:latin typeface="Calibri"/>
               </a:rPr>
-              <a:t>Our main object (weighted augmented directed Forman) vs. correlation — both horizons.</a:t>
+              <a:t>Two ways to be a re-skin — of correlation, or of degree. Curvature is neither.</a:t>
             </a:r>
           </a:p>
         </p:txBody>
@@ -5013,7 +5011,7 @@
         </p:nvGraphicFramePr>
         <p:xfrm>
           <a:off x="777240" y="2377440"/>
-          <a:ext cx="10607040" cy="1371600"/>
+          <a:ext cx="10607040" cy="2286000"/>
         </p:xfrm>
         <a:graphic>
           <a:graphicData uri="http://schemas.openxmlformats.org/drawingml/2006/table">
@@ -5022,10 +5020,11 @@
                 <a:tableStyleId>{5C22544A-7EE6-4342-B048-85BDC9FD1C3A}</a:tableStyleId>
               </a:tblPr>
               <a:tblGrid>
-                <a:gridCol w="3383280"/>
-                <a:gridCol w="1737360"/>
-                <a:gridCol w="1828800"/>
-                <a:gridCol w="3657600"/>
+                <a:gridCol w="4206240"/>
+                <a:gridCol w="1645920"/>
+                <a:gridCol w="1554480"/>
+                <a:gridCol w="1554480"/>
+                <a:gridCol w="1645920"/>
               </a:tblGrid>
               <a:tr h="457200">
                 <a:tc>
@@ -5041,7 +5040,7 @@
                           </a:solidFill>
                           <a:latin typeface="Calibri"/>
                         </a:rPr>
-                        <a:t>Test</a:t>
+                        <a:t>Object</a:t>
                       </a:r>
                     </a:p>
                   </a:txBody>
@@ -5064,7 +5063,7 @@
                           </a:solidFill>
                           <a:latin typeface="Calibri"/>
                         </a:rPr>
-                        <a:t>Intraday</a:t>
+                        <a:t>Spearman</a:t>
                       </a:r>
                     </a:p>
                     <a:p>
@@ -5076,7 +5075,7 @@
                           </a:solidFill>
                           <a:latin typeface="Calibri"/>
                         </a:rPr>
-                        <a:t>2019</a:t>
+                        <a:t>vs |ρ|</a:t>
                       </a:r>
                     </a:p>
                   </a:txBody>
@@ -5099,7 +5098,7 @@
                           </a:solidFill>
                           <a:latin typeface="Calibri"/>
                         </a:rPr>
-                        <a:t>Daily</a:t>
+                        <a:t>Jaccard</a:t>
                       </a:r>
                     </a:p>
                     <a:p>
@@ -5111,7 +5110,7 @@
                           </a:solidFill>
                           <a:latin typeface="Calibri"/>
                         </a:rPr>
-                        <a:t>2000–24</a:t>
+                        <a:t>vs corr</a:t>
                       </a:r>
                     </a:p>
                   </a:txBody>
@@ -5126,7 +5125,7 @@
                     <a:bodyPr/>
                     <a:lstStyle/>
                     <a:p>
-                      <a:pPr algn="l"/>
+                      <a:pPr algn="ctr"/>
                       <a:r>
                         <a:rPr sz="1500" b="1" i="0">
                           <a:solidFill>
@@ -5134,7 +5133,42 @@
                           </a:solidFill>
                           <a:latin typeface="Calibri"/>
                         </a:rPr>
-                        <a:t>What it means</a:t>
+                        <a:t>R² on</a:t>
+                      </a:r>
+                    </a:p>
+                    <a:p>
+                      <a:pPr algn="ctr"/>
+                      <a:r>
+                        <a:rPr sz="1500" b="1" i="0">
+                          <a:solidFill>
+                            <a:srgbClr val="FFFFFF"/>
+                          </a:solidFill>
+                          <a:latin typeface="Calibri"/>
+                        </a:rPr>
+                        <a:t>degree</a:t>
+                      </a:r>
+                    </a:p>
+                  </a:txBody>
+                  <a:tcPr anchor="ctr">
+                    <a:solidFill>
+                      <a:srgbClr val="2563EB"/>
+                    </a:solidFill>
+                  </a:tcPr>
+                </a:tc>
+                <a:tc>
+                  <a:txBody>
+                    <a:bodyPr/>
+                    <a:lstStyle/>
+                    <a:p>
+                      <a:pPr algn="ctr"/>
+                      <a:r>
+                        <a:rPr sz="1500" b="1" i="0">
+                          <a:solidFill>
+                            <a:srgbClr val="FFFFFF"/>
+                          </a:solidFill>
+                          <a:latin typeface="Calibri"/>
+                        </a:rPr>
+                        <a:t>compute</a:t>
                       </a:r>
                     </a:p>
                   </a:txBody>
@@ -5153,13 +5187,130 @@
                     <a:p>
                       <a:pPr algn="l"/>
                       <a:r>
-                        <a:rPr sz="1400" b="1" i="0">
-                          <a:solidFill>
-                            <a:srgbClr val="1F2937"/>
-                          </a:solidFill>
-                          <a:latin typeface="Calibri"/>
-                        </a:rPr>
-                        <a:t>Top-K Jaccard vs correlation</a:t>
+                        <a:rPr sz="1400" b="0" i="0">
+                          <a:solidFill>
+                            <a:srgbClr val="374151"/>
+                          </a:solidFill>
+                          <a:latin typeface="Calibri"/>
+                        </a:rPr>
+                        <a:t>Plain directed Forman  (baseline)</a:t>
+                      </a:r>
+                    </a:p>
+                  </a:txBody>
+                  <a:tcPr anchor="ctr">
+                    <a:solidFill>
+                      <a:srgbClr val="FFFFFF"/>
+                    </a:solidFill>
+                  </a:tcPr>
+                </a:tc>
+                <a:tc>
+                  <a:txBody>
+                    <a:bodyPr/>
+                    <a:lstStyle/>
+                    <a:p>
+                      <a:pPr algn="ctr"/>
+                      <a:r>
+                        <a:rPr sz="1400" b="0" i="0">
+                          <a:solidFill>
+                            <a:srgbClr val="374151"/>
+                          </a:solidFill>
+                          <a:latin typeface="Calibri"/>
+                        </a:rPr>
+                        <a:t>0.09</a:t>
+                      </a:r>
+                    </a:p>
+                  </a:txBody>
+                  <a:tcPr anchor="ctr">
+                    <a:solidFill>
+                      <a:srgbClr val="FFFFFF"/>
+                    </a:solidFill>
+                  </a:tcPr>
+                </a:tc>
+                <a:tc>
+                  <a:txBody>
+                    <a:bodyPr/>
+                    <a:lstStyle/>
+                    <a:p>
+                      <a:pPr algn="ctr"/>
+                      <a:r>
+                        <a:rPr sz="1400" b="0" i="0">
+                          <a:solidFill>
+                            <a:srgbClr val="374151"/>
+                          </a:solidFill>
+                          <a:latin typeface="Calibri"/>
+                        </a:rPr>
+                        <a:t>0.0</a:t>
+                      </a:r>
+                    </a:p>
+                  </a:txBody>
+                  <a:tcPr anchor="ctr">
+                    <a:solidFill>
+                      <a:srgbClr val="FFFFFF"/>
+                    </a:solidFill>
+                  </a:tcPr>
+                </a:tc>
+                <a:tc>
+                  <a:txBody>
+                    <a:bodyPr/>
+                    <a:lstStyle/>
+                    <a:p>
+                      <a:pPr algn="ctr"/>
+                      <a:r>
+                        <a:rPr sz="1400" b="0" i="0">
+                          <a:solidFill>
+                            <a:srgbClr val="374151"/>
+                          </a:solidFill>
+                          <a:latin typeface="Calibri"/>
+                        </a:rPr>
+                        <a:t>1.00</a:t>
+                      </a:r>
+                    </a:p>
+                  </a:txBody>
+                  <a:tcPr anchor="ctr">
+                    <a:solidFill>
+                      <a:srgbClr val="FFFFFF"/>
+                    </a:solidFill>
+                  </a:tcPr>
+                </a:tc>
+                <a:tc>
+                  <a:txBody>
+                    <a:bodyPr/>
+                    <a:lstStyle/>
+                    <a:p>
+                      <a:pPr algn="ctr"/>
+                      <a:r>
+                        <a:rPr sz="1400" b="0" i="0">
+                          <a:solidFill>
+                            <a:srgbClr val="374151"/>
+                          </a:solidFill>
+                          <a:latin typeface="Calibri"/>
+                        </a:rPr>
+                        <a:t>0.03 s</a:t>
+                      </a:r>
+                    </a:p>
+                  </a:txBody>
+                  <a:tcPr anchor="ctr">
+                    <a:solidFill>
+                      <a:srgbClr val="FFFFFF"/>
+                    </a:solidFill>
+                  </a:tcPr>
+                </a:tc>
+              </a:tr>
+              <a:tr h="457200">
+                <a:tc>
+                  <a:txBody>
+                    <a:bodyPr/>
+                    <a:lstStyle/>
+                    <a:p>
+                      <a:pPr algn="l"/>
+                      <a:r>
+                        <a:rPr sz="1400" b="0" i="0">
+                          <a:solidFill>
+                            <a:srgbClr val="374151"/>
+                          </a:solidFill>
+                          <a:latin typeface="Calibri"/>
+                        </a:rPr>
+                        <a:t>Weighted Forman</a:t>
                       </a:r>
                     </a:p>
                   </a:txBody>
@@ -5176,13 +5327,13 @@
                     <a:p>
                       <a:pPr algn="ctr"/>
                       <a:r>
-                        <a:rPr sz="1400" b="1" i="0">
-                          <a:solidFill>
-                            <a:srgbClr val="1F2937"/>
-                          </a:solidFill>
-                          <a:latin typeface="Calibri"/>
-                        </a:rPr>
-                        <a:t>≈ 0.0</a:t>
+                        <a:rPr sz="1400" b="0" i="0">
+                          <a:solidFill>
+                            <a:srgbClr val="374151"/>
+                          </a:solidFill>
+                          <a:latin typeface="Calibri"/>
+                        </a:rPr>
+                        <a:t>0.08</a:t>
                       </a:r>
                     </a:p>
                   </a:txBody>
@@ -5199,9 +5350,9 @@
                     <a:p>
                       <a:pPr algn="ctr"/>
                       <a:r>
-                        <a:rPr sz="1400" b="1" i="0">
-                          <a:solidFill>
-                            <a:srgbClr val="1F2937"/>
+                        <a:rPr sz="1400" b="0" i="0">
+                          <a:solidFill>
+                            <a:srgbClr val="374151"/>
                           </a:solidFill>
                           <a:latin typeface="Calibri"/>
                         </a:rPr>
@@ -5220,15 +5371,38 @@
                     <a:bodyPr/>
                     <a:lstStyle/>
                     <a:p>
-                      <a:pPr algn="l"/>
-                      <a:r>
-                        <a:rPr sz="1400" b="1" i="0">
-                          <a:solidFill>
-                            <a:srgbClr val="1F2937"/>
-                          </a:solidFill>
-                          <a:latin typeface="Calibri"/>
-                        </a:rPr>
-                        <a:t>near-disjoint pair sets</a:t>
+                      <a:pPr algn="ctr"/>
+                      <a:r>
+                        <a:rPr sz="1400" b="0" i="0">
+                          <a:solidFill>
+                            <a:srgbClr val="374151"/>
+                          </a:solidFill>
+                          <a:latin typeface="Calibri"/>
+                        </a:rPr>
+                        <a:t>0.97</a:t>
+                      </a:r>
+                    </a:p>
+                  </a:txBody>
+                  <a:tcPr anchor="ctr">
+                    <a:solidFill>
+                      <a:srgbClr val="EFF2FB"/>
+                    </a:solidFill>
+                  </a:tcPr>
+                </a:tc>
+                <a:tc>
+                  <a:txBody>
+                    <a:bodyPr/>
+                    <a:lstStyle/>
+                    <a:p>
+                      <a:pPr algn="ctr"/>
+                      <a:r>
+                        <a:rPr sz="1400" b="0" i="0">
+                          <a:solidFill>
+                            <a:srgbClr val="374151"/>
+                          </a:solidFill>
+                          <a:latin typeface="Calibri"/>
+                        </a:rPr>
+                        <a:t>0.03 s</a:t>
                       </a:r>
                     </a:p>
                   </a:txBody>
@@ -5253,7 +5427,7 @@
                           </a:solidFill>
                           <a:latin typeface="Calibri"/>
                         </a:rPr>
-                        <a:t>Spearman(F, |ρ|)</a:t>
+                        <a:t>Weighted augmented directed  (MAIN)</a:t>
                       </a:r>
                     </a:p>
                   </a:txBody>
@@ -5299,7 +5473,7 @@
                           </a:solidFill>
                           <a:latin typeface="Calibri"/>
                         </a:rPr>
-                        <a:t>0.07</a:t>
+                        <a:t>0.0</a:t>
                       </a:r>
                     </a:p>
                   </a:txBody>
@@ -5314,15 +5488,155 @@
                     <a:bodyPr/>
                     <a:lstStyle/>
                     <a:p>
+                      <a:pPr algn="ctr"/>
+                      <a:r>
+                        <a:rPr sz="1400" b="1" i="0">
+                          <a:solidFill>
+                            <a:srgbClr val="1F2937"/>
+                          </a:solidFill>
+                          <a:latin typeface="Calibri"/>
+                        </a:rPr>
+                        <a:t>0.56</a:t>
+                      </a:r>
+                    </a:p>
+                  </a:txBody>
+                  <a:tcPr anchor="ctr">
+                    <a:solidFill>
+                      <a:srgbClr val="EFF2FB"/>
+                    </a:solidFill>
+                  </a:tcPr>
+                </a:tc>
+                <a:tc>
+                  <a:txBody>
+                    <a:bodyPr/>
+                    <a:lstStyle/>
+                    <a:p>
+                      <a:pPr algn="ctr"/>
+                      <a:r>
+                        <a:rPr sz="1400" b="1" i="0">
+                          <a:solidFill>
+                            <a:srgbClr val="1F2937"/>
+                          </a:solidFill>
+                          <a:latin typeface="Calibri"/>
+                        </a:rPr>
+                        <a:t>0.03 s</a:t>
+                      </a:r>
+                    </a:p>
+                  </a:txBody>
+                  <a:tcPr anchor="ctr">
+                    <a:solidFill>
+                      <a:srgbClr val="EFF2FB"/>
+                    </a:solidFill>
+                  </a:tcPr>
+                </a:tc>
+              </a:tr>
+              <a:tr h="457200">
+                <a:tc>
+                  <a:txBody>
+                    <a:bodyPr/>
+                    <a:lstStyle/>
+                    <a:p>
                       <a:pPr algn="l"/>
                       <a:r>
-                        <a:rPr sz="1400" b="1" i="0">
-                          <a:solidFill>
-                            <a:srgbClr val="1F2937"/>
-                          </a:solidFill>
-                          <a:latin typeface="Calibri"/>
-                        </a:rPr>
-                        <a:t>barely tracks |ρ|  (≪ 0.8)</a:t>
+                        <a:rPr sz="1400" b="0" i="0">
+                          <a:solidFill>
+                            <a:srgbClr val="374151"/>
+                          </a:solidFill>
+                          <a:latin typeface="Calibri"/>
+                        </a:rPr>
+                        <a:t>Ollivier-Ricci</a:t>
+                      </a:r>
+                    </a:p>
+                  </a:txBody>
+                  <a:tcPr anchor="ctr">
+                    <a:solidFill>
+                      <a:srgbClr val="EFF2FB"/>
+                    </a:solidFill>
+                  </a:tcPr>
+                </a:tc>
+                <a:tc>
+                  <a:txBody>
+                    <a:bodyPr/>
+                    <a:lstStyle/>
+                    <a:p>
+                      <a:pPr algn="ctr"/>
+                      <a:r>
+                        <a:rPr sz="1400" b="0" i="0">
+                          <a:solidFill>
+                            <a:srgbClr val="374151"/>
+                          </a:solidFill>
+                          <a:latin typeface="Calibri"/>
+                        </a:rPr>
+                        <a:t>0.24</a:t>
+                      </a:r>
+                    </a:p>
+                  </a:txBody>
+                  <a:tcPr anchor="ctr">
+                    <a:solidFill>
+                      <a:srgbClr val="EFF2FB"/>
+                    </a:solidFill>
+                  </a:tcPr>
+                </a:tc>
+                <a:tc>
+                  <a:txBody>
+                    <a:bodyPr/>
+                    <a:lstStyle/>
+                    <a:p>
+                      <a:pPr algn="ctr"/>
+                      <a:r>
+                        <a:rPr sz="1400" b="0" i="0">
+                          <a:solidFill>
+                            <a:srgbClr val="374151"/>
+                          </a:solidFill>
+                          <a:latin typeface="Calibri"/>
+                        </a:rPr>
+                        <a:t>0.0</a:t>
+                      </a:r>
+                    </a:p>
+                  </a:txBody>
+                  <a:tcPr anchor="ctr">
+                    <a:solidFill>
+                      <a:srgbClr val="EFF2FB"/>
+                    </a:solidFill>
+                  </a:tcPr>
+                </a:tc>
+                <a:tc>
+                  <a:txBody>
+                    <a:bodyPr/>
+                    <a:lstStyle/>
+                    <a:p>
+                      <a:pPr algn="ctr"/>
+                      <a:r>
+                        <a:rPr sz="1400" b="0" i="0">
+                          <a:solidFill>
+                            <a:srgbClr val="374151"/>
+                          </a:solidFill>
+                          <a:latin typeface="Calibri"/>
+                        </a:rPr>
+                        <a:t>0.14</a:t>
+                      </a:r>
+                    </a:p>
+                  </a:txBody>
+                  <a:tcPr anchor="ctr">
+                    <a:solidFill>
+                      <a:srgbClr val="EFF2FB"/>
+                    </a:solidFill>
+                  </a:tcPr>
+                </a:tc>
+                <a:tc>
+                  <a:txBody>
+                    <a:bodyPr/>
+                    <a:lstStyle/>
+                    <a:p>
+                      <a:pPr algn="ctr"/>
+                      <a:r>
+                        <a:rPr sz="1400" b="0" i="0">
+                          <a:solidFill>
+                            <a:srgbClr val="374151"/>
+                          </a:solidFill>
+                          <a:latin typeface="Calibri"/>
+                        </a:rPr>
+                        <a:t>15.9 s</a:t>
                       </a:r>
                     </a:p>
                   </a:txBody>
@@ -5366,7 +5680,7 @@
                 </a:solidFill>
                 <a:latin typeface="Calibri"/>
               </a:rPr>
-              <a:t>F = the main object. Significance: curvature is not a re-skin of correlation — it holds on the 2019 intraday graph AND the full 2000–2024 daily span. This distinctness IS the headline result. (The next slide compares all four objects to each other.)</a:t>
+              <a:t>NOT correlation: Spearman ≪ 0.8 and Jaccard ≈ 0 (disjoint picks). NOT degree: the augmentation drops R²-on-degree from 1.00 (plain = pure degree) to 0.56 (44% is new). Holds at both horizons (main object daily: Spearman 0.07, Jaccard 0, across 2000–2024).</a:t>
             </a:r>
           </a:p>
         </p:txBody>
@@ -5487,7 +5801,7 @@
                 </a:solidFill>
                 <a:latin typeface="Calibri"/>
               </a:rPr>
-              <a:t>The four objects, compared</a:t>
+              <a:t>The structure is cross-sector</a:t>
             </a:r>
           </a:p>
         </p:txBody>
@@ -5545,7 +5859,7 @@
         <p:spPr>
           <a:xfrm>
             <a:off x="777240" y="1783080"/>
-            <a:ext cx="10607040" cy="640080"/>
+            <a:ext cx="10607040" cy="731520"/>
           </a:xfrm>
           <a:prstGeom prst="rect">
             <a:avLst/>
@@ -5559,641 +5873,27 @@
           <a:lstStyle/>
           <a:p>
             <a:r>
-              <a:rPr sz="1800" b="0" i="1">
+              <a:rPr sz="1900" b="0" i="1">
                 <a:solidFill>
                   <a:srgbClr val="2563EB"/>
                 </a:solidFill>
                 <a:latin typeface="Calibri"/>
               </a:rPr>
-              <a:t>All four pick pairs disjoint from correlation (Jaccard ≈ 0).</a:t>
-            </a:r>
-          </a:p>
-        </p:txBody>
-      </p:sp>
-      <p:graphicFrame>
-        <p:nvGraphicFramePr>
-          <p:cNvPr id="5" name="Table 4"/>
-          <p:cNvGraphicFramePr>
-            <a:graphicFrameLocks noGrp="1"/>
-          </p:cNvGraphicFramePr>
-          <p:nvPr/>
-        </p:nvGraphicFramePr>
-        <p:xfrm>
-          <a:off x="777240" y="2377440"/>
-          <a:ext cx="10607040" cy="2286000"/>
-        </p:xfrm>
-        <a:graphic>
-          <a:graphicData uri="http://schemas.openxmlformats.org/drawingml/2006/table">
-            <a:tbl>
-              <a:tblPr firstRow="1" bandRow="1">
-                <a:tableStyleId>{5C22544A-7EE6-4342-B048-85BDC9FD1C3A}</a:tableStyleId>
-              </a:tblPr>
-              <a:tblGrid>
-                <a:gridCol w="4023360"/>
-                <a:gridCol w="1554480"/>
-                <a:gridCol w="1920240"/>
-                <a:gridCol w="1554480"/>
-                <a:gridCol w="1554480"/>
-              </a:tblGrid>
-              <a:tr h="457200">
-                <a:tc>
-                  <a:txBody>
-                    <a:bodyPr/>
-                    <a:lstStyle/>
-                    <a:p>
-                      <a:pPr algn="l"/>
-                      <a:r>
-                        <a:rPr sz="1500" b="1" i="0">
-                          <a:solidFill>
-                            <a:srgbClr val="FFFFFF"/>
-                          </a:solidFill>
-                          <a:latin typeface="Calibri"/>
-                        </a:rPr>
-                        <a:t>Object</a:t>
-                      </a:r>
-                    </a:p>
-                  </a:txBody>
-                  <a:tcPr anchor="ctr">
-                    <a:solidFill>
-                      <a:srgbClr val="2563EB"/>
-                    </a:solidFill>
-                  </a:tcPr>
-                </a:tc>
-                <a:tc>
-                  <a:txBody>
-                    <a:bodyPr/>
-                    <a:lstStyle/>
-                    <a:p>
-                      <a:pPr algn="ctr"/>
-                      <a:r>
-                        <a:rPr sz="1500" b="1" i="0">
-                          <a:solidFill>
-                            <a:srgbClr val="FFFFFF"/>
-                          </a:solidFill>
-                          <a:latin typeface="Calibri"/>
-                        </a:rPr>
-                        <a:t>Spearman</a:t>
-                      </a:r>
-                    </a:p>
-                  </a:txBody>
-                  <a:tcPr anchor="ctr">
-                    <a:solidFill>
-                      <a:srgbClr val="2563EB"/>
-                    </a:solidFill>
-                  </a:tcPr>
-                </a:tc>
-                <a:tc>
-                  <a:txBody>
-                    <a:bodyPr/>
-                    <a:lstStyle/>
-                    <a:p>
-                      <a:pPr algn="ctr"/>
-                      <a:r>
-                        <a:rPr sz="1500" b="1" i="0">
-                          <a:solidFill>
-                            <a:srgbClr val="FFFFFF"/>
-                          </a:solidFill>
-                          <a:latin typeface="Calibri"/>
-                        </a:rPr>
-                        <a:t>R² on degree</a:t>
-                      </a:r>
-                    </a:p>
-                  </a:txBody>
-                  <a:tcPr anchor="ctr">
-                    <a:solidFill>
-                      <a:srgbClr val="2563EB"/>
-                    </a:solidFill>
-                  </a:tcPr>
-                </a:tc>
-                <a:tc>
-                  <a:txBody>
-                    <a:bodyPr/>
-                    <a:lstStyle/>
-                    <a:p>
-                      <a:pPr algn="ctr"/>
-                      <a:r>
-                        <a:rPr sz="1500" b="1" i="0">
-                          <a:solidFill>
-                            <a:srgbClr val="FFFFFF"/>
-                          </a:solidFill>
-                          <a:latin typeface="Calibri"/>
-                        </a:rPr>
-                        <a:t>mean IC</a:t>
-                      </a:r>
-                    </a:p>
-                  </a:txBody>
-                  <a:tcPr anchor="ctr">
-                    <a:solidFill>
-                      <a:srgbClr val="2563EB"/>
-                    </a:solidFill>
-                  </a:tcPr>
-                </a:tc>
-                <a:tc>
-                  <a:txBody>
-                    <a:bodyPr/>
-                    <a:lstStyle/>
-                    <a:p>
-                      <a:pPr algn="ctr"/>
-                      <a:r>
-                        <a:rPr sz="1500" b="1" i="0">
-                          <a:solidFill>
-                            <a:srgbClr val="FFFFFF"/>
-                          </a:solidFill>
-                          <a:latin typeface="Calibri"/>
-                        </a:rPr>
-                        <a:t>compute</a:t>
-                      </a:r>
-                    </a:p>
-                  </a:txBody>
-                  <a:tcPr anchor="ctr">
-                    <a:solidFill>
-                      <a:srgbClr val="2563EB"/>
-                    </a:solidFill>
-                  </a:tcPr>
-                </a:tc>
-              </a:tr>
-              <a:tr h="457200">
-                <a:tc>
-                  <a:txBody>
-                    <a:bodyPr/>
-                    <a:lstStyle/>
-                    <a:p>
-                      <a:pPr algn="l"/>
-                      <a:r>
-                        <a:rPr sz="1400" b="0" i="0">
-                          <a:solidFill>
-                            <a:srgbClr val="374151"/>
-                          </a:solidFill>
-                          <a:latin typeface="Calibri"/>
-                        </a:rPr>
-                        <a:t>Plain directed Forman  (baseline)</a:t>
-                      </a:r>
-                    </a:p>
-                  </a:txBody>
-                  <a:tcPr anchor="ctr">
-                    <a:solidFill>
-                      <a:srgbClr val="FFFFFF"/>
-                    </a:solidFill>
-                  </a:tcPr>
-                </a:tc>
-                <a:tc>
-                  <a:txBody>
-                    <a:bodyPr/>
-                    <a:lstStyle/>
-                    <a:p>
-                      <a:pPr algn="ctr"/>
-                      <a:r>
-                        <a:rPr sz="1400" b="0" i="0">
-                          <a:solidFill>
-                            <a:srgbClr val="374151"/>
-                          </a:solidFill>
-                          <a:latin typeface="Calibri"/>
-                        </a:rPr>
-                        <a:t>0.09</a:t>
-                      </a:r>
-                    </a:p>
-                  </a:txBody>
-                  <a:tcPr anchor="ctr">
-                    <a:solidFill>
-                      <a:srgbClr val="FFFFFF"/>
-                    </a:solidFill>
-                  </a:tcPr>
-                </a:tc>
-                <a:tc>
-                  <a:txBody>
-                    <a:bodyPr/>
-                    <a:lstStyle/>
-                    <a:p>
-                      <a:pPr algn="ctr"/>
-                      <a:r>
-                        <a:rPr sz="1400" b="0" i="0">
-                          <a:solidFill>
-                            <a:srgbClr val="374151"/>
-                          </a:solidFill>
-                          <a:latin typeface="Calibri"/>
-                        </a:rPr>
-                        <a:t>1.00</a:t>
-                      </a:r>
-                    </a:p>
-                  </a:txBody>
-                  <a:tcPr anchor="ctr">
-                    <a:solidFill>
-                      <a:srgbClr val="FFFFFF"/>
-                    </a:solidFill>
-                  </a:tcPr>
-                </a:tc>
-                <a:tc>
-                  <a:txBody>
-                    <a:bodyPr/>
-                    <a:lstStyle/>
-                    <a:p>
-                      <a:pPr algn="ctr"/>
-                      <a:r>
-                        <a:rPr sz="1400" b="0" i="0">
-                          <a:solidFill>
-                            <a:srgbClr val="374151"/>
-                          </a:solidFill>
-                          <a:latin typeface="Calibri"/>
-                        </a:rPr>
-                        <a:t>+0.014</a:t>
-                      </a:r>
-                    </a:p>
-                  </a:txBody>
-                  <a:tcPr anchor="ctr">
-                    <a:solidFill>
-                      <a:srgbClr val="FFFFFF"/>
-                    </a:solidFill>
-                  </a:tcPr>
-                </a:tc>
-                <a:tc>
-                  <a:txBody>
-                    <a:bodyPr/>
-                    <a:lstStyle/>
-                    <a:p>
-                      <a:pPr algn="ctr"/>
-                      <a:r>
-                        <a:rPr sz="1400" b="0" i="0">
-                          <a:solidFill>
-                            <a:srgbClr val="374151"/>
-                          </a:solidFill>
-                          <a:latin typeface="Calibri"/>
-                        </a:rPr>
-                        <a:t>0.03 s</a:t>
-                      </a:r>
-                    </a:p>
-                  </a:txBody>
-                  <a:tcPr anchor="ctr">
-                    <a:solidFill>
-                      <a:srgbClr val="FFFFFF"/>
-                    </a:solidFill>
-                  </a:tcPr>
-                </a:tc>
-              </a:tr>
-              <a:tr h="457200">
-                <a:tc>
-                  <a:txBody>
-                    <a:bodyPr/>
-                    <a:lstStyle/>
-                    <a:p>
-                      <a:pPr algn="l"/>
-                      <a:r>
-                        <a:rPr sz="1400" b="0" i="0">
-                          <a:solidFill>
-                            <a:srgbClr val="374151"/>
-                          </a:solidFill>
-                          <a:latin typeface="Calibri"/>
-                        </a:rPr>
-                        <a:t>Weighted Forman</a:t>
-                      </a:r>
-                    </a:p>
-                  </a:txBody>
-                  <a:tcPr anchor="ctr">
-                    <a:solidFill>
-                      <a:srgbClr val="EFF2FB"/>
-                    </a:solidFill>
-                  </a:tcPr>
-                </a:tc>
-                <a:tc>
-                  <a:txBody>
-                    <a:bodyPr/>
-                    <a:lstStyle/>
-                    <a:p>
-                      <a:pPr algn="ctr"/>
-                      <a:r>
-                        <a:rPr sz="1400" b="0" i="0">
-                          <a:solidFill>
-                            <a:srgbClr val="374151"/>
-                          </a:solidFill>
-                          <a:latin typeface="Calibri"/>
-                        </a:rPr>
-                        <a:t>0.08</a:t>
-                      </a:r>
-                    </a:p>
-                  </a:txBody>
-                  <a:tcPr anchor="ctr">
-                    <a:solidFill>
-                      <a:srgbClr val="EFF2FB"/>
-                    </a:solidFill>
-                  </a:tcPr>
-                </a:tc>
-                <a:tc>
-                  <a:txBody>
-                    <a:bodyPr/>
-                    <a:lstStyle/>
-                    <a:p>
-                      <a:pPr algn="ctr"/>
-                      <a:r>
-                        <a:rPr sz="1400" b="0" i="0">
-                          <a:solidFill>
-                            <a:srgbClr val="374151"/>
-                          </a:solidFill>
-                          <a:latin typeface="Calibri"/>
-                        </a:rPr>
-                        <a:t>0.97</a:t>
-                      </a:r>
-                    </a:p>
-                  </a:txBody>
-                  <a:tcPr anchor="ctr">
-                    <a:solidFill>
-                      <a:srgbClr val="EFF2FB"/>
-                    </a:solidFill>
-                  </a:tcPr>
-                </a:tc>
-                <a:tc>
-                  <a:txBody>
-                    <a:bodyPr/>
-                    <a:lstStyle/>
-                    <a:p>
-                      <a:pPr algn="ctr"/>
-                      <a:r>
-                        <a:rPr sz="1400" b="0" i="0">
-                          <a:solidFill>
-                            <a:srgbClr val="374151"/>
-                          </a:solidFill>
-                          <a:latin typeface="Calibri"/>
-                        </a:rPr>
-                        <a:t>+0.007</a:t>
-                      </a:r>
-                    </a:p>
-                  </a:txBody>
-                  <a:tcPr anchor="ctr">
-                    <a:solidFill>
-                      <a:srgbClr val="EFF2FB"/>
-                    </a:solidFill>
-                  </a:tcPr>
-                </a:tc>
-                <a:tc>
-                  <a:txBody>
-                    <a:bodyPr/>
-                    <a:lstStyle/>
-                    <a:p>
-                      <a:pPr algn="ctr"/>
-                      <a:r>
-                        <a:rPr sz="1400" b="0" i="0">
-                          <a:solidFill>
-                            <a:srgbClr val="374151"/>
-                          </a:solidFill>
-                          <a:latin typeface="Calibri"/>
-                        </a:rPr>
-                        <a:t>0.03 s</a:t>
-                      </a:r>
-                    </a:p>
-                  </a:txBody>
-                  <a:tcPr anchor="ctr">
-                    <a:solidFill>
-                      <a:srgbClr val="EFF2FB"/>
-                    </a:solidFill>
-                  </a:tcPr>
-                </a:tc>
-              </a:tr>
-              <a:tr h="457200">
-                <a:tc>
-                  <a:txBody>
-                    <a:bodyPr/>
-                    <a:lstStyle/>
-                    <a:p>
-                      <a:pPr algn="l"/>
-                      <a:r>
-                        <a:rPr sz="1400" b="1" i="0">
-                          <a:solidFill>
-                            <a:srgbClr val="1F2937"/>
-                          </a:solidFill>
-                          <a:latin typeface="Calibri"/>
-                        </a:rPr>
-                        <a:t>Weighted augmented directed  (MAIN)</a:t>
-                      </a:r>
-                    </a:p>
-                  </a:txBody>
-                  <a:tcPr anchor="ctr">
-                    <a:solidFill>
-                      <a:srgbClr val="EFF2FB"/>
-                    </a:solidFill>
-                  </a:tcPr>
-                </a:tc>
-                <a:tc>
-                  <a:txBody>
-                    <a:bodyPr/>
-                    <a:lstStyle/>
-                    <a:p>
-                      <a:pPr algn="ctr"/>
-                      <a:r>
-                        <a:rPr sz="1400" b="1" i="0">
-                          <a:solidFill>
-                            <a:srgbClr val="1F2937"/>
-                          </a:solidFill>
-                          <a:latin typeface="Calibri"/>
-                        </a:rPr>
-                        <a:t>0.18</a:t>
-                      </a:r>
-                    </a:p>
-                  </a:txBody>
-                  <a:tcPr anchor="ctr">
-                    <a:solidFill>
-                      <a:srgbClr val="EFF2FB"/>
-                    </a:solidFill>
-                  </a:tcPr>
-                </a:tc>
-                <a:tc>
-                  <a:txBody>
-                    <a:bodyPr/>
-                    <a:lstStyle/>
-                    <a:p>
-                      <a:pPr algn="ctr"/>
-                      <a:r>
-                        <a:rPr sz="1400" b="1" i="0">
-                          <a:solidFill>
-                            <a:srgbClr val="1F2937"/>
-                          </a:solidFill>
-                          <a:latin typeface="Calibri"/>
-                        </a:rPr>
-                        <a:t>0.56</a:t>
-                      </a:r>
-                    </a:p>
-                  </a:txBody>
-                  <a:tcPr anchor="ctr">
-                    <a:solidFill>
-                      <a:srgbClr val="EFF2FB"/>
-                    </a:solidFill>
-                  </a:tcPr>
-                </a:tc>
-                <a:tc>
-                  <a:txBody>
-                    <a:bodyPr/>
-                    <a:lstStyle/>
-                    <a:p>
-                      <a:pPr algn="ctr"/>
-                      <a:r>
-                        <a:rPr sz="1400" b="1" i="0">
-                          <a:solidFill>
-                            <a:srgbClr val="1F2937"/>
-                          </a:solidFill>
-                          <a:latin typeface="Calibri"/>
-                        </a:rPr>
-                        <a:t>+0.005</a:t>
-                      </a:r>
-                    </a:p>
-                  </a:txBody>
-                  <a:tcPr anchor="ctr">
-                    <a:solidFill>
-                      <a:srgbClr val="EFF2FB"/>
-                    </a:solidFill>
-                  </a:tcPr>
-                </a:tc>
-                <a:tc>
-                  <a:txBody>
-                    <a:bodyPr/>
-                    <a:lstStyle/>
-                    <a:p>
-                      <a:pPr algn="ctr"/>
-                      <a:r>
-                        <a:rPr sz="1400" b="1" i="0">
-                          <a:solidFill>
-                            <a:srgbClr val="1F2937"/>
-                          </a:solidFill>
-                          <a:latin typeface="Calibri"/>
-                        </a:rPr>
-                        <a:t>0.03 s</a:t>
-                      </a:r>
-                    </a:p>
-                  </a:txBody>
-                  <a:tcPr anchor="ctr">
-                    <a:solidFill>
-                      <a:srgbClr val="EFF2FB"/>
-                    </a:solidFill>
-                  </a:tcPr>
-                </a:tc>
-              </a:tr>
-              <a:tr h="457200">
-                <a:tc>
-                  <a:txBody>
-                    <a:bodyPr/>
-                    <a:lstStyle/>
-                    <a:p>
-                      <a:pPr algn="l"/>
-                      <a:r>
-                        <a:rPr sz="1400" b="0" i="0">
-                          <a:solidFill>
-                            <a:srgbClr val="374151"/>
-                          </a:solidFill>
-                          <a:latin typeface="Calibri"/>
-                        </a:rPr>
-                        <a:t>Ollivier-Ricci</a:t>
-                      </a:r>
-                    </a:p>
-                  </a:txBody>
-                  <a:tcPr anchor="ctr">
-                    <a:solidFill>
-                      <a:srgbClr val="EFF2FB"/>
-                    </a:solidFill>
-                  </a:tcPr>
-                </a:tc>
-                <a:tc>
-                  <a:txBody>
-                    <a:bodyPr/>
-                    <a:lstStyle/>
-                    <a:p>
-                      <a:pPr algn="ctr"/>
-                      <a:r>
-                        <a:rPr sz="1400" b="0" i="0">
-                          <a:solidFill>
-                            <a:srgbClr val="374151"/>
-                          </a:solidFill>
-                          <a:latin typeface="Calibri"/>
-                        </a:rPr>
-                        <a:t>0.24</a:t>
-                      </a:r>
-                    </a:p>
-                  </a:txBody>
-                  <a:tcPr anchor="ctr">
-                    <a:solidFill>
-                      <a:srgbClr val="EFF2FB"/>
-                    </a:solidFill>
-                  </a:tcPr>
-                </a:tc>
-                <a:tc>
-                  <a:txBody>
-                    <a:bodyPr/>
-                    <a:lstStyle/>
-                    <a:p>
-                      <a:pPr algn="ctr"/>
-                      <a:r>
-                        <a:rPr sz="1400" b="0" i="0">
-                          <a:solidFill>
-                            <a:srgbClr val="374151"/>
-                          </a:solidFill>
-                          <a:latin typeface="Calibri"/>
-                        </a:rPr>
-                        <a:t>0.14</a:t>
-                      </a:r>
-                    </a:p>
-                  </a:txBody>
-                  <a:tcPr anchor="ctr">
-                    <a:solidFill>
-                      <a:srgbClr val="EFF2FB"/>
-                    </a:solidFill>
-                  </a:tcPr>
-                </a:tc>
-                <a:tc>
-                  <a:txBody>
-                    <a:bodyPr/>
-                    <a:lstStyle/>
-                    <a:p>
-                      <a:pPr algn="ctr"/>
-                      <a:r>
-                        <a:rPr sz="1400" b="0" i="0">
-                          <a:solidFill>
-                            <a:srgbClr val="374151"/>
-                          </a:solidFill>
-                          <a:latin typeface="Calibri"/>
-                        </a:rPr>
-                        <a:t>−0.006</a:t>
-                      </a:r>
-                    </a:p>
-                  </a:txBody>
-                  <a:tcPr anchor="ctr">
-                    <a:solidFill>
-                      <a:srgbClr val="EFF2FB"/>
-                    </a:solidFill>
-                  </a:tcPr>
-                </a:tc>
-                <a:tc>
-                  <a:txBody>
-                    <a:bodyPr/>
-                    <a:lstStyle/>
-                    <a:p>
-                      <a:pPr algn="ctr"/>
-                      <a:r>
-                        <a:rPr sz="1400" b="0" i="0">
-                          <a:solidFill>
-                            <a:srgbClr val="374151"/>
-                          </a:solidFill>
-                          <a:latin typeface="Calibri"/>
-                        </a:rPr>
-                        <a:t>15.9 s</a:t>
-                      </a:r>
-                    </a:p>
-                  </a:txBody>
-                  <a:tcPr anchor="ctr">
-                    <a:solidFill>
-                      <a:srgbClr val="EFF2FB"/>
-                    </a:solidFill>
-                  </a:tcPr>
-                </a:tc>
-              </a:tr>
-            </a:tbl>
-          </a:graphicData>
-        </a:graphic>
-      </p:graphicFrame>
-      <p:sp>
-        <p:nvSpPr>
-          <p:cNvPr id="6" name="TextBox 5"/>
+              <a:t>Where do the pairs curvature picks actually live?</a:t>
+            </a:r>
+          </a:p>
+        </p:txBody>
+      </p:sp>
+      <p:sp>
+        <p:nvSpPr>
+          <p:cNvPr id="5" name="TextBox 4"/>
           <p:cNvSpPr txBox="1"/>
           <p:nvPr/>
         </p:nvSpPr>
         <p:spPr>
           <a:xfrm>
-            <a:off x="777240" y="5715000"/>
-            <a:ext cx="10607040" cy="640080"/>
+            <a:off x="777240" y="2514600"/>
+            <a:ext cx="10607040" cy="3657600"/>
           </a:xfrm>
           <a:prstGeom prst="rect">
             <a:avLst/>
@@ -6206,21 +5906,74 @@
           </a:bodyPr>
           <a:lstStyle/>
           <a:p>
-            <a:r>
-              <a:rPr sz="1400" b="0" i="1">
-                <a:solidFill>
-                  <a:srgbClr val="9CA3AF"/>
-                </a:solidFill>
-                <a:latin typeface="Calibri"/>
-              </a:rPr>
-              <a:t>Best tradeoff = weighted-augmented Forman: real higher-order signal (44% non-degree) at ~0 cost. Ollivier carries the most non-degree signal but at ~600× the compute and no IC gain. None predicts (IC ≈ 0).</a:t>
-            </a:r>
-          </a:p>
-        </p:txBody>
-      </p:sp>
-      <p:sp>
-        <p:nvSpPr>
-          <p:cNvPr id="7" name="TextBox 6"/>
+            <a:pPr>
+              <a:spcAft>
+                <a:spcPts val="1200"/>
+              </a:spcAft>
+            </a:pPr>
+            <a:r>
+              <a:rPr sz="2100" b="0" i="0">
+                <a:solidFill>
+                  <a:srgbClr val="374151"/>
+                </a:solidFill>
+                <a:latin typeface="Calibri"/>
+              </a:rPr>
+              <a:t>•  A 'triangle' = three stocks each linked to the other two — a tight local cluster, and what the curvature augmentation counts.</a:t>
+            </a:r>
+          </a:p>
+          <a:p>
+            <a:pPr>
+              <a:spcAft>
+                <a:spcPts val="1200"/>
+              </a:spcAft>
+            </a:pPr>
+            <a:r>
+              <a:rPr sz="2100" b="0" i="0">
+                <a:solidFill>
+                  <a:srgbClr val="374151"/>
+                </a:solidFill>
+                <a:latin typeface="Calibri"/>
+              </a:rPr>
+              <a:t>•  Almost all of these triangles span sectors — only ~1% sit within a single GICS sector.</a:t>
+            </a:r>
+          </a:p>
+          <a:p>
+            <a:pPr>
+              <a:spcAft>
+                <a:spcPts val="1200"/>
+              </a:spcAft>
+            </a:pPr>
+            <a:r>
+              <a:rPr sz="2100" b="0" i="0">
+                <a:solidFill>
+                  <a:srgbClr val="374151"/>
+                </a:solidFill>
+                <a:latin typeface="Calibri"/>
+              </a:rPr>
+              <a:t>•  So curvature highlights cross-sector links that a sector- or correlation-based grouping would never put together.</a:t>
+            </a:r>
+          </a:p>
+          <a:p>
+            <a:pPr>
+              <a:spcAft>
+                <a:spcPts val="1200"/>
+              </a:spcAft>
+            </a:pPr>
+            <a:r>
+              <a:rPr sz="2100" b="0" i="0">
+                <a:solidFill>
+                  <a:srgbClr val="374151"/>
+                </a:solidFill>
+                <a:latin typeface="Calibri"/>
+              </a:rPr>
+              <a:t>•  Honest caveat: so few within-group triangles → the community step can't cleanly carve out clusters.</a:t>
+            </a:r>
+          </a:p>
+        </p:txBody>
+      </p:sp>
+      <p:sp>
+        <p:nvSpPr>
+          <p:cNvPr id="6" name="TextBox 5"/>
           <p:cNvSpPr txBox="1"/>
           <p:nvPr/>
         </p:nvSpPr>
@@ -6254,7 +6007,7 @@
       </p:sp>
       <p:sp>
         <p:nvSpPr>
-          <p:cNvPr id="8" name="TextBox 7"/>
+          <p:cNvPr id="7" name="TextBox 6"/>
           <p:cNvSpPr txBox="1"/>
           <p:nvPr/>
         </p:nvSpPr>
@@ -6296,859 +6049,6 @@
 </file>
 
 <file path=ppt/slides/slide16.xml><?xml version="1.0" encoding="utf-8"?>
-<p:sld xmlns:a="http://schemas.openxmlformats.org/drawingml/2006/main" xmlns:p="http://schemas.openxmlformats.org/presentationml/2006/main" xmlns:r="http://schemas.openxmlformats.org/officeDocument/2006/relationships">
-  <p:cSld>
-    <p:spTree>
-      <p:nvGrpSpPr>
-        <p:cNvPr id="1" name=""/>
-        <p:cNvGrpSpPr/>
-        <p:nvPr/>
-      </p:nvGrpSpPr>
-      <p:grpSpPr/>
-      <p:sp>
-        <p:nvSpPr>
-          <p:cNvPr id="2" name="TextBox 1"/>
-          <p:cNvSpPr txBox="1"/>
-          <p:nvPr/>
-        </p:nvSpPr>
-        <p:spPr>
-          <a:xfrm>
-            <a:off x="777240" y="640080"/>
-            <a:ext cx="10607040" cy="822960"/>
-          </a:xfrm>
-          <a:prstGeom prst="rect">
-            <a:avLst/>
-          </a:prstGeom>
-          <a:noFill/>
-        </p:spPr>
-        <p:txBody>
-          <a:bodyPr wrap="square">
-            <a:spAutoFit/>
-          </a:bodyPr>
-          <a:lstStyle/>
-          <a:p>
-            <a:r>
-              <a:rPr sz="3000" b="1" i="0">
-                <a:solidFill>
-                  <a:srgbClr val="1F2937"/>
-                </a:solidFill>
-                <a:latin typeface="Calibri"/>
-              </a:rPr>
-              <a:t>A clean degree ablation</a:t>
-            </a:r>
-          </a:p>
-        </p:txBody>
-      </p:sp>
-      <p:sp>
-        <p:nvSpPr>
-          <p:cNvPr id="3" name="Rectangle 2"/>
-          <p:cNvSpPr/>
-          <p:nvPr/>
-        </p:nvSpPr>
-        <p:spPr>
-          <a:xfrm>
-            <a:off x="777240" y="1417320"/>
-            <a:ext cx="1828800" cy="38100"/>
-          </a:xfrm>
-          <a:prstGeom prst="rect">
-            <a:avLst/>
-          </a:prstGeom>
-          <a:solidFill>
-            <a:srgbClr val="2563EB"/>
-          </a:solidFill>
-          <a:ln>
-            <a:noFill/>
-          </a:ln>
-          <a:effectLst/>
-        </p:spPr>
-        <p:style>
-          <a:lnRef idx="1">
-            <a:schemeClr val="accent1"/>
-          </a:lnRef>
-          <a:fillRef idx="3">
-            <a:schemeClr val="accent1"/>
-          </a:fillRef>
-          <a:effectRef idx="2">
-            <a:schemeClr val="accent1"/>
-          </a:effectRef>
-          <a:fontRef idx="minor">
-            <a:schemeClr val="lt1"/>
-          </a:fontRef>
-        </p:style>
-        <p:txBody>
-          <a:bodyPr rtlCol="0" anchor="ctr"/>
-          <a:lstStyle/>
-          <a:p>
-            <a:pPr algn="ctr"/>
-          </a:p>
-        </p:txBody>
-      </p:sp>
-      <p:sp>
-        <p:nvSpPr>
-          <p:cNvPr id="4" name="TextBox 3"/>
-          <p:cNvSpPr txBox="1"/>
-          <p:nvPr/>
-        </p:nvSpPr>
-        <p:spPr>
-          <a:xfrm>
-            <a:off x="777240" y="1783080"/>
-            <a:ext cx="10607040" cy="640080"/>
-          </a:xfrm>
-          <a:prstGeom prst="rect">
-            <a:avLst/>
-          </a:prstGeom>
-          <a:noFill/>
-        </p:spPr>
-        <p:txBody>
-          <a:bodyPr wrap="square">
-            <a:spAutoFit/>
-          </a:bodyPr>
-          <a:lstStyle/>
-          <a:p>
-            <a:r>
-              <a:rPr sz="1800" b="0" i="1">
-                <a:solidFill>
-                  <a:srgbClr val="2563EB"/>
-                </a:solidFill>
-                <a:latin typeface="Calibri"/>
-              </a:rPr>
-              <a:t>Does curvature carry anything beyond connectivity? — checked at both horizons.</a:t>
-            </a:r>
-          </a:p>
-        </p:txBody>
-      </p:sp>
-      <p:graphicFrame>
-        <p:nvGraphicFramePr>
-          <p:cNvPr id="5" name="Table 4"/>
-          <p:cNvGraphicFramePr>
-            <a:graphicFrameLocks noGrp="1"/>
-          </p:cNvGraphicFramePr>
-          <p:nvPr/>
-        </p:nvGraphicFramePr>
-        <p:xfrm>
-          <a:off x="777240" y="2377440"/>
-          <a:ext cx="10607040" cy="1371600"/>
-        </p:xfrm>
-        <a:graphic>
-          <a:graphicData uri="http://schemas.openxmlformats.org/drawingml/2006/table">
-            <a:tbl>
-              <a:tblPr firstRow="1" bandRow="1">
-                <a:tableStyleId>{5C22544A-7EE6-4342-B048-85BDC9FD1C3A}</a:tableStyleId>
-              </a:tblPr>
-              <a:tblGrid>
-                <a:gridCol w="3383280"/>
-                <a:gridCol w="1737360"/>
-                <a:gridCol w="1828800"/>
-                <a:gridCol w="3657600"/>
-              </a:tblGrid>
-              <a:tr h="457200">
-                <a:tc>
-                  <a:txBody>
-                    <a:bodyPr/>
-                    <a:lstStyle/>
-                    <a:p>
-                      <a:pPr algn="l"/>
-                      <a:r>
-                        <a:rPr sz="1500" b="1" i="0">
-                          <a:solidFill>
-                            <a:srgbClr val="FFFFFF"/>
-                          </a:solidFill>
-                          <a:latin typeface="Calibri"/>
-                        </a:rPr>
-                        <a:t>Object  (R² on degree)</a:t>
-                      </a:r>
-                    </a:p>
-                  </a:txBody>
-                  <a:tcPr anchor="ctr">
-                    <a:solidFill>
-                      <a:srgbClr val="2563EB"/>
-                    </a:solidFill>
-                  </a:tcPr>
-                </a:tc>
-                <a:tc>
-                  <a:txBody>
-                    <a:bodyPr/>
-                    <a:lstStyle/>
-                    <a:p>
-                      <a:pPr algn="ctr"/>
-                      <a:r>
-                        <a:rPr sz="1500" b="1" i="0">
-                          <a:solidFill>
-                            <a:srgbClr val="FFFFFF"/>
-                          </a:solidFill>
-                          <a:latin typeface="Calibri"/>
-                        </a:rPr>
-                        <a:t>Intraday</a:t>
-                      </a:r>
-                    </a:p>
-                    <a:p>
-                      <a:pPr algn="ctr"/>
-                      <a:r>
-                        <a:rPr sz="1500" b="1" i="0">
-                          <a:solidFill>
-                            <a:srgbClr val="FFFFFF"/>
-                          </a:solidFill>
-                          <a:latin typeface="Calibri"/>
-                        </a:rPr>
-                        <a:t>2019</a:t>
-                      </a:r>
-                    </a:p>
-                  </a:txBody>
-                  <a:tcPr anchor="ctr">
-                    <a:solidFill>
-                      <a:srgbClr val="2563EB"/>
-                    </a:solidFill>
-                  </a:tcPr>
-                </a:tc>
-                <a:tc>
-                  <a:txBody>
-                    <a:bodyPr/>
-                    <a:lstStyle/>
-                    <a:p>
-                      <a:pPr algn="ctr"/>
-                      <a:r>
-                        <a:rPr sz="1500" b="1" i="0">
-                          <a:solidFill>
-                            <a:srgbClr val="FFFFFF"/>
-                          </a:solidFill>
-                          <a:latin typeface="Calibri"/>
-                        </a:rPr>
-                        <a:t>Daily</a:t>
-                      </a:r>
-                    </a:p>
-                    <a:p>
-                      <a:pPr algn="ctr"/>
-                      <a:r>
-                        <a:rPr sz="1500" b="1" i="0">
-                          <a:solidFill>
-                            <a:srgbClr val="FFFFFF"/>
-                          </a:solidFill>
-                          <a:latin typeface="Calibri"/>
-                        </a:rPr>
-                        <a:t>2000–24</a:t>
-                      </a:r>
-                    </a:p>
-                  </a:txBody>
-                  <a:tcPr anchor="ctr">
-                    <a:solidFill>
-                      <a:srgbClr val="2563EB"/>
-                    </a:solidFill>
-                  </a:tcPr>
-                </a:tc>
-                <a:tc>
-                  <a:txBody>
-                    <a:bodyPr/>
-                    <a:lstStyle/>
-                    <a:p>
-                      <a:pPr algn="l"/>
-                      <a:r>
-                        <a:rPr sz="1500" b="1" i="0">
-                          <a:solidFill>
-                            <a:srgbClr val="FFFFFF"/>
-                          </a:solidFill>
-                          <a:latin typeface="Calibri"/>
-                        </a:rPr>
-                        <a:t>What it means</a:t>
-                      </a:r>
-                    </a:p>
-                  </a:txBody>
-                  <a:tcPr anchor="ctr">
-                    <a:solidFill>
-                      <a:srgbClr val="2563EB"/>
-                    </a:solidFill>
-                  </a:tcPr>
-                </a:tc>
-              </a:tr>
-              <a:tr h="457200">
-                <a:tc>
-                  <a:txBody>
-                    <a:bodyPr/>
-                    <a:lstStyle/>
-                    <a:p>
-                      <a:pPr algn="l"/>
-                      <a:r>
-                        <a:rPr sz="1400" b="0" i="0">
-                          <a:solidFill>
-                            <a:srgbClr val="374151"/>
-                          </a:solidFill>
-                          <a:latin typeface="Calibri"/>
-                        </a:rPr>
-                        <a:t>Plain Forman</a:t>
-                      </a:r>
-                    </a:p>
-                  </a:txBody>
-                  <a:tcPr anchor="ctr">
-                    <a:solidFill>
-                      <a:srgbClr val="FFFFFF"/>
-                    </a:solidFill>
-                  </a:tcPr>
-                </a:tc>
-                <a:tc>
-                  <a:txBody>
-                    <a:bodyPr/>
-                    <a:lstStyle/>
-                    <a:p>
-                      <a:pPr algn="ctr"/>
-                      <a:r>
-                        <a:rPr sz="1400" b="0" i="0">
-                          <a:solidFill>
-                            <a:srgbClr val="374151"/>
-                          </a:solidFill>
-                          <a:latin typeface="Calibri"/>
-                        </a:rPr>
-                        <a:t>1.00</a:t>
-                      </a:r>
-                    </a:p>
-                  </a:txBody>
-                  <a:tcPr anchor="ctr">
-                    <a:solidFill>
-                      <a:srgbClr val="FFFFFF"/>
-                    </a:solidFill>
-                  </a:tcPr>
-                </a:tc>
-                <a:tc>
-                  <a:txBody>
-                    <a:bodyPr/>
-                    <a:lstStyle/>
-                    <a:p>
-                      <a:pPr algn="ctr"/>
-                      <a:r>
-                        <a:rPr sz="1400" b="0" i="0">
-                          <a:solidFill>
-                            <a:srgbClr val="374151"/>
-                          </a:solidFill>
-                          <a:latin typeface="Calibri"/>
-                        </a:rPr>
-                        <a:t>1.00</a:t>
-                      </a:r>
-                    </a:p>
-                  </a:txBody>
-                  <a:tcPr anchor="ctr">
-                    <a:solidFill>
-                      <a:srgbClr val="FFFFFF"/>
-                    </a:solidFill>
-                  </a:tcPr>
-                </a:tc>
-                <a:tc>
-                  <a:txBody>
-                    <a:bodyPr/>
-                    <a:lstStyle/>
-                    <a:p>
-                      <a:pPr algn="l"/>
-                      <a:r>
-                        <a:rPr sz="1400" b="0" i="0">
-                          <a:solidFill>
-                            <a:srgbClr val="374151"/>
-                          </a:solidFill>
-                          <a:latin typeface="Calibri"/>
-                        </a:rPr>
-                        <a:t>100% degree — pure baseline, by design</a:t>
-                      </a:r>
-                    </a:p>
-                  </a:txBody>
-                  <a:tcPr anchor="ctr">
-                    <a:solidFill>
-                      <a:srgbClr val="FFFFFF"/>
-                    </a:solidFill>
-                  </a:tcPr>
-                </a:tc>
-              </a:tr>
-              <a:tr h="457200">
-                <a:tc>
-                  <a:txBody>
-                    <a:bodyPr/>
-                    <a:lstStyle/>
-                    <a:p>
-                      <a:pPr algn="l"/>
-                      <a:r>
-                        <a:rPr sz="1400" b="1" i="0">
-                          <a:solidFill>
-                            <a:srgbClr val="1F2937"/>
-                          </a:solidFill>
-                          <a:latin typeface="Calibri"/>
-                        </a:rPr>
-                        <a:t>Augmented Forman</a:t>
-                      </a:r>
-                    </a:p>
-                  </a:txBody>
-                  <a:tcPr anchor="ctr">
-                    <a:solidFill>
-                      <a:srgbClr val="EFF2FB"/>
-                    </a:solidFill>
-                  </a:tcPr>
-                </a:tc>
-                <a:tc>
-                  <a:txBody>
-                    <a:bodyPr/>
-                    <a:lstStyle/>
-                    <a:p>
-                      <a:pPr algn="ctr"/>
-                      <a:r>
-                        <a:rPr sz="1400" b="1" i="0">
-                          <a:solidFill>
-                            <a:srgbClr val="1F2937"/>
-                          </a:solidFill>
-                          <a:latin typeface="Calibri"/>
-                        </a:rPr>
-                        <a:t>0.56</a:t>
-                      </a:r>
-                    </a:p>
-                  </a:txBody>
-                  <a:tcPr anchor="ctr">
-                    <a:solidFill>
-                      <a:srgbClr val="EFF2FB"/>
-                    </a:solidFill>
-                  </a:tcPr>
-                </a:tc>
-                <a:tc>
-                  <a:txBody>
-                    <a:bodyPr/>
-                    <a:lstStyle/>
-                    <a:p>
-                      <a:pPr algn="ctr"/>
-                      <a:r>
-                        <a:rPr sz="1400" b="1" i="0">
-                          <a:solidFill>
-                            <a:srgbClr val="1F2937"/>
-                          </a:solidFill>
-                          <a:latin typeface="Calibri"/>
-                        </a:rPr>
-                        <a:t>0.18</a:t>
-                      </a:r>
-                    </a:p>
-                  </a:txBody>
-                  <a:tcPr anchor="ctr">
-                    <a:solidFill>
-                      <a:srgbClr val="EFF2FB"/>
-                    </a:solidFill>
-                  </a:tcPr>
-                </a:tc>
-                <a:tc>
-                  <a:txBody>
-                    <a:bodyPr/>
-                    <a:lstStyle/>
-                    <a:p>
-                      <a:pPr algn="l"/>
-                      <a:r>
-                        <a:rPr sz="1400" b="1" i="0">
-                          <a:solidFill>
-                            <a:srgbClr val="1F2937"/>
-                          </a:solidFill>
-                          <a:latin typeface="Calibri"/>
-                        </a:rPr>
-                        <a:t>44–82% is NOT degree → higher-order signal</a:t>
-                      </a:r>
-                    </a:p>
-                  </a:txBody>
-                  <a:tcPr anchor="ctr">
-                    <a:solidFill>
-                      <a:srgbClr val="EFF2FB"/>
-                    </a:solidFill>
-                  </a:tcPr>
-                </a:tc>
-              </a:tr>
-            </a:tbl>
-          </a:graphicData>
-        </a:graphic>
-      </p:graphicFrame>
-      <p:sp>
-        <p:nvSpPr>
-          <p:cNvPr id="6" name="TextBox 5"/>
-          <p:cNvSpPr txBox="1"/>
-          <p:nvPr/>
-        </p:nvSpPr>
-        <p:spPr>
-          <a:xfrm>
-            <a:off x="777240" y="5715000"/>
-            <a:ext cx="10607040" cy="640080"/>
-          </a:xfrm>
-          <a:prstGeom prst="rect">
-            <a:avLst/>
-          </a:prstGeom>
-          <a:noFill/>
-        </p:spPr>
-        <p:txBody>
-          <a:bodyPr wrap="square">
-            <a:spAutoFit/>
-          </a:bodyPr>
-          <a:lstStyle/>
-          <a:p>
-            <a:r>
-              <a:rPr sz="1400" b="0" i="1">
-                <a:solidFill>
-                  <a:srgbClr val="9CA3AF"/>
-                </a:solidFill>
-                <a:latin typeface="Calibri"/>
-              </a:rPr>
-              <a:t>Significance: plain Forman = pure degree (calibration ✓); the augmented object adds real higher-order structure at both horizons — even more on daily (~82% non-degree).</a:t>
-            </a:r>
-          </a:p>
-        </p:txBody>
-      </p:sp>
-      <p:sp>
-        <p:nvSpPr>
-          <p:cNvPr id="7" name="TextBox 6"/>
-          <p:cNvSpPr txBox="1"/>
-          <p:nvPr/>
-        </p:nvSpPr>
-        <p:spPr>
-          <a:xfrm>
-            <a:off x="777240" y="6355080"/>
-            <a:ext cx="10607040" cy="365760"/>
-          </a:xfrm>
-          <a:prstGeom prst="rect">
-            <a:avLst/>
-          </a:prstGeom>
-          <a:noFill/>
-        </p:spPr>
-        <p:txBody>
-          <a:bodyPr wrap="square">
-            <a:spAutoFit/>
-          </a:bodyPr>
-          <a:lstStyle/>
-          <a:p>
-            <a:r>
-              <a:rPr sz="1100" b="0" i="0">
-                <a:solidFill>
-                  <a:srgbClr val="9CA3AF"/>
-                </a:solidFill>
-                <a:latin typeface="Calibri"/>
-              </a:rPr>
-              <a:t>Results — H1</a:t>
-            </a:r>
-          </a:p>
-        </p:txBody>
-      </p:sp>
-      <p:sp>
-        <p:nvSpPr>
-          <p:cNvPr id="8" name="TextBox 7"/>
-          <p:cNvSpPr txBox="1"/>
-          <p:nvPr/>
-        </p:nvSpPr>
-        <p:spPr>
-          <a:xfrm>
-            <a:off x="10789920" y="6355080"/>
-            <a:ext cx="1280160" cy="365760"/>
-          </a:xfrm>
-          <a:prstGeom prst="rect">
-            <a:avLst/>
-          </a:prstGeom>
-          <a:noFill/>
-        </p:spPr>
-        <p:txBody>
-          <a:bodyPr wrap="square">
-            <a:spAutoFit/>
-          </a:bodyPr>
-          <a:lstStyle/>
-          <a:p>
-            <a:pPr algn="r"/>
-            <a:r>
-              <a:rPr sz="1100" b="0" i="0">
-                <a:solidFill>
-                  <a:srgbClr val="9CA3AF"/>
-                </a:solidFill>
-                <a:latin typeface="Calibri"/>
-              </a:rPr>
-              <a:t>15</a:t>
-            </a:r>
-          </a:p>
-        </p:txBody>
-      </p:sp>
-    </p:spTree>
-  </p:cSld>
-  <p:clrMapOvr>
-    <a:masterClrMapping/>
-  </p:clrMapOvr>
-</p:sld>
-</file>
-
-<file path=ppt/slides/slide17.xml><?xml version="1.0" encoding="utf-8"?>
-<p:sld xmlns:a="http://schemas.openxmlformats.org/drawingml/2006/main" xmlns:p="http://schemas.openxmlformats.org/presentationml/2006/main" xmlns:r="http://schemas.openxmlformats.org/officeDocument/2006/relationships">
-  <p:cSld>
-    <p:spTree>
-      <p:nvGrpSpPr>
-        <p:cNvPr id="1" name=""/>
-        <p:cNvGrpSpPr/>
-        <p:nvPr/>
-      </p:nvGrpSpPr>
-      <p:grpSpPr/>
-      <p:sp>
-        <p:nvSpPr>
-          <p:cNvPr id="2" name="TextBox 1"/>
-          <p:cNvSpPr txBox="1"/>
-          <p:nvPr/>
-        </p:nvSpPr>
-        <p:spPr>
-          <a:xfrm>
-            <a:off x="777240" y="640080"/>
-            <a:ext cx="10607040" cy="822960"/>
-          </a:xfrm>
-          <a:prstGeom prst="rect">
-            <a:avLst/>
-          </a:prstGeom>
-          <a:noFill/>
-        </p:spPr>
-        <p:txBody>
-          <a:bodyPr wrap="square">
-            <a:spAutoFit/>
-          </a:bodyPr>
-          <a:lstStyle/>
-          <a:p>
-            <a:r>
-              <a:rPr sz="3000" b="1" i="0">
-                <a:solidFill>
-                  <a:srgbClr val="1F2937"/>
-                </a:solidFill>
-                <a:latin typeface="Calibri"/>
-              </a:rPr>
-              <a:t>The structure is cross-sector</a:t>
-            </a:r>
-          </a:p>
-        </p:txBody>
-      </p:sp>
-      <p:sp>
-        <p:nvSpPr>
-          <p:cNvPr id="3" name="Rectangle 2"/>
-          <p:cNvSpPr/>
-          <p:nvPr/>
-        </p:nvSpPr>
-        <p:spPr>
-          <a:xfrm>
-            <a:off x="777240" y="1417320"/>
-            <a:ext cx="1828800" cy="38100"/>
-          </a:xfrm>
-          <a:prstGeom prst="rect">
-            <a:avLst/>
-          </a:prstGeom>
-          <a:solidFill>
-            <a:srgbClr val="2563EB"/>
-          </a:solidFill>
-          <a:ln>
-            <a:noFill/>
-          </a:ln>
-          <a:effectLst/>
-        </p:spPr>
-        <p:style>
-          <a:lnRef idx="1">
-            <a:schemeClr val="accent1"/>
-          </a:lnRef>
-          <a:fillRef idx="3">
-            <a:schemeClr val="accent1"/>
-          </a:fillRef>
-          <a:effectRef idx="2">
-            <a:schemeClr val="accent1"/>
-          </a:effectRef>
-          <a:fontRef idx="minor">
-            <a:schemeClr val="lt1"/>
-          </a:fontRef>
-        </p:style>
-        <p:txBody>
-          <a:bodyPr rtlCol="0" anchor="ctr"/>
-          <a:lstStyle/>
-          <a:p>
-            <a:pPr algn="ctr"/>
-          </a:p>
-        </p:txBody>
-      </p:sp>
-      <p:sp>
-        <p:nvSpPr>
-          <p:cNvPr id="4" name="TextBox 3"/>
-          <p:cNvSpPr txBox="1"/>
-          <p:nvPr/>
-        </p:nvSpPr>
-        <p:spPr>
-          <a:xfrm>
-            <a:off x="777240" y="1783080"/>
-            <a:ext cx="10607040" cy="731520"/>
-          </a:xfrm>
-          <a:prstGeom prst="rect">
-            <a:avLst/>
-          </a:prstGeom>
-          <a:noFill/>
-        </p:spPr>
-        <p:txBody>
-          <a:bodyPr wrap="square">
-            <a:spAutoFit/>
-          </a:bodyPr>
-          <a:lstStyle/>
-          <a:p>
-            <a:r>
-              <a:rPr sz="1900" b="0" i="1">
-                <a:solidFill>
-                  <a:srgbClr val="2563EB"/>
-                </a:solidFill>
-                <a:latin typeface="Calibri"/>
-              </a:rPr>
-              <a:t>Where do the pairs curvature picks actually live?</a:t>
-            </a:r>
-          </a:p>
-        </p:txBody>
-      </p:sp>
-      <p:sp>
-        <p:nvSpPr>
-          <p:cNvPr id="5" name="TextBox 4"/>
-          <p:cNvSpPr txBox="1"/>
-          <p:nvPr/>
-        </p:nvSpPr>
-        <p:spPr>
-          <a:xfrm>
-            <a:off x="777240" y="2514600"/>
-            <a:ext cx="10607040" cy="3657600"/>
-          </a:xfrm>
-          <a:prstGeom prst="rect">
-            <a:avLst/>
-          </a:prstGeom>
-          <a:noFill/>
-        </p:spPr>
-        <p:txBody>
-          <a:bodyPr wrap="square">
-            <a:spAutoFit/>
-          </a:bodyPr>
-          <a:lstStyle/>
-          <a:p>
-            <a:pPr>
-              <a:spcAft>
-                <a:spcPts val="1200"/>
-              </a:spcAft>
-            </a:pPr>
-            <a:r>
-              <a:rPr sz="2100" b="0" i="0">
-                <a:solidFill>
-                  <a:srgbClr val="374151"/>
-                </a:solidFill>
-                <a:latin typeface="Calibri"/>
-              </a:rPr>
-              <a:t>•  A 'triangle' = three stocks each linked to the other two — a tight local cluster, and what the curvature augmentation counts.</a:t>
-            </a:r>
-          </a:p>
-          <a:p>
-            <a:pPr>
-              <a:spcAft>
-                <a:spcPts val="1200"/>
-              </a:spcAft>
-            </a:pPr>
-            <a:r>
-              <a:rPr sz="2100" b="0" i="0">
-                <a:solidFill>
-                  <a:srgbClr val="374151"/>
-                </a:solidFill>
-                <a:latin typeface="Calibri"/>
-              </a:rPr>
-              <a:t>•  Almost all of these triangles span sectors — only ~1% sit within a single GICS sector.</a:t>
-            </a:r>
-          </a:p>
-          <a:p>
-            <a:pPr>
-              <a:spcAft>
-                <a:spcPts val="1200"/>
-              </a:spcAft>
-            </a:pPr>
-            <a:r>
-              <a:rPr sz="2100" b="0" i="0">
-                <a:solidFill>
-                  <a:srgbClr val="374151"/>
-                </a:solidFill>
-                <a:latin typeface="Calibri"/>
-              </a:rPr>
-              <a:t>•  So curvature highlights cross-sector links that a sector- or correlation-based grouping would never put together.</a:t>
-            </a:r>
-          </a:p>
-          <a:p>
-            <a:pPr>
-              <a:spcAft>
-                <a:spcPts val="1200"/>
-              </a:spcAft>
-            </a:pPr>
-            <a:r>
-              <a:rPr sz="2100" b="0" i="0">
-                <a:solidFill>
-                  <a:srgbClr val="374151"/>
-                </a:solidFill>
-                <a:latin typeface="Calibri"/>
-              </a:rPr>
-              <a:t>•  Honest caveat: so few within-group triangles → the community step can't cleanly carve out clusters.</a:t>
-            </a:r>
-          </a:p>
-        </p:txBody>
-      </p:sp>
-      <p:sp>
-        <p:nvSpPr>
-          <p:cNvPr id="6" name="TextBox 5"/>
-          <p:cNvSpPr txBox="1"/>
-          <p:nvPr/>
-        </p:nvSpPr>
-        <p:spPr>
-          <a:xfrm>
-            <a:off x="777240" y="6355080"/>
-            <a:ext cx="10607040" cy="365760"/>
-          </a:xfrm>
-          <a:prstGeom prst="rect">
-            <a:avLst/>
-          </a:prstGeom>
-          <a:noFill/>
-        </p:spPr>
-        <p:txBody>
-          <a:bodyPr wrap="square">
-            <a:spAutoFit/>
-          </a:bodyPr>
-          <a:lstStyle/>
-          <a:p>
-            <a:r>
-              <a:rPr sz="1100" b="0" i="0">
-                <a:solidFill>
-                  <a:srgbClr val="9CA3AF"/>
-                </a:solidFill>
-                <a:latin typeface="Calibri"/>
-              </a:rPr>
-              <a:t>Results — H1</a:t>
-            </a:r>
-          </a:p>
-        </p:txBody>
-      </p:sp>
-      <p:sp>
-        <p:nvSpPr>
-          <p:cNvPr id="7" name="TextBox 6"/>
-          <p:cNvSpPr txBox="1"/>
-          <p:nvPr/>
-        </p:nvSpPr>
-        <p:spPr>
-          <a:xfrm>
-            <a:off x="10789920" y="6355080"/>
-            <a:ext cx="1280160" cy="365760"/>
-          </a:xfrm>
-          <a:prstGeom prst="rect">
-            <a:avLst/>
-          </a:prstGeom>
-          <a:noFill/>
-        </p:spPr>
-        <p:txBody>
-          <a:bodyPr wrap="square">
-            <a:spAutoFit/>
-          </a:bodyPr>
-          <a:lstStyle/>
-          <a:p>
-            <a:pPr algn="r"/>
-            <a:r>
-              <a:rPr sz="1100" b="0" i="0">
-                <a:solidFill>
-                  <a:srgbClr val="9CA3AF"/>
-                </a:solidFill>
-                <a:latin typeface="Calibri"/>
-              </a:rPr>
-              <a:t>16</a:t>
-            </a:r>
-          </a:p>
-        </p:txBody>
-      </p:sp>
-    </p:spTree>
-  </p:cSld>
-  <p:clrMapOvr>
-    <a:masterClrMapping/>
-  </p:clrMapOvr>
-</p:sld>
-</file>
-
-<file path=ppt/slides/slide18.xml><?xml version="1.0" encoding="utf-8"?>
 <p:sld xmlns:a="http://schemas.openxmlformats.org/drawingml/2006/main" xmlns:p="http://schemas.openxmlformats.org/presentationml/2006/main" xmlns:r="http://schemas.openxmlformats.org/officeDocument/2006/relationships">
   <p:cSld>
     <p:spTree>
@@ -7774,6 +6674,787 @@
                 </a:solidFill>
                 <a:latin typeface="Calibri"/>
               </a:rPr>
+              <a:t>15</a:t>
+            </a:r>
+          </a:p>
+        </p:txBody>
+      </p:sp>
+    </p:spTree>
+  </p:cSld>
+  <p:clrMapOvr>
+    <a:masterClrMapping/>
+  </p:clrMapOvr>
+</p:sld>
+</file>
+
+<file path=ppt/slides/slide17.xml><?xml version="1.0" encoding="utf-8"?>
+<p:sld xmlns:a="http://schemas.openxmlformats.org/drawingml/2006/main" xmlns:p="http://schemas.openxmlformats.org/presentationml/2006/main" xmlns:r="http://schemas.openxmlformats.org/officeDocument/2006/relationships">
+  <p:cSld>
+    <p:spTree>
+      <p:nvGrpSpPr>
+        <p:cNvPr id="1" name=""/>
+        <p:cNvGrpSpPr/>
+        <p:nvPr/>
+      </p:nvGrpSpPr>
+      <p:grpSpPr/>
+      <p:sp>
+        <p:nvSpPr>
+          <p:cNvPr id="2" name="TextBox 1"/>
+          <p:cNvSpPr txBox="1"/>
+          <p:nvPr/>
+        </p:nvSpPr>
+        <p:spPr>
+          <a:xfrm>
+            <a:off x="777240" y="640080"/>
+            <a:ext cx="10607040" cy="822960"/>
+          </a:xfrm>
+          <a:prstGeom prst="rect">
+            <a:avLst/>
+          </a:prstGeom>
+          <a:noFill/>
+        </p:spPr>
+        <p:txBody>
+          <a:bodyPr wrap="square">
+            <a:spAutoFit/>
+          </a:bodyPr>
+          <a:lstStyle/>
+          <a:p>
+            <a:r>
+              <a:rPr sz="3000" b="1" i="0">
+                <a:solidFill>
+                  <a:srgbClr val="1F2937"/>
+                </a:solidFill>
+                <a:latin typeface="Calibri"/>
+              </a:rPr>
+              <a:t>Did the two hypotheses hold?</a:t>
+            </a:r>
+          </a:p>
+        </p:txBody>
+      </p:sp>
+      <p:sp>
+        <p:nvSpPr>
+          <p:cNvPr id="3" name="Rectangle 2"/>
+          <p:cNvSpPr/>
+          <p:nvPr/>
+        </p:nvSpPr>
+        <p:spPr>
+          <a:xfrm>
+            <a:off x="777240" y="1417320"/>
+            <a:ext cx="1828800" cy="38100"/>
+          </a:xfrm>
+          <a:prstGeom prst="rect">
+            <a:avLst/>
+          </a:prstGeom>
+          <a:solidFill>
+            <a:srgbClr val="2563EB"/>
+          </a:solidFill>
+          <a:ln>
+            <a:noFill/>
+          </a:ln>
+          <a:effectLst/>
+        </p:spPr>
+        <p:style>
+          <a:lnRef idx="1">
+            <a:schemeClr val="accent1"/>
+          </a:lnRef>
+          <a:fillRef idx="3">
+            <a:schemeClr val="accent1"/>
+          </a:fillRef>
+          <a:effectRef idx="2">
+            <a:schemeClr val="accent1"/>
+          </a:effectRef>
+          <a:fontRef idx="minor">
+            <a:schemeClr val="lt1"/>
+          </a:fontRef>
+        </p:style>
+        <p:txBody>
+          <a:bodyPr rtlCol="0" anchor="ctr"/>
+          <a:lstStyle/>
+          <a:p>
+            <a:pPr algn="ctr"/>
+          </a:p>
+        </p:txBody>
+      </p:sp>
+      <p:sp>
+        <p:nvSpPr>
+          <p:cNvPr id="4" name="TextBox 3"/>
+          <p:cNvSpPr txBox="1"/>
+          <p:nvPr/>
+        </p:nvSpPr>
+        <p:spPr>
+          <a:xfrm>
+            <a:off x="777240" y="1600200"/>
+            <a:ext cx="10607040" cy="457200"/>
+          </a:xfrm>
+          <a:prstGeom prst="rect">
+            <a:avLst/>
+          </a:prstGeom>
+          <a:noFill/>
+        </p:spPr>
+        <p:txBody>
+          <a:bodyPr wrap="square">
+            <a:spAutoFit/>
+          </a:bodyPr>
+          <a:lstStyle/>
+          <a:p>
+            <a:r>
+              <a:rPr sz="1700" b="0" i="1">
+                <a:solidFill>
+                  <a:srgbClr val="2563EB"/>
+                </a:solidFill>
+                <a:latin typeface="Calibri"/>
+              </a:rPr>
+              <a:t>The paper stands on H1. H2 is reported transparently — across 25 years.</a:t>
+            </a:r>
+          </a:p>
+        </p:txBody>
+      </p:sp>
+      <p:sp>
+        <p:nvSpPr>
+          <p:cNvPr id="5" name="Rounded Rectangle 4"/>
+          <p:cNvSpPr/>
+          <p:nvPr/>
+        </p:nvSpPr>
+        <p:spPr>
+          <a:xfrm>
+            <a:off x="777240" y="2240280"/>
+            <a:ext cx="5074920" cy="640080"/>
+          </a:xfrm>
+          <a:prstGeom prst="roundRect">
+            <a:avLst/>
+          </a:prstGeom>
+          <a:solidFill>
+            <a:srgbClr val="159E5B"/>
+          </a:solidFill>
+          <a:ln>
+            <a:noFill/>
+          </a:ln>
+          <a:effectLst/>
+        </p:spPr>
+        <p:style>
+          <a:lnRef idx="1">
+            <a:schemeClr val="accent1"/>
+          </a:lnRef>
+          <a:fillRef idx="3">
+            <a:schemeClr val="accent1"/>
+          </a:fillRef>
+          <a:effectRef idx="2">
+            <a:schemeClr val="accent1"/>
+          </a:effectRef>
+          <a:fontRef idx="minor">
+            <a:schemeClr val="lt1"/>
+          </a:fontRef>
+        </p:style>
+        <p:txBody>
+          <a:bodyPr rtlCol="0" anchor="ctr" wrap="square"/>
+          <a:lstStyle/>
+          <a:p>
+            <a:pPr algn="ctr"/>
+            <a:r>
+              <a:rPr sz="1600" b="1" i="0">
+                <a:solidFill>
+                  <a:srgbClr val="FFFFFF"/>
+                </a:solidFill>
+                <a:latin typeface="Calibri"/>
+              </a:rPr>
+              <a:t>H1 — Structural distinctness</a:t>
+            </a:r>
+          </a:p>
+        </p:txBody>
+      </p:sp>
+      <p:sp>
+        <p:nvSpPr>
+          <p:cNvPr id="6" name="Rounded Rectangle 5"/>
+          <p:cNvSpPr/>
+          <p:nvPr/>
+        </p:nvSpPr>
+        <p:spPr>
+          <a:xfrm>
+            <a:off x="777240" y="3017520"/>
+            <a:ext cx="5074920" cy="2926080"/>
+          </a:xfrm>
+          <a:prstGeom prst="roundRect">
+            <a:avLst/>
+          </a:prstGeom>
+          <a:solidFill>
+            <a:srgbClr val="ECFBF2"/>
+          </a:solidFill>
+          <a:ln w="12700">
+            <a:solidFill>
+              <a:srgbClr val="159E5B"/>
+            </a:solidFill>
+          </a:ln>
+          <a:effectLst/>
+        </p:spPr>
+        <p:style>
+          <a:lnRef idx="1">
+            <a:schemeClr val="accent1"/>
+          </a:lnRef>
+          <a:fillRef idx="3">
+            <a:schemeClr val="accent1"/>
+          </a:fillRef>
+          <a:effectRef idx="2">
+            <a:schemeClr val="accent1"/>
+          </a:effectRef>
+          <a:fontRef idx="minor">
+            <a:schemeClr val="lt1"/>
+          </a:fontRef>
+        </p:style>
+        <p:txBody>
+          <a:bodyPr rtlCol="0" anchor="ctr" wrap="square" lIns="274320" rIns="274320" tIns="228600"/>
+          <a:lstStyle/>
+          <a:p>
+            <a:pPr algn="ctr"/>
+            <a:r>
+              <a:rPr sz="2200" b="1" i="0">
+                <a:solidFill>
+                  <a:srgbClr val="159E5B"/>
+                </a:solidFill>
+                <a:latin typeface="Calibri"/>
+              </a:rPr>
+              <a:t>✓  CONFIRMED</a:t>
+            </a:r>
+          </a:p>
+          <a:p>
+            <a:pPr>
+              <a:spcBef>
+                <a:spcPts val="1000"/>
+              </a:spcBef>
+            </a:pPr>
+            <a:r>
+              <a:rPr sz="1500" b="0" i="0">
+                <a:solidFill>
+                  <a:srgbClr val="374151"/>
+                </a:solidFill>
+                <a:latin typeface="Calibri"/>
+              </a:rPr>
+              <a:t>•  Jaccard 0, Spearman 0.07–0.18 vs correlation</a:t>
+            </a:r>
+          </a:p>
+          <a:p>
+            <a:pPr>
+              <a:spcBef>
+                <a:spcPts val="1000"/>
+              </a:spcBef>
+            </a:pPr>
+            <a:r>
+              <a:rPr sz="1500" b="0" i="0">
+                <a:solidFill>
+                  <a:srgbClr val="374151"/>
+                </a:solidFill>
+                <a:latin typeface="Calibri"/>
+              </a:rPr>
+              <a:t>•  augmented Forman: 44–82% non-degree signal</a:t>
+            </a:r>
+          </a:p>
+          <a:p>
+            <a:pPr>
+              <a:spcBef>
+                <a:spcPts val="1000"/>
+              </a:spcBef>
+            </a:pPr>
+            <a:r>
+              <a:rPr sz="1500" b="0" i="0">
+                <a:solidFill>
+                  <a:srgbClr val="374151"/>
+                </a:solidFill>
+                <a:latin typeface="Calibri"/>
+              </a:rPr>
+              <a:t>•  robust across 2019 intraday &amp; 25-yr daily</a:t>
+            </a:r>
+          </a:p>
+        </p:txBody>
+      </p:sp>
+      <p:sp>
+        <p:nvSpPr>
+          <p:cNvPr id="7" name="Rounded Rectangle 6"/>
+          <p:cNvSpPr/>
+          <p:nvPr/>
+        </p:nvSpPr>
+        <p:spPr>
+          <a:xfrm>
+            <a:off x="6309360" y="2240280"/>
+            <a:ext cx="5074920" cy="640080"/>
+          </a:xfrm>
+          <a:prstGeom prst="roundRect">
+            <a:avLst/>
+          </a:prstGeom>
+          <a:solidFill>
+            <a:srgbClr val="D97706"/>
+          </a:solidFill>
+          <a:ln>
+            <a:noFill/>
+          </a:ln>
+          <a:effectLst/>
+        </p:spPr>
+        <p:style>
+          <a:lnRef idx="1">
+            <a:schemeClr val="accent1"/>
+          </a:lnRef>
+          <a:fillRef idx="3">
+            <a:schemeClr val="accent1"/>
+          </a:fillRef>
+          <a:effectRef idx="2">
+            <a:schemeClr val="accent1"/>
+          </a:effectRef>
+          <a:fontRef idx="minor">
+            <a:schemeClr val="lt1"/>
+          </a:fontRef>
+        </p:style>
+        <p:txBody>
+          <a:bodyPr rtlCol="0" anchor="ctr" wrap="square"/>
+          <a:lstStyle/>
+          <a:p>
+            <a:pPr algn="ctr"/>
+            <a:r>
+              <a:rPr sz="1600" b="1" i="0">
+                <a:solidFill>
+                  <a:srgbClr val="FFFFFF"/>
+                </a:solidFill>
+                <a:latin typeface="Calibri"/>
+              </a:rPr>
+              <a:t>H2 — Predictive edge</a:t>
+            </a:r>
+          </a:p>
+        </p:txBody>
+      </p:sp>
+      <p:sp>
+        <p:nvSpPr>
+          <p:cNvPr id="8" name="Rounded Rectangle 7"/>
+          <p:cNvSpPr/>
+          <p:nvPr/>
+        </p:nvSpPr>
+        <p:spPr>
+          <a:xfrm>
+            <a:off x="6309360" y="3017520"/>
+            <a:ext cx="5074920" cy="2926080"/>
+          </a:xfrm>
+          <a:prstGeom prst="roundRect">
+            <a:avLst/>
+          </a:prstGeom>
+          <a:solidFill>
+            <a:srgbClr val="FDF4E6"/>
+          </a:solidFill>
+          <a:ln w="12700">
+            <a:solidFill>
+              <a:srgbClr val="D97706"/>
+            </a:solidFill>
+          </a:ln>
+          <a:effectLst/>
+        </p:spPr>
+        <p:style>
+          <a:lnRef idx="1">
+            <a:schemeClr val="accent1"/>
+          </a:lnRef>
+          <a:fillRef idx="3">
+            <a:schemeClr val="accent1"/>
+          </a:fillRef>
+          <a:effectRef idx="2">
+            <a:schemeClr val="accent1"/>
+          </a:effectRef>
+          <a:fontRef idx="minor">
+            <a:schemeClr val="lt1"/>
+          </a:fontRef>
+        </p:style>
+        <p:txBody>
+          <a:bodyPr rtlCol="0" anchor="ctr" wrap="square" lIns="274320" rIns="274320" tIns="228600"/>
+          <a:lstStyle/>
+          <a:p>
+            <a:pPr algn="ctr"/>
+            <a:r>
+              <a:rPr sz="2200" b="1" i="0">
+                <a:solidFill>
+                  <a:srgbClr val="D97706"/>
+                </a:solidFill>
+                <a:latin typeface="Calibri"/>
+              </a:rPr>
+              <a:t>✗  NOT SUPPORTED</a:t>
+            </a:r>
+          </a:p>
+          <a:p>
+            <a:pPr>
+              <a:spcBef>
+                <a:spcPts val="1000"/>
+              </a:spcBef>
+            </a:pPr>
+            <a:r>
+              <a:rPr sz="1500" b="0" i="0">
+                <a:solidFill>
+                  <a:srgbClr val="374151"/>
+                </a:solidFill>
+                <a:latin typeface="Calibri"/>
+              </a:rPr>
+              <a:t>•  Intraday 2019: Forman leads, but CIs span zero</a:t>
+            </a:r>
+          </a:p>
+          <a:p>
+            <a:pPr>
+              <a:spcBef>
+                <a:spcPts val="1000"/>
+              </a:spcBef>
+            </a:pPr>
+            <a:r>
+              <a:rPr sz="1500" b="0" i="0">
+                <a:solidFill>
+                  <a:srgbClr val="374151"/>
+                </a:solidFill>
+                <a:latin typeface="Calibri"/>
+              </a:rPr>
+              <a:t>•  Daily 25-yr: curvature negative, correlation best</a:t>
+            </a:r>
+          </a:p>
+          <a:p>
+            <a:pPr>
+              <a:spcBef>
+                <a:spcPts val="1000"/>
+              </a:spcBef>
+            </a:pPr>
+            <a:r>
+              <a:rPr sz="1500" b="0" i="0">
+                <a:solidFill>
+                  <a:srgbClr val="374151"/>
+                </a:solidFill>
+                <a:latin typeface="Calibri"/>
+              </a:rPr>
+              <a:t>•  no predictive edge; the claim rests on H1</a:t>
+            </a:r>
+          </a:p>
+        </p:txBody>
+      </p:sp>
+      <p:sp>
+        <p:nvSpPr>
+          <p:cNvPr id="9" name="TextBox 8"/>
+          <p:cNvSpPr txBox="1"/>
+          <p:nvPr/>
+        </p:nvSpPr>
+        <p:spPr>
+          <a:xfrm>
+            <a:off x="777240" y="6355080"/>
+            <a:ext cx="10607040" cy="365760"/>
+          </a:xfrm>
+          <a:prstGeom prst="rect">
+            <a:avLst/>
+          </a:prstGeom>
+          <a:noFill/>
+        </p:spPr>
+        <p:txBody>
+          <a:bodyPr wrap="square">
+            <a:spAutoFit/>
+          </a:bodyPr>
+          <a:lstStyle/>
+          <a:p>
+            <a:r>
+              <a:rPr sz="1100" b="0" i="0">
+                <a:solidFill>
+                  <a:srgbClr val="9CA3AF"/>
+                </a:solidFill>
+                <a:latin typeface="Calibri"/>
+              </a:rPr>
+              <a:t>Verdict</a:t>
+            </a:r>
+          </a:p>
+        </p:txBody>
+      </p:sp>
+      <p:sp>
+        <p:nvSpPr>
+          <p:cNvPr id="10" name="TextBox 9"/>
+          <p:cNvSpPr txBox="1"/>
+          <p:nvPr/>
+        </p:nvSpPr>
+        <p:spPr>
+          <a:xfrm>
+            <a:off x="10789920" y="6355080"/>
+            <a:ext cx="1280160" cy="365760"/>
+          </a:xfrm>
+          <a:prstGeom prst="rect">
+            <a:avLst/>
+          </a:prstGeom>
+          <a:noFill/>
+        </p:spPr>
+        <p:txBody>
+          <a:bodyPr wrap="square">
+            <a:spAutoFit/>
+          </a:bodyPr>
+          <a:lstStyle/>
+          <a:p>
+            <a:pPr algn="r"/>
+            <a:r>
+              <a:rPr sz="1100" b="0" i="0">
+                <a:solidFill>
+                  <a:srgbClr val="9CA3AF"/>
+                </a:solidFill>
+                <a:latin typeface="Calibri"/>
+              </a:rPr>
+              <a:t>16</a:t>
+            </a:r>
+          </a:p>
+        </p:txBody>
+      </p:sp>
+    </p:spTree>
+  </p:cSld>
+  <p:clrMapOvr>
+    <a:masterClrMapping/>
+  </p:clrMapOvr>
+</p:sld>
+</file>
+
+<file path=ppt/slides/slide18.xml><?xml version="1.0" encoding="utf-8"?>
+<p:sld xmlns:a="http://schemas.openxmlformats.org/drawingml/2006/main" xmlns:p="http://schemas.openxmlformats.org/presentationml/2006/main" xmlns:r="http://schemas.openxmlformats.org/officeDocument/2006/relationships">
+  <p:cSld>
+    <p:spTree>
+      <p:nvGrpSpPr>
+        <p:cNvPr id="1" name=""/>
+        <p:cNvGrpSpPr/>
+        <p:nvPr/>
+      </p:nvGrpSpPr>
+      <p:grpSpPr/>
+      <p:sp>
+        <p:nvSpPr>
+          <p:cNvPr id="2" name="TextBox 1"/>
+          <p:cNvSpPr txBox="1"/>
+          <p:nvPr/>
+        </p:nvSpPr>
+        <p:spPr>
+          <a:xfrm>
+            <a:off x="777240" y="640080"/>
+            <a:ext cx="10607040" cy="822960"/>
+          </a:xfrm>
+          <a:prstGeom prst="rect">
+            <a:avLst/>
+          </a:prstGeom>
+          <a:noFill/>
+        </p:spPr>
+        <p:txBody>
+          <a:bodyPr wrap="square">
+            <a:spAutoFit/>
+          </a:bodyPr>
+          <a:lstStyle/>
+          <a:p>
+            <a:r>
+              <a:rPr sz="3000" b="1" i="0">
+                <a:solidFill>
+                  <a:srgbClr val="1F2937"/>
+                </a:solidFill>
+                <a:latin typeface="Calibri"/>
+              </a:rPr>
+              <a:t>Agentic AI workflow</a:t>
+            </a:r>
+          </a:p>
+        </p:txBody>
+      </p:sp>
+      <p:sp>
+        <p:nvSpPr>
+          <p:cNvPr id="3" name="Rectangle 2"/>
+          <p:cNvSpPr/>
+          <p:nvPr/>
+        </p:nvSpPr>
+        <p:spPr>
+          <a:xfrm>
+            <a:off x="777240" y="1417320"/>
+            <a:ext cx="1828800" cy="38100"/>
+          </a:xfrm>
+          <a:prstGeom prst="rect">
+            <a:avLst/>
+          </a:prstGeom>
+          <a:solidFill>
+            <a:srgbClr val="2563EB"/>
+          </a:solidFill>
+          <a:ln>
+            <a:noFill/>
+          </a:ln>
+          <a:effectLst/>
+        </p:spPr>
+        <p:style>
+          <a:lnRef idx="1">
+            <a:schemeClr val="accent1"/>
+          </a:lnRef>
+          <a:fillRef idx="3">
+            <a:schemeClr val="accent1"/>
+          </a:fillRef>
+          <a:effectRef idx="2">
+            <a:schemeClr val="accent1"/>
+          </a:effectRef>
+          <a:fontRef idx="minor">
+            <a:schemeClr val="lt1"/>
+          </a:fontRef>
+        </p:style>
+        <p:txBody>
+          <a:bodyPr rtlCol="0" anchor="ctr"/>
+          <a:lstStyle/>
+          <a:p>
+            <a:pPr algn="ctr"/>
+          </a:p>
+        </p:txBody>
+      </p:sp>
+      <p:sp>
+        <p:nvSpPr>
+          <p:cNvPr id="4" name="TextBox 3"/>
+          <p:cNvSpPr txBox="1"/>
+          <p:nvPr/>
+        </p:nvSpPr>
+        <p:spPr>
+          <a:xfrm>
+            <a:off x="777240" y="1783080"/>
+            <a:ext cx="10607040" cy="731520"/>
+          </a:xfrm>
+          <a:prstGeom prst="rect">
+            <a:avLst/>
+          </a:prstGeom>
+          <a:noFill/>
+        </p:spPr>
+        <p:txBody>
+          <a:bodyPr wrap="square">
+            <a:spAutoFit/>
+          </a:bodyPr>
+          <a:lstStyle/>
+          <a:p>
+            <a:r>
+              <a:rPr sz="1900" b="0" i="1">
+                <a:solidFill>
+                  <a:srgbClr val="2563EB"/>
+                </a:solidFill>
+                <a:latin typeface="Calibri"/>
+              </a:rPr>
+              <a:t>What agentic AI did here.</a:t>
+            </a:r>
+          </a:p>
+        </p:txBody>
+      </p:sp>
+      <p:sp>
+        <p:nvSpPr>
+          <p:cNvPr id="5" name="TextBox 4"/>
+          <p:cNvSpPr txBox="1"/>
+          <p:nvPr/>
+        </p:nvSpPr>
+        <p:spPr>
+          <a:xfrm>
+            <a:off x="777240" y="2514600"/>
+            <a:ext cx="10607040" cy="3657600"/>
+          </a:xfrm>
+          <a:prstGeom prst="rect">
+            <a:avLst/>
+          </a:prstGeom>
+          <a:noFill/>
+        </p:spPr>
+        <p:txBody>
+          <a:bodyPr wrap="square">
+            <a:spAutoFit/>
+          </a:bodyPr>
+          <a:lstStyle/>
+          <a:p>
+            <a:pPr>
+              <a:spcAft>
+                <a:spcPts val="1200"/>
+              </a:spcAft>
+            </a:pPr>
+            <a:r>
+              <a:rPr sz="2100" b="0" i="0">
+                <a:solidFill>
+                  <a:srgbClr val="374151"/>
+                </a:solidFill>
+                <a:latin typeface="Calibri"/>
+              </a:rPr>
+              <a:t>•  Helped me research the idea — surveying the curvature and lead-lag literature, and coding the pipeline.</a:t>
+            </a:r>
+          </a:p>
+          <a:p>
+            <a:pPr>
+              <a:spcAft>
+                <a:spcPts val="1200"/>
+              </a:spcAft>
+            </a:pPr>
+            <a:r>
+              <a:rPr sz="2100" b="0" i="0">
+                <a:solidFill>
+                  <a:srgbClr val="374151"/>
+                </a:solidFill>
+                <a:latin typeface="Calibri"/>
+              </a:rPr>
+              <a:t>•  Its core role: linking curvature (graph geometry) to directed lead-lag networks (the finance side).</a:t>
+            </a:r>
+          </a:p>
+          <a:p>
+            <a:pPr>
+              <a:spcAft>
+                <a:spcPts val="1200"/>
+              </a:spcAft>
+            </a:pPr>
+            <a:r>
+              <a:rPr sz="2100" b="0" i="0">
+                <a:solidFill>
+                  <a:srgbClr val="374151"/>
+                </a:solidFill>
+                <a:latin typeface="Calibri"/>
+              </a:rPr>
+              <a:t>•  Framing and judgment stayed human.</a:t>
+            </a:r>
+          </a:p>
+        </p:txBody>
+      </p:sp>
+      <p:sp>
+        <p:nvSpPr>
+          <p:cNvPr id="6" name="TextBox 5"/>
+          <p:cNvSpPr txBox="1"/>
+          <p:nvPr/>
+        </p:nvSpPr>
+        <p:spPr>
+          <a:xfrm>
+            <a:off x="777240" y="6355080"/>
+            <a:ext cx="10607040" cy="365760"/>
+          </a:xfrm>
+          <a:prstGeom prst="rect">
+            <a:avLst/>
+          </a:prstGeom>
+          <a:noFill/>
+        </p:spPr>
+        <p:txBody>
+          <a:bodyPr wrap="square">
+            <a:spAutoFit/>
+          </a:bodyPr>
+          <a:lstStyle/>
+          <a:p>
+            <a:r>
+              <a:rPr sz="1100" b="0" i="0">
+                <a:solidFill>
+                  <a:srgbClr val="9CA3AF"/>
+                </a:solidFill>
+                <a:latin typeface="Calibri"/>
+              </a:rPr>
+              <a:t>Agentic AI</a:t>
+            </a:r>
+          </a:p>
+        </p:txBody>
+      </p:sp>
+      <p:sp>
+        <p:nvSpPr>
+          <p:cNvPr id="7" name="TextBox 6"/>
+          <p:cNvSpPr txBox="1"/>
+          <p:nvPr/>
+        </p:nvSpPr>
+        <p:spPr>
+          <a:xfrm>
+            <a:off x="10789920" y="6355080"/>
+            <a:ext cx="1280160" cy="365760"/>
+          </a:xfrm>
+          <a:prstGeom prst="rect">
+            <a:avLst/>
+          </a:prstGeom>
+          <a:noFill/>
+        </p:spPr>
+        <p:txBody>
+          <a:bodyPr wrap="square">
+            <a:spAutoFit/>
+          </a:bodyPr>
+          <a:lstStyle/>
+          <a:p>
+            <a:pPr algn="r"/>
+            <a:r>
+              <a:rPr sz="1100" b="0" i="0">
+                <a:solidFill>
+                  <a:srgbClr val="9CA3AF"/>
+                </a:solidFill>
+                <a:latin typeface="Calibri"/>
+              </a:rPr>
               <a:t>17</a:t>
             </a:r>
           </a:p>
@@ -7826,7 +7507,7 @@
                 </a:solidFill>
                 <a:latin typeface="Calibri"/>
               </a:rPr>
-              <a:t>Did the two hypotheses hold?</a:t>
+              <a:t>Limitations</a:t>
             </a:r>
           </a:p>
         </p:txBody>
@@ -7883,8 +7564,8 @@
         </p:nvSpPr>
         <p:spPr>
           <a:xfrm>
-            <a:off x="777240" y="1600200"/>
-            <a:ext cx="10607040" cy="457200"/>
+            <a:off x="777240" y="1783080"/>
+            <a:ext cx="10607040" cy="731520"/>
           </a:xfrm>
           <a:prstGeom prst="rect">
             <a:avLst/>
@@ -7898,339 +7579,27 @@
           <a:lstStyle/>
           <a:p>
             <a:r>
-              <a:rPr sz="1700" b="0" i="1">
+              <a:rPr sz="1900" b="0" i="1">
                 <a:solidFill>
                   <a:srgbClr val="2563EB"/>
                 </a:solidFill>
                 <a:latin typeface="Calibri"/>
               </a:rPr>
-              <a:t>The paper stands on H1. H2 is reported transparently — across 25 years.</a:t>
-            </a:r>
-          </a:p>
-        </p:txBody>
-      </p:sp>
-      <p:sp>
-        <p:nvSpPr>
-          <p:cNvPr id="5" name="Rounded Rectangle 4"/>
-          <p:cNvSpPr/>
-          <p:nvPr/>
-        </p:nvSpPr>
-        <p:spPr>
-          <a:xfrm>
-            <a:off x="777240" y="2240280"/>
-            <a:ext cx="5074920" cy="640080"/>
-          </a:xfrm>
-          <a:prstGeom prst="roundRect">
-            <a:avLst/>
-          </a:prstGeom>
-          <a:solidFill>
-            <a:srgbClr val="159E5B"/>
-          </a:solidFill>
-          <a:ln>
-            <a:noFill/>
-          </a:ln>
-          <a:effectLst/>
-        </p:spPr>
-        <p:style>
-          <a:lnRef idx="1">
-            <a:schemeClr val="accent1"/>
-          </a:lnRef>
-          <a:fillRef idx="3">
-            <a:schemeClr val="accent1"/>
-          </a:fillRef>
-          <a:effectRef idx="2">
-            <a:schemeClr val="accent1"/>
-          </a:effectRef>
-          <a:fontRef idx="minor">
-            <a:schemeClr val="lt1"/>
-          </a:fontRef>
-        </p:style>
-        <p:txBody>
-          <a:bodyPr rtlCol="0" anchor="ctr" wrap="square"/>
-          <a:lstStyle/>
-          <a:p>
-            <a:pPr algn="ctr"/>
-            <a:r>
-              <a:rPr sz="1600" b="1" i="0">
-                <a:solidFill>
-                  <a:srgbClr val="FFFFFF"/>
-                </a:solidFill>
-                <a:latin typeface="Calibri"/>
-              </a:rPr>
-              <a:t>H1 — Structural distinctness</a:t>
-            </a:r>
-          </a:p>
-        </p:txBody>
-      </p:sp>
-      <p:sp>
-        <p:nvSpPr>
-          <p:cNvPr id="6" name="Rounded Rectangle 5"/>
-          <p:cNvSpPr/>
-          <p:nvPr/>
-        </p:nvSpPr>
-        <p:spPr>
-          <a:xfrm>
-            <a:off x="777240" y="3017520"/>
-            <a:ext cx="5074920" cy="2926080"/>
-          </a:xfrm>
-          <a:prstGeom prst="roundRect">
-            <a:avLst/>
-          </a:prstGeom>
-          <a:solidFill>
-            <a:srgbClr val="ECFBF2"/>
-          </a:solidFill>
-          <a:ln w="12700">
-            <a:solidFill>
-              <a:srgbClr val="159E5B"/>
-            </a:solidFill>
-          </a:ln>
-          <a:effectLst/>
-        </p:spPr>
-        <p:style>
-          <a:lnRef idx="1">
-            <a:schemeClr val="accent1"/>
-          </a:lnRef>
-          <a:fillRef idx="3">
-            <a:schemeClr val="accent1"/>
-          </a:fillRef>
-          <a:effectRef idx="2">
-            <a:schemeClr val="accent1"/>
-          </a:effectRef>
-          <a:fontRef idx="minor">
-            <a:schemeClr val="lt1"/>
-          </a:fontRef>
-        </p:style>
-        <p:txBody>
-          <a:bodyPr rtlCol="0" anchor="ctr" wrap="square" lIns="274320" rIns="274320" tIns="228600"/>
-          <a:lstStyle/>
-          <a:p>
-            <a:pPr algn="ctr"/>
-            <a:r>
-              <a:rPr sz="2200" b="1" i="0">
-                <a:solidFill>
-                  <a:srgbClr val="159E5B"/>
-                </a:solidFill>
-                <a:latin typeface="Calibri"/>
-              </a:rPr>
-              <a:t>✓  CONFIRMED</a:t>
-            </a:r>
-          </a:p>
-          <a:p>
-            <a:pPr>
-              <a:spcBef>
-                <a:spcPts val="1000"/>
-              </a:spcBef>
-            </a:pPr>
-            <a:r>
-              <a:rPr sz="1500" b="0" i="0">
-                <a:solidFill>
-                  <a:srgbClr val="374151"/>
-                </a:solidFill>
-                <a:latin typeface="Calibri"/>
-              </a:rPr>
-              <a:t>•  Jaccard 0, Spearman 0.07–0.18 vs correlation</a:t>
-            </a:r>
-          </a:p>
-          <a:p>
-            <a:pPr>
-              <a:spcBef>
-                <a:spcPts val="1000"/>
-              </a:spcBef>
-            </a:pPr>
-            <a:r>
-              <a:rPr sz="1500" b="0" i="0">
-                <a:solidFill>
-                  <a:srgbClr val="374151"/>
-                </a:solidFill>
-                <a:latin typeface="Calibri"/>
-              </a:rPr>
-              <a:t>•  augmented Forman: 44–82% non-degree signal</a:t>
-            </a:r>
-          </a:p>
-          <a:p>
-            <a:pPr>
-              <a:spcBef>
-                <a:spcPts val="1000"/>
-              </a:spcBef>
-            </a:pPr>
-            <a:r>
-              <a:rPr sz="1500" b="0" i="0">
-                <a:solidFill>
-                  <a:srgbClr val="374151"/>
-                </a:solidFill>
-                <a:latin typeface="Calibri"/>
-              </a:rPr>
-              <a:t>•  robust across 2019 intraday &amp; 25-yr daily</a:t>
-            </a:r>
-          </a:p>
-        </p:txBody>
-      </p:sp>
-      <p:sp>
-        <p:nvSpPr>
-          <p:cNvPr id="7" name="Rounded Rectangle 6"/>
-          <p:cNvSpPr/>
-          <p:nvPr/>
-        </p:nvSpPr>
-        <p:spPr>
-          <a:xfrm>
-            <a:off x="6309360" y="2240280"/>
-            <a:ext cx="5074920" cy="640080"/>
-          </a:xfrm>
-          <a:prstGeom prst="roundRect">
-            <a:avLst/>
-          </a:prstGeom>
-          <a:solidFill>
-            <a:srgbClr val="D97706"/>
-          </a:solidFill>
-          <a:ln>
-            <a:noFill/>
-          </a:ln>
-          <a:effectLst/>
-        </p:spPr>
-        <p:style>
-          <a:lnRef idx="1">
-            <a:schemeClr val="accent1"/>
-          </a:lnRef>
-          <a:fillRef idx="3">
-            <a:schemeClr val="accent1"/>
-          </a:fillRef>
-          <a:effectRef idx="2">
-            <a:schemeClr val="accent1"/>
-          </a:effectRef>
-          <a:fontRef idx="minor">
-            <a:schemeClr val="lt1"/>
-          </a:fontRef>
-        </p:style>
-        <p:txBody>
-          <a:bodyPr rtlCol="0" anchor="ctr" wrap="square"/>
-          <a:lstStyle/>
-          <a:p>
-            <a:pPr algn="ctr"/>
-            <a:r>
-              <a:rPr sz="1600" b="1" i="0">
-                <a:solidFill>
-                  <a:srgbClr val="FFFFFF"/>
-                </a:solidFill>
-                <a:latin typeface="Calibri"/>
-              </a:rPr>
-              <a:t>H2 — Predictive edge</a:t>
-            </a:r>
-          </a:p>
-        </p:txBody>
-      </p:sp>
-      <p:sp>
-        <p:nvSpPr>
-          <p:cNvPr id="8" name="Rounded Rectangle 7"/>
-          <p:cNvSpPr/>
-          <p:nvPr/>
-        </p:nvSpPr>
-        <p:spPr>
-          <a:xfrm>
-            <a:off x="6309360" y="3017520"/>
-            <a:ext cx="5074920" cy="2926080"/>
-          </a:xfrm>
-          <a:prstGeom prst="roundRect">
-            <a:avLst/>
-          </a:prstGeom>
-          <a:solidFill>
-            <a:srgbClr val="FDF4E6"/>
-          </a:solidFill>
-          <a:ln w="12700">
-            <a:solidFill>
-              <a:srgbClr val="D97706"/>
-            </a:solidFill>
-          </a:ln>
-          <a:effectLst/>
-        </p:spPr>
-        <p:style>
-          <a:lnRef idx="1">
-            <a:schemeClr val="accent1"/>
-          </a:lnRef>
-          <a:fillRef idx="3">
-            <a:schemeClr val="accent1"/>
-          </a:fillRef>
-          <a:effectRef idx="2">
-            <a:schemeClr val="accent1"/>
-          </a:effectRef>
-          <a:fontRef idx="minor">
-            <a:schemeClr val="lt1"/>
-          </a:fontRef>
-        </p:style>
-        <p:txBody>
-          <a:bodyPr rtlCol="0" anchor="ctr" wrap="square" lIns="274320" rIns="274320" tIns="228600"/>
-          <a:lstStyle/>
-          <a:p>
-            <a:pPr algn="ctr"/>
-            <a:r>
-              <a:rPr sz="2200" b="1" i="0">
-                <a:solidFill>
-                  <a:srgbClr val="D97706"/>
-                </a:solidFill>
-                <a:latin typeface="Calibri"/>
-              </a:rPr>
-              <a:t>✗  NOT SUPPORTED</a:t>
-            </a:r>
-          </a:p>
-          <a:p>
-            <a:pPr>
-              <a:spcBef>
-                <a:spcPts val="1000"/>
-              </a:spcBef>
-            </a:pPr>
-            <a:r>
-              <a:rPr sz="1500" b="0" i="0">
-                <a:solidFill>
-                  <a:srgbClr val="374151"/>
-                </a:solidFill>
-                <a:latin typeface="Calibri"/>
-              </a:rPr>
-              <a:t>•  Intraday 2019: Forman leads, but CIs span zero</a:t>
-            </a:r>
-          </a:p>
-          <a:p>
-            <a:pPr>
-              <a:spcBef>
-                <a:spcPts val="1000"/>
-              </a:spcBef>
-            </a:pPr>
-            <a:r>
-              <a:rPr sz="1500" b="0" i="0">
-                <a:solidFill>
-                  <a:srgbClr val="374151"/>
-                </a:solidFill>
-                <a:latin typeface="Calibri"/>
-              </a:rPr>
-              <a:t>•  Daily 25-yr: curvature negative, correlation best</a:t>
-            </a:r>
-          </a:p>
-          <a:p>
-            <a:pPr>
-              <a:spcBef>
-                <a:spcPts val="1000"/>
-              </a:spcBef>
-            </a:pPr>
-            <a:r>
-              <a:rPr sz="1500" b="0" i="0">
-                <a:solidFill>
-                  <a:srgbClr val="374151"/>
-                </a:solidFill>
-                <a:latin typeface="Calibri"/>
-              </a:rPr>
-              <a:t>•  no predictive edge; the claim rests on H1</a:t>
-            </a:r>
-          </a:p>
-        </p:txBody>
-      </p:sp>
-      <p:sp>
-        <p:nvSpPr>
-          <p:cNvPr id="9" name="TextBox 8"/>
+              <a:t>Stated plainly — these shape what we can and can't claim.</a:t>
+            </a:r>
+          </a:p>
+        </p:txBody>
+      </p:sp>
+      <p:sp>
+        <p:nvSpPr>
+          <p:cNvPr id="5" name="TextBox 4"/>
           <p:cNvSpPr txBox="1"/>
           <p:nvPr/>
         </p:nvSpPr>
         <p:spPr>
           <a:xfrm>
-            <a:off x="777240" y="6355080"/>
-            <a:ext cx="10607040" cy="365760"/>
+            <a:off x="777240" y="2514600"/>
+            <a:ext cx="10607040" cy="3657600"/>
           </a:xfrm>
           <a:prstGeom prst="rect">
             <a:avLst/>
@@ -8243,6 +7612,109 @@
           </a:bodyPr>
           <a:lstStyle/>
           <a:p>
+            <a:pPr>
+              <a:spcAft>
+                <a:spcPts val="1200"/>
+              </a:spcAft>
+            </a:pPr>
+            <a:r>
+              <a:rPr sz="2100" b="0" i="0">
+                <a:solidFill>
+                  <a:srgbClr val="374151"/>
+                </a:solidFill>
+                <a:latin typeface="Calibri"/>
+              </a:rPr>
+              <a:t>•  Intraday is 2019 only (TAQ cost) — not a 25-year intraday panel.</a:t>
+            </a:r>
+          </a:p>
+          <a:p>
+            <a:pPr>
+              <a:spcAft>
+                <a:spcPts val="1200"/>
+              </a:spcAft>
+            </a:pPr>
+            <a:r>
+              <a:rPr sz="2100" b="0" i="0">
+                <a:solidFill>
+                  <a:srgbClr val="374151"/>
+                </a:solidFill>
+                <a:latin typeface="Calibri"/>
+              </a:rPr>
+              <a:t>•  Triangle-sparse network limits AFRC community separability (Fesser–Weber–Lambiotte).</a:t>
+            </a:r>
+          </a:p>
+          <a:p>
+            <a:pPr>
+              <a:spcAft>
+                <a:spcPts val="1200"/>
+              </a:spcAft>
+            </a:pPr>
+            <a:r>
+              <a:rPr sz="2100" b="0" i="0">
+                <a:solidFill>
+                  <a:srgbClr val="374151"/>
+                </a:solidFill>
+                <a:latin typeface="Calibri"/>
+              </a:rPr>
+              <a:t>•  Directed line-graph &amp; directed curvature-gap are theoretically open — undirected reduction used.</a:t>
+            </a:r>
+          </a:p>
+          <a:p>
+            <a:pPr>
+              <a:spcAft>
+                <a:spcPts val="1200"/>
+              </a:spcAft>
+            </a:pPr>
+            <a:r>
+              <a:rPr sz="2100" b="0" i="0">
+                <a:solidFill>
+                  <a:srgbClr val="374151"/>
+                </a:solidFill>
+                <a:latin typeface="Calibri"/>
+              </a:rPr>
+              <a:t>•  Predictive IC evaluated at fixed k = 20; not pre-registered.</a:t>
+            </a:r>
+          </a:p>
+          <a:p>
+            <a:pPr>
+              <a:spcAft>
+                <a:spcPts val="1200"/>
+              </a:spcAft>
+            </a:pPr>
+            <a:r>
+              <a:rPr sz="2100" b="0" i="0">
+                <a:solidFill>
+                  <a:srgbClr val="374151"/>
+                </a:solidFill>
+                <a:latin typeface="Calibri"/>
+              </a:rPr>
+              <a:t>•  Daily universe is survivor-biased within each window (continuous-presence filter).</a:t>
+            </a:r>
+          </a:p>
+        </p:txBody>
+      </p:sp>
+      <p:sp>
+        <p:nvSpPr>
+          <p:cNvPr id="6" name="TextBox 5"/>
+          <p:cNvSpPr txBox="1"/>
+          <p:nvPr/>
+        </p:nvSpPr>
+        <p:spPr>
+          <a:xfrm>
+            <a:off x="777240" y="6355080"/>
+            <a:ext cx="10607040" cy="365760"/>
+          </a:xfrm>
+          <a:prstGeom prst="rect">
+            <a:avLst/>
+          </a:prstGeom>
+          <a:noFill/>
+        </p:spPr>
+        <p:txBody>
+          <a:bodyPr wrap="square">
+            <a:spAutoFit/>
+          </a:bodyPr>
+          <a:lstStyle/>
+          <a:p>
             <a:r>
               <a:rPr sz="1100" b="0" i="0">
                 <a:solidFill>
@@ -8250,14 +7722,14 @@
                 </a:solidFill>
                 <a:latin typeface="Calibri"/>
               </a:rPr>
-              <a:t>Verdict</a:t>
-            </a:r>
-          </a:p>
-        </p:txBody>
-      </p:sp>
-      <p:sp>
-        <p:nvSpPr>
-          <p:cNvPr id="10" name="TextBox 9"/>
+              <a:t>Limitations</a:t>
+            </a:r>
+          </a:p>
+        </p:txBody>
+      </p:sp>
+      <p:sp>
+        <p:nvSpPr>
+          <p:cNvPr id="7" name="TextBox 6"/>
           <p:cNvSpPr txBox="1"/>
           <p:nvPr/>
         </p:nvSpPr>
@@ -8639,7 +8111,7 @@
                 </a:solidFill>
                 <a:latin typeface="Calibri"/>
               </a:rPr>
-              <a:t>Agentic AI workflow</a:t>
+              <a:t>What's next</a:t>
             </a:r>
           </a:p>
         </p:txBody>
@@ -8717,7 +8189,7 @@
                 </a:solidFill>
                 <a:latin typeface="Calibri"/>
               </a:rPr>
-              <a:t>What agentic AI did here.</a:t>
+              <a:t>H2 failed — so pivot from forecasting returns to what curvature is strong at: structure.</a:t>
             </a:r>
           </a:p>
         </p:txBody>
@@ -8756,7 +8228,7 @@
                 </a:solidFill>
                 <a:latin typeface="Calibri"/>
               </a:rPr>
-              <a:t>•  Helped me research the idea — surveying the curvature and lead-lag literature, and coding the pipeline.</a:t>
+              <a:t>•  Curvature as a fragility / systemic-risk signal — Sandhu's original result was curvature rising before crashes; bring that to the directed graph.</a:t>
             </a:r>
           </a:p>
           <a:p>
@@ -8772,7 +8244,7 @@
                 </a:solidFill>
                 <a:latin typeface="Calibri"/>
               </a:rPr>
-              <a:t>•  Its core role: linking curvature (graph geometry) to directed lead-lag networks (the finance side).</a:t>
+              <a:t>•  Regime shifts: does the cross-sector structure change around stress? The 2008 &amp; 2020 intraday pulls feed exactly this.</a:t>
             </a:r>
           </a:p>
           <a:p>
@@ -8788,7 +8260,23 @@
                 </a:solidFill>
                 <a:latin typeface="Calibri"/>
               </a:rPr>
-              <a:t>•  Framing and judgment stayed human.</a:t>
+              <a:t>•  Directed line-graph &amp; curvature-gap theory (open; possible Weber collaboration).</a:t>
+            </a:r>
+          </a:p>
+          <a:p>
+            <a:pPr>
+              <a:spcAft>
+                <a:spcPts val="1200"/>
+              </a:spcAft>
+            </a:pPr>
+            <a:r>
+              <a:rPr sz="2100" b="0" i="0">
+                <a:solidFill>
+                  <a:srgbClr val="374151"/>
+                </a:solidFill>
+                <a:latin typeface="Calibri"/>
+              </a:rPr>
+              <a:t>•  Extend to an 8-page ACM sigconf — ICAIF 2026, deadline Aug 2.</a:t>
             </a:r>
           </a:p>
         </p:txBody>
@@ -8822,7 +8310,7 @@
                 </a:solidFill>
                 <a:latin typeface="Calibri"/>
               </a:rPr>
-              <a:t>Agentic AI</a:t>
+              <a:t>What's next</a:t>
             </a:r>
           </a:p>
         </p:txBody>
@@ -8871,594 +8359,6 @@
 </file>
 
 <file path=ppt/slides/slide21.xml><?xml version="1.0" encoding="utf-8"?>
-<p:sld xmlns:a="http://schemas.openxmlformats.org/drawingml/2006/main" xmlns:p="http://schemas.openxmlformats.org/presentationml/2006/main" xmlns:r="http://schemas.openxmlformats.org/officeDocument/2006/relationships">
-  <p:cSld>
-    <p:spTree>
-      <p:nvGrpSpPr>
-        <p:cNvPr id="1" name=""/>
-        <p:cNvGrpSpPr/>
-        <p:nvPr/>
-      </p:nvGrpSpPr>
-      <p:grpSpPr/>
-      <p:sp>
-        <p:nvSpPr>
-          <p:cNvPr id="2" name="TextBox 1"/>
-          <p:cNvSpPr txBox="1"/>
-          <p:nvPr/>
-        </p:nvSpPr>
-        <p:spPr>
-          <a:xfrm>
-            <a:off x="777240" y="640080"/>
-            <a:ext cx="10607040" cy="822960"/>
-          </a:xfrm>
-          <a:prstGeom prst="rect">
-            <a:avLst/>
-          </a:prstGeom>
-          <a:noFill/>
-        </p:spPr>
-        <p:txBody>
-          <a:bodyPr wrap="square">
-            <a:spAutoFit/>
-          </a:bodyPr>
-          <a:lstStyle/>
-          <a:p>
-            <a:r>
-              <a:rPr sz="3000" b="1" i="0">
-                <a:solidFill>
-                  <a:srgbClr val="1F2937"/>
-                </a:solidFill>
-                <a:latin typeface="Calibri"/>
-              </a:rPr>
-              <a:t>Limitations</a:t>
-            </a:r>
-          </a:p>
-        </p:txBody>
-      </p:sp>
-      <p:sp>
-        <p:nvSpPr>
-          <p:cNvPr id="3" name="Rectangle 2"/>
-          <p:cNvSpPr/>
-          <p:nvPr/>
-        </p:nvSpPr>
-        <p:spPr>
-          <a:xfrm>
-            <a:off x="777240" y="1417320"/>
-            <a:ext cx="1828800" cy="38100"/>
-          </a:xfrm>
-          <a:prstGeom prst="rect">
-            <a:avLst/>
-          </a:prstGeom>
-          <a:solidFill>
-            <a:srgbClr val="2563EB"/>
-          </a:solidFill>
-          <a:ln>
-            <a:noFill/>
-          </a:ln>
-          <a:effectLst/>
-        </p:spPr>
-        <p:style>
-          <a:lnRef idx="1">
-            <a:schemeClr val="accent1"/>
-          </a:lnRef>
-          <a:fillRef idx="3">
-            <a:schemeClr val="accent1"/>
-          </a:fillRef>
-          <a:effectRef idx="2">
-            <a:schemeClr val="accent1"/>
-          </a:effectRef>
-          <a:fontRef idx="minor">
-            <a:schemeClr val="lt1"/>
-          </a:fontRef>
-        </p:style>
-        <p:txBody>
-          <a:bodyPr rtlCol="0" anchor="ctr"/>
-          <a:lstStyle/>
-          <a:p>
-            <a:pPr algn="ctr"/>
-          </a:p>
-        </p:txBody>
-      </p:sp>
-      <p:sp>
-        <p:nvSpPr>
-          <p:cNvPr id="4" name="TextBox 3"/>
-          <p:cNvSpPr txBox="1"/>
-          <p:nvPr/>
-        </p:nvSpPr>
-        <p:spPr>
-          <a:xfrm>
-            <a:off x="777240" y="1783080"/>
-            <a:ext cx="10607040" cy="731520"/>
-          </a:xfrm>
-          <a:prstGeom prst="rect">
-            <a:avLst/>
-          </a:prstGeom>
-          <a:noFill/>
-        </p:spPr>
-        <p:txBody>
-          <a:bodyPr wrap="square">
-            <a:spAutoFit/>
-          </a:bodyPr>
-          <a:lstStyle/>
-          <a:p>
-            <a:r>
-              <a:rPr sz="1900" b="0" i="1">
-                <a:solidFill>
-                  <a:srgbClr val="2563EB"/>
-                </a:solidFill>
-                <a:latin typeface="Calibri"/>
-              </a:rPr>
-              <a:t>Stated plainly — these shape what we can and can't claim.</a:t>
-            </a:r>
-          </a:p>
-        </p:txBody>
-      </p:sp>
-      <p:sp>
-        <p:nvSpPr>
-          <p:cNvPr id="5" name="TextBox 4"/>
-          <p:cNvSpPr txBox="1"/>
-          <p:nvPr/>
-        </p:nvSpPr>
-        <p:spPr>
-          <a:xfrm>
-            <a:off x="777240" y="2514600"/>
-            <a:ext cx="10607040" cy="3657600"/>
-          </a:xfrm>
-          <a:prstGeom prst="rect">
-            <a:avLst/>
-          </a:prstGeom>
-          <a:noFill/>
-        </p:spPr>
-        <p:txBody>
-          <a:bodyPr wrap="square">
-            <a:spAutoFit/>
-          </a:bodyPr>
-          <a:lstStyle/>
-          <a:p>
-            <a:pPr>
-              <a:spcAft>
-                <a:spcPts val="1200"/>
-              </a:spcAft>
-            </a:pPr>
-            <a:r>
-              <a:rPr sz="2100" b="0" i="0">
-                <a:solidFill>
-                  <a:srgbClr val="374151"/>
-                </a:solidFill>
-                <a:latin typeface="Calibri"/>
-              </a:rPr>
-              <a:t>•  Intraday is 2019 only (TAQ cost) — not a 25-year intraday panel.</a:t>
-            </a:r>
-          </a:p>
-          <a:p>
-            <a:pPr>
-              <a:spcAft>
-                <a:spcPts val="1200"/>
-              </a:spcAft>
-            </a:pPr>
-            <a:r>
-              <a:rPr sz="2100" b="0" i="0">
-                <a:solidFill>
-                  <a:srgbClr val="374151"/>
-                </a:solidFill>
-                <a:latin typeface="Calibri"/>
-              </a:rPr>
-              <a:t>•  Triangle-sparse network limits AFRC community separability (Fesser–Weber–Lambiotte).</a:t>
-            </a:r>
-          </a:p>
-          <a:p>
-            <a:pPr>
-              <a:spcAft>
-                <a:spcPts val="1200"/>
-              </a:spcAft>
-            </a:pPr>
-            <a:r>
-              <a:rPr sz="2100" b="0" i="0">
-                <a:solidFill>
-                  <a:srgbClr val="374151"/>
-                </a:solidFill>
-                <a:latin typeface="Calibri"/>
-              </a:rPr>
-              <a:t>•  Directed line-graph &amp; directed curvature-gap are theoretically open — undirected reduction used.</a:t>
-            </a:r>
-          </a:p>
-          <a:p>
-            <a:pPr>
-              <a:spcAft>
-                <a:spcPts val="1200"/>
-              </a:spcAft>
-            </a:pPr>
-            <a:r>
-              <a:rPr sz="2100" b="0" i="0">
-                <a:solidFill>
-                  <a:srgbClr val="374151"/>
-                </a:solidFill>
-                <a:latin typeface="Calibri"/>
-              </a:rPr>
-              <a:t>•  Predictive IC evaluated at fixed k = 20; not pre-registered.</a:t>
-            </a:r>
-          </a:p>
-          <a:p>
-            <a:pPr>
-              <a:spcAft>
-                <a:spcPts val="1200"/>
-              </a:spcAft>
-            </a:pPr>
-            <a:r>
-              <a:rPr sz="2100" b="0" i="0">
-                <a:solidFill>
-                  <a:srgbClr val="374151"/>
-                </a:solidFill>
-                <a:latin typeface="Calibri"/>
-              </a:rPr>
-              <a:t>•  Daily universe is survivor-biased within each window (continuous-presence filter).</a:t>
-            </a:r>
-          </a:p>
-        </p:txBody>
-      </p:sp>
-      <p:sp>
-        <p:nvSpPr>
-          <p:cNvPr id="6" name="TextBox 5"/>
-          <p:cNvSpPr txBox="1"/>
-          <p:nvPr/>
-        </p:nvSpPr>
-        <p:spPr>
-          <a:xfrm>
-            <a:off x="777240" y="6355080"/>
-            <a:ext cx="10607040" cy="365760"/>
-          </a:xfrm>
-          <a:prstGeom prst="rect">
-            <a:avLst/>
-          </a:prstGeom>
-          <a:noFill/>
-        </p:spPr>
-        <p:txBody>
-          <a:bodyPr wrap="square">
-            <a:spAutoFit/>
-          </a:bodyPr>
-          <a:lstStyle/>
-          <a:p>
-            <a:r>
-              <a:rPr sz="1100" b="0" i="0">
-                <a:solidFill>
-                  <a:srgbClr val="9CA3AF"/>
-                </a:solidFill>
-                <a:latin typeface="Calibri"/>
-              </a:rPr>
-              <a:t>Limitations</a:t>
-            </a:r>
-          </a:p>
-        </p:txBody>
-      </p:sp>
-      <p:sp>
-        <p:nvSpPr>
-          <p:cNvPr id="7" name="TextBox 6"/>
-          <p:cNvSpPr txBox="1"/>
-          <p:nvPr/>
-        </p:nvSpPr>
-        <p:spPr>
-          <a:xfrm>
-            <a:off x="10789920" y="6355080"/>
-            <a:ext cx="1280160" cy="365760"/>
-          </a:xfrm>
-          <a:prstGeom prst="rect">
-            <a:avLst/>
-          </a:prstGeom>
-          <a:noFill/>
-        </p:spPr>
-        <p:txBody>
-          <a:bodyPr wrap="square">
-            <a:spAutoFit/>
-          </a:bodyPr>
-          <a:lstStyle/>
-          <a:p>
-            <a:pPr algn="r"/>
-            <a:r>
-              <a:rPr sz="1100" b="0" i="0">
-                <a:solidFill>
-                  <a:srgbClr val="9CA3AF"/>
-                </a:solidFill>
-                <a:latin typeface="Calibri"/>
-              </a:rPr>
-              <a:t>20</a:t>
-            </a:r>
-          </a:p>
-        </p:txBody>
-      </p:sp>
-    </p:spTree>
-  </p:cSld>
-  <p:clrMapOvr>
-    <a:masterClrMapping/>
-  </p:clrMapOvr>
-</p:sld>
-</file>
-
-<file path=ppt/slides/slide22.xml><?xml version="1.0" encoding="utf-8"?>
-<p:sld xmlns:a="http://schemas.openxmlformats.org/drawingml/2006/main" xmlns:p="http://schemas.openxmlformats.org/presentationml/2006/main" xmlns:r="http://schemas.openxmlformats.org/officeDocument/2006/relationships">
-  <p:cSld>
-    <p:spTree>
-      <p:nvGrpSpPr>
-        <p:cNvPr id="1" name=""/>
-        <p:cNvGrpSpPr/>
-        <p:nvPr/>
-      </p:nvGrpSpPr>
-      <p:grpSpPr/>
-      <p:sp>
-        <p:nvSpPr>
-          <p:cNvPr id="2" name="TextBox 1"/>
-          <p:cNvSpPr txBox="1"/>
-          <p:nvPr/>
-        </p:nvSpPr>
-        <p:spPr>
-          <a:xfrm>
-            <a:off x="777240" y="640080"/>
-            <a:ext cx="10607040" cy="822960"/>
-          </a:xfrm>
-          <a:prstGeom prst="rect">
-            <a:avLst/>
-          </a:prstGeom>
-          <a:noFill/>
-        </p:spPr>
-        <p:txBody>
-          <a:bodyPr wrap="square">
-            <a:spAutoFit/>
-          </a:bodyPr>
-          <a:lstStyle/>
-          <a:p>
-            <a:r>
-              <a:rPr sz="3000" b="1" i="0">
-                <a:solidFill>
-                  <a:srgbClr val="1F2937"/>
-                </a:solidFill>
-                <a:latin typeface="Calibri"/>
-              </a:rPr>
-              <a:t>What's next</a:t>
-            </a:r>
-          </a:p>
-        </p:txBody>
-      </p:sp>
-      <p:sp>
-        <p:nvSpPr>
-          <p:cNvPr id="3" name="Rectangle 2"/>
-          <p:cNvSpPr/>
-          <p:nvPr/>
-        </p:nvSpPr>
-        <p:spPr>
-          <a:xfrm>
-            <a:off x="777240" y="1417320"/>
-            <a:ext cx="1828800" cy="38100"/>
-          </a:xfrm>
-          <a:prstGeom prst="rect">
-            <a:avLst/>
-          </a:prstGeom>
-          <a:solidFill>
-            <a:srgbClr val="2563EB"/>
-          </a:solidFill>
-          <a:ln>
-            <a:noFill/>
-          </a:ln>
-          <a:effectLst/>
-        </p:spPr>
-        <p:style>
-          <a:lnRef idx="1">
-            <a:schemeClr val="accent1"/>
-          </a:lnRef>
-          <a:fillRef idx="3">
-            <a:schemeClr val="accent1"/>
-          </a:fillRef>
-          <a:effectRef idx="2">
-            <a:schemeClr val="accent1"/>
-          </a:effectRef>
-          <a:fontRef idx="minor">
-            <a:schemeClr val="lt1"/>
-          </a:fontRef>
-        </p:style>
-        <p:txBody>
-          <a:bodyPr rtlCol="0" anchor="ctr"/>
-          <a:lstStyle/>
-          <a:p>
-            <a:pPr algn="ctr"/>
-          </a:p>
-        </p:txBody>
-      </p:sp>
-      <p:sp>
-        <p:nvSpPr>
-          <p:cNvPr id="4" name="TextBox 3"/>
-          <p:cNvSpPr txBox="1"/>
-          <p:nvPr/>
-        </p:nvSpPr>
-        <p:spPr>
-          <a:xfrm>
-            <a:off x="777240" y="1783080"/>
-            <a:ext cx="10607040" cy="731520"/>
-          </a:xfrm>
-          <a:prstGeom prst="rect">
-            <a:avLst/>
-          </a:prstGeom>
-          <a:noFill/>
-        </p:spPr>
-        <p:txBody>
-          <a:bodyPr wrap="square">
-            <a:spAutoFit/>
-          </a:bodyPr>
-          <a:lstStyle/>
-          <a:p>
-            <a:r>
-              <a:rPr sz="1900" b="0" i="1">
-                <a:solidFill>
-                  <a:srgbClr val="2563EB"/>
-                </a:solidFill>
-                <a:latin typeface="Calibri"/>
-              </a:rPr>
-              <a:t>H2 failed — so pivot from forecasting returns to what curvature is strong at: structure.</a:t>
-            </a:r>
-          </a:p>
-        </p:txBody>
-      </p:sp>
-      <p:sp>
-        <p:nvSpPr>
-          <p:cNvPr id="5" name="TextBox 4"/>
-          <p:cNvSpPr txBox="1"/>
-          <p:nvPr/>
-        </p:nvSpPr>
-        <p:spPr>
-          <a:xfrm>
-            <a:off x="777240" y="2514600"/>
-            <a:ext cx="10607040" cy="3657600"/>
-          </a:xfrm>
-          <a:prstGeom prst="rect">
-            <a:avLst/>
-          </a:prstGeom>
-          <a:noFill/>
-        </p:spPr>
-        <p:txBody>
-          <a:bodyPr wrap="square">
-            <a:spAutoFit/>
-          </a:bodyPr>
-          <a:lstStyle/>
-          <a:p>
-            <a:pPr>
-              <a:spcAft>
-                <a:spcPts val="1200"/>
-              </a:spcAft>
-            </a:pPr>
-            <a:r>
-              <a:rPr sz="2100" b="0" i="0">
-                <a:solidFill>
-                  <a:srgbClr val="374151"/>
-                </a:solidFill>
-                <a:latin typeface="Calibri"/>
-              </a:rPr>
-              <a:t>•  Curvature as a fragility / systemic-risk signal — Sandhu's original result was curvature rising before crashes; bring that to the directed graph.</a:t>
-            </a:r>
-          </a:p>
-          <a:p>
-            <a:pPr>
-              <a:spcAft>
-                <a:spcPts val="1200"/>
-              </a:spcAft>
-            </a:pPr>
-            <a:r>
-              <a:rPr sz="2100" b="0" i="0">
-                <a:solidFill>
-                  <a:srgbClr val="374151"/>
-                </a:solidFill>
-                <a:latin typeface="Calibri"/>
-              </a:rPr>
-              <a:t>•  Regime shifts: does the cross-sector structure change around stress? The 2008 &amp; 2020 intraday pulls feed exactly this.</a:t>
-            </a:r>
-          </a:p>
-          <a:p>
-            <a:pPr>
-              <a:spcAft>
-                <a:spcPts val="1200"/>
-              </a:spcAft>
-            </a:pPr>
-            <a:r>
-              <a:rPr sz="2100" b="0" i="0">
-                <a:solidFill>
-                  <a:srgbClr val="374151"/>
-                </a:solidFill>
-                <a:latin typeface="Calibri"/>
-              </a:rPr>
-              <a:t>•  Directed line-graph &amp; curvature-gap theory (open; possible Weber collaboration).</a:t>
-            </a:r>
-          </a:p>
-          <a:p>
-            <a:pPr>
-              <a:spcAft>
-                <a:spcPts val="1200"/>
-              </a:spcAft>
-            </a:pPr>
-            <a:r>
-              <a:rPr sz="2100" b="0" i="0">
-                <a:solidFill>
-                  <a:srgbClr val="374151"/>
-                </a:solidFill>
-                <a:latin typeface="Calibri"/>
-              </a:rPr>
-              <a:t>•  Extend to an 8-page ACM sigconf — ICAIF 2026, deadline Aug 2.</a:t>
-            </a:r>
-          </a:p>
-        </p:txBody>
-      </p:sp>
-      <p:sp>
-        <p:nvSpPr>
-          <p:cNvPr id="6" name="TextBox 5"/>
-          <p:cNvSpPr txBox="1"/>
-          <p:nvPr/>
-        </p:nvSpPr>
-        <p:spPr>
-          <a:xfrm>
-            <a:off x="777240" y="6355080"/>
-            <a:ext cx="10607040" cy="365760"/>
-          </a:xfrm>
-          <a:prstGeom prst="rect">
-            <a:avLst/>
-          </a:prstGeom>
-          <a:noFill/>
-        </p:spPr>
-        <p:txBody>
-          <a:bodyPr wrap="square">
-            <a:spAutoFit/>
-          </a:bodyPr>
-          <a:lstStyle/>
-          <a:p>
-            <a:r>
-              <a:rPr sz="1100" b="0" i="0">
-                <a:solidFill>
-                  <a:srgbClr val="9CA3AF"/>
-                </a:solidFill>
-                <a:latin typeface="Calibri"/>
-              </a:rPr>
-              <a:t>What's next</a:t>
-            </a:r>
-          </a:p>
-        </p:txBody>
-      </p:sp>
-      <p:sp>
-        <p:nvSpPr>
-          <p:cNvPr id="7" name="TextBox 6"/>
-          <p:cNvSpPr txBox="1"/>
-          <p:nvPr/>
-        </p:nvSpPr>
-        <p:spPr>
-          <a:xfrm>
-            <a:off x="10789920" y="6355080"/>
-            <a:ext cx="1280160" cy="365760"/>
-          </a:xfrm>
-          <a:prstGeom prst="rect">
-            <a:avLst/>
-          </a:prstGeom>
-          <a:noFill/>
-        </p:spPr>
-        <p:txBody>
-          <a:bodyPr wrap="square">
-            <a:spAutoFit/>
-          </a:bodyPr>
-          <a:lstStyle/>
-          <a:p>
-            <a:pPr algn="r"/>
-            <a:r>
-              <a:rPr sz="1100" b="0" i="0">
-                <a:solidFill>
-                  <a:srgbClr val="9CA3AF"/>
-                </a:solidFill>
-                <a:latin typeface="Calibri"/>
-              </a:rPr>
-              <a:t>21</a:t>
-            </a:r>
-          </a:p>
-        </p:txBody>
-      </p:sp>
-    </p:spTree>
-  </p:cSld>
-  <p:clrMapOvr>
-    <a:masterClrMapping/>
-  </p:clrMapOvr>
-</p:sld>
-</file>
-
-<file path=ppt/slides/slide23.xml><?xml version="1.0" encoding="utf-8"?>
 <p:sld xmlns:a="http://schemas.openxmlformats.org/drawingml/2006/main" xmlns:p="http://schemas.openxmlformats.org/presentationml/2006/main" xmlns:r="http://schemas.openxmlformats.org/officeDocument/2006/relationships">
   <p:cSld>
     <p:spTree>
@@ -9945,7 +8845,7 @@
                 </a:solidFill>
                 <a:latin typeface="Calibri"/>
               </a:rPr>
-              <a:t>22</a:t>
+              <a:t>20</a:t>
             </a:r>
           </a:p>
         </p:txBody>

</xml_diff>

<commit_message>
Deck: elaborate Limitations bullets with plain 'what it means' lines
Co-Authored-By: Claude Opus 4.8 (1M context) <noreply@anthropic.com>
</commit_message>
<xml_diff>
--- a/slides/Ricci_Curvature_LeadLag.pptx
+++ b/slides/Ricci_Curvature_LeadLag.pptx
@@ -7585,7 +7585,7 @@
                 </a:solidFill>
                 <a:latin typeface="Calibri"/>
               </a:rPr>
-              <a:t>Stated plainly — these shape what we can and can't claim.</a:t>
+              <a:t>Where this isn't airtight — in plain terms.</a:t>
             </a:r>
           </a:p>
         </p:txBody>
@@ -7624,7 +7624,23 @@
                 </a:solidFill>
                 <a:latin typeface="Calibri"/>
               </a:rPr>
-              <a:t>•  Intraday is 2019 only (TAQ cost) — not a 25-year intraday panel.</a:t>
+              <a:t>•  Intraday is one year (2019).</a:t>
+            </a:r>
+          </a:p>
+          <a:p>
+            <a:pPr lvl="1">
+              <a:spcAft>
+                <a:spcPts val="600"/>
+              </a:spcAft>
+            </a:pPr>
+            <a:r>
+              <a:rPr sz="1800" b="0" i="0">
+                <a:solidFill>
+                  <a:srgbClr val="9CA3AF"/>
+                </a:solidFill>
+                <a:latin typeface="Calibri"/>
+              </a:rPr>
+              <a:t>–  25 years of 30-min TAQ is too costly to pull; daily covers the full 25.</a:t>
             </a:r>
           </a:p>
           <a:p>
@@ -7640,7 +7656,23 @@
                 </a:solidFill>
                 <a:latin typeface="Calibri"/>
               </a:rPr>
-              <a:t>•  Triangle-sparse network limits AFRC community separability (Fesser–Weber–Lambiotte).</a:t>
+              <a:t>•  The clustering step is weak — too few triangles.</a:t>
+            </a:r>
+          </a:p>
+          <a:p>
+            <a:pPr lvl="1">
+              <a:spcAft>
+                <a:spcPts val="600"/>
+              </a:spcAft>
+            </a:pPr>
+            <a:r>
+              <a:rPr sz="1800" b="0" i="0">
+                <a:solidFill>
+                  <a:srgbClr val="9CA3AF"/>
+                </a:solidFill>
+                <a:latin typeface="Calibri"/>
+              </a:rPr>
+              <a:t>–  finding communities needs triangles (tight clusters have them, bridges don't); ours are too sparse to separate clusters, so we don't lean on it.</a:t>
             </a:r>
           </a:p>
           <a:p>
@@ -7656,7 +7688,23 @@
                 </a:solidFill>
                 <a:latin typeface="Calibri"/>
               </a:rPr>
-              <a:t>•  Directed line-graph &amp; directed curvature-gap are theoretically open — undirected reduction used.</a:t>
+              <a:t>•  Prediction used the top-20 pairs, not fixed in advance.</a:t>
+            </a:r>
+          </a:p>
+          <a:p>
+            <a:pPr lvl="1">
+              <a:spcAft>
+                <a:spcPts val="600"/>
+              </a:spcAft>
+            </a:pPr>
+            <a:r>
+              <a:rPr sz="1800" b="0" i="0">
+                <a:solidFill>
+                  <a:srgbClr val="9CA3AF"/>
+                </a:solidFill>
+                <a:latin typeface="Calibri"/>
+              </a:rPr>
+              <a:t>–  so it's not fully immune to a 'why 20?' challenge — though the IC was null anyway, so there was nothing to tune.</a:t>
             </a:r>
           </a:p>
           <a:p>
@@ -7672,23 +7720,23 @@
                 </a:solidFill>
                 <a:latin typeface="Calibri"/>
               </a:rPr>
-              <a:t>•  Predictive IC evaluated at fixed k = 20; not pre-registered.</a:t>
-            </a:r>
-          </a:p>
-          <a:p>
-            <a:pPr>
+              <a:t>•  Each daily window used only stocks that survived it.</a:t>
+            </a:r>
+          </a:p>
+          <a:p>
+            <a:pPr lvl="1">
               <a:spcAft>
-                <a:spcPts val="1200"/>
+                <a:spcPts val="600"/>
               </a:spcAft>
             </a:pPr>
             <a:r>
-              <a:rPr sz="2100" b="0" i="0">
-                <a:solidFill>
-                  <a:srgbClr val="374151"/>
-                </a:solidFill>
-                <a:latin typeface="Calibri"/>
-              </a:rPr>
-              <a:t>•  Daily universe is survivor-biased within each window (continuous-presence filter).</a:t>
+              <a:rPr sz="1800" b="0" i="0">
+                <a:solidFill>
+                  <a:srgbClr val="9CA3AF"/>
+                </a:solidFill>
+                <a:latin typeface="Calibri"/>
+              </a:rPr>
+              <a:t>–  stocks delisted/merged mid-window are dropped → mild survivorship bias.</a:t>
             </a:r>
           </a:p>
         </p:txBody>

</xml_diff>

<commit_message>
Deck: drop line graph from pipeline (it was off in all headline runs)
The line graph is implemented but compute_linegraph=False in the intraday run and
absent from the daily walk-forward, so no reported result used it. Pipeline slide
now shows the 5 stages that actually ran; line graph noted under limitations only.
Generalized the flow-chart helper to handle 5 or 6 boxes.

Co-Authored-By: Claude Opus 4.8 (1M context) <noreply@anthropic.com>
</commit_message>
<xml_diff>
--- a/slides/Ricci_Curvature_LeadLag.pptx
+++ b/slides/Ricci_Curvature_LeadLag.pptx
@@ -10595,7 +10595,7 @@
                 </a:solidFill>
                 <a:latin typeface="Calibri"/>
               </a:rPr>
-              <a:t>Six stages, fully automated.</a:t>
+              <a:t>Five stages, fully automated.</a:t>
             </a:r>
           </a:p>
         </p:txBody>
@@ -10995,7 +10995,7 @@
                 </a:solidFill>
                 <a:latin typeface="Calibri"/>
               </a:rPr>
-              <a:t>Line graph  L(G)</a:t>
+              <a:t>Validation cascade</a:t>
             </a:r>
           </a:p>
           <a:p>
@@ -11011,7 +11011,7 @@
                 </a:solidFill>
                 <a:latin typeface="Calibri"/>
               </a:rPr>
-              <a:t>curvature pair-communities</a:t>
+              <a:t>curvature ≠ corr / degree?</a:t>
             </a:r>
           </a:p>
         </p:txBody>
@@ -11031,7 +11031,7 @@
             <a:avLst/>
           </a:prstGeom>
           <a:solidFill>
-            <a:srgbClr val="EFF2FB"/>
+            <a:srgbClr val="2563EB"/>
           </a:solidFill>
           <a:ln w="15875">
             <a:solidFill>
@@ -11062,11 +11062,11 @@
             <a:r>
               <a:rPr sz="1400" b="1" i="0">
                 <a:solidFill>
-                  <a:srgbClr val="1F2937"/>
-                </a:solidFill>
-                <a:latin typeface="Calibri"/>
-              </a:rPr>
-              <a:t>Validation cascade</a:t>
+                  <a:srgbClr val="FFFFFF"/>
+                </a:solidFill>
+                <a:latin typeface="Calibri"/>
+              </a:rPr>
+              <a:t>Structurally isolated pairs</a:t>
             </a:r>
           </a:p>
           <a:p>
@@ -11078,36 +11078,34 @@
             <a:r>
               <a:rPr sz="1000" b="0" i="0">
                 <a:solidFill>
-                  <a:srgbClr val="9CA3AF"/>
-                </a:solidFill>
-                <a:latin typeface="Calibri"/>
-              </a:rPr>
-              <a:t>curvature ≠ corr / degree?</a:t>
-            </a:r>
-          </a:p>
-        </p:txBody>
-      </p:sp>
-      <p:sp>
-        <p:nvSpPr>
-          <p:cNvPr id="13" name="Rounded Rectangle 12"/>
+                  <a:srgbClr val="E5EDFF"/>
+                </a:solidFill>
+                <a:latin typeface="Calibri"/>
+              </a:rPr>
+              <a:t>the structural output</a:t>
+            </a:r>
+          </a:p>
+        </p:txBody>
+      </p:sp>
+      <p:sp>
+        <p:nvSpPr>
+          <p:cNvPr id="13" name="Left Arrow 12"/>
           <p:cNvSpPr/>
           <p:nvPr/>
         </p:nvSpPr>
         <p:spPr>
           <a:xfrm>
-            <a:off x="777240" y="4343400"/>
-            <a:ext cx="3017520" cy="1005840"/>
-          </a:xfrm>
-          <a:prstGeom prst="roundRect">
+            <a:off x="7251192" y="4690872"/>
+            <a:ext cx="384048" cy="310896"/>
+          </a:xfrm>
+          <a:prstGeom prst="leftArrow">
             <a:avLst/>
           </a:prstGeom>
           <a:solidFill>
             <a:srgbClr val="2563EB"/>
           </a:solidFill>
-          <a:ln w="15875">
-            <a:solidFill>
-              <a:srgbClr val="2563EB"/>
-            </a:solidFill>
+          <a:ln>
+            <a:noFill/>
           </a:ln>
           <a:effectLst/>
         </p:spPr>
@@ -11126,129 +11124,16 @@
           </a:fontRef>
         </p:style>
         <p:txBody>
-          <a:bodyPr rtlCol="0" anchor="ctr" wrap="square" lIns="73152" rIns="73152" tIns="27432" bIns="27432"/>
+          <a:bodyPr rtlCol="0" anchor="ctr"/>
           <a:lstStyle/>
           <a:p>
             <a:pPr algn="ctr"/>
-            <a:r>
-              <a:rPr sz="1400" b="1" i="0">
-                <a:solidFill>
-                  <a:srgbClr val="FFFFFF"/>
-                </a:solidFill>
-                <a:latin typeface="Calibri"/>
-              </a:rPr>
-              <a:t>Structurally isolated pairs</a:t>
-            </a:r>
-          </a:p>
-          <a:p>
-            <a:pPr algn="ctr">
-              <a:spcBef>
-                <a:spcPts val="200"/>
-              </a:spcBef>
-            </a:pPr>
-            <a:r>
-              <a:rPr sz="1000" b="0" i="0">
-                <a:solidFill>
-                  <a:srgbClr val="E5EDFF"/>
-                </a:solidFill>
-                <a:latin typeface="Calibri"/>
-              </a:rPr>
-              <a:t>the structural output</a:t>
-            </a:r>
-          </a:p>
-        </p:txBody>
-      </p:sp>
-      <p:sp>
-        <p:nvSpPr>
-          <p:cNvPr id="14" name="Left Arrow 13"/>
-          <p:cNvSpPr/>
-          <p:nvPr/>
-        </p:nvSpPr>
-        <p:spPr>
-          <a:xfrm>
-            <a:off x="7251192" y="4690872"/>
-            <a:ext cx="384048" cy="310896"/>
-          </a:xfrm>
-          <a:prstGeom prst="leftArrow">
-            <a:avLst/>
-          </a:prstGeom>
-          <a:solidFill>
-            <a:srgbClr val="2563EB"/>
-          </a:solidFill>
-          <a:ln>
-            <a:noFill/>
-          </a:ln>
-          <a:effectLst/>
-        </p:spPr>
-        <p:style>
-          <a:lnRef idx="1">
-            <a:schemeClr val="accent1"/>
-          </a:lnRef>
-          <a:fillRef idx="3">
-            <a:schemeClr val="accent1"/>
-          </a:fillRef>
-          <a:effectRef idx="2">
-            <a:schemeClr val="accent1"/>
-          </a:effectRef>
-          <a:fontRef idx="minor">
-            <a:schemeClr val="lt1"/>
-          </a:fontRef>
-        </p:style>
-        <p:txBody>
-          <a:bodyPr rtlCol="0" anchor="ctr"/>
-          <a:lstStyle/>
-          <a:p>
-            <a:pPr algn="ctr"/>
-          </a:p>
-        </p:txBody>
-      </p:sp>
-      <p:sp>
-        <p:nvSpPr>
-          <p:cNvPr id="15" name="Left Arrow 14"/>
-          <p:cNvSpPr/>
-          <p:nvPr/>
-        </p:nvSpPr>
-        <p:spPr>
-          <a:xfrm>
-            <a:off x="3822191" y="4690872"/>
-            <a:ext cx="384048" cy="310896"/>
-          </a:xfrm>
-          <a:prstGeom prst="leftArrow">
-            <a:avLst/>
-          </a:prstGeom>
-          <a:solidFill>
-            <a:srgbClr val="2563EB"/>
-          </a:solidFill>
-          <a:ln>
-            <a:noFill/>
-          </a:ln>
-          <a:effectLst/>
-        </p:spPr>
-        <p:style>
-          <a:lnRef idx="1">
-            <a:schemeClr val="accent1"/>
-          </a:lnRef>
-          <a:fillRef idx="3">
-            <a:schemeClr val="accent1"/>
-          </a:fillRef>
-          <a:effectRef idx="2">
-            <a:schemeClr val="accent1"/>
-          </a:effectRef>
-          <a:fontRef idx="minor">
-            <a:schemeClr val="lt1"/>
-          </a:fontRef>
-        </p:style>
-        <p:txBody>
-          <a:bodyPr rtlCol="0" anchor="ctr"/>
-          <a:lstStyle/>
-          <a:p>
-            <a:pPr algn="ctr"/>
-          </a:p>
-        </p:txBody>
-      </p:sp>
-      <p:sp>
-        <p:nvSpPr>
-          <p:cNvPr id="16" name="TextBox 15"/>
+          </a:p>
+        </p:txBody>
+      </p:sp>
+      <p:sp>
+        <p:nvSpPr>
+          <p:cNvPr id="14" name="TextBox 13"/>
           <p:cNvSpPr txBox="1"/>
           <p:nvPr/>
         </p:nvSpPr>
@@ -11282,7 +11167,7 @@
       </p:sp>
       <p:sp>
         <p:nvSpPr>
-          <p:cNvPr id="17" name="TextBox 16"/>
+          <p:cNvPr id="15" name="TextBox 14"/>
           <p:cNvSpPr txBox="1"/>
           <p:nvPr/>
         </p:nvSpPr>

</xml_diff>

<commit_message>
Deck: add 'The agentic orchestrator' slide (what it did + future role)
Co-Authored-By: Claude Opus 4.8 (1M context) <noreply@anthropic.com>
</commit_message>
<xml_diff>
--- a/slides/Ricci_Curvature_LeadLag.pptx
+++ b/slides/Ricci_Curvature_LeadLag.pptx
@@ -26,6 +26,7 @@
     <p:sldId id="274" r:id="rId25"/>
     <p:sldId id="275" r:id="rId26"/>
     <p:sldId id="276" r:id="rId27"/>
+    <p:sldId id="277" r:id="rId28"/>
   </p:sldIdLst>
   <p:sldSz cx="12191695" cy="6858000" type="screen4x3"/>
   <p:notesSz cx="6858000" cy="9144000"/>
@@ -7507,7 +7508,7 @@
                 </a:solidFill>
                 <a:latin typeface="Calibri"/>
               </a:rPr>
-              <a:t>Limitations</a:t>
+              <a:t>The agentic orchestrator</a:t>
             </a:r>
           </a:p>
         </p:txBody>
@@ -7565,41 +7566,7 @@
         <p:spPr>
           <a:xfrm>
             <a:off x="777240" y="1783080"/>
-            <a:ext cx="10607040" cy="731520"/>
-          </a:xfrm>
-          <a:prstGeom prst="rect">
-            <a:avLst/>
-          </a:prstGeom>
-          <a:noFill/>
-        </p:spPr>
-        <p:txBody>
-          <a:bodyPr wrap="square">
-            <a:spAutoFit/>
-          </a:bodyPr>
-          <a:lstStyle/>
-          <a:p>
-            <a:r>
-              <a:rPr sz="1900" b="0" i="1">
-                <a:solidFill>
-                  <a:srgbClr val="2563EB"/>
-                </a:solidFill>
-                <a:latin typeface="Calibri"/>
-              </a:rPr>
-              <a:t>Where this isn't airtight — in plain terms.</a:t>
-            </a:r>
-          </a:p>
-        </p:txBody>
-      </p:sp>
-      <p:sp>
-        <p:nvSpPr>
-          <p:cNvPr id="5" name="TextBox 4"/>
-          <p:cNvSpPr txBox="1"/>
-          <p:nvPr/>
-        </p:nvSpPr>
-        <p:spPr>
-          <a:xfrm>
-            <a:off x="777240" y="2514600"/>
-            <a:ext cx="10607040" cy="3657600"/>
+            <a:ext cx="10607040" cy="2743200"/>
           </a:xfrm>
           <a:prstGeom prst="rect">
             <a:avLst/>
@@ -7624,23 +7591,7 @@
                 </a:solidFill>
                 <a:latin typeface="Calibri"/>
               </a:rPr>
-              <a:t>•  Intraday is one year (2019).</a:t>
-            </a:r>
-          </a:p>
-          <a:p>
-            <a:pPr lvl="1">
-              <a:spcAft>
-                <a:spcPts val="600"/>
-              </a:spcAft>
-            </a:pPr>
-            <a:r>
-              <a:rPr sz="1800" b="0" i="0">
-                <a:solidFill>
-                  <a:srgbClr val="9CA3AF"/>
-                </a:solidFill>
-                <a:latin typeface="Calibri"/>
-              </a:rPr>
-              <a:t>–  25 years of 30-min TAQ is too costly to pull; daily covers the full 25.</a:t>
+              <a:t>•  Proposed 12 candidate signals — 3 residualizations × 2 thresholds × 2 curvature objects — and accepted 6, rejected 6.</a:t>
             </a:r>
           </a:p>
           <a:p>
@@ -7656,23 +7607,7 @@
                 </a:solidFill>
                 <a:latin typeface="Calibri"/>
               </a:rPr>
-              <a:t>•  The clustering step is weak — too few triangles.</a:t>
-            </a:r>
-          </a:p>
-          <a:p>
-            <a:pPr lvl="1">
-              <a:spcAft>
-                <a:spcPts val="600"/>
-              </a:spcAft>
-            </a:pPr>
-            <a:r>
-              <a:rPr sz="1800" b="0" i="0">
-                <a:solidFill>
-                  <a:srgbClr val="9CA3AF"/>
-                </a:solidFill>
-                <a:latin typeface="Calibri"/>
-              </a:rPr>
-              <a:t>–  finding communities needs triangles (tight clusters have them, bridges don't); ours are too sparse to separate clusters, so we don't lean on it.</a:t>
+              <a:t>•  Auto-rejected every plain-Forman (R²-on-degree = 1.00, pure degree); accepted every augmented (0.45–0.67).</a:t>
             </a:r>
           </a:p>
           <a:p>
@@ -7688,55 +7623,71 @@
                 </a:solidFill>
                 <a:latin typeface="Calibri"/>
               </a:rPr>
-              <a:t>•  Prediction used the top-20 pairs, not fixed in advance.</a:t>
-            </a:r>
-          </a:p>
-          <a:p>
-            <a:pPr lvl="1">
-              <a:spcAft>
-                <a:spcPts val="600"/>
-              </a:spcAft>
-            </a:pPr>
-            <a:r>
-              <a:rPr sz="1800" b="0" i="0">
-                <a:solidFill>
-                  <a:srgbClr val="9CA3AF"/>
-                </a:solidFill>
-                <a:latin typeface="Calibri"/>
-              </a:rPr>
-              <a:t>–  so it's not fully immune to a 'why 20?' challenge — though the IC was null anyway, so there was nothing to tune.</a:t>
-            </a:r>
-          </a:p>
-          <a:p>
-            <a:pPr>
-              <a:spcAft>
-                <a:spcPts val="1200"/>
-              </a:spcAft>
-            </a:pPr>
-            <a:r>
-              <a:rPr sz="2100" b="0" i="0">
-                <a:solidFill>
-                  <a:srgbClr val="374151"/>
-                </a:solidFill>
-                <a:latin typeface="Calibri"/>
-              </a:rPr>
-              <a:t>•  Each daily window used only stocks that survived it.</a:t>
-            </a:r>
-          </a:p>
-          <a:p>
-            <a:pPr lvl="1">
-              <a:spcAft>
-                <a:spcPts val="600"/>
-              </a:spcAft>
-            </a:pPr>
-            <a:r>
-              <a:rPr sz="1800" b="0" i="0">
-                <a:solidFill>
-                  <a:srgbClr val="9CA3AF"/>
-                </a:solidFill>
-                <a:latin typeface="Calibri"/>
-              </a:rPr>
-              <a:t>–  stocks delisted/merged mid-window are dropped → mild survivorship bias.</a:t>
+              <a:t>•  Real result it produced: H1 holds under all three residualizations (market / sector / PCA) — every decision logged with its reason.</a:t>
+            </a:r>
+          </a:p>
+        </p:txBody>
+      </p:sp>
+      <p:sp>
+        <p:nvSpPr>
+          <p:cNvPr id="5" name="Rounded Rectangle 4"/>
+          <p:cNvSpPr/>
+          <p:nvPr/>
+        </p:nvSpPr>
+        <p:spPr>
+          <a:xfrm>
+            <a:off x="777240" y="4983480"/>
+            <a:ext cx="10607040" cy="1051560"/>
+          </a:xfrm>
+          <a:prstGeom prst="roundRect">
+            <a:avLst/>
+          </a:prstGeom>
+          <a:solidFill>
+            <a:srgbClr val="EFF2FB"/>
+          </a:solidFill>
+          <a:ln w="15875">
+            <a:solidFill>
+              <a:srgbClr val="2563EB"/>
+            </a:solidFill>
+          </a:ln>
+          <a:effectLst/>
+        </p:spPr>
+        <p:style>
+          <a:lnRef idx="1">
+            <a:schemeClr val="accent1"/>
+          </a:lnRef>
+          <a:fillRef idx="3">
+            <a:schemeClr val="accent1"/>
+          </a:fillRef>
+          <a:effectRef idx="2">
+            <a:schemeClr val="accent1"/>
+          </a:effectRef>
+          <a:fontRef idx="minor">
+            <a:schemeClr val="lt1"/>
+          </a:fontRef>
+        </p:style>
+        <p:txBody>
+          <a:bodyPr rtlCol="0" anchor="ctr" wrap="square" lIns="228600" rIns="228600"/>
+          <a:lstStyle/>
+          <a:p>
+            <a:pPr algn="ctr"/>
+            <a:r>
+              <a:rPr sz="1400" b="1" i="0">
+                <a:solidFill>
+                  <a:srgbClr val="2563EB"/>
+                </a:solidFill>
+                <a:latin typeface="Calibri"/>
+              </a:rPr>
+              <a:t>Future role   </a:t>
+            </a:r>
+            <a:r>
+              <a:rPr sz="1700" b="1" i="0">
+                <a:solidFill>
+                  <a:srgbClr val="1F2937"/>
+                </a:solidFill>
+                <a:latin typeface="Calibri"/>
+              </a:rPr>
+              <a:t>Going forward it proposes &amp; vets the next hypotheses — today it sweeps a fixed grid; an LLM proposer would let it generate novel signal families.</a:t>
             </a:r>
           </a:p>
         </p:txBody>
@@ -7770,7 +7721,7 @@
                 </a:solidFill>
                 <a:latin typeface="Calibri"/>
               </a:rPr>
-              <a:t>Limitations</a:t>
+              <a:t>Agentic AI</a:t>
             </a:r>
           </a:p>
         </p:txBody>
@@ -8159,7 +8110,7 @@
                 </a:solidFill>
                 <a:latin typeface="Calibri"/>
               </a:rPr>
-              <a:t>What's next</a:t>
+              <a:t>Limitations</a:t>
             </a:r>
           </a:p>
         </p:txBody>
@@ -8237,7 +8188,7 @@
                 </a:solidFill>
                 <a:latin typeface="Calibri"/>
               </a:rPr>
-              <a:t>H2 failed — so pivot from forecasting returns to what curvature is strong at: structure.</a:t>
+              <a:t>Where this isn't airtight — in plain terms.</a:t>
             </a:r>
           </a:p>
         </p:txBody>
@@ -8276,7 +8227,23 @@
                 </a:solidFill>
                 <a:latin typeface="Calibri"/>
               </a:rPr>
-              <a:t>•  Curvature as a fragility / systemic-risk signal — Sandhu's original result was curvature rising before crashes; bring that to the directed graph.</a:t>
+              <a:t>•  Intraday is one year (2019).</a:t>
+            </a:r>
+          </a:p>
+          <a:p>
+            <a:pPr lvl="1">
+              <a:spcAft>
+                <a:spcPts val="600"/>
+              </a:spcAft>
+            </a:pPr>
+            <a:r>
+              <a:rPr sz="1800" b="0" i="0">
+                <a:solidFill>
+                  <a:srgbClr val="9CA3AF"/>
+                </a:solidFill>
+                <a:latin typeface="Calibri"/>
+              </a:rPr>
+              <a:t>–  25 years of 30-min TAQ is too costly to pull; daily covers the full 25.</a:t>
             </a:r>
           </a:p>
           <a:p>
@@ -8292,7 +8259,23 @@
                 </a:solidFill>
                 <a:latin typeface="Calibri"/>
               </a:rPr>
-              <a:t>•  Regime shifts: does the cross-sector structure change around stress? The 2008 &amp; 2020 intraday pulls feed exactly this.</a:t>
+              <a:t>•  The clustering step is weak — too few triangles.</a:t>
+            </a:r>
+          </a:p>
+          <a:p>
+            <a:pPr lvl="1">
+              <a:spcAft>
+                <a:spcPts val="600"/>
+              </a:spcAft>
+            </a:pPr>
+            <a:r>
+              <a:rPr sz="1800" b="0" i="0">
+                <a:solidFill>
+                  <a:srgbClr val="9CA3AF"/>
+                </a:solidFill>
+                <a:latin typeface="Calibri"/>
+              </a:rPr>
+              <a:t>–  finding communities needs triangles (tight clusters have them, bridges don't); ours are too sparse to separate clusters, so we don't lean on it.</a:t>
             </a:r>
           </a:p>
           <a:p>
@@ -8308,7 +8291,23 @@
                 </a:solidFill>
                 <a:latin typeface="Calibri"/>
               </a:rPr>
-              <a:t>•  Line graph → cluster lead-lag *relationships* (not stocks) into communities, e.g. for diversification — once we have a triangle-richer graph (directed theory still open).</a:t>
+              <a:t>•  Prediction used the top-20 pairs, not fixed in advance.</a:t>
+            </a:r>
+          </a:p>
+          <a:p>
+            <a:pPr lvl="1">
+              <a:spcAft>
+                <a:spcPts val="600"/>
+              </a:spcAft>
+            </a:pPr>
+            <a:r>
+              <a:rPr sz="1800" b="0" i="0">
+                <a:solidFill>
+                  <a:srgbClr val="9CA3AF"/>
+                </a:solidFill>
+                <a:latin typeface="Calibri"/>
+              </a:rPr>
+              <a:t>–  so it's not fully immune to a 'why 20?' challenge — though the IC was null anyway, so there was nothing to tune.</a:t>
             </a:r>
           </a:p>
           <a:p>
@@ -8324,7 +8323,23 @@
                 </a:solidFill>
                 <a:latin typeface="Calibri"/>
               </a:rPr>
-              <a:t>•  Extend to an 8-page ACM sigconf — ICAIF 2026, deadline Aug 2.</a:t>
+              <a:t>•  Each daily window used only stocks that survived it.</a:t>
+            </a:r>
+          </a:p>
+          <a:p>
+            <a:pPr lvl="1">
+              <a:spcAft>
+                <a:spcPts val="600"/>
+              </a:spcAft>
+            </a:pPr>
+            <a:r>
+              <a:rPr sz="1800" b="0" i="0">
+                <a:solidFill>
+                  <a:srgbClr val="9CA3AF"/>
+                </a:solidFill>
+                <a:latin typeface="Calibri"/>
+              </a:rPr>
+              <a:t>–  stocks delisted/merged mid-window are dropped → mild survivorship bias.</a:t>
             </a:r>
           </a:p>
         </p:txBody>
@@ -8358,7 +8373,7 @@
                 </a:solidFill>
                 <a:latin typeface="Calibri"/>
               </a:rPr>
-              <a:t>What's next</a:t>
+              <a:t>Limitations</a:t>
             </a:r>
           </a:p>
         </p:txBody>
@@ -8407,6 +8422,292 @@
 </file>
 
 <file path=ppt/slides/slide21.xml><?xml version="1.0" encoding="utf-8"?>
+<p:sld xmlns:a="http://schemas.openxmlformats.org/drawingml/2006/main" xmlns:p="http://schemas.openxmlformats.org/presentationml/2006/main" xmlns:r="http://schemas.openxmlformats.org/officeDocument/2006/relationships">
+  <p:cSld>
+    <p:spTree>
+      <p:nvGrpSpPr>
+        <p:cNvPr id="1" name=""/>
+        <p:cNvGrpSpPr/>
+        <p:nvPr/>
+      </p:nvGrpSpPr>
+      <p:grpSpPr/>
+      <p:sp>
+        <p:nvSpPr>
+          <p:cNvPr id="2" name="TextBox 1"/>
+          <p:cNvSpPr txBox="1"/>
+          <p:nvPr/>
+        </p:nvSpPr>
+        <p:spPr>
+          <a:xfrm>
+            <a:off x="777240" y="640080"/>
+            <a:ext cx="10607040" cy="822960"/>
+          </a:xfrm>
+          <a:prstGeom prst="rect">
+            <a:avLst/>
+          </a:prstGeom>
+          <a:noFill/>
+        </p:spPr>
+        <p:txBody>
+          <a:bodyPr wrap="square">
+            <a:spAutoFit/>
+          </a:bodyPr>
+          <a:lstStyle/>
+          <a:p>
+            <a:r>
+              <a:rPr sz="3000" b="1" i="0">
+                <a:solidFill>
+                  <a:srgbClr val="1F2937"/>
+                </a:solidFill>
+                <a:latin typeface="Calibri"/>
+              </a:rPr>
+              <a:t>What's next</a:t>
+            </a:r>
+          </a:p>
+        </p:txBody>
+      </p:sp>
+      <p:sp>
+        <p:nvSpPr>
+          <p:cNvPr id="3" name="Rectangle 2"/>
+          <p:cNvSpPr/>
+          <p:nvPr/>
+        </p:nvSpPr>
+        <p:spPr>
+          <a:xfrm>
+            <a:off x="777240" y="1417320"/>
+            <a:ext cx="1828800" cy="38100"/>
+          </a:xfrm>
+          <a:prstGeom prst="rect">
+            <a:avLst/>
+          </a:prstGeom>
+          <a:solidFill>
+            <a:srgbClr val="2563EB"/>
+          </a:solidFill>
+          <a:ln>
+            <a:noFill/>
+          </a:ln>
+          <a:effectLst/>
+        </p:spPr>
+        <p:style>
+          <a:lnRef idx="1">
+            <a:schemeClr val="accent1"/>
+          </a:lnRef>
+          <a:fillRef idx="3">
+            <a:schemeClr val="accent1"/>
+          </a:fillRef>
+          <a:effectRef idx="2">
+            <a:schemeClr val="accent1"/>
+          </a:effectRef>
+          <a:fontRef idx="minor">
+            <a:schemeClr val="lt1"/>
+          </a:fontRef>
+        </p:style>
+        <p:txBody>
+          <a:bodyPr rtlCol="0" anchor="ctr"/>
+          <a:lstStyle/>
+          <a:p>
+            <a:pPr algn="ctr"/>
+          </a:p>
+        </p:txBody>
+      </p:sp>
+      <p:sp>
+        <p:nvSpPr>
+          <p:cNvPr id="4" name="TextBox 3"/>
+          <p:cNvSpPr txBox="1"/>
+          <p:nvPr/>
+        </p:nvSpPr>
+        <p:spPr>
+          <a:xfrm>
+            <a:off x="777240" y="1783080"/>
+            <a:ext cx="10607040" cy="731520"/>
+          </a:xfrm>
+          <a:prstGeom prst="rect">
+            <a:avLst/>
+          </a:prstGeom>
+          <a:noFill/>
+        </p:spPr>
+        <p:txBody>
+          <a:bodyPr wrap="square">
+            <a:spAutoFit/>
+          </a:bodyPr>
+          <a:lstStyle/>
+          <a:p>
+            <a:r>
+              <a:rPr sz="1900" b="0" i="1">
+                <a:solidFill>
+                  <a:srgbClr val="2563EB"/>
+                </a:solidFill>
+                <a:latin typeface="Calibri"/>
+              </a:rPr>
+              <a:t>H2 failed — so pivot from forecasting returns to what curvature is strong at: structure.</a:t>
+            </a:r>
+          </a:p>
+        </p:txBody>
+      </p:sp>
+      <p:sp>
+        <p:nvSpPr>
+          <p:cNvPr id="5" name="TextBox 4"/>
+          <p:cNvSpPr txBox="1"/>
+          <p:nvPr/>
+        </p:nvSpPr>
+        <p:spPr>
+          <a:xfrm>
+            <a:off x="777240" y="2514600"/>
+            <a:ext cx="10607040" cy="3657600"/>
+          </a:xfrm>
+          <a:prstGeom prst="rect">
+            <a:avLst/>
+          </a:prstGeom>
+          <a:noFill/>
+        </p:spPr>
+        <p:txBody>
+          <a:bodyPr wrap="square">
+            <a:spAutoFit/>
+          </a:bodyPr>
+          <a:lstStyle/>
+          <a:p>
+            <a:pPr>
+              <a:spcAft>
+                <a:spcPts val="1200"/>
+              </a:spcAft>
+            </a:pPr>
+            <a:r>
+              <a:rPr sz="2100" b="0" i="0">
+                <a:solidFill>
+                  <a:srgbClr val="374151"/>
+                </a:solidFill>
+                <a:latin typeface="Calibri"/>
+              </a:rPr>
+              <a:t>•  Curvature as a fragility / systemic-risk signal — Sandhu's original result was curvature rising before crashes; bring that to the directed graph.</a:t>
+            </a:r>
+          </a:p>
+          <a:p>
+            <a:pPr>
+              <a:spcAft>
+                <a:spcPts val="1200"/>
+              </a:spcAft>
+            </a:pPr>
+            <a:r>
+              <a:rPr sz="2100" b="0" i="0">
+                <a:solidFill>
+                  <a:srgbClr val="374151"/>
+                </a:solidFill>
+                <a:latin typeface="Calibri"/>
+              </a:rPr>
+              <a:t>•  Regime shifts: does the cross-sector structure change around stress? The 2008 &amp; 2020 intraday pulls feed exactly this.</a:t>
+            </a:r>
+          </a:p>
+          <a:p>
+            <a:pPr>
+              <a:spcAft>
+                <a:spcPts val="1200"/>
+              </a:spcAft>
+            </a:pPr>
+            <a:r>
+              <a:rPr sz="2100" b="0" i="0">
+                <a:solidFill>
+                  <a:srgbClr val="374151"/>
+                </a:solidFill>
+                <a:latin typeface="Calibri"/>
+              </a:rPr>
+              <a:t>•  Line graph → cluster lead-lag *relationships* (not stocks) into communities, e.g. for diversification — once we have a triangle-richer graph (directed theory still open).</a:t>
+            </a:r>
+          </a:p>
+          <a:p>
+            <a:pPr>
+              <a:spcAft>
+                <a:spcPts val="1200"/>
+              </a:spcAft>
+            </a:pPr>
+            <a:r>
+              <a:rPr sz="2100" b="0" i="0">
+                <a:solidFill>
+                  <a:srgbClr val="374151"/>
+                </a:solidFill>
+                <a:latin typeface="Calibri"/>
+              </a:rPr>
+              <a:t>•  Extend to an 8-page ACM sigconf — ICAIF 2026, deadline Aug 2.</a:t>
+            </a:r>
+          </a:p>
+        </p:txBody>
+      </p:sp>
+      <p:sp>
+        <p:nvSpPr>
+          <p:cNvPr id="6" name="TextBox 5"/>
+          <p:cNvSpPr txBox="1"/>
+          <p:nvPr/>
+        </p:nvSpPr>
+        <p:spPr>
+          <a:xfrm>
+            <a:off x="777240" y="6355080"/>
+            <a:ext cx="10607040" cy="365760"/>
+          </a:xfrm>
+          <a:prstGeom prst="rect">
+            <a:avLst/>
+          </a:prstGeom>
+          <a:noFill/>
+        </p:spPr>
+        <p:txBody>
+          <a:bodyPr wrap="square">
+            <a:spAutoFit/>
+          </a:bodyPr>
+          <a:lstStyle/>
+          <a:p>
+            <a:r>
+              <a:rPr sz="1100" b="0" i="0">
+                <a:solidFill>
+                  <a:srgbClr val="9CA3AF"/>
+                </a:solidFill>
+                <a:latin typeface="Calibri"/>
+              </a:rPr>
+              <a:t>What's next</a:t>
+            </a:r>
+          </a:p>
+        </p:txBody>
+      </p:sp>
+      <p:sp>
+        <p:nvSpPr>
+          <p:cNvPr id="7" name="TextBox 6"/>
+          <p:cNvSpPr txBox="1"/>
+          <p:nvPr/>
+        </p:nvSpPr>
+        <p:spPr>
+          <a:xfrm>
+            <a:off x="10789920" y="6355080"/>
+            <a:ext cx="1280160" cy="365760"/>
+          </a:xfrm>
+          <a:prstGeom prst="rect">
+            <a:avLst/>
+          </a:prstGeom>
+          <a:noFill/>
+        </p:spPr>
+        <p:txBody>
+          <a:bodyPr wrap="square">
+            <a:spAutoFit/>
+          </a:bodyPr>
+          <a:lstStyle/>
+          <a:p>
+            <a:pPr algn="r"/>
+            <a:r>
+              <a:rPr sz="1100" b="0" i="0">
+                <a:solidFill>
+                  <a:srgbClr val="9CA3AF"/>
+                </a:solidFill>
+                <a:latin typeface="Calibri"/>
+              </a:rPr>
+              <a:t>20</a:t>
+            </a:r>
+          </a:p>
+        </p:txBody>
+      </p:sp>
+    </p:spTree>
+  </p:cSld>
+  <p:clrMapOvr>
+    <a:masterClrMapping/>
+  </p:clrMapOvr>
+</p:sld>
+</file>
+
+<file path=ppt/slides/slide22.xml><?xml version="1.0" encoding="utf-8"?>
 <p:sld xmlns:a="http://schemas.openxmlformats.org/drawingml/2006/main" xmlns:p="http://schemas.openxmlformats.org/presentationml/2006/main" xmlns:r="http://schemas.openxmlformats.org/officeDocument/2006/relationships">
   <p:cSld>
     <p:spTree>
@@ -8893,7 +9194,7 @@
                 </a:solidFill>
                 <a:latin typeface="Calibri"/>
               </a:rPr>
-              <a:t>20</a:t>
+              <a:t>21</a:t>
             </a:r>
           </a:p>
         </p:txBody>

</xml_diff>

<commit_message>
Deck: state the top-10% sparsification on the graph-build slide
Audience was never told the graph keeps only the strongest ~10% of pairs — the
reason it's sparse (and later triangle-sparse). Added to Step 1 + talk script.

Co-Authored-By: Claude Opus 4.8 (1M context) <noreply@anthropic.com>
</commit_message>
<xml_diff>
--- a/slides/Ricci_Curvature_LeadLag.pptx
+++ b/slides/Ricci_Curvature_LeadLag.pptx
@@ -11680,6 +11680,22 @@
                 <a:latin typeface="Calibri"/>
               </a:rPr>
               <a:t>–  ρ_ij(τ) = corr( i's return today, j's return τ bars later ); τ* = the peak-signal lag, per pair — so the sign of w says who leads.</a:t>
+            </a:r>
+          </a:p>
+          <a:p>
+            <a:pPr>
+              <a:spcAft>
+                <a:spcPts val="1200"/>
+              </a:spcAft>
+            </a:pPr>
+            <a:r>
+              <a:rPr sz="2100" b="0" i="0">
+                <a:solidFill>
+                  <a:srgbClr val="374151"/>
+                </a:solidFill>
+                <a:latin typeface="Calibri"/>
+              </a:rPr>
+              <a:t>•  Keep only the strongest ~10% of pairs as edges — most lead-lag is noise; this is why the graph is sparse.</a:t>
             </a:r>
           </a:p>
           <a:p>

</xml_diff>